<commit_message>
All transport type can have a default listening address.
Changed my mind... :)
</commit_message>
<xml_diff>
--- a/Doc/CK-AppIdentity.pptx
+++ b/Doc/CK-AppIdentity.pptx
@@ -5,7 +5,7 @@
     <p:sldMasterId id="2147483648" r:id="rId1"/>
   </p:sldMasterIdLst>
   <p:notesMasterIdLst>
-    <p:notesMasterId r:id="rId31"/>
+    <p:notesMasterId r:id="rId33"/>
   </p:notesMasterIdLst>
   <p:sldIdLst>
     <p:sldId id="256" r:id="rId2"/>
@@ -37,6 +37,8 @@
     <p:sldId id="284" r:id="rId28"/>
     <p:sldId id="285" r:id="rId29"/>
     <p:sldId id="286" r:id="rId30"/>
+    <p:sldId id="287" r:id="rId31"/>
+    <p:sldId id="288" r:id="rId32"/>
   </p:sldIdLst>
   <p:sldSz cx="12192000" cy="6858000"/>
   <p:notesSz cx="6858000" cy="9144000"/>
@@ -959,7 +961,7 @@
               <a:t>TransportType</a:t>
             </a:r>
             <a:r>
-              <a:rPr lang="en-US"/>
+              <a:rPr lang="en-US" dirty="0"/>
               <a:t> model.</a:t>
             </a:r>
           </a:p>
@@ -1687,6 +1689,174 @@
     <p:extLst>
       <p:ext uri="{BB962C8B-B14F-4D97-AF65-F5344CB8AC3E}">
         <p14:creationId xmlns:p14="http://schemas.microsoft.com/office/powerpoint/2010/main" val="1132549190"/>
+      </p:ext>
+    </p:extLst>
+  </p:cSld>
+  <p:clrMapOvr>
+    <a:masterClrMapping/>
+  </p:clrMapOvr>
+</p:notes>
+</file>
+
+<file path=ppt/notesSlides/notesSlide8.xml><?xml version="1.0" encoding="utf-8"?>
+<p:notes xmlns:a="http://schemas.openxmlformats.org/drawingml/2006/main" xmlns:r="http://schemas.openxmlformats.org/officeDocument/2006/relationships" xmlns:p="http://schemas.openxmlformats.org/presentationml/2006/main">
+  <p:cSld>
+    <p:spTree>
+      <p:nvGrpSpPr>
+        <p:cNvPr id="1" name=""/>
+        <p:cNvGrpSpPr/>
+        <p:nvPr/>
+      </p:nvGrpSpPr>
+      <p:grpSpPr>
+        <a:xfrm>
+          <a:off x="0" y="0"/>
+          <a:ext cx="0" cy="0"/>
+          <a:chOff x="0" y="0"/>
+          <a:chExt cx="0" cy="0"/>
+        </a:xfrm>
+      </p:grpSpPr>
+      <p:sp>
+        <p:nvSpPr>
+          <p:cNvPr id="2" name="Slide Image Placeholder 1"/>
+          <p:cNvSpPr>
+            <a:spLocks noGrp="1" noRot="1" noChangeAspect="1"/>
+          </p:cNvSpPr>
+          <p:nvPr>
+            <p:ph type="sldImg"/>
+          </p:nvPr>
+        </p:nvSpPr>
+        <p:spPr/>
+      </p:sp>
+      <p:sp>
+        <p:nvSpPr>
+          <p:cNvPr id="3" name="Notes Placeholder 2"/>
+          <p:cNvSpPr>
+            <a:spLocks noGrp="1"/>
+          </p:cNvSpPr>
+          <p:nvPr>
+            <p:ph type="body" idx="1"/>
+          </p:nvPr>
+        </p:nvSpPr>
+        <p:spPr/>
+        <p:txBody>
+          <a:bodyPr/>
+          <a:lstStyle/>
+          <a:p>
+            <a:endParaRPr lang="en-US" dirty="0"/>
+          </a:p>
+        </p:txBody>
+      </p:sp>
+      <p:sp>
+        <p:nvSpPr>
+          <p:cNvPr id="4" name="Slide Number Placeholder 3"/>
+          <p:cNvSpPr>
+            <a:spLocks noGrp="1"/>
+          </p:cNvSpPr>
+          <p:nvPr>
+            <p:ph type="sldNum" sz="quarter" idx="5"/>
+          </p:nvPr>
+        </p:nvSpPr>
+        <p:spPr/>
+        <p:txBody>
+          <a:bodyPr/>
+          <a:lstStyle/>
+          <a:p>
+            <a:fld id="{E05EDB92-2FE2-4164-AA27-D03258A20DF4}" type="slidenum">
+              <a:rPr lang="en-US" smtClean="0"/>
+              <a:t>30</a:t>
+            </a:fld>
+            <a:endParaRPr lang="en-US"/>
+          </a:p>
+        </p:txBody>
+      </p:sp>
+    </p:spTree>
+    <p:extLst>
+      <p:ext uri="{BB962C8B-B14F-4D97-AF65-F5344CB8AC3E}">
+        <p14:creationId xmlns:p14="http://schemas.microsoft.com/office/powerpoint/2010/main" val="213048778"/>
+      </p:ext>
+    </p:extLst>
+  </p:cSld>
+  <p:clrMapOvr>
+    <a:masterClrMapping/>
+  </p:clrMapOvr>
+</p:notes>
+</file>
+
+<file path=ppt/notesSlides/notesSlide9.xml><?xml version="1.0" encoding="utf-8"?>
+<p:notes xmlns:a="http://schemas.openxmlformats.org/drawingml/2006/main" xmlns:r="http://schemas.openxmlformats.org/officeDocument/2006/relationships" xmlns:p="http://schemas.openxmlformats.org/presentationml/2006/main">
+  <p:cSld>
+    <p:spTree>
+      <p:nvGrpSpPr>
+        <p:cNvPr id="1" name=""/>
+        <p:cNvGrpSpPr/>
+        <p:nvPr/>
+      </p:nvGrpSpPr>
+      <p:grpSpPr>
+        <a:xfrm>
+          <a:off x="0" y="0"/>
+          <a:ext cx="0" cy="0"/>
+          <a:chOff x="0" y="0"/>
+          <a:chExt cx="0" cy="0"/>
+        </a:xfrm>
+      </p:grpSpPr>
+      <p:sp>
+        <p:nvSpPr>
+          <p:cNvPr id="2" name="Slide Image Placeholder 1"/>
+          <p:cNvSpPr>
+            <a:spLocks noGrp="1" noRot="1" noChangeAspect="1"/>
+          </p:cNvSpPr>
+          <p:nvPr>
+            <p:ph type="sldImg"/>
+          </p:nvPr>
+        </p:nvSpPr>
+        <p:spPr/>
+      </p:sp>
+      <p:sp>
+        <p:nvSpPr>
+          <p:cNvPr id="3" name="Notes Placeholder 2"/>
+          <p:cNvSpPr>
+            <a:spLocks noGrp="1"/>
+          </p:cNvSpPr>
+          <p:nvPr>
+            <p:ph type="body" idx="1"/>
+          </p:nvPr>
+        </p:nvSpPr>
+        <p:spPr/>
+        <p:txBody>
+          <a:bodyPr/>
+          <a:lstStyle/>
+          <a:p>
+            <a:endParaRPr lang="en-US" dirty="0"/>
+          </a:p>
+        </p:txBody>
+      </p:sp>
+      <p:sp>
+        <p:nvSpPr>
+          <p:cNvPr id="4" name="Slide Number Placeholder 3"/>
+          <p:cNvSpPr>
+            <a:spLocks noGrp="1"/>
+          </p:cNvSpPr>
+          <p:nvPr>
+            <p:ph type="sldNum" sz="quarter" idx="5"/>
+          </p:nvPr>
+        </p:nvSpPr>
+        <p:spPr/>
+        <p:txBody>
+          <a:bodyPr/>
+          <a:lstStyle/>
+          <a:p>
+            <a:fld id="{E05EDB92-2FE2-4164-AA27-D03258A20DF4}" type="slidenum">
+              <a:rPr lang="en-US" smtClean="0"/>
+              <a:t>31</a:t>
+            </a:fld>
+            <a:endParaRPr lang="en-US"/>
+          </a:p>
+        </p:txBody>
+      </p:sp>
+    </p:spTree>
+    <p:extLst>
+      <p:ext uri="{BB962C8B-B14F-4D97-AF65-F5344CB8AC3E}">
+        <p14:creationId xmlns:p14="http://schemas.microsoft.com/office/powerpoint/2010/main" val="1570586495"/>
       </p:ext>
     </p:extLst>
   </p:cSld>
@@ -13920,35 +14090,625 @@
           <a:bodyPr/>
           <a:lstStyle/>
           <a:p>
-            <a:endParaRPr lang="en-US" dirty="0"/>
+            <a:r>
+              <a:rPr lang="en-US" dirty="0"/>
+              <a:t>Creating new messages</a:t>
+            </a:r>
           </a:p>
         </p:txBody>
       </p:sp>
       <p:sp>
         <p:nvSpPr>
-          <p:cNvPr id="3" name="Content Placeholder 2">
+          <p:cNvPr id="10" name="Content Placeholder 2">
             <a:extLst>
               <a:ext uri="{FF2B5EF4-FFF2-40B4-BE49-F238E27FC236}">
-                <a16:creationId xmlns:a16="http://schemas.microsoft.com/office/drawing/2014/main" id="{7520F365-7A16-563B-2B49-2EDE70A00237}"/>
+                <a16:creationId xmlns:a16="http://schemas.microsoft.com/office/drawing/2014/main" id="{1CC84568-F688-2F94-8756-D5862C7EDE27}"/>
               </a:ext>
             </a:extLst>
           </p:cNvPr>
-          <p:cNvSpPr>
-            <a:spLocks noGrp="1"/>
+          <p:cNvSpPr txBox="1">
+            <a:spLocks/>
           </p:cNvSpPr>
+          <p:nvPr/>
+        </p:nvSpPr>
+        <p:spPr>
+          <a:xfrm>
+            <a:off x="838200" y="1825625"/>
+            <a:ext cx="10515600" cy="4516560"/>
+          </a:xfrm>
+          <a:prstGeom prst="rect">
+            <a:avLst/>
+          </a:prstGeom>
+        </p:spPr>
+        <p:txBody>
+          <a:bodyPr vert="horz" lIns="91440" tIns="45720" rIns="91440" bIns="45720" rtlCol="0">
+            <a:normAutofit lnSpcReduction="10000"/>
+          </a:bodyPr>
+          <a:lstStyle>
+            <a:lvl1pPr marL="228600" indent="-228600" algn="l" defTabSz="914400" rtl="0" eaLnBrk="1" latinLnBrk="0" hangingPunct="1">
+              <a:lnSpc>
+                <a:spcPct val="90000"/>
+              </a:lnSpc>
+              <a:spcBef>
+                <a:spcPts val="1000"/>
+              </a:spcBef>
+              <a:buFont typeface="Arial" panose="020B0604020202020204" pitchFamily="34" charset="0"/>
+              <a:buChar char="•"/>
+              <a:defRPr sz="2800" kern="1200">
+                <a:solidFill>
+                  <a:schemeClr val="tx1"/>
+                </a:solidFill>
+                <a:latin typeface="+mn-lt"/>
+                <a:ea typeface="+mn-ea"/>
+                <a:cs typeface="+mn-cs"/>
+              </a:defRPr>
+            </a:lvl1pPr>
+            <a:lvl2pPr marL="685800" indent="-228600" algn="l" defTabSz="914400" rtl="0" eaLnBrk="1" latinLnBrk="0" hangingPunct="1">
+              <a:lnSpc>
+                <a:spcPct val="90000"/>
+              </a:lnSpc>
+              <a:spcBef>
+                <a:spcPts val="500"/>
+              </a:spcBef>
+              <a:buFont typeface="Arial" panose="020B0604020202020204" pitchFamily="34" charset="0"/>
+              <a:buChar char="•"/>
+              <a:defRPr sz="2400" kern="1200">
+                <a:solidFill>
+                  <a:schemeClr val="tx1"/>
+                </a:solidFill>
+                <a:latin typeface="+mn-lt"/>
+                <a:ea typeface="+mn-ea"/>
+                <a:cs typeface="+mn-cs"/>
+              </a:defRPr>
+            </a:lvl2pPr>
+            <a:lvl3pPr marL="1143000" indent="-228600" algn="l" defTabSz="914400" rtl="0" eaLnBrk="1" latinLnBrk="0" hangingPunct="1">
+              <a:lnSpc>
+                <a:spcPct val="90000"/>
+              </a:lnSpc>
+              <a:spcBef>
+                <a:spcPts val="500"/>
+              </a:spcBef>
+              <a:buFont typeface="Arial" panose="020B0604020202020204" pitchFamily="34" charset="0"/>
+              <a:buChar char="•"/>
+              <a:defRPr sz="2000" kern="1200">
+                <a:solidFill>
+                  <a:schemeClr val="tx1"/>
+                </a:solidFill>
+                <a:latin typeface="+mn-lt"/>
+                <a:ea typeface="+mn-ea"/>
+                <a:cs typeface="+mn-cs"/>
+              </a:defRPr>
+            </a:lvl3pPr>
+            <a:lvl4pPr marL="1600200" indent="-228600" algn="l" defTabSz="914400" rtl="0" eaLnBrk="1" latinLnBrk="0" hangingPunct="1">
+              <a:lnSpc>
+                <a:spcPct val="90000"/>
+              </a:lnSpc>
+              <a:spcBef>
+                <a:spcPts val="500"/>
+              </a:spcBef>
+              <a:buFont typeface="Arial" panose="020B0604020202020204" pitchFamily="34" charset="0"/>
+              <a:buChar char="•"/>
+              <a:defRPr sz="1800" kern="1200">
+                <a:solidFill>
+                  <a:schemeClr val="tx1"/>
+                </a:solidFill>
+                <a:latin typeface="+mn-lt"/>
+                <a:ea typeface="+mn-ea"/>
+                <a:cs typeface="+mn-cs"/>
+              </a:defRPr>
+            </a:lvl4pPr>
+            <a:lvl5pPr marL="2057400" indent="-228600" algn="l" defTabSz="914400" rtl="0" eaLnBrk="1" latinLnBrk="0" hangingPunct="1">
+              <a:lnSpc>
+                <a:spcPct val="90000"/>
+              </a:lnSpc>
+              <a:spcBef>
+                <a:spcPts val="500"/>
+              </a:spcBef>
+              <a:buFont typeface="Arial" panose="020B0604020202020204" pitchFamily="34" charset="0"/>
+              <a:buChar char="•"/>
+              <a:defRPr sz="1800" kern="1200">
+                <a:solidFill>
+                  <a:schemeClr val="tx1"/>
+                </a:solidFill>
+                <a:latin typeface="+mn-lt"/>
+                <a:ea typeface="+mn-ea"/>
+                <a:cs typeface="+mn-cs"/>
+              </a:defRPr>
+            </a:lvl5pPr>
+            <a:lvl6pPr marL="2514600" indent="-228600" algn="l" defTabSz="914400" rtl="0" eaLnBrk="1" latinLnBrk="0" hangingPunct="1">
+              <a:lnSpc>
+                <a:spcPct val="90000"/>
+              </a:lnSpc>
+              <a:spcBef>
+                <a:spcPts val="500"/>
+              </a:spcBef>
+              <a:buFont typeface="Arial" panose="020B0604020202020204" pitchFamily="34" charset="0"/>
+              <a:buChar char="•"/>
+              <a:defRPr sz="1800" kern="1200">
+                <a:solidFill>
+                  <a:schemeClr val="tx1"/>
+                </a:solidFill>
+                <a:latin typeface="+mn-lt"/>
+                <a:ea typeface="+mn-ea"/>
+                <a:cs typeface="+mn-cs"/>
+              </a:defRPr>
+            </a:lvl6pPr>
+            <a:lvl7pPr marL="2971800" indent="-228600" algn="l" defTabSz="914400" rtl="0" eaLnBrk="1" latinLnBrk="0" hangingPunct="1">
+              <a:lnSpc>
+                <a:spcPct val="90000"/>
+              </a:lnSpc>
+              <a:spcBef>
+                <a:spcPts val="500"/>
+              </a:spcBef>
+              <a:buFont typeface="Arial" panose="020B0604020202020204" pitchFamily="34" charset="0"/>
+              <a:buChar char="•"/>
+              <a:defRPr sz="1800" kern="1200">
+                <a:solidFill>
+                  <a:schemeClr val="tx1"/>
+                </a:solidFill>
+                <a:latin typeface="+mn-lt"/>
+                <a:ea typeface="+mn-ea"/>
+                <a:cs typeface="+mn-cs"/>
+              </a:defRPr>
+            </a:lvl7pPr>
+            <a:lvl8pPr marL="3429000" indent="-228600" algn="l" defTabSz="914400" rtl="0" eaLnBrk="1" latinLnBrk="0" hangingPunct="1">
+              <a:lnSpc>
+                <a:spcPct val="90000"/>
+              </a:lnSpc>
+              <a:spcBef>
+                <a:spcPts val="500"/>
+              </a:spcBef>
+              <a:buFont typeface="Arial" panose="020B0604020202020204" pitchFamily="34" charset="0"/>
+              <a:buChar char="•"/>
+              <a:defRPr sz="1800" kern="1200">
+                <a:solidFill>
+                  <a:schemeClr val="tx1"/>
+                </a:solidFill>
+                <a:latin typeface="+mn-lt"/>
+                <a:ea typeface="+mn-ea"/>
+                <a:cs typeface="+mn-cs"/>
+              </a:defRPr>
+            </a:lvl8pPr>
+            <a:lvl9pPr marL="3886200" indent="-228600" algn="l" defTabSz="914400" rtl="0" eaLnBrk="1" latinLnBrk="0" hangingPunct="1">
+              <a:lnSpc>
+                <a:spcPct val="90000"/>
+              </a:lnSpc>
+              <a:spcBef>
+                <a:spcPts val="500"/>
+              </a:spcBef>
+              <a:buFont typeface="Arial" panose="020B0604020202020204" pitchFamily="34" charset="0"/>
+              <a:buChar char="•"/>
+              <a:defRPr sz="1800" kern="1200">
+                <a:solidFill>
+                  <a:schemeClr val="tx1"/>
+                </a:solidFill>
+                <a:latin typeface="+mn-lt"/>
+                <a:ea typeface="+mn-ea"/>
+                <a:cs typeface="+mn-cs"/>
+              </a:defRPr>
+            </a:lvl9pPr>
+          </a:lstStyle>
+          <a:p>
+            <a:r>
+              <a:rPr lang="en-US" dirty="0"/>
+              <a:t>Only an </a:t>
+            </a:r>
+            <a:r>
+              <a:rPr lang="en-US" sz="2000" dirty="0" err="1">
+                <a:latin typeface="Consolas" panose="020B0609020204030204" pitchFamily="49" charset="0"/>
+                <a:cs typeface="Courier New" panose="02070309020205020404" pitchFamily="49" charset="0"/>
+              </a:rPr>
+              <a:t>OutgoingMessageFactory</a:t>
+            </a:r>
+            <a:r>
+              <a:rPr lang="en-US" dirty="0"/>
+              <a:t> can </a:t>
+            </a:r>
+            <a:br>
+              <a:rPr lang="en-US" dirty="0"/>
+            </a:br>
+            <a:r>
+              <a:rPr lang="en-US" dirty="0"/>
+              <a:t>create new messages:</a:t>
+            </a:r>
+          </a:p>
+          <a:p>
+            <a:endParaRPr lang="en-US" dirty="0"/>
+          </a:p>
+          <a:p>
+            <a:endParaRPr lang="en-US" dirty="0"/>
+          </a:p>
+          <a:p>
+            <a:endParaRPr lang="en-US" dirty="0"/>
+          </a:p>
+          <a:p>
+            <a:r>
+              <a:rPr lang="en-US" dirty="0"/>
+              <a:t>Messages must be disposed once done with them</a:t>
+            </a:r>
+          </a:p>
+          <a:p>
+            <a:pPr lvl="1"/>
+            <a:r>
+              <a:rPr lang="en-US" dirty="0"/>
+              <a:t>Allocated memory is reused.</a:t>
+            </a:r>
+          </a:p>
+          <a:p>
+            <a:r>
+              <a:rPr lang="en-US" dirty="0"/>
+              <a:t>Messages can be “Retained” when needed (reference counting)</a:t>
+            </a:r>
+          </a:p>
+          <a:p>
+            <a:r>
+              <a:rPr lang="en-US" dirty="0" err="1"/>
+              <a:t>CreateStatic</a:t>
+            </a:r>
+            <a:r>
+              <a:rPr lang="en-US" dirty="0"/>
+              <a:t> returns messages don’t need to be disposed.</a:t>
+            </a:r>
+          </a:p>
+          <a:p>
+            <a:pPr lvl="1"/>
+            <a:r>
+              <a:rPr lang="en-US" dirty="0"/>
+              <a:t>Dispose()/Retain() calls are ignored.</a:t>
+            </a:r>
+          </a:p>
+        </p:txBody>
+      </p:sp>
+      <p:sp>
+        <p:nvSpPr>
+          <p:cNvPr id="12" name="TextBox 11">
+            <a:extLst>
+              <a:ext uri="{FF2B5EF4-FFF2-40B4-BE49-F238E27FC236}">
+                <a16:creationId xmlns:a16="http://schemas.microsoft.com/office/drawing/2014/main" id="{B101A3D9-3364-B380-BE27-B3376CE6CD06}"/>
+              </a:ext>
+            </a:extLst>
+          </p:cNvPr>
+          <p:cNvSpPr txBox="1"/>
+          <p:nvPr/>
+        </p:nvSpPr>
+        <p:spPr>
+          <a:xfrm>
+            <a:off x="1078524" y="2715481"/>
+            <a:ext cx="9448800" cy="1477328"/>
+          </a:xfrm>
+          <a:prstGeom prst="rect">
+            <a:avLst/>
+          </a:prstGeom>
+          <a:noFill/>
+        </p:spPr>
+        <p:txBody>
+          <a:bodyPr wrap="square">
+            <a:spAutoFit/>
+          </a:bodyPr>
+          <a:lstStyle/>
+          <a:p>
+            <a:r>
+              <a:rPr lang="en-US" sz="1800" dirty="0">
+                <a:solidFill>
+                  <a:srgbClr val="0000FF"/>
+                </a:solidFill>
+                <a:latin typeface="Consolas" panose="020B0609020204030204" pitchFamily="49" charset="0"/>
+              </a:rPr>
+              <a:t>public</a:t>
+            </a:r>
+            <a:r>
+              <a:rPr lang="en-US" sz="1800" dirty="0">
+                <a:solidFill>
+                  <a:srgbClr val="000000"/>
+                </a:solidFill>
+                <a:latin typeface="Consolas" panose="020B0609020204030204" pitchFamily="49" charset="0"/>
+              </a:rPr>
+              <a:t> </a:t>
+            </a:r>
+            <a:r>
+              <a:rPr lang="en-US" sz="1800" dirty="0" err="1">
+                <a:solidFill>
+                  <a:srgbClr val="000000"/>
+                </a:solidFill>
+                <a:latin typeface="Consolas" panose="020B0609020204030204" pitchFamily="49" charset="0"/>
+              </a:rPr>
+              <a:t>TransportMessage</a:t>
+            </a:r>
+            <a:r>
+              <a:rPr lang="en-US" sz="1800" dirty="0">
+                <a:solidFill>
+                  <a:srgbClr val="000000"/>
+                </a:solidFill>
+                <a:latin typeface="Consolas" panose="020B0609020204030204" pitchFamily="49" charset="0"/>
+              </a:rPr>
+              <a:t> Create( Action&lt;</a:t>
+            </a:r>
+            <a:r>
+              <a:rPr lang="en-US" sz="1800" dirty="0" err="1">
+                <a:solidFill>
+                  <a:srgbClr val="000000"/>
+                </a:solidFill>
+                <a:latin typeface="Consolas" panose="020B0609020204030204" pitchFamily="49" charset="0"/>
+              </a:rPr>
+              <a:t>IBufferWriter</a:t>
+            </a:r>
+            <a:r>
+              <a:rPr lang="en-US" sz="1800" dirty="0">
+                <a:solidFill>
+                  <a:srgbClr val="000000"/>
+                </a:solidFill>
+                <a:latin typeface="Consolas" panose="020B0609020204030204" pitchFamily="49" charset="0"/>
+              </a:rPr>
+              <a:t>&lt;</a:t>
+            </a:r>
+            <a:r>
+              <a:rPr lang="en-US" sz="1800" dirty="0">
+                <a:solidFill>
+                  <a:srgbClr val="0000FF"/>
+                </a:solidFill>
+                <a:latin typeface="Consolas" panose="020B0609020204030204" pitchFamily="49" charset="0"/>
+              </a:rPr>
+              <a:t>byte</a:t>
+            </a:r>
+            <a:r>
+              <a:rPr lang="en-US" sz="1800" dirty="0">
+                <a:solidFill>
+                  <a:srgbClr val="000000"/>
+                </a:solidFill>
+                <a:latin typeface="Consolas" panose="020B0609020204030204" pitchFamily="49" charset="0"/>
+              </a:rPr>
+              <a:t>&gt;&gt; writer,</a:t>
+            </a:r>
+          </a:p>
+          <a:p>
+            <a:r>
+              <a:rPr lang="en-US" sz="1800" dirty="0">
+                <a:solidFill>
+                  <a:srgbClr val="000000"/>
+                </a:solidFill>
+                <a:latin typeface="Consolas" panose="020B0609020204030204" pitchFamily="49" charset="0"/>
+              </a:rPr>
+              <a:t>                                </a:t>
+            </a:r>
+            <a:r>
+              <a:rPr lang="en-US" sz="1800" dirty="0">
+                <a:solidFill>
+                  <a:srgbClr val="0000FF"/>
+                </a:solidFill>
+                <a:latin typeface="Consolas" panose="020B0609020204030204" pitchFamily="49" charset="0"/>
+              </a:rPr>
+              <a:t>bool</a:t>
+            </a:r>
+            <a:r>
+              <a:rPr lang="en-US" sz="1800" dirty="0">
+                <a:solidFill>
+                  <a:srgbClr val="000000"/>
+                </a:solidFill>
+                <a:latin typeface="Consolas" panose="020B0609020204030204" pitchFamily="49" charset="0"/>
+              </a:rPr>
+              <a:t> </a:t>
+            </a:r>
+            <a:r>
+              <a:rPr lang="en-US" sz="1800" dirty="0" err="1">
+                <a:solidFill>
+                  <a:srgbClr val="000000"/>
+                </a:solidFill>
+                <a:latin typeface="Consolas" panose="020B0609020204030204" pitchFamily="49" charset="0"/>
+              </a:rPr>
+              <a:t>isControl</a:t>
+            </a:r>
+            <a:r>
+              <a:rPr lang="en-US" sz="1800" dirty="0">
+                <a:solidFill>
+                  <a:srgbClr val="000000"/>
+                </a:solidFill>
+                <a:latin typeface="Consolas" panose="020B0609020204030204" pitchFamily="49" charset="0"/>
+              </a:rPr>
+              <a:t> = </a:t>
+            </a:r>
+            <a:r>
+              <a:rPr lang="en-US" sz="1800" dirty="0">
+                <a:solidFill>
+                  <a:srgbClr val="0000FF"/>
+                </a:solidFill>
+                <a:latin typeface="Consolas" panose="020B0609020204030204" pitchFamily="49" charset="0"/>
+              </a:rPr>
+              <a:t>false </a:t>
+            </a:r>
+            <a:r>
+              <a:rPr lang="en-US" sz="1800" dirty="0">
+                <a:solidFill>
+                  <a:srgbClr val="000000"/>
+                </a:solidFill>
+                <a:latin typeface="Consolas" panose="020B0609020204030204" pitchFamily="49" charset="0"/>
+              </a:rPr>
+              <a:t>);</a:t>
+            </a:r>
+          </a:p>
+          <a:p>
+            <a:r>
+              <a:rPr lang="en-US" sz="1800" dirty="0">
+                <a:solidFill>
+                  <a:srgbClr val="0000FF"/>
+                </a:solidFill>
+                <a:latin typeface="Consolas" panose="020B0609020204030204" pitchFamily="49" charset="0"/>
+              </a:rPr>
+              <a:t>public</a:t>
+            </a:r>
+            <a:r>
+              <a:rPr lang="en-US" sz="1800" dirty="0">
+                <a:solidFill>
+                  <a:srgbClr val="000000"/>
+                </a:solidFill>
+                <a:latin typeface="Consolas" panose="020B0609020204030204" pitchFamily="49" charset="0"/>
+              </a:rPr>
+              <a:t> </a:t>
+            </a:r>
+            <a:r>
+              <a:rPr lang="en-US" sz="1800" dirty="0" err="1">
+                <a:solidFill>
+                  <a:srgbClr val="000000"/>
+                </a:solidFill>
+                <a:latin typeface="Consolas" panose="020B0609020204030204" pitchFamily="49" charset="0"/>
+              </a:rPr>
+              <a:t>TransportMessage</a:t>
+            </a:r>
+            <a:r>
+              <a:rPr lang="en-US" sz="1800" dirty="0">
+                <a:solidFill>
+                  <a:srgbClr val="000000"/>
+                </a:solidFill>
+                <a:latin typeface="Consolas" panose="020B0609020204030204" pitchFamily="49" charset="0"/>
+              </a:rPr>
+              <a:t> Create( Action&lt;</a:t>
+            </a:r>
+            <a:r>
+              <a:rPr lang="en-US" sz="1800" dirty="0" err="1">
+                <a:solidFill>
+                  <a:srgbClr val="000000"/>
+                </a:solidFill>
+                <a:latin typeface="Consolas" panose="020B0609020204030204" pitchFamily="49" charset="0"/>
+              </a:rPr>
+              <a:t>MutableSequence</a:t>
+            </a:r>
+            <a:r>
+              <a:rPr lang="en-US" sz="1800" dirty="0">
+                <a:solidFill>
+                  <a:srgbClr val="000000"/>
+                </a:solidFill>
+                <a:latin typeface="Consolas" panose="020B0609020204030204" pitchFamily="49" charset="0"/>
+              </a:rPr>
+              <a:t>&lt;</a:t>
+            </a:r>
+            <a:r>
+              <a:rPr lang="en-US" sz="1800" dirty="0">
+                <a:solidFill>
+                  <a:srgbClr val="0000FF"/>
+                </a:solidFill>
+                <a:latin typeface="Consolas" panose="020B0609020204030204" pitchFamily="49" charset="0"/>
+              </a:rPr>
+              <a:t>byte</a:t>
+            </a:r>
+            <a:r>
+              <a:rPr lang="en-US" sz="1800" dirty="0">
+                <a:solidFill>
+                  <a:srgbClr val="000000"/>
+                </a:solidFill>
+                <a:latin typeface="Consolas" panose="020B0609020204030204" pitchFamily="49" charset="0"/>
+              </a:rPr>
+              <a:t>&gt;&gt; writer,</a:t>
+            </a:r>
+          </a:p>
+          <a:p>
+            <a:r>
+              <a:rPr lang="en-US" sz="1800" dirty="0">
+                <a:solidFill>
+                  <a:srgbClr val="000000"/>
+                </a:solidFill>
+                <a:latin typeface="Consolas" panose="020B0609020204030204" pitchFamily="49" charset="0"/>
+              </a:rPr>
+              <a:t>                                </a:t>
+            </a:r>
+            <a:r>
+              <a:rPr lang="en-US" sz="1800" dirty="0">
+                <a:solidFill>
+                  <a:srgbClr val="0000FF"/>
+                </a:solidFill>
+                <a:latin typeface="Consolas" panose="020B0609020204030204" pitchFamily="49" charset="0"/>
+              </a:rPr>
+              <a:t>bool</a:t>
+            </a:r>
+            <a:r>
+              <a:rPr lang="en-US" sz="1800" dirty="0">
+                <a:solidFill>
+                  <a:srgbClr val="000000"/>
+                </a:solidFill>
+                <a:latin typeface="Consolas" panose="020B0609020204030204" pitchFamily="49" charset="0"/>
+              </a:rPr>
+              <a:t> </a:t>
+            </a:r>
+            <a:r>
+              <a:rPr lang="en-US" sz="1800" dirty="0" err="1">
+                <a:solidFill>
+                  <a:srgbClr val="000000"/>
+                </a:solidFill>
+                <a:latin typeface="Consolas" panose="020B0609020204030204" pitchFamily="49" charset="0"/>
+              </a:rPr>
+              <a:t>isControl</a:t>
+            </a:r>
+            <a:r>
+              <a:rPr lang="en-US" sz="1800" dirty="0">
+                <a:solidFill>
+                  <a:srgbClr val="000000"/>
+                </a:solidFill>
+                <a:latin typeface="Consolas" panose="020B0609020204030204" pitchFamily="49" charset="0"/>
+              </a:rPr>
+              <a:t> = </a:t>
+            </a:r>
+            <a:r>
+              <a:rPr lang="en-US" sz="1800" dirty="0">
+                <a:solidFill>
+                  <a:srgbClr val="0000FF"/>
+                </a:solidFill>
+                <a:latin typeface="Consolas" panose="020B0609020204030204" pitchFamily="49" charset="0"/>
+              </a:rPr>
+              <a:t>false </a:t>
+            </a:r>
+            <a:r>
+              <a:rPr lang="en-US" sz="1800" dirty="0">
+                <a:solidFill>
+                  <a:srgbClr val="000000"/>
+                </a:solidFill>
+                <a:latin typeface="Consolas" panose="020B0609020204030204" pitchFamily="49" charset="0"/>
+              </a:rPr>
+              <a:t>);</a:t>
+            </a:r>
+          </a:p>
+          <a:p>
+            <a:endParaRPr lang="en-US" sz="1800" dirty="0">
+              <a:solidFill>
+                <a:srgbClr val="000000"/>
+              </a:solidFill>
+              <a:latin typeface="Consolas" panose="020B0609020204030204" pitchFamily="49" charset="0"/>
+            </a:endParaRPr>
+          </a:p>
+        </p:txBody>
+      </p:sp>
+      <p:pic>
+        <p:nvPicPr>
+          <p:cNvPr id="16" name="Content Placeholder 15" descr="Graphical user interface, text, application, chat or text message&#10;&#10;Description automatically generated">
+            <a:extLst>
+              <a:ext uri="{FF2B5EF4-FFF2-40B4-BE49-F238E27FC236}">
+                <a16:creationId xmlns:a16="http://schemas.microsoft.com/office/drawing/2014/main" id="{B9C368B7-B971-1A32-863D-EFEC2CD1A66D}"/>
+              </a:ext>
+            </a:extLst>
+          </p:cNvPr>
+          <p:cNvPicPr>
+            <a:picLocks noGrp="1" noChangeAspect="1"/>
+          </p:cNvPicPr>
           <p:nvPr>
             <p:ph idx="1"/>
           </p:nvPr>
-        </p:nvSpPr>
-        <p:spPr/>
-        <p:txBody>
-          <a:bodyPr/>
-          <a:lstStyle/>
-          <a:p>
-            <a:endParaRPr lang="en-US"/>
-          </a:p>
-        </p:txBody>
-      </p:sp>
+        </p:nvPicPr>
+        <p:blipFill>
+          <a:blip r:embed="rId2">
+            <a:extLst>
+              <a:ext uri="{28A0092B-C50C-407E-A947-70E740481C1C}">
+                <a14:useLocalDpi xmlns:a14="http://schemas.microsoft.com/office/drawing/2010/main" val="0"/>
+              </a:ext>
+            </a:extLst>
+          </a:blip>
+          <a:stretch>
+            <a:fillRect/>
+          </a:stretch>
+        </p:blipFill>
+        <p:spPr>
+          <a:xfrm>
+            <a:off x="6365630" y="515815"/>
+            <a:ext cx="5716130" cy="2047266"/>
+          </a:xfrm>
+        </p:spPr>
+      </p:pic>
     </p:spTree>
     <p:extLst>
       <p:ext uri="{BB962C8B-B14F-4D97-AF65-F5344CB8AC3E}">
@@ -14108,6 +14868,884 @@
     <p:extLst>
       <p:ext uri="{BB962C8B-B14F-4D97-AF65-F5344CB8AC3E}">
         <p14:creationId xmlns:p14="http://schemas.microsoft.com/office/powerpoint/2010/main" val="1297341357"/>
+      </p:ext>
+    </p:extLst>
+  </p:cSld>
+  <p:clrMapOvr>
+    <a:masterClrMapping/>
+  </p:clrMapOvr>
+</p:sld>
+</file>
+
+<file path=ppt/slides/slide30.xml><?xml version="1.0" encoding="utf-8"?>
+<p:sld xmlns:a="http://schemas.openxmlformats.org/drawingml/2006/main" xmlns:r="http://schemas.openxmlformats.org/officeDocument/2006/relationships" xmlns:p="http://schemas.openxmlformats.org/presentationml/2006/main">
+  <p:cSld>
+    <p:spTree>
+      <p:nvGrpSpPr>
+        <p:cNvPr id="1" name=""/>
+        <p:cNvGrpSpPr/>
+        <p:nvPr/>
+      </p:nvGrpSpPr>
+      <p:grpSpPr>
+        <a:xfrm>
+          <a:off x="0" y="0"/>
+          <a:ext cx="0" cy="0"/>
+          <a:chOff x="0" y="0"/>
+          <a:chExt cx="0" cy="0"/>
+        </a:xfrm>
+      </p:grpSpPr>
+      <p:sp>
+        <p:nvSpPr>
+          <p:cNvPr id="8" name="Content Placeholder 2">
+            <a:extLst>
+              <a:ext uri="{FF2B5EF4-FFF2-40B4-BE49-F238E27FC236}">
+                <a16:creationId xmlns:a16="http://schemas.microsoft.com/office/drawing/2014/main" id="{028A174E-C40C-EE9F-57EC-1C6C06A73727}"/>
+              </a:ext>
+            </a:extLst>
+          </p:cNvPr>
+          <p:cNvSpPr txBox="1">
+            <a:spLocks/>
+          </p:cNvSpPr>
+          <p:nvPr/>
+        </p:nvSpPr>
+        <p:spPr>
+          <a:xfrm>
+            <a:off x="838200" y="1825625"/>
+            <a:ext cx="8607669" cy="4516560"/>
+          </a:xfrm>
+          <a:prstGeom prst="rect">
+            <a:avLst/>
+          </a:prstGeom>
+        </p:spPr>
+        <p:txBody>
+          <a:bodyPr vert="horz" lIns="91440" tIns="45720" rIns="91440" bIns="45720" rtlCol="0">
+            <a:normAutofit fontScale="92500" lnSpcReduction="10000"/>
+          </a:bodyPr>
+          <a:lstStyle>
+            <a:lvl1pPr marL="228600" indent="-228600" algn="l" defTabSz="914400" rtl="0" eaLnBrk="1" latinLnBrk="0" hangingPunct="1">
+              <a:lnSpc>
+                <a:spcPct val="90000"/>
+              </a:lnSpc>
+              <a:spcBef>
+                <a:spcPts val="1000"/>
+              </a:spcBef>
+              <a:buFont typeface="Arial" panose="020B0604020202020204" pitchFamily="34" charset="0"/>
+              <a:buChar char="•"/>
+              <a:defRPr sz="2800" kern="1200">
+                <a:solidFill>
+                  <a:schemeClr val="tx1"/>
+                </a:solidFill>
+                <a:latin typeface="+mn-lt"/>
+                <a:ea typeface="+mn-ea"/>
+                <a:cs typeface="+mn-cs"/>
+              </a:defRPr>
+            </a:lvl1pPr>
+            <a:lvl2pPr marL="685800" indent="-228600" algn="l" defTabSz="914400" rtl="0" eaLnBrk="1" latinLnBrk="0" hangingPunct="1">
+              <a:lnSpc>
+                <a:spcPct val="90000"/>
+              </a:lnSpc>
+              <a:spcBef>
+                <a:spcPts val="500"/>
+              </a:spcBef>
+              <a:buFont typeface="Arial" panose="020B0604020202020204" pitchFamily="34" charset="0"/>
+              <a:buChar char="•"/>
+              <a:defRPr sz="2400" kern="1200">
+                <a:solidFill>
+                  <a:schemeClr val="tx1"/>
+                </a:solidFill>
+                <a:latin typeface="+mn-lt"/>
+                <a:ea typeface="+mn-ea"/>
+                <a:cs typeface="+mn-cs"/>
+              </a:defRPr>
+            </a:lvl2pPr>
+            <a:lvl3pPr marL="1143000" indent="-228600" algn="l" defTabSz="914400" rtl="0" eaLnBrk="1" latinLnBrk="0" hangingPunct="1">
+              <a:lnSpc>
+                <a:spcPct val="90000"/>
+              </a:lnSpc>
+              <a:spcBef>
+                <a:spcPts val="500"/>
+              </a:spcBef>
+              <a:buFont typeface="Arial" panose="020B0604020202020204" pitchFamily="34" charset="0"/>
+              <a:buChar char="•"/>
+              <a:defRPr sz="2000" kern="1200">
+                <a:solidFill>
+                  <a:schemeClr val="tx1"/>
+                </a:solidFill>
+                <a:latin typeface="+mn-lt"/>
+                <a:ea typeface="+mn-ea"/>
+                <a:cs typeface="+mn-cs"/>
+              </a:defRPr>
+            </a:lvl3pPr>
+            <a:lvl4pPr marL="1600200" indent="-228600" algn="l" defTabSz="914400" rtl="0" eaLnBrk="1" latinLnBrk="0" hangingPunct="1">
+              <a:lnSpc>
+                <a:spcPct val="90000"/>
+              </a:lnSpc>
+              <a:spcBef>
+                <a:spcPts val="500"/>
+              </a:spcBef>
+              <a:buFont typeface="Arial" panose="020B0604020202020204" pitchFamily="34" charset="0"/>
+              <a:buChar char="•"/>
+              <a:defRPr sz="1800" kern="1200">
+                <a:solidFill>
+                  <a:schemeClr val="tx1"/>
+                </a:solidFill>
+                <a:latin typeface="+mn-lt"/>
+                <a:ea typeface="+mn-ea"/>
+                <a:cs typeface="+mn-cs"/>
+              </a:defRPr>
+            </a:lvl4pPr>
+            <a:lvl5pPr marL="2057400" indent="-228600" algn="l" defTabSz="914400" rtl="0" eaLnBrk="1" latinLnBrk="0" hangingPunct="1">
+              <a:lnSpc>
+                <a:spcPct val="90000"/>
+              </a:lnSpc>
+              <a:spcBef>
+                <a:spcPts val="500"/>
+              </a:spcBef>
+              <a:buFont typeface="Arial" panose="020B0604020202020204" pitchFamily="34" charset="0"/>
+              <a:buChar char="•"/>
+              <a:defRPr sz="1800" kern="1200">
+                <a:solidFill>
+                  <a:schemeClr val="tx1"/>
+                </a:solidFill>
+                <a:latin typeface="+mn-lt"/>
+                <a:ea typeface="+mn-ea"/>
+                <a:cs typeface="+mn-cs"/>
+              </a:defRPr>
+            </a:lvl5pPr>
+            <a:lvl6pPr marL="2514600" indent="-228600" algn="l" defTabSz="914400" rtl="0" eaLnBrk="1" latinLnBrk="0" hangingPunct="1">
+              <a:lnSpc>
+                <a:spcPct val="90000"/>
+              </a:lnSpc>
+              <a:spcBef>
+                <a:spcPts val="500"/>
+              </a:spcBef>
+              <a:buFont typeface="Arial" panose="020B0604020202020204" pitchFamily="34" charset="0"/>
+              <a:buChar char="•"/>
+              <a:defRPr sz="1800" kern="1200">
+                <a:solidFill>
+                  <a:schemeClr val="tx1"/>
+                </a:solidFill>
+                <a:latin typeface="+mn-lt"/>
+                <a:ea typeface="+mn-ea"/>
+                <a:cs typeface="+mn-cs"/>
+              </a:defRPr>
+            </a:lvl6pPr>
+            <a:lvl7pPr marL="2971800" indent="-228600" algn="l" defTabSz="914400" rtl="0" eaLnBrk="1" latinLnBrk="0" hangingPunct="1">
+              <a:lnSpc>
+                <a:spcPct val="90000"/>
+              </a:lnSpc>
+              <a:spcBef>
+                <a:spcPts val="500"/>
+              </a:spcBef>
+              <a:buFont typeface="Arial" panose="020B0604020202020204" pitchFamily="34" charset="0"/>
+              <a:buChar char="•"/>
+              <a:defRPr sz="1800" kern="1200">
+                <a:solidFill>
+                  <a:schemeClr val="tx1"/>
+                </a:solidFill>
+                <a:latin typeface="+mn-lt"/>
+                <a:ea typeface="+mn-ea"/>
+                <a:cs typeface="+mn-cs"/>
+              </a:defRPr>
+            </a:lvl7pPr>
+            <a:lvl8pPr marL="3429000" indent="-228600" algn="l" defTabSz="914400" rtl="0" eaLnBrk="1" latinLnBrk="0" hangingPunct="1">
+              <a:lnSpc>
+                <a:spcPct val="90000"/>
+              </a:lnSpc>
+              <a:spcBef>
+                <a:spcPts val="500"/>
+              </a:spcBef>
+              <a:buFont typeface="Arial" panose="020B0604020202020204" pitchFamily="34" charset="0"/>
+              <a:buChar char="•"/>
+              <a:defRPr sz="1800" kern="1200">
+                <a:solidFill>
+                  <a:schemeClr val="tx1"/>
+                </a:solidFill>
+                <a:latin typeface="+mn-lt"/>
+                <a:ea typeface="+mn-ea"/>
+                <a:cs typeface="+mn-cs"/>
+              </a:defRPr>
+            </a:lvl8pPr>
+            <a:lvl9pPr marL="3886200" indent="-228600" algn="l" defTabSz="914400" rtl="0" eaLnBrk="1" latinLnBrk="0" hangingPunct="1">
+              <a:lnSpc>
+                <a:spcPct val="90000"/>
+              </a:lnSpc>
+              <a:spcBef>
+                <a:spcPts val="500"/>
+              </a:spcBef>
+              <a:buFont typeface="Arial" panose="020B0604020202020204" pitchFamily="34" charset="0"/>
+              <a:buChar char="•"/>
+              <a:defRPr sz="1800" kern="1200">
+                <a:solidFill>
+                  <a:schemeClr val="tx1"/>
+                </a:solidFill>
+                <a:latin typeface="+mn-lt"/>
+                <a:ea typeface="+mn-ea"/>
+                <a:cs typeface="+mn-cs"/>
+              </a:defRPr>
+            </a:lvl9pPr>
+          </a:lstStyle>
+          <a:p>
+            <a:r>
+              <a:rPr lang="en-US" dirty="0"/>
+              <a:t>Only an </a:t>
+            </a:r>
+            <a:r>
+              <a:rPr lang="en-US" sz="2000" dirty="0" err="1">
+                <a:latin typeface="Consolas" panose="020B0609020204030204" pitchFamily="49" charset="0"/>
+                <a:cs typeface="Courier New" panose="02070309020205020404" pitchFamily="49" charset="0"/>
+              </a:rPr>
+              <a:t>IncomingMessageFactory</a:t>
+            </a:r>
+            <a:r>
+              <a:rPr lang="en-US" dirty="0"/>
+              <a:t> can read messages:</a:t>
+            </a:r>
+          </a:p>
+          <a:p>
+            <a:endParaRPr lang="en-US" dirty="0"/>
+          </a:p>
+          <a:p>
+            <a:endParaRPr lang="en-US" dirty="0"/>
+          </a:p>
+          <a:p>
+            <a:endParaRPr lang="en-US" dirty="0"/>
+          </a:p>
+          <a:p>
+            <a:endParaRPr lang="en-US" dirty="0"/>
+          </a:p>
+          <a:p>
+            <a:r>
+              <a:rPr lang="en-US" dirty="0"/>
+              <a:t>From any asynchronous function that can fill a buffer with an exact count of bytes.</a:t>
+            </a:r>
+          </a:p>
+          <a:p>
+            <a:r>
+              <a:rPr lang="en-US" dirty="0"/>
+              <a:t>The developer never interacts directly with an </a:t>
+            </a:r>
+            <a:r>
+              <a:rPr lang="en-US" dirty="0" err="1"/>
+              <a:t>IncomingMessageFactory</a:t>
+            </a:r>
+            <a:r>
+              <a:rPr lang="en-US" dirty="0"/>
+              <a:t>.</a:t>
+            </a:r>
+          </a:p>
+          <a:p>
+            <a:r>
+              <a:rPr lang="en-US" dirty="0"/>
+              <a:t>Concrete Transport implementations provide the </a:t>
+            </a:r>
+            <a:r>
+              <a:rPr lang="en-US" sz="2200" dirty="0" err="1">
+                <a:solidFill>
+                  <a:srgbClr val="000000"/>
+                </a:solidFill>
+                <a:latin typeface="Consolas" panose="020B0609020204030204" pitchFamily="49" charset="0"/>
+              </a:rPr>
+              <a:t>exactReader</a:t>
+            </a:r>
+            <a:r>
+              <a:rPr lang="en-US" dirty="0"/>
+              <a:t> function.</a:t>
+            </a:r>
+          </a:p>
+        </p:txBody>
+      </p:sp>
+      <p:sp>
+        <p:nvSpPr>
+          <p:cNvPr id="2" name="Title 1">
+            <a:extLst>
+              <a:ext uri="{FF2B5EF4-FFF2-40B4-BE49-F238E27FC236}">
+                <a16:creationId xmlns:a16="http://schemas.microsoft.com/office/drawing/2014/main" id="{70FD56D0-2F2C-42C4-3EEA-E4CCE70C904F}"/>
+              </a:ext>
+            </a:extLst>
+          </p:cNvPr>
+          <p:cNvSpPr>
+            <a:spLocks noGrp="1"/>
+          </p:cNvSpPr>
+          <p:nvPr>
+            <p:ph type="title"/>
+          </p:nvPr>
+        </p:nvSpPr>
+        <p:spPr/>
+        <p:txBody>
+          <a:bodyPr/>
+          <a:lstStyle/>
+          <a:p>
+            <a:r>
+              <a:rPr lang="en-US" dirty="0"/>
+              <a:t>Reading incoming messages</a:t>
+            </a:r>
+          </a:p>
+        </p:txBody>
+      </p:sp>
+      <p:pic>
+        <p:nvPicPr>
+          <p:cNvPr id="5" name="Content Placeholder 4" descr="Graphical user interface, application&#10;&#10;Description automatically generated">
+            <a:extLst>
+              <a:ext uri="{FF2B5EF4-FFF2-40B4-BE49-F238E27FC236}">
+                <a16:creationId xmlns:a16="http://schemas.microsoft.com/office/drawing/2014/main" id="{CD2D2A67-F26C-B52C-0846-6487A7DF0B10}"/>
+              </a:ext>
+            </a:extLst>
+          </p:cNvPr>
+          <p:cNvPicPr>
+            <a:picLocks noGrp="1" noChangeAspect="1"/>
+          </p:cNvPicPr>
+          <p:nvPr>
+            <p:ph idx="1"/>
+          </p:nvPr>
+        </p:nvPicPr>
+        <p:blipFill>
+          <a:blip r:embed="rId3">
+            <a:extLst>
+              <a:ext uri="{28A0092B-C50C-407E-A947-70E740481C1C}">
+                <a14:useLocalDpi xmlns:a14="http://schemas.microsoft.com/office/drawing/2010/main" val="0"/>
+              </a:ext>
+            </a:extLst>
+          </a:blip>
+          <a:stretch>
+            <a:fillRect/>
+          </a:stretch>
+        </p:blipFill>
+        <p:spPr>
+          <a:xfrm>
+            <a:off x="9601200" y="146641"/>
+            <a:ext cx="2454795" cy="6564718"/>
+          </a:xfrm>
+        </p:spPr>
+      </p:pic>
+      <p:sp>
+        <p:nvSpPr>
+          <p:cNvPr id="7" name="TextBox 6">
+            <a:extLst>
+              <a:ext uri="{FF2B5EF4-FFF2-40B4-BE49-F238E27FC236}">
+                <a16:creationId xmlns:a16="http://schemas.microsoft.com/office/drawing/2014/main" id="{ADFAAF37-5FFB-5FCF-739F-A7F6192E67D4}"/>
+              </a:ext>
+            </a:extLst>
+          </p:cNvPr>
+          <p:cNvSpPr txBox="1"/>
+          <p:nvPr/>
+        </p:nvSpPr>
+        <p:spPr>
+          <a:xfrm>
+            <a:off x="993531" y="2329579"/>
+            <a:ext cx="8452338" cy="1754326"/>
+          </a:xfrm>
+          <a:prstGeom prst="rect">
+            <a:avLst/>
+          </a:prstGeom>
+          <a:noFill/>
+        </p:spPr>
+        <p:txBody>
+          <a:bodyPr wrap="square">
+            <a:spAutoFit/>
+          </a:bodyPr>
+          <a:lstStyle/>
+          <a:p>
+            <a:r>
+              <a:rPr lang="en-US" sz="1800" dirty="0">
+                <a:solidFill>
+                  <a:srgbClr val="0000FF"/>
+                </a:solidFill>
+                <a:latin typeface="Consolas" panose="020B0609020204030204" pitchFamily="49" charset="0"/>
+              </a:rPr>
+              <a:t>public</a:t>
+            </a:r>
+            <a:r>
+              <a:rPr lang="en-US" sz="1800" dirty="0">
+                <a:solidFill>
+                  <a:srgbClr val="000000"/>
+                </a:solidFill>
+                <a:latin typeface="Consolas" panose="020B0609020204030204" pitchFamily="49" charset="0"/>
+              </a:rPr>
+              <a:t> Task&lt;</a:t>
+            </a:r>
+            <a:r>
+              <a:rPr lang="en-US" sz="1800" dirty="0" err="1">
+                <a:solidFill>
+                  <a:srgbClr val="000000"/>
+                </a:solidFill>
+                <a:latin typeface="Consolas" panose="020B0609020204030204" pitchFamily="49" charset="0"/>
+              </a:rPr>
+              <a:t>TransportMessage</a:t>
+            </a:r>
+            <a:r>
+              <a:rPr lang="en-US" sz="1800" dirty="0">
+                <a:solidFill>
+                  <a:srgbClr val="000000"/>
+                </a:solidFill>
+                <a:latin typeface="Consolas" panose="020B0609020204030204" pitchFamily="49" charset="0"/>
+              </a:rPr>
+              <a:t>&gt; </a:t>
+            </a:r>
+            <a:r>
+              <a:rPr lang="en-US" sz="1800" dirty="0" err="1">
+                <a:solidFill>
+                  <a:srgbClr val="000000"/>
+                </a:solidFill>
+                <a:latin typeface="Consolas" panose="020B0609020204030204" pitchFamily="49" charset="0"/>
+              </a:rPr>
+              <a:t>ReadAsync</a:t>
+            </a:r>
+            <a:endParaRPr lang="en-US" sz="1800" dirty="0">
+              <a:solidFill>
+                <a:srgbClr val="000000"/>
+              </a:solidFill>
+              <a:latin typeface="Consolas" panose="020B0609020204030204" pitchFamily="49" charset="0"/>
+            </a:endParaRPr>
+          </a:p>
+          <a:p>
+            <a:r>
+              <a:rPr lang="en-US" sz="1800" dirty="0">
+                <a:solidFill>
+                  <a:srgbClr val="000000"/>
+                </a:solidFill>
+                <a:latin typeface="Consolas" panose="020B0609020204030204" pitchFamily="49" charset="0"/>
+              </a:rPr>
+              <a:t>( </a:t>
+            </a:r>
+          </a:p>
+          <a:p>
+            <a:r>
+              <a:rPr lang="en-US" dirty="0">
+                <a:solidFill>
+                  <a:srgbClr val="000000"/>
+                </a:solidFill>
+                <a:latin typeface="Consolas" panose="020B0609020204030204" pitchFamily="49" charset="0"/>
+              </a:rPr>
+              <a:t>    </a:t>
+            </a:r>
+            <a:r>
+              <a:rPr lang="en-US" sz="1800" dirty="0" err="1">
+                <a:solidFill>
+                  <a:srgbClr val="000000"/>
+                </a:solidFill>
+                <a:latin typeface="Consolas" panose="020B0609020204030204" pitchFamily="49" charset="0"/>
+              </a:rPr>
+              <a:t>Func</a:t>
+            </a:r>
+            <a:r>
+              <a:rPr lang="en-US" sz="1800" dirty="0">
+                <a:solidFill>
+                  <a:srgbClr val="000000"/>
+                </a:solidFill>
+                <a:latin typeface="Consolas" panose="020B0609020204030204" pitchFamily="49" charset="0"/>
+              </a:rPr>
+              <a:t>&lt;Memory&lt;</a:t>
+            </a:r>
+            <a:r>
+              <a:rPr lang="en-US" sz="1800" dirty="0">
+                <a:solidFill>
+                  <a:srgbClr val="0000FF"/>
+                </a:solidFill>
+                <a:latin typeface="Consolas" panose="020B0609020204030204" pitchFamily="49" charset="0"/>
+              </a:rPr>
+              <a:t>byte</a:t>
+            </a:r>
+            <a:r>
+              <a:rPr lang="en-US" sz="1800" dirty="0">
+                <a:solidFill>
+                  <a:srgbClr val="000000"/>
+                </a:solidFill>
+                <a:latin typeface="Consolas" panose="020B0609020204030204" pitchFamily="49" charset="0"/>
+              </a:rPr>
+              <a:t>&gt;, </a:t>
+            </a:r>
+            <a:r>
+              <a:rPr lang="en-US" sz="1800" dirty="0" err="1">
+                <a:solidFill>
+                  <a:srgbClr val="000000"/>
+                </a:solidFill>
+                <a:latin typeface="Consolas" panose="020B0609020204030204" pitchFamily="49" charset="0"/>
+              </a:rPr>
+              <a:t>CancellationToken</a:t>
+            </a:r>
+            <a:r>
+              <a:rPr lang="en-US" sz="1800" dirty="0">
+                <a:solidFill>
+                  <a:srgbClr val="000000"/>
+                </a:solidFill>
+                <a:latin typeface="Consolas" panose="020B0609020204030204" pitchFamily="49" charset="0"/>
+              </a:rPr>
+              <a:t>, </a:t>
+            </a:r>
+            <a:r>
+              <a:rPr lang="en-US" sz="1800" dirty="0" err="1">
+                <a:solidFill>
+                  <a:srgbClr val="000000"/>
+                </a:solidFill>
+                <a:latin typeface="Consolas" panose="020B0609020204030204" pitchFamily="49" charset="0"/>
+              </a:rPr>
+              <a:t>ValueTask</a:t>
+            </a:r>
+            <a:r>
+              <a:rPr lang="en-US" sz="1800" dirty="0">
+                <a:solidFill>
+                  <a:srgbClr val="000000"/>
+                </a:solidFill>
+                <a:latin typeface="Consolas" panose="020B0609020204030204" pitchFamily="49" charset="0"/>
+              </a:rPr>
+              <a:t>&gt; </a:t>
+            </a:r>
+            <a:r>
+              <a:rPr lang="en-US" sz="1800" dirty="0" err="1">
+                <a:solidFill>
+                  <a:srgbClr val="000000"/>
+                </a:solidFill>
+                <a:latin typeface="Consolas" panose="020B0609020204030204" pitchFamily="49" charset="0"/>
+              </a:rPr>
+              <a:t>exactReader</a:t>
+            </a:r>
+            <a:r>
+              <a:rPr lang="en-US" sz="1800" dirty="0">
+                <a:solidFill>
+                  <a:srgbClr val="000000"/>
+                </a:solidFill>
+                <a:latin typeface="Consolas" panose="020B0609020204030204" pitchFamily="49" charset="0"/>
+              </a:rPr>
+              <a:t>,</a:t>
+            </a:r>
+          </a:p>
+          <a:p>
+            <a:r>
+              <a:rPr lang="en-US" sz="1800" dirty="0">
+                <a:solidFill>
+                  <a:srgbClr val="0000FF"/>
+                </a:solidFill>
+                <a:latin typeface="Consolas" panose="020B0609020204030204" pitchFamily="49" charset="0"/>
+              </a:rPr>
+              <a:t>    int</a:t>
+            </a:r>
+            <a:r>
+              <a:rPr lang="en-US" sz="1800" dirty="0">
+                <a:solidFill>
+                  <a:srgbClr val="000000"/>
+                </a:solidFill>
+                <a:latin typeface="Consolas" panose="020B0609020204030204" pitchFamily="49" charset="0"/>
+              </a:rPr>
+              <a:t> </a:t>
+            </a:r>
+            <a:r>
+              <a:rPr lang="en-US" sz="1800" dirty="0" err="1">
+                <a:solidFill>
+                  <a:srgbClr val="000000"/>
+                </a:solidFill>
+                <a:latin typeface="Consolas" panose="020B0609020204030204" pitchFamily="49" charset="0"/>
+              </a:rPr>
+              <a:t>maxMessageLength</a:t>
+            </a:r>
+            <a:r>
+              <a:rPr lang="en-US" sz="1800" dirty="0">
+                <a:solidFill>
+                  <a:srgbClr val="000000"/>
+                </a:solidFill>
+                <a:latin typeface="Consolas" panose="020B0609020204030204" pitchFamily="49" charset="0"/>
+              </a:rPr>
+              <a:t> = </a:t>
+            </a:r>
+            <a:r>
+              <a:rPr lang="en-US" sz="1800" dirty="0" err="1">
+                <a:solidFill>
+                  <a:srgbClr val="0000FF"/>
+                </a:solidFill>
+                <a:latin typeface="Consolas" panose="020B0609020204030204" pitchFamily="49" charset="0"/>
+              </a:rPr>
+              <a:t>int</a:t>
+            </a:r>
+            <a:r>
+              <a:rPr lang="en-US" sz="1800" dirty="0" err="1">
+                <a:solidFill>
+                  <a:srgbClr val="000000"/>
+                </a:solidFill>
+                <a:latin typeface="Consolas" panose="020B0609020204030204" pitchFamily="49" charset="0"/>
+              </a:rPr>
+              <a:t>.MaxValue</a:t>
+            </a:r>
+            <a:r>
+              <a:rPr lang="en-US" sz="1800" dirty="0">
+                <a:solidFill>
+                  <a:srgbClr val="000000"/>
+                </a:solidFill>
+                <a:latin typeface="Consolas" panose="020B0609020204030204" pitchFamily="49" charset="0"/>
+              </a:rPr>
+              <a:t>,</a:t>
+            </a:r>
+          </a:p>
+          <a:p>
+            <a:r>
+              <a:rPr lang="en-US" sz="1800" dirty="0">
+                <a:solidFill>
+                  <a:srgbClr val="000000"/>
+                </a:solidFill>
+                <a:latin typeface="Consolas" panose="020B0609020204030204" pitchFamily="49" charset="0"/>
+              </a:rPr>
+              <a:t>    </a:t>
+            </a:r>
+            <a:r>
+              <a:rPr lang="en-US" sz="1800" dirty="0" err="1">
+                <a:solidFill>
+                  <a:srgbClr val="000000"/>
+                </a:solidFill>
+                <a:latin typeface="Consolas" panose="020B0609020204030204" pitchFamily="49" charset="0"/>
+              </a:rPr>
+              <a:t>CancellationToken</a:t>
+            </a:r>
+            <a:r>
+              <a:rPr lang="en-US" sz="1800" dirty="0">
+                <a:solidFill>
+                  <a:srgbClr val="000000"/>
+                </a:solidFill>
+                <a:latin typeface="Consolas" panose="020B0609020204030204" pitchFamily="49" charset="0"/>
+              </a:rPr>
+              <a:t> cancellation = </a:t>
+            </a:r>
+            <a:r>
+              <a:rPr lang="en-US" sz="1800" dirty="0">
+                <a:solidFill>
+                  <a:srgbClr val="0000FF"/>
+                </a:solidFill>
+                <a:latin typeface="Consolas" panose="020B0609020204030204" pitchFamily="49" charset="0"/>
+              </a:rPr>
+              <a:t>default</a:t>
+            </a:r>
+            <a:r>
+              <a:rPr lang="en-US" sz="1800" dirty="0">
+                <a:solidFill>
+                  <a:srgbClr val="000000"/>
+                </a:solidFill>
+                <a:latin typeface="Consolas" panose="020B0609020204030204" pitchFamily="49" charset="0"/>
+              </a:rPr>
+              <a:t> </a:t>
+            </a:r>
+          </a:p>
+          <a:p>
+            <a:r>
+              <a:rPr lang="en-US" sz="1800" dirty="0">
+                <a:solidFill>
+                  <a:srgbClr val="000000"/>
+                </a:solidFill>
+                <a:latin typeface="Consolas" panose="020B0609020204030204" pitchFamily="49" charset="0"/>
+              </a:rPr>
+              <a:t>)</a:t>
+            </a:r>
+            <a:endParaRPr lang="en-US" dirty="0"/>
+          </a:p>
+        </p:txBody>
+      </p:sp>
+    </p:spTree>
+    <p:extLst>
+      <p:ext uri="{BB962C8B-B14F-4D97-AF65-F5344CB8AC3E}">
+        <p14:creationId xmlns:p14="http://schemas.microsoft.com/office/powerpoint/2010/main" val="1074243622"/>
+      </p:ext>
+    </p:extLst>
+  </p:cSld>
+  <p:clrMapOvr>
+    <a:masterClrMapping/>
+  </p:clrMapOvr>
+</p:sld>
+</file>
+
+<file path=ppt/slides/slide31.xml><?xml version="1.0" encoding="utf-8"?>
+<p:sld xmlns:a="http://schemas.openxmlformats.org/drawingml/2006/main" xmlns:r="http://schemas.openxmlformats.org/officeDocument/2006/relationships" xmlns:p="http://schemas.openxmlformats.org/presentationml/2006/main">
+  <p:cSld>
+    <p:bg>
+      <p:bgPr>
+        <a:solidFill>
+          <a:schemeClr val="bg1"/>
+        </a:solidFill>
+        <a:effectLst/>
+      </p:bgPr>
+    </p:bg>
+    <p:spTree>
+      <p:nvGrpSpPr>
+        <p:cNvPr id="1" name=""/>
+        <p:cNvGrpSpPr/>
+        <p:nvPr/>
+      </p:nvGrpSpPr>
+      <p:grpSpPr>
+        <a:xfrm>
+          <a:off x="0" y="0"/>
+          <a:ext cx="0" cy="0"/>
+          <a:chOff x="0" y="0"/>
+          <a:chExt cx="0" cy="0"/>
+        </a:xfrm>
+      </p:grpSpPr>
+      <p:sp>
+        <p:nvSpPr>
+          <p:cNvPr id="2" name="Title 1">
+            <a:extLst>
+              <a:ext uri="{FF2B5EF4-FFF2-40B4-BE49-F238E27FC236}">
+                <a16:creationId xmlns:a16="http://schemas.microsoft.com/office/drawing/2014/main" id="{6D8CEF7E-C184-9ED5-678F-E522EE7861ED}"/>
+              </a:ext>
+            </a:extLst>
+          </p:cNvPr>
+          <p:cNvSpPr>
+            <a:spLocks noGrp="1"/>
+          </p:cNvSpPr>
+          <p:nvPr>
+            <p:ph type="title"/>
+          </p:nvPr>
+        </p:nvSpPr>
+        <p:spPr/>
+        <p:txBody>
+          <a:bodyPr/>
+          <a:lstStyle/>
+          <a:p>
+            <a:r>
+              <a:rPr lang="en-US" dirty="0"/>
+              <a:t>Implementing</a:t>
+            </a:r>
+            <a:br>
+              <a:rPr lang="en-US" dirty="0"/>
+            </a:br>
+            <a:r>
+              <a:rPr lang="en-US" dirty="0"/>
+              <a:t>Transports</a:t>
+            </a:r>
+          </a:p>
+        </p:txBody>
+      </p:sp>
+      <p:sp>
+        <p:nvSpPr>
+          <p:cNvPr id="9" name="Content Placeholder 8">
+            <a:extLst>
+              <a:ext uri="{FF2B5EF4-FFF2-40B4-BE49-F238E27FC236}">
+                <a16:creationId xmlns:a16="http://schemas.microsoft.com/office/drawing/2014/main" id="{9F56818D-148F-7DD5-0B72-C665916F8DDC}"/>
+              </a:ext>
+            </a:extLst>
+          </p:cNvPr>
+          <p:cNvSpPr>
+            <a:spLocks noGrp="1"/>
+          </p:cNvSpPr>
+          <p:nvPr>
+            <p:ph idx="1"/>
+          </p:nvPr>
+        </p:nvSpPr>
+        <p:spPr>
+          <a:xfrm>
+            <a:off x="685800" y="1825624"/>
+            <a:ext cx="4446248" cy="4843531"/>
+          </a:xfrm>
+        </p:spPr>
+        <p:txBody>
+          <a:bodyPr>
+            <a:normAutofit/>
+          </a:bodyPr>
+          <a:lstStyle/>
+          <a:p>
+            <a:r>
+              <a:rPr lang="en-US" dirty="0"/>
+              <a:t>3 classes to specialize.</a:t>
+            </a:r>
+          </a:p>
+          <a:p>
+            <a:r>
+              <a:rPr lang="en-US" dirty="0"/>
+              <a:t>Straight wrappers, no error management required.</a:t>
+            </a:r>
+          </a:p>
+          <a:p>
+            <a:r>
+              <a:rPr lang="en-US" dirty="0"/>
+              <a:t>Package First</a:t>
+            </a:r>
+          </a:p>
+          <a:p>
+            <a:endParaRPr lang="en-US" dirty="0"/>
+          </a:p>
+          <a:p>
+            <a:r>
+              <a:rPr lang="en-US" dirty="0"/>
+              <a:t>Example of </a:t>
+            </a:r>
+            <a:r>
+              <a:rPr lang="en-US" dirty="0" err="1"/>
+              <a:t>TCPSocket</a:t>
+            </a:r>
+            <a:endParaRPr lang="en-US" dirty="0"/>
+          </a:p>
+          <a:p>
+            <a:pPr lvl="1"/>
+            <a:r>
+              <a:rPr lang="en-US" dirty="0" err="1"/>
+              <a:t>AddressProtocolName</a:t>
+            </a:r>
+            <a:r>
+              <a:rPr lang="en-US" dirty="0"/>
+              <a:t>: “</a:t>
+            </a:r>
+            <a:r>
+              <a:rPr lang="en-US" dirty="0" err="1"/>
+              <a:t>tcp</a:t>
+            </a:r>
+            <a:r>
+              <a:rPr lang="en-US" dirty="0"/>
+              <a:t>”</a:t>
+            </a:r>
+          </a:p>
+          <a:p>
+            <a:endParaRPr lang="en-US" dirty="0"/>
+          </a:p>
+          <a:p>
+            <a:r>
+              <a:rPr lang="en-US" dirty="0"/>
+              <a:t>Developers don’t interact with Transports layer.</a:t>
+            </a:r>
+          </a:p>
+          <a:p>
+            <a:pPr lvl="1"/>
+            <a:endParaRPr lang="en-US" dirty="0"/>
+          </a:p>
+          <a:p>
+            <a:pPr lvl="1"/>
+            <a:endParaRPr lang="en-US" dirty="0"/>
+          </a:p>
+        </p:txBody>
+      </p:sp>
+      <p:pic>
+        <p:nvPicPr>
+          <p:cNvPr id="13" name="Picture 12" descr="Diagram&#10;&#10;Description automatically generated">
+            <a:extLst>
+              <a:ext uri="{FF2B5EF4-FFF2-40B4-BE49-F238E27FC236}">
+                <a16:creationId xmlns:a16="http://schemas.microsoft.com/office/drawing/2014/main" id="{5B7E97A0-34C4-CC0C-12FC-6AFA8966FE23}"/>
+              </a:ext>
+            </a:extLst>
+          </p:cNvPr>
+          <p:cNvPicPr>
+            <a:picLocks noChangeAspect="1"/>
+          </p:cNvPicPr>
+          <p:nvPr/>
+        </p:nvPicPr>
+        <p:blipFill>
+          <a:blip r:embed="rId3">
+            <a:extLst>
+              <a:ext uri="{28A0092B-C50C-407E-A947-70E740481C1C}">
+                <a14:useLocalDpi xmlns:a14="http://schemas.microsoft.com/office/drawing/2010/main" val="0"/>
+              </a:ext>
+            </a:extLst>
+          </a:blip>
+          <a:stretch>
+            <a:fillRect/>
+          </a:stretch>
+        </p:blipFill>
+        <p:spPr>
+          <a:xfrm>
+            <a:off x="5204165" y="90854"/>
+            <a:ext cx="6812870" cy="6767146"/>
+          </a:xfrm>
+          <a:prstGeom prst="rect">
+            <a:avLst/>
+          </a:prstGeom>
+        </p:spPr>
+      </p:pic>
+    </p:spTree>
+    <p:extLst>
+      <p:ext uri="{BB962C8B-B14F-4D97-AF65-F5344CB8AC3E}">
+        <p14:creationId xmlns:p14="http://schemas.microsoft.com/office/powerpoint/2010/main" val="2227821959"/>
       </p:ext>
     </p:extLst>
   </p:cSld>

</xml_diff>

<commit_message>
Doc up to BlobChannel.
</commit_message>
<xml_diff>
--- a/Doc/CK-AppIdentity.pptx
+++ b/Doc/CK-AppIdentity.pptx
@@ -16244,34 +16244,110 @@
           <a:p>
             <a:r>
               <a:rPr lang="en-US" dirty="0"/>
+              <a:t>The </a:t>
+            </a:r>
+            <a:r>
+              <a:rPr lang="en-US" dirty="0" err="1"/>
+              <a:t>BlobChannel</a:t>
+            </a:r>
+            <a:r>
+              <a:rPr lang="en-US" dirty="0"/>
+              <a:t> is more a sample than a useful channel.</a:t>
+            </a:r>
+            <a:br>
+              <a:rPr lang="en-US" dirty="0"/>
+            </a:br>
+            <a:endParaRPr lang="en-US" dirty="0"/>
+          </a:p>
+          <a:p>
+            <a:r>
+              <a:rPr lang="en-US" dirty="0"/>
               <a:t>Using a Channel</a:t>
             </a:r>
+          </a:p>
+          <a:p>
+            <a:pPr lvl="1"/>
+            <a:r>
+              <a:rPr lang="en-US" dirty="0" err="1">
+                <a:hlinkClick r:id="rId2"/>
+              </a:rPr>
+              <a:t>CK.AppIdentity.BlobChannel.Tests</a:t>
+            </a:r>
+            <a:r>
+              <a:rPr lang="en-US" dirty="0">
+                <a:hlinkClick r:id="rId2"/>
+              </a:rPr>
+              <a:t>/</a:t>
+            </a:r>
+            <a:r>
+              <a:rPr lang="en-US" dirty="0" err="1">
+                <a:hlinkClick r:id="rId2"/>
+              </a:rPr>
+              <a:t>BasicExchangeTests</a:t>
+            </a:r>
+            <a:r>
+              <a:rPr lang="en-US" dirty="0"/>
+              <a:t> </a:t>
+            </a:r>
+          </a:p>
+          <a:p>
+            <a:endParaRPr lang="en-US" dirty="0"/>
+          </a:p>
+          <a:p>
+            <a:r>
+              <a:rPr lang="en-US" dirty="0"/>
+              <a:t>The </a:t>
+            </a:r>
+            <a:r>
+              <a:rPr lang="en-US" dirty="0" err="1"/>
+              <a:t>CK.AppIdentity.BlobChannel</a:t>
+            </a:r>
+            <a:r>
+              <a:rPr lang="en-US" dirty="0"/>
+              <a:t> implementation</a:t>
+            </a:r>
+          </a:p>
+          <a:p>
+            <a:pPr lvl="1"/>
+            <a:r>
+              <a:rPr lang="en-US" dirty="0" err="1">
+                <a:hlinkClick r:id="rId3"/>
+              </a:rPr>
+              <a:t>BlobChannelFeatureDriver.cs</a:t>
+            </a:r>
+            <a:endParaRPr lang="en-US" dirty="0"/>
+          </a:p>
+          <a:p>
+            <a:pPr lvl="1"/>
+            <a:r>
+              <a:rPr lang="en-US" dirty="0" err="1">
+                <a:hlinkClick r:id="rId4"/>
+              </a:rPr>
+              <a:t>BlobChannelFeature.cs</a:t>
+            </a:r>
+            <a:endParaRPr lang="en-US" dirty="0"/>
+          </a:p>
+          <a:p>
+            <a:pPr lvl="1"/>
+            <a:r>
+              <a:rPr lang="en-US" dirty="0" err="1">
+                <a:hlinkClick r:id="rId5"/>
+              </a:rPr>
+              <a:t>BlobChannelFeature.Protocol.cs</a:t>
+            </a:r>
+            <a:endParaRPr lang="en-US" dirty="0"/>
           </a:p>
           <a:p>
             <a:pPr lvl="1"/>
             <a:endParaRPr lang="en-US" dirty="0"/>
           </a:p>
           <a:p>
-            <a:r>
-              <a:rPr lang="en-US" dirty="0"/>
-              <a:t>The </a:t>
-            </a:r>
-            <a:r>
-              <a:rPr lang="en-US" dirty="0" err="1"/>
-              <a:t>BlobChannel</a:t>
-            </a:r>
-            <a:r>
-              <a:rPr lang="en-US" dirty="0"/>
-              <a:t> implementation</a:t>
-            </a:r>
-          </a:p>
-          <a:p>
             <a:pPr lvl="1"/>
             <a:endParaRPr lang="en-US" dirty="0"/>
           </a:p>
           <a:p>
             <a:pPr lvl="1"/>
-            <a:endParaRPr lang="en-US"/>
+            <a:endParaRPr lang="en-US" dirty="0"/>
           </a:p>
           <a:p>
             <a:pPr lvl="1"/>
@@ -16298,14 +16374,14 @@
           <p:nvPr/>
         </p:nvPicPr>
         <p:blipFill>
-          <a:blip r:embed="rId2"/>
+          <a:blip r:embed="rId6"/>
           <a:stretch>
             <a:fillRect/>
           </a:stretch>
         </p:blipFill>
         <p:spPr>
           <a:xfrm>
-            <a:off x="8472018" y="2943570"/>
+            <a:off x="8442522" y="4391215"/>
             <a:ext cx="3276987" cy="1324262"/>
           </a:xfrm>
           <a:prstGeom prst="rect">

</xml_diff>

<commit_message>
Fix and Roamap in the pptx.
</commit_message>
<xml_diff>
--- a/Doc/CK-AppIdentity.pptx
+++ b/Doc/CK-AppIdentity.pptx
@@ -5,7 +5,7 @@
     <p:sldMasterId id="2147483648" r:id="rId1"/>
   </p:sldMasterIdLst>
   <p:notesMasterIdLst>
-    <p:notesMasterId r:id="rId35"/>
+    <p:notesMasterId r:id="rId38"/>
   </p:notesMasterIdLst>
   <p:sldIdLst>
     <p:sldId id="256" r:id="rId2"/>
@@ -41,6 +41,9 @@
     <p:sldId id="288" r:id="rId32"/>
     <p:sldId id="289" r:id="rId33"/>
     <p:sldId id="290" r:id="rId34"/>
+    <p:sldId id="291" r:id="rId35"/>
+    <p:sldId id="292" r:id="rId36"/>
+    <p:sldId id="293" r:id="rId37"/>
   </p:sldIdLst>
   <p:sldSz cx="12192000" cy="6858000"/>
   <p:notesSz cx="6858000" cy="9144000"/>
@@ -258,7 +261,7 @@
           <a:p>
             <a:fld id="{7EBA75D8-A9A5-4FAF-B563-7A079B630A7E}" type="datetimeFigureOut">
               <a:rPr lang="en-US" smtClean="0"/>
-              <a:t>4/22/2023</a:t>
+              <a:t>4/24/2023</a:t>
             </a:fld>
             <a:endParaRPr lang="en-US"/>
           </a:p>
@@ -2044,7 +2047,7 @@
           <a:p>
             <a:fld id="{7D1F2140-8D48-49AC-AD8D-683E6FF4DC34}" type="datetimeFigureOut">
               <a:rPr lang="en-US" smtClean="0"/>
-              <a:t>4/22/2023</a:t>
+              <a:t>4/24/2023</a:t>
             </a:fld>
             <a:endParaRPr lang="en-US"/>
           </a:p>
@@ -2242,7 +2245,7 @@
           <a:p>
             <a:fld id="{7D1F2140-8D48-49AC-AD8D-683E6FF4DC34}" type="datetimeFigureOut">
               <a:rPr lang="en-US" smtClean="0"/>
-              <a:t>4/22/2023</a:t>
+              <a:t>4/24/2023</a:t>
             </a:fld>
             <a:endParaRPr lang="en-US"/>
           </a:p>
@@ -2450,7 +2453,7 @@
           <a:p>
             <a:fld id="{7D1F2140-8D48-49AC-AD8D-683E6FF4DC34}" type="datetimeFigureOut">
               <a:rPr lang="en-US" smtClean="0"/>
-              <a:t>4/22/2023</a:t>
+              <a:t>4/24/2023</a:t>
             </a:fld>
             <a:endParaRPr lang="en-US"/>
           </a:p>
@@ -2648,7 +2651,7 @@
           <a:p>
             <a:fld id="{7D1F2140-8D48-49AC-AD8D-683E6FF4DC34}" type="datetimeFigureOut">
               <a:rPr lang="en-US" smtClean="0"/>
-              <a:t>4/22/2023</a:t>
+              <a:t>4/24/2023</a:t>
             </a:fld>
             <a:endParaRPr lang="en-US"/>
           </a:p>
@@ -2923,7 +2926,7 @@
           <a:p>
             <a:fld id="{7D1F2140-8D48-49AC-AD8D-683E6FF4DC34}" type="datetimeFigureOut">
               <a:rPr lang="en-US" smtClean="0"/>
-              <a:t>4/22/2023</a:t>
+              <a:t>4/24/2023</a:t>
             </a:fld>
             <a:endParaRPr lang="en-US"/>
           </a:p>
@@ -3188,7 +3191,7 @@
           <a:p>
             <a:fld id="{7D1F2140-8D48-49AC-AD8D-683E6FF4DC34}" type="datetimeFigureOut">
               <a:rPr lang="en-US" smtClean="0"/>
-              <a:t>4/22/2023</a:t>
+              <a:t>4/24/2023</a:t>
             </a:fld>
             <a:endParaRPr lang="en-US"/>
           </a:p>
@@ -3600,7 +3603,7 @@
           <a:p>
             <a:fld id="{7D1F2140-8D48-49AC-AD8D-683E6FF4DC34}" type="datetimeFigureOut">
               <a:rPr lang="en-US" smtClean="0"/>
-              <a:t>4/22/2023</a:t>
+              <a:t>4/24/2023</a:t>
             </a:fld>
             <a:endParaRPr lang="en-US"/>
           </a:p>
@@ -3741,7 +3744,7 @@
           <a:p>
             <a:fld id="{7D1F2140-8D48-49AC-AD8D-683E6FF4DC34}" type="datetimeFigureOut">
               <a:rPr lang="en-US" smtClean="0"/>
-              <a:t>4/22/2023</a:t>
+              <a:t>4/24/2023</a:t>
             </a:fld>
             <a:endParaRPr lang="en-US"/>
           </a:p>
@@ -3854,7 +3857,7 @@
           <a:p>
             <a:fld id="{7D1F2140-8D48-49AC-AD8D-683E6FF4DC34}" type="datetimeFigureOut">
               <a:rPr lang="en-US" smtClean="0"/>
-              <a:t>4/22/2023</a:t>
+              <a:t>4/24/2023</a:t>
             </a:fld>
             <a:endParaRPr lang="en-US"/>
           </a:p>
@@ -4165,7 +4168,7 @@
           <a:p>
             <a:fld id="{7D1F2140-8D48-49AC-AD8D-683E6FF4DC34}" type="datetimeFigureOut">
               <a:rPr lang="en-US" smtClean="0"/>
-              <a:t>4/22/2023</a:t>
+              <a:t>4/24/2023</a:t>
             </a:fld>
             <a:endParaRPr lang="en-US"/>
           </a:p>
@@ -4453,7 +4456,7 @@
           <a:p>
             <a:fld id="{7D1F2140-8D48-49AC-AD8D-683E6FF4DC34}" type="datetimeFigureOut">
               <a:rPr lang="en-US" smtClean="0"/>
-              <a:t>4/22/2023</a:t>
+              <a:t>4/24/2023</a:t>
             </a:fld>
             <a:endParaRPr lang="en-US"/>
           </a:p>
@@ -4694,7 +4697,7 @@
           <a:p>
             <a:fld id="{7D1F2140-8D48-49AC-AD8D-683E6FF4DC34}" type="datetimeFigureOut">
               <a:rPr lang="en-US" smtClean="0"/>
-              <a:t>4/22/2023</a:t>
+              <a:t>4/24/2023</a:t>
             </a:fld>
             <a:endParaRPr lang="en-US"/>
           </a:p>
@@ -13200,7 +13203,7 @@
           <a:p>
             <a:r>
               <a:rPr lang="en-US" dirty="0"/>
-              <a:t>Opt-in feature: available by default on all Remotes that are not in the domain “Undefined”</a:t>
+              <a:t>Opt-out feature: available by default on all Remotes that are not in the domain “Undefined”</a:t>
             </a:r>
           </a:p>
           <a:p>
@@ -15773,8 +15776,8 @@
           </a:prstGeom>
         </p:spPr>
       </p:pic>
-      <mc:AlternateContent xmlns:mc="http://schemas.openxmlformats.org/markup-compatibility/2006">
-        <mc:Choice xmlns:p14="http://schemas.microsoft.com/office/powerpoint/2010/main" Requires="p14">
+      <mc:AlternateContent xmlns:mc="http://schemas.openxmlformats.org/markup-compatibility/2006" xmlns:p14="http://schemas.microsoft.com/office/powerpoint/2010/main">
+        <mc:Choice Requires="p14">
           <p:contentPart p14:bwMode="auto" r:id="rId4">
             <p14:nvContentPartPr>
               <p14:cNvPr id="16" name="Ink 15">
@@ -15793,7 +15796,7 @@
             </p14:xfrm>
           </p:contentPart>
         </mc:Choice>
-        <mc:Fallback>
+        <mc:Fallback xmlns="">
           <p:pic>
             <p:nvPicPr>
               <p:cNvPr id="16" name="Ink 15">
@@ -16393,6 +16396,981 @@
     <p:extLst>
       <p:ext uri="{BB962C8B-B14F-4D97-AF65-F5344CB8AC3E}">
         <p14:creationId xmlns:p14="http://schemas.microsoft.com/office/powerpoint/2010/main" val="1987487120"/>
+      </p:ext>
+    </p:extLst>
+  </p:cSld>
+  <p:clrMapOvr>
+    <a:masterClrMapping/>
+  </p:clrMapOvr>
+</p:sld>
+</file>
+
+<file path=ppt/slides/slide34.xml><?xml version="1.0" encoding="utf-8"?>
+<p:sld xmlns:a="http://schemas.openxmlformats.org/drawingml/2006/main" xmlns:r="http://schemas.openxmlformats.org/officeDocument/2006/relationships" xmlns:p="http://schemas.openxmlformats.org/presentationml/2006/main">
+  <p:cSld>
+    <p:spTree>
+      <p:nvGrpSpPr>
+        <p:cNvPr id="1" name=""/>
+        <p:cNvGrpSpPr/>
+        <p:nvPr/>
+      </p:nvGrpSpPr>
+      <p:grpSpPr>
+        <a:xfrm>
+          <a:off x="0" y="0"/>
+          <a:ext cx="0" cy="0"/>
+          <a:chOff x="0" y="0"/>
+          <a:chExt cx="0" cy="0"/>
+        </a:xfrm>
+      </p:grpSpPr>
+      <p:sp>
+        <p:nvSpPr>
+          <p:cNvPr id="2" name="Title 1">
+            <a:extLst>
+              <a:ext uri="{FF2B5EF4-FFF2-40B4-BE49-F238E27FC236}">
+                <a16:creationId xmlns:a16="http://schemas.microsoft.com/office/drawing/2014/main" id="{96430CD7-8283-9031-1738-32DC1DF85B7B}"/>
+              </a:ext>
+            </a:extLst>
+          </p:cNvPr>
+          <p:cNvSpPr>
+            <a:spLocks noGrp="1"/>
+          </p:cNvSpPr>
+          <p:nvPr>
+            <p:ph type="title"/>
+          </p:nvPr>
+        </p:nvSpPr>
+        <p:spPr/>
+        <p:txBody>
+          <a:bodyPr/>
+          <a:lstStyle/>
+          <a:p>
+            <a:r>
+              <a:rPr lang="en-US" dirty="0"/>
+              <a:t>Roadmap</a:t>
+            </a:r>
+          </a:p>
+        </p:txBody>
+      </p:sp>
+      <p:sp>
+        <p:nvSpPr>
+          <p:cNvPr id="3" name="Content Placeholder 2">
+            <a:extLst>
+              <a:ext uri="{FF2B5EF4-FFF2-40B4-BE49-F238E27FC236}">
+                <a16:creationId xmlns:a16="http://schemas.microsoft.com/office/drawing/2014/main" id="{CE6F859C-4726-43EF-F0A8-B73939B70279}"/>
+              </a:ext>
+            </a:extLst>
+          </p:cNvPr>
+          <p:cNvSpPr>
+            <a:spLocks noGrp="1"/>
+          </p:cNvSpPr>
+          <p:nvPr>
+            <p:ph idx="1"/>
+          </p:nvPr>
+        </p:nvSpPr>
+        <p:spPr/>
+        <p:txBody>
+          <a:bodyPr>
+            <a:normAutofit fontScale="62500" lnSpcReduction="20000"/>
+          </a:bodyPr>
+          <a:lstStyle/>
+          <a:p>
+            <a:r>
+              <a:rPr lang="en-US" dirty="0" err="1"/>
+              <a:t>Cris</a:t>
+            </a:r>
+            <a:r>
+              <a:rPr lang="en-US" dirty="0"/>
+              <a:t> feature (next slide).</a:t>
+            </a:r>
+          </a:p>
+          <a:p>
+            <a:r>
+              <a:rPr lang="en-US" dirty="0"/>
+              <a:t>Enlistment of new Parties: </a:t>
+            </a:r>
+            <a:r>
+              <a:rPr lang="en-US" dirty="0" err="1"/>
+              <a:t>AcceptUri</a:t>
+            </a:r>
+            <a:r>
+              <a:rPr lang="en-US" dirty="0"/>
+              <a:t> &amp; </a:t>
+            </a:r>
+            <a:r>
+              <a:rPr lang="en-US" dirty="0" err="1"/>
+              <a:t>UnknownRemote</a:t>
+            </a:r>
+            <a:endParaRPr lang="en-US" dirty="0"/>
+          </a:p>
+          <a:p>
+            <a:r>
+              <a:rPr lang="en-US" dirty="0"/>
+              <a:t>Poco store (</a:t>
+            </a:r>
+            <a:r>
+              <a:rPr lang="en-US" dirty="0">
+                <a:hlinkClick r:id="rId2"/>
+              </a:rPr>
+              <a:t>https://github.com/microsoft/FASTER</a:t>
+            </a:r>
+            <a:r>
+              <a:rPr lang="en-US" dirty="0"/>
+              <a:t>)</a:t>
+            </a:r>
+          </a:p>
+          <a:p>
+            <a:pPr lvl="1"/>
+            <a:r>
+              <a:rPr lang="en-US" dirty="0"/>
+              <a:t>KV or Log?</a:t>
+            </a:r>
+          </a:p>
+          <a:p>
+            <a:pPr lvl="1"/>
+            <a:r>
+              <a:rPr lang="en-US" dirty="0"/>
+              <a:t>For the moment, we can live with a in-memory only store.</a:t>
+            </a:r>
+          </a:p>
+          <a:p>
+            <a:r>
+              <a:rPr lang="en-US" dirty="0"/>
+              <a:t>“X509Store” (</a:t>
+            </a:r>
+            <a:r>
+              <a:rPr lang="en-US" dirty="0" err="1"/>
+              <a:t>.Net</a:t>
+            </a:r>
+            <a:r>
+              <a:rPr lang="en-US" dirty="0"/>
+              <a:t> core or not?)</a:t>
+            </a:r>
+          </a:p>
+          <a:p>
+            <a:pPr lvl="1"/>
+            <a:r>
+              <a:rPr lang="en-US" dirty="0"/>
+              <a:t>First step</a:t>
+            </a:r>
+          </a:p>
+          <a:p>
+            <a:pPr lvl="2"/>
+            <a:r>
+              <a:rPr lang="en-US" dirty="0"/>
+              <a:t>The primary signing certificate that identifies the party.</a:t>
+            </a:r>
+          </a:p>
+          <a:p>
+            <a:pPr lvl="2"/>
+            <a:r>
+              <a:rPr lang="en-US" dirty="0"/>
+              <a:t>Rolling it (or not?)</a:t>
+            </a:r>
+          </a:p>
+          <a:p>
+            <a:pPr lvl="1"/>
+            <a:r>
+              <a:rPr lang="en-US" dirty="0"/>
+              <a:t>Other certificates</a:t>
+            </a:r>
+          </a:p>
+          <a:p>
+            <a:pPr lvl="2"/>
+            <a:r>
+              <a:rPr lang="en-US" dirty="0"/>
+              <a:t>Name for them?</a:t>
+            </a:r>
+          </a:p>
+          <a:p>
+            <a:pPr lvl="2"/>
+            <a:r>
+              <a:rPr lang="en-US" dirty="0"/>
+              <a:t>Rolling?</a:t>
+            </a:r>
+          </a:p>
+          <a:p>
+            <a:pPr lvl="2"/>
+            <a:r>
+              <a:rPr lang="en-US" dirty="0"/>
+              <a:t>Orchard use the X509Store only for its primary certificate, others are on disk, optionally protected by a password.</a:t>
+            </a:r>
+          </a:p>
+          <a:p>
+            <a:pPr marL="914400" lvl="2" indent="0">
+              <a:buNone/>
+            </a:pPr>
+            <a:r>
+              <a:rPr lang="en-US" dirty="0">
+                <a:hlinkClick r:id="rId3"/>
+              </a:rPr>
+              <a:t>https://github.com/OrchardCMS/OrchardCore/blob/main/src/OrchardCore.Modules/OrchardCore.OpenId/Services/OpenIdServerService.cs</a:t>
+            </a:r>
+            <a:endParaRPr lang="en-US" dirty="0"/>
+          </a:p>
+          <a:p>
+            <a:pPr lvl="1"/>
+            <a:r>
+              <a:rPr lang="en-US" dirty="0"/>
+              <a:t>How to generate TSL compliant certificates?</a:t>
+            </a:r>
+          </a:p>
+          <a:p>
+            <a:r>
+              <a:rPr lang="en-US" dirty="0"/>
+              <a:t>Provide a way to monitor the </a:t>
+            </a:r>
+            <a:r>
+              <a:rPr lang="en-US" dirty="0" err="1"/>
+              <a:t>TransportMessage</a:t>
+            </a:r>
+            <a:r>
+              <a:rPr lang="en-US" dirty="0"/>
+              <a:t> Retain/Dispose errors </a:t>
+            </a:r>
+          </a:p>
+          <a:p>
+            <a:pPr lvl="1"/>
+            <a:r>
+              <a:rPr lang="en-US" dirty="0"/>
+              <a:t>Because ref counting sucks</a:t>
+            </a:r>
+          </a:p>
+          <a:p>
+            <a:endParaRPr lang="en-US" dirty="0"/>
+          </a:p>
+        </p:txBody>
+      </p:sp>
+    </p:spTree>
+    <p:extLst>
+      <p:ext uri="{BB962C8B-B14F-4D97-AF65-F5344CB8AC3E}">
+        <p14:creationId xmlns:p14="http://schemas.microsoft.com/office/powerpoint/2010/main" val="1240639712"/>
+      </p:ext>
+    </p:extLst>
+  </p:cSld>
+  <p:clrMapOvr>
+    <a:masterClrMapping/>
+  </p:clrMapOvr>
+</p:sld>
+</file>
+
+<file path=ppt/slides/slide35.xml><?xml version="1.0" encoding="utf-8"?>
+<p:sld xmlns:a="http://schemas.openxmlformats.org/drawingml/2006/main" xmlns:r="http://schemas.openxmlformats.org/officeDocument/2006/relationships" xmlns:p="http://schemas.openxmlformats.org/presentationml/2006/main">
+  <p:cSld>
+    <p:spTree>
+      <p:nvGrpSpPr>
+        <p:cNvPr id="1" name=""/>
+        <p:cNvGrpSpPr/>
+        <p:nvPr/>
+      </p:nvGrpSpPr>
+      <p:grpSpPr>
+        <a:xfrm>
+          <a:off x="0" y="0"/>
+          <a:ext cx="0" cy="0"/>
+          <a:chOff x="0" y="0"/>
+          <a:chExt cx="0" cy="0"/>
+        </a:xfrm>
+      </p:grpSpPr>
+      <p:sp>
+        <p:nvSpPr>
+          <p:cNvPr id="2" name="Title 1">
+            <a:extLst>
+              <a:ext uri="{FF2B5EF4-FFF2-40B4-BE49-F238E27FC236}">
+                <a16:creationId xmlns:a16="http://schemas.microsoft.com/office/drawing/2014/main" id="{5B1EBC4F-39D3-FAF0-AB9D-35A61EBB7F39}"/>
+              </a:ext>
+            </a:extLst>
+          </p:cNvPr>
+          <p:cNvSpPr>
+            <a:spLocks noGrp="1"/>
+          </p:cNvSpPr>
+          <p:nvPr>
+            <p:ph type="title"/>
+          </p:nvPr>
+        </p:nvSpPr>
+        <p:spPr/>
+        <p:txBody>
+          <a:bodyPr/>
+          <a:lstStyle/>
+          <a:p>
+            <a:r>
+              <a:rPr lang="en-US" dirty="0" err="1"/>
+              <a:t>Cris</a:t>
+            </a:r>
+            <a:r>
+              <a:rPr lang="en-US" dirty="0"/>
+              <a:t> feature</a:t>
+            </a:r>
+          </a:p>
+        </p:txBody>
+      </p:sp>
+      <p:sp>
+        <p:nvSpPr>
+          <p:cNvPr id="4" name="Content Placeholder 2">
+            <a:extLst>
+              <a:ext uri="{FF2B5EF4-FFF2-40B4-BE49-F238E27FC236}">
+                <a16:creationId xmlns:a16="http://schemas.microsoft.com/office/drawing/2014/main" id="{C29E0310-D200-A432-CC9E-332FDFE41015}"/>
+              </a:ext>
+            </a:extLst>
+          </p:cNvPr>
+          <p:cNvSpPr txBox="1">
+            <a:spLocks/>
+          </p:cNvSpPr>
+          <p:nvPr/>
+        </p:nvSpPr>
+        <p:spPr>
+          <a:xfrm>
+            <a:off x="838200" y="1562582"/>
+            <a:ext cx="10515600" cy="4766781"/>
+          </a:xfrm>
+          <a:prstGeom prst="rect">
+            <a:avLst/>
+          </a:prstGeom>
+        </p:spPr>
+        <p:txBody>
+          <a:bodyPr vert="horz" lIns="91440" tIns="45720" rIns="91440" bIns="45720" rtlCol="0">
+            <a:normAutofit fontScale="47500" lnSpcReduction="20000"/>
+          </a:bodyPr>
+          <a:lstStyle>
+            <a:lvl1pPr marL="228600" indent="-228600" algn="l" defTabSz="914400" rtl="0" eaLnBrk="1" latinLnBrk="0" hangingPunct="1">
+              <a:lnSpc>
+                <a:spcPct val="90000"/>
+              </a:lnSpc>
+              <a:spcBef>
+                <a:spcPts val="1000"/>
+              </a:spcBef>
+              <a:buFont typeface="Arial" panose="020B0604020202020204" pitchFamily="34" charset="0"/>
+              <a:buChar char="•"/>
+              <a:defRPr sz="2800" kern="1200">
+                <a:solidFill>
+                  <a:schemeClr val="tx1"/>
+                </a:solidFill>
+                <a:latin typeface="+mn-lt"/>
+                <a:ea typeface="+mn-ea"/>
+                <a:cs typeface="+mn-cs"/>
+              </a:defRPr>
+            </a:lvl1pPr>
+            <a:lvl2pPr marL="685800" indent="-228600" algn="l" defTabSz="914400" rtl="0" eaLnBrk="1" latinLnBrk="0" hangingPunct="1">
+              <a:lnSpc>
+                <a:spcPct val="90000"/>
+              </a:lnSpc>
+              <a:spcBef>
+                <a:spcPts val="500"/>
+              </a:spcBef>
+              <a:buFont typeface="Arial" panose="020B0604020202020204" pitchFamily="34" charset="0"/>
+              <a:buChar char="•"/>
+              <a:defRPr sz="2400" kern="1200">
+                <a:solidFill>
+                  <a:schemeClr val="tx1"/>
+                </a:solidFill>
+                <a:latin typeface="+mn-lt"/>
+                <a:ea typeface="+mn-ea"/>
+                <a:cs typeface="+mn-cs"/>
+              </a:defRPr>
+            </a:lvl2pPr>
+            <a:lvl3pPr marL="1143000" indent="-228600" algn="l" defTabSz="914400" rtl="0" eaLnBrk="1" latinLnBrk="0" hangingPunct="1">
+              <a:lnSpc>
+                <a:spcPct val="90000"/>
+              </a:lnSpc>
+              <a:spcBef>
+                <a:spcPts val="500"/>
+              </a:spcBef>
+              <a:buFont typeface="Arial" panose="020B0604020202020204" pitchFamily="34" charset="0"/>
+              <a:buChar char="•"/>
+              <a:defRPr sz="2000" kern="1200">
+                <a:solidFill>
+                  <a:schemeClr val="tx1"/>
+                </a:solidFill>
+                <a:latin typeface="+mn-lt"/>
+                <a:ea typeface="+mn-ea"/>
+                <a:cs typeface="+mn-cs"/>
+              </a:defRPr>
+            </a:lvl3pPr>
+            <a:lvl4pPr marL="1600200" indent="-228600" algn="l" defTabSz="914400" rtl="0" eaLnBrk="1" latinLnBrk="0" hangingPunct="1">
+              <a:lnSpc>
+                <a:spcPct val="90000"/>
+              </a:lnSpc>
+              <a:spcBef>
+                <a:spcPts val="500"/>
+              </a:spcBef>
+              <a:buFont typeface="Arial" panose="020B0604020202020204" pitchFamily="34" charset="0"/>
+              <a:buChar char="•"/>
+              <a:defRPr sz="1800" kern="1200">
+                <a:solidFill>
+                  <a:schemeClr val="tx1"/>
+                </a:solidFill>
+                <a:latin typeface="+mn-lt"/>
+                <a:ea typeface="+mn-ea"/>
+                <a:cs typeface="+mn-cs"/>
+              </a:defRPr>
+            </a:lvl4pPr>
+            <a:lvl5pPr marL="2057400" indent="-228600" algn="l" defTabSz="914400" rtl="0" eaLnBrk="1" latinLnBrk="0" hangingPunct="1">
+              <a:lnSpc>
+                <a:spcPct val="90000"/>
+              </a:lnSpc>
+              <a:spcBef>
+                <a:spcPts val="500"/>
+              </a:spcBef>
+              <a:buFont typeface="Arial" panose="020B0604020202020204" pitchFamily="34" charset="0"/>
+              <a:buChar char="•"/>
+              <a:defRPr sz="1800" kern="1200">
+                <a:solidFill>
+                  <a:schemeClr val="tx1"/>
+                </a:solidFill>
+                <a:latin typeface="+mn-lt"/>
+                <a:ea typeface="+mn-ea"/>
+                <a:cs typeface="+mn-cs"/>
+              </a:defRPr>
+            </a:lvl5pPr>
+            <a:lvl6pPr marL="2514600" indent="-228600" algn="l" defTabSz="914400" rtl="0" eaLnBrk="1" latinLnBrk="0" hangingPunct="1">
+              <a:lnSpc>
+                <a:spcPct val="90000"/>
+              </a:lnSpc>
+              <a:spcBef>
+                <a:spcPts val="500"/>
+              </a:spcBef>
+              <a:buFont typeface="Arial" panose="020B0604020202020204" pitchFamily="34" charset="0"/>
+              <a:buChar char="•"/>
+              <a:defRPr sz="1800" kern="1200">
+                <a:solidFill>
+                  <a:schemeClr val="tx1"/>
+                </a:solidFill>
+                <a:latin typeface="+mn-lt"/>
+                <a:ea typeface="+mn-ea"/>
+                <a:cs typeface="+mn-cs"/>
+              </a:defRPr>
+            </a:lvl6pPr>
+            <a:lvl7pPr marL="2971800" indent="-228600" algn="l" defTabSz="914400" rtl="0" eaLnBrk="1" latinLnBrk="0" hangingPunct="1">
+              <a:lnSpc>
+                <a:spcPct val="90000"/>
+              </a:lnSpc>
+              <a:spcBef>
+                <a:spcPts val="500"/>
+              </a:spcBef>
+              <a:buFont typeface="Arial" panose="020B0604020202020204" pitchFamily="34" charset="0"/>
+              <a:buChar char="•"/>
+              <a:defRPr sz="1800" kern="1200">
+                <a:solidFill>
+                  <a:schemeClr val="tx1"/>
+                </a:solidFill>
+                <a:latin typeface="+mn-lt"/>
+                <a:ea typeface="+mn-ea"/>
+                <a:cs typeface="+mn-cs"/>
+              </a:defRPr>
+            </a:lvl7pPr>
+            <a:lvl8pPr marL="3429000" indent="-228600" algn="l" defTabSz="914400" rtl="0" eaLnBrk="1" latinLnBrk="0" hangingPunct="1">
+              <a:lnSpc>
+                <a:spcPct val="90000"/>
+              </a:lnSpc>
+              <a:spcBef>
+                <a:spcPts val="500"/>
+              </a:spcBef>
+              <a:buFont typeface="Arial" panose="020B0604020202020204" pitchFamily="34" charset="0"/>
+              <a:buChar char="•"/>
+              <a:defRPr sz="1800" kern="1200">
+                <a:solidFill>
+                  <a:schemeClr val="tx1"/>
+                </a:solidFill>
+                <a:latin typeface="+mn-lt"/>
+                <a:ea typeface="+mn-ea"/>
+                <a:cs typeface="+mn-cs"/>
+              </a:defRPr>
+            </a:lvl8pPr>
+            <a:lvl9pPr marL="3886200" indent="-228600" algn="l" defTabSz="914400" rtl="0" eaLnBrk="1" latinLnBrk="0" hangingPunct="1">
+              <a:lnSpc>
+                <a:spcPct val="90000"/>
+              </a:lnSpc>
+              <a:spcBef>
+                <a:spcPts val="500"/>
+              </a:spcBef>
+              <a:buFont typeface="Arial" panose="020B0604020202020204" pitchFamily="34" charset="0"/>
+              <a:buChar char="•"/>
+              <a:defRPr sz="1800" kern="1200">
+                <a:solidFill>
+                  <a:schemeClr val="tx1"/>
+                </a:solidFill>
+                <a:latin typeface="+mn-lt"/>
+                <a:ea typeface="+mn-ea"/>
+                <a:cs typeface="+mn-cs"/>
+              </a:defRPr>
+            </a:lvl9pPr>
+          </a:lstStyle>
+          <a:p>
+            <a:r>
+              <a:rPr lang="en-US" dirty="0"/>
+              <a:t>Common DI or 2 DI (one for the WebApp, one for </a:t>
+            </a:r>
+            <a:r>
+              <a:rPr lang="en-US" dirty="0" err="1"/>
+              <a:t>AppIdentity</a:t>
+            </a:r>
+            <a:r>
+              <a:rPr lang="en-US" dirty="0"/>
+              <a:t>)?</a:t>
+            </a:r>
+          </a:p>
+          <a:p>
+            <a:r>
+              <a:rPr lang="en-US" dirty="0"/>
+              <a:t>2 DI containers introduce the “Absolute Singletons” issue</a:t>
+            </a:r>
+          </a:p>
+          <a:p>
+            <a:pPr lvl="1"/>
+            <a:r>
+              <a:rPr lang="en-US" dirty="0"/>
+              <a:t>Should the same instance of a singleton service be registered in both DI?</a:t>
+            </a:r>
+          </a:p>
+          <a:p>
+            <a:pPr lvl="1"/>
+            <a:r>
+              <a:rPr lang="en-US" dirty="0"/>
+              <a:t>For all singleton services? May be for </a:t>
+            </a:r>
+            <a:r>
+              <a:rPr lang="en-US" dirty="0" err="1"/>
+              <a:t>IRealObject</a:t>
+            </a:r>
+            <a:r>
+              <a:rPr lang="en-US" dirty="0"/>
+              <a:t> only?</a:t>
+            </a:r>
+          </a:p>
+          <a:p>
+            <a:r>
+              <a:rPr lang="en-US" dirty="0"/>
+              <a:t>My preference:</a:t>
+            </a:r>
+          </a:p>
+          <a:p>
+            <a:pPr lvl="1"/>
+            <a:r>
+              <a:rPr lang="en-US" dirty="0"/>
+              <a:t>A </a:t>
+            </a:r>
+            <a:r>
+              <a:rPr lang="en-US" dirty="0" err="1"/>
+              <a:t>CK-AppIdentity:Local:WebApplication</a:t>
+            </a:r>
+            <a:r>
+              <a:rPr lang="en-US" dirty="0"/>
+              <a:t> section that defines the WebApp as an “island” of the application.</a:t>
+            </a:r>
+          </a:p>
+          <a:p>
+            <a:pPr lvl="2"/>
+            <a:r>
+              <a:rPr lang="en-US" dirty="0"/>
+              <a:t>DI of the app has no “Web” dependent services (“Process” services only).</a:t>
+            </a:r>
+          </a:p>
+          <a:p>
+            <a:pPr lvl="2"/>
+            <a:r>
+              <a:rPr lang="en-US" dirty="0"/>
+              <a:t>The </a:t>
+            </a:r>
+            <a:r>
+              <a:rPr lang="en-US" dirty="0" err="1"/>
+              <a:t>WebApplicationBuilder.Services</a:t>
+            </a:r>
+            <a:r>
+              <a:rPr lang="en-US" dirty="0"/>
+              <a:t> is pre-configured with all the “process services” registrations.</a:t>
+            </a:r>
+          </a:p>
+          <a:p>
+            <a:pPr lvl="1"/>
+            <a:r>
+              <a:rPr lang="en-US" dirty="0"/>
+              <a:t>Can we build the App DI without all the services that depends on the “Web” layer?</a:t>
+            </a:r>
+          </a:p>
+          <a:p>
+            <a:pPr lvl="2"/>
+            <a:r>
+              <a:rPr lang="en-US" dirty="0" err="1"/>
+              <a:t>ScopedHttpContext</a:t>
+            </a:r>
+            <a:r>
+              <a:rPr lang="en-US" dirty="0"/>
+              <a:t>, </a:t>
+            </a:r>
+            <a:r>
+              <a:rPr lang="en-US" dirty="0" err="1"/>
+              <a:t>IAuthenticationService</a:t>
+            </a:r>
+            <a:r>
+              <a:rPr lang="en-US" dirty="0"/>
+              <a:t>, etc.</a:t>
+            </a:r>
+          </a:p>
+          <a:p>
+            <a:pPr lvl="1"/>
+            <a:r>
+              <a:rPr lang="en-US" dirty="0"/>
+              <a:t>Is the “Front” vs. “Process” distinction enough?</a:t>
+            </a:r>
+          </a:p>
+          <a:p>
+            <a:pPr lvl="2"/>
+            <a:r>
+              <a:rPr lang="en-US" dirty="0"/>
+              <a:t>In such case, “Front” means “Web”… </a:t>
+            </a:r>
+          </a:p>
+          <a:p>
+            <a:pPr lvl="2"/>
+            <a:r>
+              <a:rPr lang="en-US" dirty="0"/>
+              <a:t>This may be a first approach, but ideally services are tagged with more than a single “trait”.</a:t>
+            </a:r>
+          </a:p>
+          <a:p>
+            <a:pPr lvl="2"/>
+            <a:r>
+              <a:rPr lang="en-US" dirty="0"/>
+              <a:t>Or we skip any service defined in “</a:t>
+            </a:r>
+            <a:r>
+              <a:rPr lang="en-US" dirty="0" err="1"/>
+              <a:t>Microsoft.AspNetCore</a:t>
+            </a:r>
+            <a:r>
+              <a:rPr lang="en-US" dirty="0"/>
+              <a:t>” namespace ? A list of regex on AQN?</a:t>
+            </a:r>
+          </a:p>
+          <a:p>
+            <a:pPr lvl="2"/>
+            <a:r>
+              <a:rPr lang="en-US" dirty="0"/>
+              <a:t>Does a “list of regex on AQN” defines an “End Point”?</a:t>
+            </a:r>
+          </a:p>
+          <a:p>
+            <a:pPr lvl="3"/>
+            <a:r>
+              <a:rPr lang="en-US" dirty="0"/>
+              <a:t>If yes, one should be able to “</a:t>
+            </a:r>
+            <a:r>
+              <a:rPr lang="en-US" dirty="0" err="1"/>
+              <a:t>ConfigureServices</a:t>
+            </a:r>
+            <a:r>
+              <a:rPr lang="en-US" dirty="0"/>
+              <a:t>” with or without a set of “End Points”…</a:t>
+            </a:r>
+          </a:p>
+          <a:p>
+            <a:pPr lvl="1"/>
+            <a:r>
+              <a:rPr lang="en-US" dirty="0"/>
+              <a:t>Even if this is possible, we have yet to synchronize the singleton instances (or not)…</a:t>
+            </a:r>
+          </a:p>
+          <a:p>
+            <a:pPr lvl="1"/>
+            <a:r>
+              <a:rPr lang="en-US" dirty="0"/>
+              <a:t>This may be the best way in terms of architecture BUT it’s not a short-term solution.</a:t>
+            </a:r>
+          </a:p>
+          <a:p>
+            <a:r>
+              <a:rPr lang="en-US" dirty="0"/>
+              <a:t>The other way is that the Application DI is the WebApp one (if the app is a WebApp) just like today.</a:t>
+            </a:r>
+          </a:p>
+          <a:p>
+            <a:pPr lvl="1"/>
+            <a:r>
+              <a:rPr lang="en-US" dirty="0"/>
+              <a:t>But now services must be “hidden”/”overridden” in </a:t>
+            </a:r>
+            <a:r>
+              <a:rPr lang="en-US" dirty="0" err="1"/>
+              <a:t>AppIdentity</a:t>
+            </a:r>
+            <a:r>
+              <a:rPr lang="en-US" dirty="0"/>
+              <a:t> services, at least for the </a:t>
+            </a:r>
+            <a:r>
+              <a:rPr lang="en-US" dirty="0" err="1"/>
+              <a:t>CrisExecutor</a:t>
+            </a:r>
+            <a:r>
+              <a:rPr lang="en-US" dirty="0"/>
+              <a:t>.</a:t>
+            </a:r>
+          </a:p>
+          <a:p>
+            <a:pPr lvl="1"/>
+            <a:r>
+              <a:rPr lang="en-US" dirty="0"/>
+              <a:t>If a command handler relies on a “Web” singleton or scoped service, we are doomed (will fail at runtime).</a:t>
+            </a:r>
+          </a:p>
+          <a:p>
+            <a:pPr lvl="1"/>
+            <a:r>
+              <a:rPr lang="en-US" dirty="0"/>
+              <a:t>But </a:t>
+            </a:r>
+            <a:r>
+              <a:rPr lang="en-US" dirty="0" err="1"/>
+              <a:t>CK.Cris.Executor</a:t>
+            </a:r>
+            <a:r>
+              <a:rPr lang="en-US" dirty="0"/>
+              <a:t> do its job (</a:t>
+            </a:r>
+            <a:r>
+              <a:rPr lang="en-US" dirty="0" err="1"/>
+              <a:t>CommandValidator</a:t>
+            </a:r>
+            <a:r>
+              <a:rPr lang="en-US" dirty="0"/>
+              <a:t>, </a:t>
+            </a:r>
+            <a:r>
+              <a:rPr lang="en-US" dirty="0" err="1"/>
+              <a:t>RawCommandExecutor</a:t>
+            </a:r>
+            <a:r>
+              <a:rPr lang="en-US" dirty="0"/>
+              <a:t>) based on an explicit </a:t>
+            </a:r>
+            <a:r>
+              <a:rPr lang="en-US" dirty="0" err="1"/>
+              <a:t>IServiceProvider</a:t>
+            </a:r>
+            <a:r>
+              <a:rPr lang="en-US" dirty="0"/>
+              <a:t>.</a:t>
+            </a:r>
+          </a:p>
+          <a:p>
+            <a:pPr lvl="1"/>
+            <a:r>
+              <a:rPr lang="en-US" dirty="0"/>
+              <a:t>We can provide a </a:t>
+            </a:r>
+            <a:r>
+              <a:rPr lang="en-US" dirty="0" err="1"/>
+              <a:t>IServiceProvider</a:t>
+            </a:r>
+            <a:r>
+              <a:rPr lang="en-US" dirty="0"/>
+              <a:t> that hides/replaces some services for the command handling.</a:t>
+            </a:r>
+            <a:endParaRPr lang="en-US" dirty="0">
+              <a:sym typeface="Wingdings" panose="05000000000000000000" pitchFamily="2" charset="2"/>
+            </a:endParaRPr>
+          </a:p>
+          <a:p>
+            <a:pPr marL="457200" lvl="1" indent="0">
+              <a:buNone/>
+            </a:pPr>
+            <a:r>
+              <a:rPr lang="en-US" dirty="0">
+                <a:sym typeface="Wingdings" panose="05000000000000000000" pitchFamily="2" charset="2"/>
+              </a:rPr>
+              <a:t> This is not ideal, but it should work if not too many “Web” services are concerned and we can provide a replacement for the services at stake …</a:t>
+            </a:r>
+            <a:endParaRPr lang="en-US" dirty="0"/>
+          </a:p>
+        </p:txBody>
+      </p:sp>
+    </p:spTree>
+    <p:extLst>
+      <p:ext uri="{BB962C8B-B14F-4D97-AF65-F5344CB8AC3E}">
+        <p14:creationId xmlns:p14="http://schemas.microsoft.com/office/powerpoint/2010/main" val="3058767410"/>
+      </p:ext>
+    </p:extLst>
+  </p:cSld>
+  <p:clrMapOvr>
+    <a:masterClrMapping/>
+  </p:clrMapOvr>
+</p:sld>
+</file>
+
+<file path=ppt/slides/slide36.xml><?xml version="1.0" encoding="utf-8"?>
+<p:sld xmlns:a="http://schemas.openxmlformats.org/drawingml/2006/main" xmlns:r="http://schemas.openxmlformats.org/officeDocument/2006/relationships" xmlns:p="http://schemas.openxmlformats.org/presentationml/2006/main">
+  <p:cSld>
+    <p:spTree>
+      <p:nvGrpSpPr>
+        <p:cNvPr id="1" name=""/>
+        <p:cNvGrpSpPr/>
+        <p:nvPr/>
+      </p:nvGrpSpPr>
+      <p:grpSpPr>
+        <a:xfrm>
+          <a:off x="0" y="0"/>
+          <a:ext cx="0" cy="0"/>
+          <a:chOff x="0" y="0"/>
+          <a:chExt cx="0" cy="0"/>
+        </a:xfrm>
+      </p:grpSpPr>
+      <p:sp>
+        <p:nvSpPr>
+          <p:cNvPr id="2" name="Title 1">
+            <a:extLst>
+              <a:ext uri="{FF2B5EF4-FFF2-40B4-BE49-F238E27FC236}">
+                <a16:creationId xmlns:a16="http://schemas.microsoft.com/office/drawing/2014/main" id="{50EAFAF5-98A2-D125-4496-C05967A7110A}"/>
+              </a:ext>
+            </a:extLst>
+          </p:cNvPr>
+          <p:cNvSpPr>
+            <a:spLocks noGrp="1"/>
+          </p:cNvSpPr>
+          <p:nvPr>
+            <p:ph type="title"/>
+          </p:nvPr>
+        </p:nvSpPr>
+        <p:spPr/>
+        <p:txBody>
+          <a:bodyPr/>
+          <a:lstStyle/>
+          <a:p>
+            <a:r>
+              <a:rPr lang="en-US" dirty="0"/>
+              <a:t>Other questions &amp; To do</a:t>
+            </a:r>
+          </a:p>
+        </p:txBody>
+      </p:sp>
+      <p:sp>
+        <p:nvSpPr>
+          <p:cNvPr id="3" name="Content Placeholder 2">
+            <a:extLst>
+              <a:ext uri="{FF2B5EF4-FFF2-40B4-BE49-F238E27FC236}">
+                <a16:creationId xmlns:a16="http://schemas.microsoft.com/office/drawing/2014/main" id="{3C1C559C-F4C7-F864-231C-921ED15BE2E9}"/>
+              </a:ext>
+            </a:extLst>
+          </p:cNvPr>
+          <p:cNvSpPr>
+            <a:spLocks noGrp="1"/>
+          </p:cNvSpPr>
+          <p:nvPr>
+            <p:ph idx="1"/>
+          </p:nvPr>
+        </p:nvSpPr>
+        <p:spPr/>
+        <p:txBody>
+          <a:bodyPr/>
+          <a:lstStyle/>
+          <a:p>
+            <a:r>
+              <a:rPr lang="en-US" dirty="0"/>
+              <a:t>Internalize </a:t>
+            </a:r>
+            <a:r>
+              <a:rPr lang="en-US" dirty="0" err="1"/>
+              <a:t>TransportMessage</a:t>
+            </a:r>
+            <a:endParaRPr lang="en-US" dirty="0"/>
+          </a:p>
+          <a:p>
+            <a:pPr lvl="1"/>
+            <a:r>
+              <a:rPr lang="en-US" dirty="0"/>
+              <a:t>Differentiate </a:t>
+            </a:r>
+            <a:r>
+              <a:rPr lang="en-US" dirty="0" err="1"/>
+              <a:t>IOutgoingTransportMessage</a:t>
+            </a:r>
+            <a:r>
+              <a:rPr lang="en-US" dirty="0"/>
+              <a:t> and </a:t>
+            </a:r>
+            <a:r>
+              <a:rPr lang="en-US" dirty="0" err="1"/>
+              <a:t>IIncomingTransportMessage</a:t>
+            </a:r>
+            <a:endParaRPr lang="en-US" dirty="0"/>
+          </a:p>
+          <a:p>
+            <a:pPr lvl="1"/>
+            <a:r>
+              <a:rPr lang="en-US" dirty="0"/>
+              <a:t>Assume the outgoing message mutability: Freeze and </a:t>
+            </a:r>
+            <a:r>
+              <a:rPr lang="en-US" dirty="0" err="1"/>
+              <a:t>IsFrozen</a:t>
+            </a:r>
+            <a:endParaRPr lang="en-US" dirty="0"/>
+          </a:p>
+          <a:p>
+            <a:r>
+              <a:rPr lang="en-US" dirty="0"/>
+              <a:t>Add a “Layer” API on the </a:t>
+            </a:r>
+            <a:r>
+              <a:rPr lang="en-US" dirty="0" err="1"/>
+              <a:t>TransportMessage</a:t>
+            </a:r>
+            <a:endParaRPr lang="en-US" dirty="0"/>
+          </a:p>
+          <a:p>
+            <a:r>
+              <a:rPr lang="en-US" dirty="0"/>
+              <a:t>Implements the “</a:t>
+            </a:r>
+            <a:r>
+              <a:rPr lang="en-US" dirty="0" err="1"/>
+              <a:t>BigMessage</a:t>
+            </a:r>
+            <a:r>
+              <a:rPr lang="en-US" dirty="0"/>
+              <a:t>” slicing (0 Protocol).</a:t>
+            </a:r>
+          </a:p>
+          <a:p>
+            <a:r>
+              <a:rPr lang="en-US" dirty="0"/>
+              <a:t>Should “Response” channel be renamed “</a:t>
+            </a:r>
+            <a:r>
+              <a:rPr lang="en-US" dirty="0" err="1"/>
+              <a:t>HighPriority</a:t>
+            </a:r>
+            <a:r>
+              <a:rPr lang="en-US" dirty="0"/>
+              <a:t>”?</a:t>
+            </a:r>
+          </a:p>
+          <a:p>
+            <a:pPr lvl="1"/>
+            <a:r>
+              <a:rPr lang="en-US" dirty="0"/>
+              <a:t>Responses would use it but the “</a:t>
+            </a:r>
+            <a:r>
+              <a:rPr lang="en-US" dirty="0" err="1"/>
+              <a:t>CancelCurrentBigMessage</a:t>
+            </a:r>
+            <a:r>
+              <a:rPr lang="en-US" dirty="0"/>
+              <a:t>” would also use it (</a:t>
+            </a:r>
+            <a:r>
+              <a:rPr lang="en-US"/>
+              <a:t>and it is </a:t>
+            </a:r>
+            <a:r>
+              <a:rPr lang="en-US" dirty="0"/>
+              <a:t>not a response).</a:t>
+            </a:r>
+          </a:p>
+        </p:txBody>
+      </p:sp>
+    </p:spTree>
+    <p:extLst>
+      <p:ext uri="{BB962C8B-B14F-4D97-AF65-F5344CB8AC3E}">
+        <p14:creationId xmlns:p14="http://schemas.microsoft.com/office/powerpoint/2010/main" val="479290701"/>
       </p:ext>
     </p:extLst>
   </p:cSld>

</xml_diff>

<commit_message>
Forgot to close the pptx :(
</commit_message>
<xml_diff>
--- a/Doc/CK-AppIdentity.pptx
+++ b/Doc/CK-AppIdentity.pptx
@@ -151,6 +151,35 @@
 </file>
 
 <file path=ppt/ink/ink1.xml><?xml version="1.0" encoding="utf-8"?>
+<inkml:ink xmlns:inkml="http://www.w3.org/2003/InkML">
+  <inkml:definitions>
+    <inkml:context xml:id="ctx0">
+      <inkml:inkSource xml:id="inkSrc0">
+        <inkml:traceFormat>
+          <inkml:channel name="X" type="integer" min="-2.14748E9" max="2.14748E9" units="cm"/>
+          <inkml:channel name="Y" type="integer" min="-2.14748E9" max="2.14748E9" units="cm"/>
+        </inkml:traceFormat>
+        <inkml:channelProperties>
+          <inkml:channelProperty channel="X" name="resolution" value="1000" units="1/cm"/>
+          <inkml:channelProperty channel="Y" name="resolution" value="1000" units="1/cm"/>
+        </inkml:channelProperties>
+      </inkml:inkSource>
+      <inkml:timestamp xml:id="ts0" timeString="2023-04-24T17:00:42.164"/>
+    </inkml:context>
+    <inkml:brush xml:id="br0">
+      <inkml:brushProperty name="width" value="0.3" units="cm"/>
+      <inkml:brushProperty name="height" value="0.6" units="cm"/>
+      <inkml:brushProperty name="color" value="#FFFC00"/>
+      <inkml:brushProperty name="tip" value="rectangle"/>
+      <inkml:brushProperty name="rasterOp" value="maskPen"/>
+      <inkml:brushProperty name="ignorePressure" value="1"/>
+    </inkml:brush>
+  </inkml:definitions>
+  <inkml:trace contextRef="#ctx0" brushRef="#br0">14 170,'51'0,"662"-22,-623 9,108-29,-25 4,-13 14,227-6,165 30,-231 3,1036-3,-1268 4,0 4,-1 4,0 4,-2 3,143 52,-172-48,-39-15,-1-1,1 0,0-1,0-1,1-1,22 2,267-7,48 4,-313 3,-38-3,-13 0,-63 4,-1-3,-139-10,133 1,0-4,0-4,1-3,-137-47,139 36,-97-21,160 46,-1 1,1-1,0 2,0 0,-1 1,1 0,0 0,-18 6,-11 5,-44 18,40-13,41-15,-37 14,0-2,-1-1,0-3,-58 7,-369 7,105-10,-11 0,307-16,26 0,1 2,-41 6,70-5,0 2,0-1,0 1,1 1,-1 0,1 1,0 0,0 0,1 1,0 1,-13 10,7-4,0-1,-1-1,-1 0,0-1,0-1,-29 10,-119 26,137-39,13-1,0 1,0 0,0 1,1 1,-15 9,19-9,-1-1,-1 0,1-1,-1-1,0 0,0 0,-1-1,-19 2,-3-4,0-1,0-2,-36-7,-106-24,100 16,-88-7,110 19,-18 0,-142-26,182 22,0 1,-69-3,86 10,-1 0,1 2,0 0,0 1,0 0,0 2,-30 11,-33 23,-20 9,86-43,1 0,-1-1,0-1,0 0,-25 1,35-4,-1 0,0 0,0-1,1 0,-1 0,0 0,1-1,-1 1,1-1,0 0,-1 0,1-1,0 1,0-1,1 0,-1 0,0 0,1-1,0 1,-5-7,-1-3,1 0,0-1,1 0,-11-28,17 39,0 0,0 0,0 0,0 0,0 0,1 0,-1 0,1-1,0 1,0 0,0 0,0 0,2-6,-1 7,0 1,0-1,0 1,0-1,1 1,-1-1,0 1,1-1,-1 1,1 0,0 0,-1 0,1 0,0 0,0 0,0 1,-1-1,1 1,0-1,0 1,0-1,0 1,0 0,0 0,2 0,34 0,-1 2,0 1,62 13,-27-3,39 5,121 17,-167-28,102-3,-144-4,0-2,-1-1,1-1,-1 0,0-2,0 0,35-17,-39 16,0 1,1 1,0 0,-1 2,1 0,1 1,-1 0,37 4,-20-2,624 3,-598 1,-1 3,1 2,105 32,-110-26,12 3,15 5,1-4,140 15,-208-35,0 0,0-1,0-1,0-1,-1 0,22-9,-9 4,89-26,199-32,-252 61,114 6,-77 2,738-2,-822 1,-1 1,34 7,21 4,-22-13,-1-1,1-3,96-20,-52 7,-77 14,1 1,0 0,-1 1,1 1,0 1,0 1,31 6,-26-2</inkml:trace>
+</inkml:ink>
+</file>
+
+<file path=ppt/ink/ink2.xml><?xml version="1.0" encoding="utf-8"?>
 <inkml:ink xmlns:inkml="http://www.w3.org/2003/InkML">
   <inkml:definitions>
     <inkml:context xml:id="ctx0">
@@ -11430,7 +11459,7 @@
         <p:spPr/>
         <p:txBody>
           <a:bodyPr>
-            <a:normAutofit fontScale="92500" lnSpcReduction="20000"/>
+            <a:normAutofit fontScale="92500" lnSpcReduction="10000"/>
           </a:bodyPr>
           <a:lstStyle/>
           <a:p>
@@ -11519,125 +11548,6 @@
             <a:r>
               <a:rPr lang="en-US" dirty="0"/>
               <a:t>).</a:t>
-            </a:r>
-          </a:p>
-          <a:p>
-            <a:pPr lvl="1"/>
-            <a:r>
-              <a:rPr lang="en-US" dirty="0"/>
-              <a:t> </a:t>
-            </a:r>
-            <a:r>
-              <a:rPr lang="en-US" sz="1600" dirty="0">
-                <a:solidFill>
-                  <a:srgbClr val="0000FF"/>
-                </a:solidFill>
-                <a:latin typeface="Consolas" panose="020B0609020204030204" pitchFamily="49" charset="0"/>
-              </a:rPr>
-              <a:t>void</a:t>
-            </a:r>
-            <a:r>
-              <a:rPr lang="en-US" sz="1600" dirty="0">
-                <a:solidFill>
-                  <a:srgbClr val="000000"/>
-                </a:solidFill>
-                <a:latin typeface="Consolas" panose="020B0609020204030204" pitchFamily="49" charset="0"/>
-              </a:rPr>
-              <a:t> </a:t>
-            </a:r>
-            <a:r>
-              <a:rPr lang="en-US" sz="1600" dirty="0" err="1">
-                <a:solidFill>
-                  <a:srgbClr val="000000"/>
-                </a:solidFill>
-                <a:latin typeface="Consolas" panose="020B0609020204030204" pitchFamily="49" charset="0"/>
-              </a:rPr>
-              <a:t>AddFeature</a:t>
-            </a:r>
-            <a:r>
-              <a:rPr lang="en-US" sz="1600" dirty="0">
-                <a:solidFill>
-                  <a:srgbClr val="000000"/>
-                </a:solidFill>
-                <a:latin typeface="Consolas" panose="020B0609020204030204" pitchFamily="49" charset="0"/>
-              </a:rPr>
-              <a:t>( </a:t>
-            </a:r>
-            <a:r>
-              <a:rPr lang="en-US" sz="1600" dirty="0">
-                <a:solidFill>
-                  <a:srgbClr val="0000FF"/>
-                </a:solidFill>
-                <a:latin typeface="Consolas" panose="020B0609020204030204" pitchFamily="49" charset="0"/>
-              </a:rPr>
-              <a:t>object</a:t>
-            </a:r>
-            <a:r>
-              <a:rPr lang="en-US" sz="1600" dirty="0">
-                <a:solidFill>
-                  <a:srgbClr val="000000"/>
-                </a:solidFill>
-                <a:latin typeface="Consolas" panose="020B0609020204030204" pitchFamily="49" charset="0"/>
-              </a:rPr>
-              <a:t> feature )</a:t>
-            </a:r>
-            <a:r>
-              <a:rPr lang="en-US" dirty="0"/>
-              <a:t> and </a:t>
-            </a:r>
-            <a:r>
-              <a:rPr lang="en-US" sz="1600" dirty="0">
-                <a:solidFill>
-                  <a:srgbClr val="0000FF"/>
-                </a:solidFill>
-                <a:latin typeface="Consolas" panose="020B0609020204030204" pitchFamily="49" charset="0"/>
-              </a:rPr>
-              <a:t>void</a:t>
-            </a:r>
-            <a:r>
-              <a:rPr lang="en-US" sz="1600" dirty="0">
-                <a:solidFill>
-                  <a:srgbClr val="000000"/>
-                </a:solidFill>
-                <a:latin typeface="Consolas" panose="020B0609020204030204" pitchFamily="49" charset="0"/>
-              </a:rPr>
-              <a:t> </a:t>
-            </a:r>
-            <a:r>
-              <a:rPr lang="en-US" sz="1600" dirty="0" err="1">
-                <a:solidFill>
-                  <a:srgbClr val="000000"/>
-                </a:solidFill>
-                <a:latin typeface="Consolas" panose="020B0609020204030204" pitchFamily="49" charset="0"/>
-              </a:rPr>
-              <a:t>RemoveFeature</a:t>
-            </a:r>
-            <a:r>
-              <a:rPr lang="en-US" sz="1600" dirty="0">
-                <a:solidFill>
-                  <a:srgbClr val="000000"/>
-                </a:solidFill>
-                <a:latin typeface="Consolas" panose="020B0609020204030204" pitchFamily="49" charset="0"/>
-              </a:rPr>
-              <a:t>( </a:t>
-            </a:r>
-            <a:r>
-              <a:rPr lang="en-US" sz="1600" dirty="0">
-                <a:solidFill>
-                  <a:srgbClr val="0000FF"/>
-                </a:solidFill>
-                <a:latin typeface="Consolas" panose="020B0609020204030204" pitchFamily="49" charset="0"/>
-              </a:rPr>
-              <a:t>object</a:t>
-            </a:r>
-            <a:r>
-              <a:rPr lang="en-US" sz="1600" dirty="0">
-                <a:solidFill>
-                  <a:srgbClr val="000000"/>
-                </a:solidFill>
-                <a:latin typeface="Consolas" panose="020B0609020204030204" pitchFamily="49" charset="0"/>
-              </a:rPr>
-              <a:t> feature )</a:t>
             </a:r>
             <a:br>
               <a:rPr lang="en-US" sz="1600" dirty="0">
@@ -13298,6 +13208,57 @@
           </a:p>
         </p:txBody>
       </p:sp>
+      <mc:AlternateContent xmlns:mc="http://schemas.openxmlformats.org/markup-compatibility/2006">
+        <mc:Choice xmlns:p14="http://schemas.microsoft.com/office/powerpoint/2010/main" Requires="p14">
+          <p:contentPart p14:bwMode="auto" r:id="rId3">
+            <p14:nvContentPartPr>
+              <p14:cNvPr id="4" name="Ink 3">
+                <a:extLst>
+                  <a:ext uri="{FF2B5EF4-FFF2-40B4-BE49-F238E27FC236}">
+                    <a16:creationId xmlns:a16="http://schemas.microsoft.com/office/drawing/2014/main" id="{B7B4A735-853C-A50C-B584-BA5FB8D4C33A}"/>
+                  </a:ext>
+                </a:extLst>
+              </p14:cNvPr>
+              <p14:cNvContentPartPr/>
+              <p14:nvPr/>
+            </p14:nvContentPartPr>
+            <p14:xfrm>
+              <a:off x="7101000" y="3347750"/>
+              <a:ext cx="2017080" cy="191160"/>
+            </p14:xfrm>
+          </p:contentPart>
+        </mc:Choice>
+        <mc:Fallback>
+          <p:pic>
+            <p:nvPicPr>
+              <p:cNvPr id="4" name="Ink 3">
+                <a:extLst>
+                  <a:ext uri="{FF2B5EF4-FFF2-40B4-BE49-F238E27FC236}">
+                    <a16:creationId xmlns:a16="http://schemas.microsoft.com/office/drawing/2014/main" id="{B7B4A735-853C-A50C-B584-BA5FB8D4C33A}"/>
+                  </a:ext>
+                </a:extLst>
+              </p:cNvPr>
+              <p:cNvPicPr/>
+              <p:nvPr/>
+            </p:nvPicPr>
+            <p:blipFill>
+              <a:blip r:embed="rId4"/>
+              <a:stretch>
+                <a:fillRect/>
+              </a:stretch>
+            </p:blipFill>
+            <p:spPr>
+              <a:xfrm>
+                <a:off x="7047360" y="3240110"/>
+                <a:ext cx="2124720" cy="406800"/>
+              </a:xfrm>
+              <a:prstGeom prst="rect">
+                <a:avLst/>
+              </a:prstGeom>
+            </p:spPr>
+          </p:pic>
+        </mc:Fallback>
+      </mc:AlternateContent>
     </p:spTree>
     <p:extLst>
       <p:ext uri="{BB962C8B-B14F-4D97-AF65-F5344CB8AC3E}">
@@ -13506,7 +13467,7 @@
         <p:spPr>
           <a:xfrm>
             <a:off x="838200" y="4830217"/>
-            <a:ext cx="9419492" cy="996170"/>
+            <a:ext cx="9419492" cy="1900007"/>
           </a:xfrm>
           <a:prstGeom prst="rect">
             <a:avLst/>
@@ -13559,7 +13520,31 @@
             </a:r>
             <a:r>
               <a:rPr lang="en-US" sz="2800" dirty="0"/>
-              <a:t> can be awaited before using the Transport.</a:t>
+              <a:t> can be awaited before using the Transport:</a:t>
+            </a:r>
+          </a:p>
+          <a:p>
+            <a:pPr marL="685800" lvl="1" indent="-228600">
+              <a:lnSpc>
+                <a:spcPct val="90000"/>
+              </a:lnSpc>
+              <a:spcBef>
+                <a:spcPts val="1000"/>
+              </a:spcBef>
+              <a:buFont typeface="Arial" panose="020B0604020202020204" pitchFamily="34" charset="0"/>
+              <a:buChar char="•"/>
+            </a:pPr>
+            <a:r>
+              <a:rPr lang="en-US" sz="2800" dirty="0"/>
+              <a:t>At least one connection has been established </a:t>
+            </a:r>
+            <a:r>
+              <a:rPr lang="en-US" sz="2800" b="1" dirty="0"/>
+              <a:t>recently</a:t>
+            </a:r>
+            <a:r>
+              <a:rPr lang="en-US" sz="2800" dirty="0"/>
+              <a:t> with the other side</a:t>
             </a:r>
           </a:p>
         </p:txBody>

</xml_diff>

<commit_message>
No more PocoChannel: Cris must do the job.
</commit_message>
<xml_diff>
--- a/Doc/CK-AppIdentity.pptx
+++ b/Doc/CK-AppIdentity.pptx
@@ -5,7 +5,7 @@
     <p:sldMasterId id="2147483648" r:id="rId1"/>
   </p:sldMasterIdLst>
   <p:notesMasterIdLst>
-    <p:notesMasterId r:id="rId38"/>
+    <p:notesMasterId r:id="rId39"/>
   </p:notesMasterIdLst>
   <p:sldIdLst>
     <p:sldId id="256" r:id="rId2"/>
@@ -43,7 +43,8 @@
     <p:sldId id="290" r:id="rId34"/>
     <p:sldId id="291" r:id="rId35"/>
     <p:sldId id="292" r:id="rId36"/>
-    <p:sldId id="293" r:id="rId37"/>
+    <p:sldId id="294" r:id="rId37"/>
+    <p:sldId id="293" r:id="rId38"/>
   </p:sldIdLst>
   <p:sldSz cx="12192000" cy="6858000"/>
   <p:notesSz cx="6858000" cy="9144000"/>
@@ -17311,6 +17312,208 @@
 </file>
 
 <file path=ppt/slides/slide36.xml><?xml version="1.0" encoding="utf-8"?>
+<p:sld xmlns:a="http://schemas.openxmlformats.org/drawingml/2006/main" xmlns:r="http://schemas.openxmlformats.org/officeDocument/2006/relationships" xmlns:p="http://schemas.openxmlformats.org/presentationml/2006/main">
+  <p:cSld>
+    <p:spTree>
+      <p:nvGrpSpPr>
+        <p:cNvPr id="1" name=""/>
+        <p:cNvGrpSpPr/>
+        <p:nvPr/>
+      </p:nvGrpSpPr>
+      <p:grpSpPr>
+        <a:xfrm>
+          <a:off x="0" y="0"/>
+          <a:ext cx="0" cy="0"/>
+          <a:chOff x="0" y="0"/>
+          <a:chExt cx="0" cy="0"/>
+        </a:xfrm>
+      </p:grpSpPr>
+      <p:sp>
+        <p:nvSpPr>
+          <p:cNvPr id="2" name="Title 1">
+            <a:extLst>
+              <a:ext uri="{FF2B5EF4-FFF2-40B4-BE49-F238E27FC236}">
+                <a16:creationId xmlns:a16="http://schemas.microsoft.com/office/drawing/2014/main" id="{DEC82137-8E30-732F-A684-E7B1E4656A8E}"/>
+              </a:ext>
+            </a:extLst>
+          </p:cNvPr>
+          <p:cNvSpPr>
+            <a:spLocks noGrp="1"/>
+          </p:cNvSpPr>
+          <p:nvPr>
+            <p:ph type="title"/>
+          </p:nvPr>
+        </p:nvSpPr>
+        <p:spPr/>
+        <p:txBody>
+          <a:bodyPr/>
+          <a:lstStyle/>
+          <a:p>
+            <a:r>
+              <a:rPr lang="en-US" dirty="0" err="1"/>
+              <a:t>CrisSession</a:t>
+            </a:r>
+            <a:endParaRPr lang="en-US" dirty="0"/>
+          </a:p>
+        </p:txBody>
+      </p:sp>
+      <p:sp>
+        <p:nvSpPr>
+          <p:cNvPr id="3" name="Content Placeholder 2">
+            <a:extLst>
+              <a:ext uri="{FF2B5EF4-FFF2-40B4-BE49-F238E27FC236}">
+                <a16:creationId xmlns:a16="http://schemas.microsoft.com/office/drawing/2014/main" id="{1AE3B35E-C4A6-EA97-FFAD-FE9D1FB60395}"/>
+              </a:ext>
+            </a:extLst>
+          </p:cNvPr>
+          <p:cNvSpPr>
+            <a:spLocks noGrp="1"/>
+          </p:cNvSpPr>
+          <p:nvPr>
+            <p:ph idx="1"/>
+          </p:nvPr>
+        </p:nvSpPr>
+        <p:spPr/>
+        <p:txBody>
+          <a:bodyPr>
+            <a:normAutofit lnSpcReduction="10000"/>
+          </a:bodyPr>
+          <a:lstStyle/>
+          <a:p>
+            <a:r>
+              <a:rPr lang="en-US" dirty="0"/>
+              <a:t>Non concurrent, non reentrant (just like the </a:t>
+            </a:r>
+            <a:r>
+              <a:rPr lang="en-US" dirty="0" err="1"/>
+              <a:t>ActivityMonitor</a:t>
+            </a:r>
+            <a:r>
+              <a:rPr lang="en-US" dirty="0"/>
+              <a:t>)</a:t>
+            </a:r>
+          </a:p>
+          <a:p>
+            <a:r>
+              <a:rPr lang="en-US" dirty="0"/>
+              <a:t>Exposes a </a:t>
+            </a:r>
+            <a:r>
+              <a:rPr lang="en-US" dirty="0" err="1"/>
+              <a:t>ActivityMonitor</a:t>
+            </a:r>
+            <a:endParaRPr lang="en-US" dirty="0"/>
+          </a:p>
+          <a:p>
+            <a:r>
+              <a:rPr lang="en-US" dirty="0"/>
+              <a:t>Captures an initial command followed by events and subordinate sessions.</a:t>
+            </a:r>
+          </a:p>
+          <a:p>
+            <a:r>
+              <a:rPr lang="en-US" dirty="0"/>
+              <a:t>A session must be explicitly closed.</a:t>
+            </a:r>
+          </a:p>
+          <a:p>
+            <a:pPr lvl="1"/>
+            <a:r>
+              <a:rPr lang="en-US" dirty="0"/>
+              <a:t>This handles “Super Asynchronous” pattern:</a:t>
+            </a:r>
+          </a:p>
+          <a:p>
+            <a:pPr lvl="2"/>
+            <a:r>
+              <a:rPr lang="en-US" dirty="0"/>
+              <a:t>A “</a:t>
+            </a:r>
+            <a:r>
+              <a:rPr lang="en-US" dirty="0" err="1"/>
+              <a:t>StartXXX</a:t>
+            </a:r>
+            <a:r>
+              <a:rPr lang="en-US" dirty="0"/>
+              <a:t>” command starts a remote “activity”.</a:t>
+            </a:r>
+          </a:p>
+          <a:p>
+            <a:pPr lvl="2"/>
+            <a:r>
+              <a:rPr lang="en-US" dirty="0"/>
+              <a:t>A “</a:t>
+            </a:r>
+            <a:r>
+              <a:rPr lang="en-US" dirty="0" err="1"/>
+              <a:t>StopXXX</a:t>
+            </a:r>
+            <a:r>
+              <a:rPr lang="en-US" dirty="0"/>
+              <a:t>” command stops it.</a:t>
+            </a:r>
+          </a:p>
+          <a:p>
+            <a:pPr lvl="1"/>
+            <a:r>
+              <a:rPr lang="en-US" dirty="0"/>
+              <a:t>Optionally, the availability of the </a:t>
+            </a:r>
+            <a:r>
+              <a:rPr lang="en-US" dirty="0" err="1"/>
+              <a:t>TResult</a:t>
+            </a:r>
+            <a:r>
+              <a:rPr lang="en-US" dirty="0"/>
+              <a:t> of a </a:t>
+            </a:r>
+            <a:r>
+              <a:rPr lang="en-US" dirty="0" err="1"/>
+              <a:t>ICommand</a:t>
+            </a:r>
+            <a:r>
+              <a:rPr lang="en-US" dirty="0"/>
+              <a:t>&lt;</a:t>
+            </a:r>
+            <a:r>
+              <a:rPr lang="en-US" dirty="0" err="1"/>
+              <a:t>TResult</a:t>
+            </a:r>
+            <a:r>
+              <a:rPr lang="en-US" dirty="0"/>
+              <a:t>&gt; automatically closes the session.</a:t>
+            </a:r>
+          </a:p>
+          <a:p>
+            <a:r>
+              <a:rPr lang="en-US" dirty="0"/>
+              <a:t>A session seems to capture the result(s) of a </a:t>
+            </a:r>
+            <a:r>
+              <a:rPr lang="en-US" b="1" dirty="0"/>
+              <a:t>Workflow</a:t>
+            </a:r>
+            <a:r>
+              <a:rPr lang="en-US" dirty="0"/>
+              <a:t>!</a:t>
+            </a:r>
+          </a:p>
+        </p:txBody>
+      </p:sp>
+    </p:spTree>
+    <p:extLst>
+      <p:ext uri="{BB962C8B-B14F-4D97-AF65-F5344CB8AC3E}">
+        <p14:creationId xmlns:p14="http://schemas.microsoft.com/office/powerpoint/2010/main" val="125256644"/>
+      </p:ext>
+    </p:extLst>
+  </p:cSld>
+  <p:clrMapOvr>
+    <a:masterClrMapping/>
+  </p:clrMapOvr>
+</p:sld>
+</file>
+
+<file path=ppt/slides/slide37.xml><?xml version="1.0" encoding="utf-8"?>
 <p:sld xmlns:a="http://schemas.openxmlformats.org/drawingml/2006/main" xmlns:r="http://schemas.openxmlformats.org/officeDocument/2006/relationships" xmlns:p="http://schemas.openxmlformats.org/presentationml/2006/main">
   <p:cSld>
     <p:spTree>

</xml_diff>

<commit_message>
WIP. Adding comments and thoughts...
Forgot to mention previously that for a domain controller
name, it is the existence of the Address that determines if
we are on a RemoteParty vs. a DomainParty.

More generally "Address" and "Parties" are mutually exclusive.
To allow a DomainParty tio have no parties (that is weird), the
"Address" is the key.
</commit_message>
<xml_diff>
--- a/Doc/CK-AppIdentity.pptx
+++ b/Doc/CK-AppIdentity.pptx
@@ -5,7 +5,7 @@
     <p:sldMasterId id="2147483648" r:id="rId1"/>
   </p:sldMasterIdLst>
   <p:notesMasterIdLst>
-    <p:notesMasterId r:id="rId46"/>
+    <p:notesMasterId r:id="rId47"/>
   </p:notesMasterIdLst>
   <p:sldIdLst>
     <p:sldId id="256" r:id="rId2"/>
@@ -27,31 +27,32 @@
     <p:sldId id="303" r:id="rId18"/>
     <p:sldId id="274" r:id="rId19"/>
     <p:sldId id="275" r:id="rId20"/>
-    <p:sldId id="276" r:id="rId21"/>
-    <p:sldId id="277" r:id="rId22"/>
-    <p:sldId id="278" r:id="rId23"/>
-    <p:sldId id="279" r:id="rId24"/>
-    <p:sldId id="280" r:id="rId25"/>
-    <p:sldId id="282" r:id="rId26"/>
-    <p:sldId id="281" r:id="rId27"/>
-    <p:sldId id="283" r:id="rId28"/>
-    <p:sldId id="284" r:id="rId29"/>
-    <p:sldId id="285" r:id="rId30"/>
-    <p:sldId id="286" r:id="rId31"/>
-    <p:sldId id="287" r:id="rId32"/>
-    <p:sldId id="288" r:id="rId33"/>
-    <p:sldId id="289" r:id="rId34"/>
-    <p:sldId id="290" r:id="rId35"/>
-    <p:sldId id="297" r:id="rId36"/>
-    <p:sldId id="298" r:id="rId37"/>
-    <p:sldId id="299" r:id="rId38"/>
-    <p:sldId id="300" r:id="rId39"/>
-    <p:sldId id="301" r:id="rId40"/>
-    <p:sldId id="302" r:id="rId41"/>
-    <p:sldId id="291" r:id="rId42"/>
-    <p:sldId id="292" r:id="rId43"/>
-    <p:sldId id="294" r:id="rId44"/>
-    <p:sldId id="293" r:id="rId45"/>
+    <p:sldId id="304" r:id="rId21"/>
+    <p:sldId id="276" r:id="rId22"/>
+    <p:sldId id="277" r:id="rId23"/>
+    <p:sldId id="278" r:id="rId24"/>
+    <p:sldId id="279" r:id="rId25"/>
+    <p:sldId id="280" r:id="rId26"/>
+    <p:sldId id="282" r:id="rId27"/>
+    <p:sldId id="281" r:id="rId28"/>
+    <p:sldId id="283" r:id="rId29"/>
+    <p:sldId id="284" r:id="rId30"/>
+    <p:sldId id="285" r:id="rId31"/>
+    <p:sldId id="286" r:id="rId32"/>
+    <p:sldId id="287" r:id="rId33"/>
+    <p:sldId id="288" r:id="rId34"/>
+    <p:sldId id="289" r:id="rId35"/>
+    <p:sldId id="290" r:id="rId36"/>
+    <p:sldId id="297" r:id="rId37"/>
+    <p:sldId id="298" r:id="rId38"/>
+    <p:sldId id="299" r:id="rId39"/>
+    <p:sldId id="300" r:id="rId40"/>
+    <p:sldId id="301" r:id="rId41"/>
+    <p:sldId id="302" r:id="rId42"/>
+    <p:sldId id="291" r:id="rId43"/>
+    <p:sldId id="292" r:id="rId44"/>
+    <p:sldId id="294" r:id="rId45"/>
+    <p:sldId id="293" r:id="rId46"/>
   </p:sldIdLst>
   <p:sldSz cx="12192000" cy="6858000"/>
   <p:notesSz cx="6858000" cy="9144000"/>
@@ -770,7 +771,7 @@
           <a:p>
             <a:fld id="{E05EDB92-2FE2-4164-AA27-D03258A20DF4}" type="slidenum">
               <a:rPr lang="en-US" smtClean="0"/>
-              <a:t>21</a:t>
+              <a:t>22</a:t>
             </a:fld>
             <a:endParaRPr lang="en-US"/>
           </a:p>
@@ -854,7 +855,7 @@
           <a:p>
             <a:fld id="{E05EDB92-2FE2-4164-AA27-D03258A20DF4}" type="slidenum">
               <a:rPr lang="en-US" smtClean="0"/>
-              <a:t>22</a:t>
+              <a:t>23</a:t>
             </a:fld>
             <a:endParaRPr lang="en-US"/>
           </a:p>
@@ -952,7 +953,7 @@
           <a:p>
             <a:fld id="{E05EDB92-2FE2-4164-AA27-D03258A20DF4}" type="slidenum">
               <a:rPr lang="en-US" smtClean="0"/>
-              <a:t>25</a:t>
+              <a:t>26</a:t>
             </a:fld>
             <a:endParaRPr lang="en-US"/>
           </a:p>
@@ -1058,7 +1059,7 @@
           <a:p>
             <a:fld id="{E05EDB92-2FE2-4164-AA27-D03258A20DF4}" type="slidenum">
               <a:rPr lang="en-US" smtClean="0"/>
-              <a:t>27</a:t>
+              <a:t>28</a:t>
             </a:fld>
             <a:endParaRPr lang="en-US"/>
           </a:p>
@@ -1523,7 +1524,7 @@
           <a:p>
             <a:fld id="{E05EDB92-2FE2-4164-AA27-D03258A20DF4}" type="slidenum">
               <a:rPr lang="en-US" smtClean="0"/>
-              <a:t>28</a:t>
+              <a:t>29</a:t>
             </a:fld>
             <a:endParaRPr lang="en-US"/>
           </a:p>
@@ -1728,7 +1729,7 @@
           <a:p>
             <a:fld id="{E05EDB92-2FE2-4164-AA27-D03258A20DF4}" type="slidenum">
               <a:rPr lang="en-US" smtClean="0"/>
-              <a:t>29</a:t>
+              <a:t>30</a:t>
             </a:fld>
             <a:endParaRPr lang="en-US"/>
           </a:p>
@@ -1812,7 +1813,7 @@
           <a:p>
             <a:fld id="{E05EDB92-2FE2-4164-AA27-D03258A20DF4}" type="slidenum">
               <a:rPr lang="en-US" smtClean="0"/>
-              <a:t>31</a:t>
+              <a:t>32</a:t>
             </a:fld>
             <a:endParaRPr lang="en-US"/>
           </a:p>
@@ -1896,7 +1897,7 @@
           <a:p>
             <a:fld id="{E05EDB92-2FE2-4164-AA27-D03258A20DF4}" type="slidenum">
               <a:rPr lang="en-US" smtClean="0"/>
-              <a:t>32</a:t>
+              <a:t>33</a:t>
             </a:fld>
             <a:endParaRPr lang="en-US"/>
           </a:p>
@@ -7256,7 +7257,7 @@
             </a:r>
             <a:r>
               <a:rPr lang="en-US" dirty="0"/>
-              <a:t>"</a:t>
+              <a:t>",</a:t>
             </a:r>
           </a:p>
           <a:p>
@@ -7873,8 +7874,8 @@
         </p:nvSpPr>
         <p:spPr>
           <a:xfrm>
-            <a:off x="654838" y="1690688"/>
-            <a:ext cx="4100042" cy="3108543"/>
+            <a:off x="654837" y="1690688"/>
+            <a:ext cx="5347929" cy="2462213"/>
           </a:xfrm>
           <a:prstGeom prst="rect">
             <a:avLst/>
@@ -7985,7 +7986,7 @@
                 <a:latin typeface="Courier New" panose="02070309020205020404" pitchFamily="49" charset="0"/>
                 <a:cs typeface="Courier New" panose="02070309020205020404" pitchFamily="49" charset="0"/>
               </a:rPr>
-              <a:t>DomainName</a:t>
+              <a:t>FullName</a:t>
             </a:r>
             <a:r>
               <a:rPr lang="en-US" sz="1400" dirty="0">
@@ -7995,7 +7996,7 @@
               <a:t>": "</a:t>
             </a:r>
             <a:r>
-              <a:rPr lang="en-US" sz="1400" b="1" dirty="0" err="1">
+              <a:rPr lang="en-US" sz="1400" dirty="0" err="1">
                 <a:latin typeface="Courier New" panose="02070309020205020404" pitchFamily="49" charset="0"/>
                 <a:cs typeface="Courier New" panose="02070309020205020404" pitchFamily="49" charset="0"/>
               </a:rPr>
@@ -8006,6 +8007,20 @@
                 <a:latin typeface="Courier New" panose="02070309020205020404" pitchFamily="49" charset="0"/>
                 <a:cs typeface="Courier New" panose="02070309020205020404" pitchFamily="49" charset="0"/>
               </a:rPr>
+              <a:t>/$</a:t>
+            </a:r>
+            <a:r>
+              <a:rPr lang="en-US" sz="1400" dirty="0" err="1">
+                <a:latin typeface="Courier New" panose="02070309020205020404" pitchFamily="49" charset="0"/>
+                <a:cs typeface="Courier New" panose="02070309020205020404" pitchFamily="49" charset="0"/>
+              </a:rPr>
+              <a:t>LaToulousaine</a:t>
+            </a:r>
+            <a:r>
+              <a:rPr lang="en-US" sz="1400" dirty="0">
+                <a:latin typeface="Courier New" panose="02070309020205020404" pitchFamily="49" charset="0"/>
+                <a:cs typeface="Courier New" panose="02070309020205020404" pitchFamily="49" charset="0"/>
+              </a:rPr>
               <a:t>",</a:t>
             </a:r>
           </a:p>
@@ -8033,98 +8048,36 @@
                 <a:latin typeface="Courier New" panose="02070309020205020404" pitchFamily="49" charset="0"/>
                 <a:cs typeface="Courier New" panose="02070309020205020404" pitchFamily="49" charset="0"/>
               </a:rPr>
-              <a:t>      </a:t>
-            </a:r>
-            <a:r>
-              <a:rPr lang="en-US" sz="1400" b="1" dirty="0">
+              <a:t>      "</a:t>
+            </a:r>
+            <a:r>
+              <a:rPr lang="en-US" sz="1400" dirty="0" err="1">
+                <a:latin typeface="Courier New" panose="02070309020205020404" pitchFamily="49" charset="0"/>
+                <a:cs typeface="Courier New" panose="02070309020205020404" pitchFamily="49" charset="0"/>
+              </a:rPr>
+              <a:t>PartyName</a:t>
+            </a:r>
+            <a:r>
+              <a:rPr lang="en-US" sz="1400" dirty="0">
+                <a:latin typeface="Courier New" panose="02070309020205020404" pitchFamily="49" charset="0"/>
+                <a:cs typeface="Courier New" panose="02070309020205020404" pitchFamily="49" charset="0"/>
+              </a:rPr>
+              <a:t>": "$</a:t>
+            </a:r>
+            <a:r>
+              <a:rPr lang="en-US" sz="1400" dirty="0" err="1">
+                <a:latin typeface="Courier New" panose="02070309020205020404" pitchFamily="49" charset="0"/>
+                <a:cs typeface="Courier New" panose="02070309020205020404" pitchFamily="49" charset="0"/>
+              </a:rPr>
+              <a:t>SignatureBox</a:t>
+            </a:r>
+            <a:r>
+              <a:rPr lang="en-US" sz="1400" dirty="0">
                 <a:latin typeface="Courier New" panose="02070309020205020404" pitchFamily="49" charset="0"/>
                 <a:cs typeface="Courier New" panose="02070309020205020404" pitchFamily="49" charset="0"/>
               </a:rPr>
               <a:t>"</a:t>
             </a:r>
-            <a:r>
-              <a:rPr lang="en-US" sz="1400" b="1" dirty="0" err="1">
-                <a:latin typeface="Courier New" panose="02070309020205020404" pitchFamily="49" charset="0"/>
-                <a:cs typeface="Courier New" panose="02070309020205020404" pitchFamily="49" charset="0"/>
-              </a:rPr>
-              <a:t>PartyName</a:t>
-            </a:r>
-            <a:r>
-              <a:rPr lang="en-US" sz="1400" b="1" dirty="0">
-                <a:latin typeface="Courier New" panose="02070309020205020404" pitchFamily="49" charset="0"/>
-                <a:cs typeface="Courier New" panose="02070309020205020404" pitchFamily="49" charset="0"/>
-              </a:rPr>
-              <a:t>": "$</a:t>
-            </a:r>
-            <a:r>
-              <a:rPr lang="en-US" sz="1400" b="1" dirty="0" err="1">
-                <a:latin typeface="Courier New" panose="02070309020205020404" pitchFamily="49" charset="0"/>
-                <a:cs typeface="Courier New" panose="02070309020205020404" pitchFamily="49" charset="0"/>
-              </a:rPr>
-              <a:t>LaToulousaine</a:t>
-            </a:r>
-            <a:r>
-              <a:rPr lang="en-US" sz="1400" b="1" dirty="0">
-                <a:latin typeface="Courier New" panose="02070309020205020404" pitchFamily="49" charset="0"/>
-                <a:cs typeface="Courier New" panose="02070309020205020404" pitchFamily="49" charset="0"/>
-              </a:rPr>
-              <a:t>"</a:t>
-            </a:r>
-          </a:p>
-          <a:p>
-            <a:r>
-              <a:rPr lang="en-US" sz="1400" dirty="0">
-                <a:latin typeface="Courier New" panose="02070309020205020404" pitchFamily="49" charset="0"/>
-                <a:cs typeface="Courier New" panose="02070309020205020404" pitchFamily="49" charset="0"/>
-              </a:rPr>
-              <a:t>    },</a:t>
-            </a:r>
-          </a:p>
-          <a:p>
-            <a:r>
-              <a:rPr lang="en-US" sz="1400" dirty="0">
-                <a:latin typeface="Courier New" panose="02070309020205020404" pitchFamily="49" charset="0"/>
-                <a:cs typeface="Courier New" panose="02070309020205020404" pitchFamily="49" charset="0"/>
-              </a:rPr>
-              <a:t>    {</a:t>
-            </a:r>
-          </a:p>
-          <a:p>
-            <a:r>
-              <a:rPr lang="en-US" sz="1400" dirty="0">
-                <a:latin typeface="Courier New" panose="02070309020205020404" pitchFamily="49" charset="0"/>
-                <a:cs typeface="Courier New" panose="02070309020205020404" pitchFamily="49" charset="0"/>
-              </a:rPr>
-              <a:t>      "</a:t>
-            </a:r>
-            <a:r>
-              <a:rPr lang="en-US" sz="1400" dirty="0" err="1">
-                <a:latin typeface="Courier New" panose="02070309020205020404" pitchFamily="49" charset="0"/>
-                <a:cs typeface="Courier New" panose="02070309020205020404" pitchFamily="49" charset="0"/>
-              </a:rPr>
-              <a:t>PartyName</a:t>
-            </a:r>
-            <a:r>
-              <a:rPr lang="en-US" sz="1400" dirty="0">
-                <a:latin typeface="Courier New" panose="02070309020205020404" pitchFamily="49" charset="0"/>
-                <a:cs typeface="Courier New" panose="02070309020205020404" pitchFamily="49" charset="0"/>
-              </a:rPr>
-              <a:t>": "$</a:t>
-            </a:r>
-            <a:r>
-              <a:rPr lang="en-US" sz="1400" dirty="0" err="1">
-                <a:latin typeface="Courier New" panose="02070309020205020404" pitchFamily="49" charset="0"/>
-                <a:cs typeface="Courier New" panose="02070309020205020404" pitchFamily="49" charset="0"/>
-              </a:rPr>
-              <a:t>SignatureBox</a:t>
-            </a:r>
-            <a:r>
-              <a:rPr lang="en-US" sz="1400" dirty="0">
-                <a:latin typeface="Courier New" panose="02070309020205020404" pitchFamily="49" charset="0"/>
-                <a:cs typeface="Courier New" panose="02070309020205020404" pitchFamily="49" charset="0"/>
-              </a:rPr>
-              <a:t>"</a:t>
-            </a:r>
           </a:p>
           <a:p>
             <a:r>
@@ -8151,58 +8104,6 @@
                 <a:cs typeface="Courier New" panose="02070309020205020404" pitchFamily="49" charset="0"/>
               </a:rPr>
               <a:t>}</a:t>
-            </a:r>
-          </a:p>
-        </p:txBody>
-      </p:sp>
-      <p:sp>
-        <p:nvSpPr>
-          <p:cNvPr id="15" name="Callout: Line 14">
-            <a:extLst>
-              <a:ext uri="{FF2B5EF4-FFF2-40B4-BE49-F238E27FC236}">
-                <a16:creationId xmlns:a16="http://schemas.microsoft.com/office/drawing/2014/main" id="{FF13DBD5-8C06-09FE-57BC-171777836FD4}"/>
-              </a:ext>
-            </a:extLst>
-          </p:cNvPr>
-          <p:cNvSpPr/>
-          <p:nvPr/>
-        </p:nvSpPr>
-        <p:spPr>
-          <a:xfrm>
-            <a:off x="8499622" y="5750778"/>
-            <a:ext cx="1466552" cy="579120"/>
-          </a:xfrm>
-          <a:prstGeom prst="borderCallout1">
-            <a:avLst>
-              <a:gd name="adj1" fmla="val -4057"/>
-              <a:gd name="adj2" fmla="val 47711"/>
-              <a:gd name="adj3" fmla="val -64693"/>
-              <a:gd name="adj4" fmla="val 47859"/>
-            </a:avLst>
-          </a:prstGeom>
-        </p:spPr>
-        <p:style>
-          <a:lnRef idx="2">
-            <a:schemeClr val="dk1"/>
-          </a:lnRef>
-          <a:fillRef idx="1">
-            <a:schemeClr val="lt1"/>
-          </a:fillRef>
-          <a:effectRef idx="0">
-            <a:schemeClr val="dk1"/>
-          </a:effectRef>
-          <a:fontRef idx="minor">
-            <a:schemeClr val="dk1"/>
-          </a:fontRef>
-        </p:style>
-        <p:txBody>
-          <a:bodyPr rtlCol="0" anchor="ctr"/>
-          <a:lstStyle/>
-          <a:p>
-            <a:pPr algn="ctr"/>
-            <a:r>
-              <a:rPr lang="en-US" dirty="0"/>
-              <a:t>No Change!</a:t>
             </a:r>
           </a:p>
         </p:txBody>
@@ -8306,6 +8207,707 @@
             <a:r>
               <a:rPr lang="en-US" dirty="0"/>
               <a:t>” is now hosted.</a:t>
+            </a:r>
+          </a:p>
+        </p:txBody>
+      </p:sp>
+      <p:sp>
+        <p:nvSpPr>
+          <p:cNvPr id="7" name="Rectangle 6">
+            <a:extLst>
+              <a:ext uri="{FF2B5EF4-FFF2-40B4-BE49-F238E27FC236}">
+                <a16:creationId xmlns:a16="http://schemas.microsoft.com/office/drawing/2014/main" id="{876621B1-1DCC-0779-5BE9-1D9091CDB19A}"/>
+              </a:ext>
+            </a:extLst>
+          </p:cNvPr>
+          <p:cNvSpPr/>
+          <p:nvPr/>
+        </p:nvSpPr>
+        <p:spPr>
+          <a:xfrm>
+            <a:off x="6793041" y="1690688"/>
+            <a:ext cx="4733364" cy="3754874"/>
+          </a:xfrm>
+          <a:custGeom>
+            <a:avLst/>
+            <a:gdLst>
+              <a:gd name="connsiteX0" fmla="*/ 0 w 4733364"/>
+              <a:gd name="connsiteY0" fmla="*/ 0 h 3754874"/>
+              <a:gd name="connsiteX1" fmla="*/ 544337 w 4733364"/>
+              <a:gd name="connsiteY1" fmla="*/ 0 h 3754874"/>
+              <a:gd name="connsiteX2" fmla="*/ 994006 w 4733364"/>
+              <a:gd name="connsiteY2" fmla="*/ 0 h 3754874"/>
+              <a:gd name="connsiteX3" fmla="*/ 1680344 w 4733364"/>
+              <a:gd name="connsiteY3" fmla="*/ 0 h 3754874"/>
+              <a:gd name="connsiteX4" fmla="*/ 2224681 w 4733364"/>
+              <a:gd name="connsiteY4" fmla="*/ 0 h 3754874"/>
+              <a:gd name="connsiteX5" fmla="*/ 2769018 w 4733364"/>
+              <a:gd name="connsiteY5" fmla="*/ 0 h 3754874"/>
+              <a:gd name="connsiteX6" fmla="*/ 3455356 w 4733364"/>
+              <a:gd name="connsiteY6" fmla="*/ 0 h 3754874"/>
+              <a:gd name="connsiteX7" fmla="*/ 3952359 w 4733364"/>
+              <a:gd name="connsiteY7" fmla="*/ 0 h 3754874"/>
+              <a:gd name="connsiteX8" fmla="*/ 4733364 w 4733364"/>
+              <a:gd name="connsiteY8" fmla="*/ 0 h 3754874"/>
+              <a:gd name="connsiteX9" fmla="*/ 4733364 w 4733364"/>
+              <a:gd name="connsiteY9" fmla="*/ 611508 h 3754874"/>
+              <a:gd name="connsiteX10" fmla="*/ 4733364 w 4733364"/>
+              <a:gd name="connsiteY10" fmla="*/ 1072821 h 3754874"/>
+              <a:gd name="connsiteX11" fmla="*/ 4733364 w 4733364"/>
+              <a:gd name="connsiteY11" fmla="*/ 1609232 h 3754874"/>
+              <a:gd name="connsiteX12" fmla="*/ 4733364 w 4733364"/>
+              <a:gd name="connsiteY12" fmla="*/ 2183191 h 3754874"/>
+              <a:gd name="connsiteX13" fmla="*/ 4733364 w 4733364"/>
+              <a:gd name="connsiteY13" fmla="*/ 2606955 h 3754874"/>
+              <a:gd name="connsiteX14" fmla="*/ 4733364 w 4733364"/>
+              <a:gd name="connsiteY14" fmla="*/ 3143366 h 3754874"/>
+              <a:gd name="connsiteX15" fmla="*/ 4733364 w 4733364"/>
+              <a:gd name="connsiteY15" fmla="*/ 3754874 h 3754874"/>
+              <a:gd name="connsiteX16" fmla="*/ 4141694 w 4733364"/>
+              <a:gd name="connsiteY16" fmla="*/ 3754874 h 3754874"/>
+              <a:gd name="connsiteX17" fmla="*/ 3455356 w 4733364"/>
+              <a:gd name="connsiteY17" fmla="*/ 3754874 h 3754874"/>
+              <a:gd name="connsiteX18" fmla="*/ 2863685 w 4733364"/>
+              <a:gd name="connsiteY18" fmla="*/ 3754874 h 3754874"/>
+              <a:gd name="connsiteX19" fmla="*/ 2414016 w 4733364"/>
+              <a:gd name="connsiteY19" fmla="*/ 3754874 h 3754874"/>
+              <a:gd name="connsiteX20" fmla="*/ 1917012 w 4733364"/>
+              <a:gd name="connsiteY20" fmla="*/ 3754874 h 3754874"/>
+              <a:gd name="connsiteX21" fmla="*/ 1230675 w 4733364"/>
+              <a:gd name="connsiteY21" fmla="*/ 3754874 h 3754874"/>
+              <a:gd name="connsiteX22" fmla="*/ 639004 w 4733364"/>
+              <a:gd name="connsiteY22" fmla="*/ 3754874 h 3754874"/>
+              <a:gd name="connsiteX23" fmla="*/ 0 w 4733364"/>
+              <a:gd name="connsiteY23" fmla="*/ 3754874 h 3754874"/>
+              <a:gd name="connsiteX24" fmla="*/ 0 w 4733364"/>
+              <a:gd name="connsiteY24" fmla="*/ 3218463 h 3754874"/>
+              <a:gd name="connsiteX25" fmla="*/ 0 w 4733364"/>
+              <a:gd name="connsiteY25" fmla="*/ 2794699 h 3754874"/>
+              <a:gd name="connsiteX26" fmla="*/ 0 w 4733364"/>
+              <a:gd name="connsiteY26" fmla="*/ 2370935 h 3754874"/>
+              <a:gd name="connsiteX27" fmla="*/ 0 w 4733364"/>
+              <a:gd name="connsiteY27" fmla="*/ 1796975 h 3754874"/>
+              <a:gd name="connsiteX28" fmla="*/ 0 w 4733364"/>
+              <a:gd name="connsiteY28" fmla="*/ 1335662 h 3754874"/>
+              <a:gd name="connsiteX29" fmla="*/ 0 w 4733364"/>
+              <a:gd name="connsiteY29" fmla="*/ 724154 h 3754874"/>
+              <a:gd name="connsiteX30" fmla="*/ 0 w 4733364"/>
+              <a:gd name="connsiteY30" fmla="*/ 0 h 3754874"/>
+            </a:gdLst>
+            <a:ahLst/>
+            <a:cxnLst>
+              <a:cxn ang="0">
+                <a:pos x="connsiteX0" y="connsiteY0"/>
+              </a:cxn>
+              <a:cxn ang="0">
+                <a:pos x="connsiteX1" y="connsiteY1"/>
+              </a:cxn>
+              <a:cxn ang="0">
+                <a:pos x="connsiteX2" y="connsiteY2"/>
+              </a:cxn>
+              <a:cxn ang="0">
+                <a:pos x="connsiteX3" y="connsiteY3"/>
+              </a:cxn>
+              <a:cxn ang="0">
+                <a:pos x="connsiteX4" y="connsiteY4"/>
+              </a:cxn>
+              <a:cxn ang="0">
+                <a:pos x="connsiteX5" y="connsiteY5"/>
+              </a:cxn>
+              <a:cxn ang="0">
+                <a:pos x="connsiteX6" y="connsiteY6"/>
+              </a:cxn>
+              <a:cxn ang="0">
+                <a:pos x="connsiteX7" y="connsiteY7"/>
+              </a:cxn>
+              <a:cxn ang="0">
+                <a:pos x="connsiteX8" y="connsiteY8"/>
+              </a:cxn>
+              <a:cxn ang="0">
+                <a:pos x="connsiteX9" y="connsiteY9"/>
+              </a:cxn>
+              <a:cxn ang="0">
+                <a:pos x="connsiteX10" y="connsiteY10"/>
+              </a:cxn>
+              <a:cxn ang="0">
+                <a:pos x="connsiteX11" y="connsiteY11"/>
+              </a:cxn>
+              <a:cxn ang="0">
+                <a:pos x="connsiteX12" y="connsiteY12"/>
+              </a:cxn>
+              <a:cxn ang="0">
+                <a:pos x="connsiteX13" y="connsiteY13"/>
+              </a:cxn>
+              <a:cxn ang="0">
+                <a:pos x="connsiteX14" y="connsiteY14"/>
+              </a:cxn>
+              <a:cxn ang="0">
+                <a:pos x="connsiteX15" y="connsiteY15"/>
+              </a:cxn>
+              <a:cxn ang="0">
+                <a:pos x="connsiteX16" y="connsiteY16"/>
+              </a:cxn>
+              <a:cxn ang="0">
+                <a:pos x="connsiteX17" y="connsiteY17"/>
+              </a:cxn>
+              <a:cxn ang="0">
+                <a:pos x="connsiteX18" y="connsiteY18"/>
+              </a:cxn>
+              <a:cxn ang="0">
+                <a:pos x="connsiteX19" y="connsiteY19"/>
+              </a:cxn>
+              <a:cxn ang="0">
+                <a:pos x="connsiteX20" y="connsiteY20"/>
+              </a:cxn>
+              <a:cxn ang="0">
+                <a:pos x="connsiteX21" y="connsiteY21"/>
+              </a:cxn>
+              <a:cxn ang="0">
+                <a:pos x="connsiteX22" y="connsiteY22"/>
+              </a:cxn>
+              <a:cxn ang="0">
+                <a:pos x="connsiteX23" y="connsiteY23"/>
+              </a:cxn>
+              <a:cxn ang="0">
+                <a:pos x="connsiteX24" y="connsiteY24"/>
+              </a:cxn>
+              <a:cxn ang="0">
+                <a:pos x="connsiteX25" y="connsiteY25"/>
+              </a:cxn>
+              <a:cxn ang="0">
+                <a:pos x="connsiteX26" y="connsiteY26"/>
+              </a:cxn>
+              <a:cxn ang="0">
+                <a:pos x="connsiteX27" y="connsiteY27"/>
+              </a:cxn>
+              <a:cxn ang="0">
+                <a:pos x="connsiteX28" y="connsiteY28"/>
+              </a:cxn>
+              <a:cxn ang="0">
+                <a:pos x="connsiteX29" y="connsiteY29"/>
+              </a:cxn>
+              <a:cxn ang="0">
+                <a:pos x="connsiteX30" y="connsiteY30"/>
+              </a:cxn>
+            </a:cxnLst>
+            <a:rect l="l" t="t" r="r" b="b"/>
+            <a:pathLst>
+              <a:path w="4733364" h="3754874" extrusionOk="0">
+                <a:moveTo>
+                  <a:pt x="0" y="0"/>
+                </a:moveTo>
+                <a:cubicBezTo>
+                  <a:pt x="229468" y="-50895"/>
+                  <a:pt x="294370" y="35903"/>
+                  <a:pt x="544337" y="0"/>
+                </a:cubicBezTo>
+                <a:cubicBezTo>
+                  <a:pt x="794304" y="-35903"/>
+                  <a:pt x="820079" y="34170"/>
+                  <a:pt x="994006" y="0"/>
+                </a:cubicBezTo>
+                <a:cubicBezTo>
+                  <a:pt x="1167933" y="-34170"/>
+                  <a:pt x="1374133" y="58138"/>
+                  <a:pt x="1680344" y="0"/>
+                </a:cubicBezTo>
+                <a:cubicBezTo>
+                  <a:pt x="1986555" y="-58138"/>
+                  <a:pt x="2046752" y="42581"/>
+                  <a:pt x="2224681" y="0"/>
+                </a:cubicBezTo>
+                <a:cubicBezTo>
+                  <a:pt x="2402610" y="-42581"/>
+                  <a:pt x="2583036" y="36101"/>
+                  <a:pt x="2769018" y="0"/>
+                </a:cubicBezTo>
+                <a:cubicBezTo>
+                  <a:pt x="2955000" y="-36101"/>
+                  <a:pt x="3247585" y="49086"/>
+                  <a:pt x="3455356" y="0"/>
+                </a:cubicBezTo>
+                <a:cubicBezTo>
+                  <a:pt x="3663127" y="-49086"/>
+                  <a:pt x="3818168" y="55487"/>
+                  <a:pt x="3952359" y="0"/>
+                </a:cubicBezTo>
+                <a:cubicBezTo>
+                  <a:pt x="4086550" y="-55487"/>
+                  <a:pt x="4361088" y="71153"/>
+                  <a:pt x="4733364" y="0"/>
+                </a:cubicBezTo>
+                <a:cubicBezTo>
+                  <a:pt x="4749522" y="123515"/>
+                  <a:pt x="4685277" y="353000"/>
+                  <a:pt x="4733364" y="611508"/>
+                </a:cubicBezTo>
+                <a:cubicBezTo>
+                  <a:pt x="4781451" y="870016"/>
+                  <a:pt x="4679557" y="972846"/>
+                  <a:pt x="4733364" y="1072821"/>
+                </a:cubicBezTo>
+                <a:cubicBezTo>
+                  <a:pt x="4787171" y="1172796"/>
+                  <a:pt x="4697483" y="1382836"/>
+                  <a:pt x="4733364" y="1609232"/>
+                </a:cubicBezTo>
+                <a:cubicBezTo>
+                  <a:pt x="4769245" y="1835628"/>
+                  <a:pt x="4697524" y="2027386"/>
+                  <a:pt x="4733364" y="2183191"/>
+                </a:cubicBezTo>
+                <a:cubicBezTo>
+                  <a:pt x="4769204" y="2338996"/>
+                  <a:pt x="4727974" y="2427041"/>
+                  <a:pt x="4733364" y="2606955"/>
+                </a:cubicBezTo>
+                <a:cubicBezTo>
+                  <a:pt x="4738754" y="2786869"/>
+                  <a:pt x="4733228" y="2965049"/>
+                  <a:pt x="4733364" y="3143366"/>
+                </a:cubicBezTo>
+                <a:cubicBezTo>
+                  <a:pt x="4733500" y="3321683"/>
+                  <a:pt x="4668483" y="3520497"/>
+                  <a:pt x="4733364" y="3754874"/>
+                </a:cubicBezTo>
+                <a:cubicBezTo>
+                  <a:pt x="4525963" y="3774907"/>
+                  <a:pt x="4436615" y="3711015"/>
+                  <a:pt x="4141694" y="3754874"/>
+                </a:cubicBezTo>
+                <a:cubicBezTo>
+                  <a:pt x="3846773" y="3798733"/>
+                  <a:pt x="3793273" y="3675467"/>
+                  <a:pt x="3455356" y="3754874"/>
+                </a:cubicBezTo>
+                <a:cubicBezTo>
+                  <a:pt x="3117439" y="3834281"/>
+                  <a:pt x="3117900" y="3743300"/>
+                  <a:pt x="2863685" y="3754874"/>
+                </a:cubicBezTo>
+                <a:cubicBezTo>
+                  <a:pt x="2609470" y="3766448"/>
+                  <a:pt x="2551397" y="3712888"/>
+                  <a:pt x="2414016" y="3754874"/>
+                </a:cubicBezTo>
+                <a:cubicBezTo>
+                  <a:pt x="2276635" y="3796860"/>
+                  <a:pt x="2026307" y="3697298"/>
+                  <a:pt x="1917012" y="3754874"/>
+                </a:cubicBezTo>
+                <a:cubicBezTo>
+                  <a:pt x="1807717" y="3812450"/>
+                  <a:pt x="1498914" y="3753701"/>
+                  <a:pt x="1230675" y="3754874"/>
+                </a:cubicBezTo>
+                <a:cubicBezTo>
+                  <a:pt x="962436" y="3756047"/>
+                  <a:pt x="901520" y="3748643"/>
+                  <a:pt x="639004" y="3754874"/>
+                </a:cubicBezTo>
+                <a:cubicBezTo>
+                  <a:pt x="376488" y="3761105"/>
+                  <a:pt x="174782" y="3752861"/>
+                  <a:pt x="0" y="3754874"/>
+                </a:cubicBezTo>
+                <a:cubicBezTo>
+                  <a:pt x="-53902" y="3605730"/>
+                  <a:pt x="60600" y="3338802"/>
+                  <a:pt x="0" y="3218463"/>
+                </a:cubicBezTo>
+                <a:cubicBezTo>
+                  <a:pt x="-60600" y="3098124"/>
+                  <a:pt x="43054" y="2892626"/>
+                  <a:pt x="0" y="2794699"/>
+                </a:cubicBezTo>
+                <a:cubicBezTo>
+                  <a:pt x="-43054" y="2696772"/>
+                  <a:pt x="46355" y="2470556"/>
+                  <a:pt x="0" y="2370935"/>
+                </a:cubicBezTo>
+                <a:cubicBezTo>
+                  <a:pt x="-46355" y="2271314"/>
+                  <a:pt x="20903" y="1997827"/>
+                  <a:pt x="0" y="1796975"/>
+                </a:cubicBezTo>
+                <a:cubicBezTo>
+                  <a:pt x="-20903" y="1596123"/>
+                  <a:pt x="31988" y="1460266"/>
+                  <a:pt x="0" y="1335662"/>
+                </a:cubicBezTo>
+                <a:cubicBezTo>
+                  <a:pt x="-31988" y="1211058"/>
+                  <a:pt x="37542" y="864533"/>
+                  <a:pt x="0" y="724154"/>
+                </a:cubicBezTo>
+                <a:cubicBezTo>
+                  <a:pt x="-37542" y="583775"/>
+                  <a:pt x="7023" y="181575"/>
+                  <a:pt x="0" y="0"/>
+                </a:cubicBezTo>
+                <a:close/>
+              </a:path>
+            </a:pathLst>
+          </a:custGeom>
+          <a:noFill/>
+          <a:ln>
+            <a:prstDash val="sysDash"/>
+            <a:extLst>
+              <a:ext uri="{C807C97D-BFC1-408E-A445-0C87EB9F89A2}">
+                <ask:lineSketchStyleProps xmlns:ask="http://schemas.microsoft.com/office/drawing/2018/sketchyshapes" sd="1219033472">
+                  <a:prstGeom prst="rect">
+                    <a:avLst/>
+                  </a:prstGeom>
+                  <ask:type>
+                    <ask:lineSketchScribble/>
+                  </ask:type>
+                </ask:lineSketchStyleProps>
+              </a:ext>
+            </a:extLst>
+          </a:ln>
+        </p:spPr>
+        <p:style>
+          <a:lnRef idx="2">
+            <a:schemeClr val="accent1">
+              <a:shade val="15000"/>
+            </a:schemeClr>
+          </a:lnRef>
+          <a:fillRef idx="1">
+            <a:schemeClr val="accent1"/>
+          </a:fillRef>
+          <a:effectRef idx="0">
+            <a:schemeClr val="accent1"/>
+          </a:effectRef>
+          <a:fontRef idx="minor">
+            <a:schemeClr val="lt1"/>
+          </a:fontRef>
+        </p:style>
+        <p:txBody>
+          <a:bodyPr rtlCol="0" anchor="ctr"/>
+          <a:lstStyle/>
+          <a:p>
+            <a:pPr algn="ctr"/>
+            <a:endParaRPr lang="en-US"/>
+          </a:p>
+        </p:txBody>
+      </p:sp>
+      <p:sp>
+        <p:nvSpPr>
+          <p:cNvPr id="6" name="Rectangle 5">
+            <a:extLst>
+              <a:ext uri="{FF2B5EF4-FFF2-40B4-BE49-F238E27FC236}">
+                <a16:creationId xmlns:a16="http://schemas.microsoft.com/office/drawing/2014/main" id="{BF72FE9D-A494-0880-7478-23B8F8658432}"/>
+              </a:ext>
+            </a:extLst>
+          </p:cNvPr>
+          <p:cNvSpPr/>
+          <p:nvPr/>
+        </p:nvSpPr>
+        <p:spPr>
+          <a:xfrm>
+            <a:off x="1075765" y="2549562"/>
+            <a:ext cx="4733364" cy="1161826"/>
+          </a:xfrm>
+          <a:custGeom>
+            <a:avLst/>
+            <a:gdLst>
+              <a:gd name="connsiteX0" fmla="*/ 0 w 4733364"/>
+              <a:gd name="connsiteY0" fmla="*/ 0 h 1161826"/>
+              <a:gd name="connsiteX1" fmla="*/ 544337 w 4733364"/>
+              <a:gd name="connsiteY1" fmla="*/ 0 h 1161826"/>
+              <a:gd name="connsiteX2" fmla="*/ 994006 w 4733364"/>
+              <a:gd name="connsiteY2" fmla="*/ 0 h 1161826"/>
+              <a:gd name="connsiteX3" fmla="*/ 1680344 w 4733364"/>
+              <a:gd name="connsiteY3" fmla="*/ 0 h 1161826"/>
+              <a:gd name="connsiteX4" fmla="*/ 2224681 w 4733364"/>
+              <a:gd name="connsiteY4" fmla="*/ 0 h 1161826"/>
+              <a:gd name="connsiteX5" fmla="*/ 2769018 w 4733364"/>
+              <a:gd name="connsiteY5" fmla="*/ 0 h 1161826"/>
+              <a:gd name="connsiteX6" fmla="*/ 3455356 w 4733364"/>
+              <a:gd name="connsiteY6" fmla="*/ 0 h 1161826"/>
+              <a:gd name="connsiteX7" fmla="*/ 3952359 w 4733364"/>
+              <a:gd name="connsiteY7" fmla="*/ 0 h 1161826"/>
+              <a:gd name="connsiteX8" fmla="*/ 4733364 w 4733364"/>
+              <a:gd name="connsiteY8" fmla="*/ 0 h 1161826"/>
+              <a:gd name="connsiteX9" fmla="*/ 4733364 w 4733364"/>
+              <a:gd name="connsiteY9" fmla="*/ 604150 h 1161826"/>
+              <a:gd name="connsiteX10" fmla="*/ 4733364 w 4733364"/>
+              <a:gd name="connsiteY10" fmla="*/ 1161826 h 1161826"/>
+              <a:gd name="connsiteX11" fmla="*/ 4141694 w 4733364"/>
+              <a:gd name="connsiteY11" fmla="*/ 1161826 h 1161826"/>
+              <a:gd name="connsiteX12" fmla="*/ 3597357 w 4733364"/>
+              <a:gd name="connsiteY12" fmla="*/ 1161826 h 1161826"/>
+              <a:gd name="connsiteX13" fmla="*/ 2911019 w 4733364"/>
+              <a:gd name="connsiteY13" fmla="*/ 1161826 h 1161826"/>
+              <a:gd name="connsiteX14" fmla="*/ 2224681 w 4733364"/>
+              <a:gd name="connsiteY14" fmla="*/ 1161826 h 1161826"/>
+              <a:gd name="connsiteX15" fmla="*/ 1727678 w 4733364"/>
+              <a:gd name="connsiteY15" fmla="*/ 1161826 h 1161826"/>
+              <a:gd name="connsiteX16" fmla="*/ 1136007 w 4733364"/>
+              <a:gd name="connsiteY16" fmla="*/ 1161826 h 1161826"/>
+              <a:gd name="connsiteX17" fmla="*/ 0 w 4733364"/>
+              <a:gd name="connsiteY17" fmla="*/ 1161826 h 1161826"/>
+              <a:gd name="connsiteX18" fmla="*/ 0 w 4733364"/>
+              <a:gd name="connsiteY18" fmla="*/ 580913 h 1161826"/>
+              <a:gd name="connsiteX19" fmla="*/ 0 w 4733364"/>
+              <a:gd name="connsiteY19" fmla="*/ 0 h 1161826"/>
+            </a:gdLst>
+            <a:ahLst/>
+            <a:cxnLst>
+              <a:cxn ang="0">
+                <a:pos x="connsiteX0" y="connsiteY0"/>
+              </a:cxn>
+              <a:cxn ang="0">
+                <a:pos x="connsiteX1" y="connsiteY1"/>
+              </a:cxn>
+              <a:cxn ang="0">
+                <a:pos x="connsiteX2" y="connsiteY2"/>
+              </a:cxn>
+              <a:cxn ang="0">
+                <a:pos x="connsiteX3" y="connsiteY3"/>
+              </a:cxn>
+              <a:cxn ang="0">
+                <a:pos x="connsiteX4" y="connsiteY4"/>
+              </a:cxn>
+              <a:cxn ang="0">
+                <a:pos x="connsiteX5" y="connsiteY5"/>
+              </a:cxn>
+              <a:cxn ang="0">
+                <a:pos x="connsiteX6" y="connsiteY6"/>
+              </a:cxn>
+              <a:cxn ang="0">
+                <a:pos x="connsiteX7" y="connsiteY7"/>
+              </a:cxn>
+              <a:cxn ang="0">
+                <a:pos x="connsiteX8" y="connsiteY8"/>
+              </a:cxn>
+              <a:cxn ang="0">
+                <a:pos x="connsiteX9" y="connsiteY9"/>
+              </a:cxn>
+              <a:cxn ang="0">
+                <a:pos x="connsiteX10" y="connsiteY10"/>
+              </a:cxn>
+              <a:cxn ang="0">
+                <a:pos x="connsiteX11" y="connsiteY11"/>
+              </a:cxn>
+              <a:cxn ang="0">
+                <a:pos x="connsiteX12" y="connsiteY12"/>
+              </a:cxn>
+              <a:cxn ang="0">
+                <a:pos x="connsiteX13" y="connsiteY13"/>
+              </a:cxn>
+              <a:cxn ang="0">
+                <a:pos x="connsiteX14" y="connsiteY14"/>
+              </a:cxn>
+              <a:cxn ang="0">
+                <a:pos x="connsiteX15" y="connsiteY15"/>
+              </a:cxn>
+              <a:cxn ang="0">
+                <a:pos x="connsiteX16" y="connsiteY16"/>
+              </a:cxn>
+              <a:cxn ang="0">
+                <a:pos x="connsiteX17" y="connsiteY17"/>
+              </a:cxn>
+              <a:cxn ang="0">
+                <a:pos x="connsiteX18" y="connsiteY18"/>
+              </a:cxn>
+              <a:cxn ang="0">
+                <a:pos x="connsiteX19" y="connsiteY19"/>
+              </a:cxn>
+            </a:cxnLst>
+            <a:rect l="l" t="t" r="r" b="b"/>
+            <a:pathLst>
+              <a:path w="4733364" h="1161826" extrusionOk="0">
+                <a:moveTo>
+                  <a:pt x="0" y="0"/>
+                </a:moveTo>
+                <a:cubicBezTo>
+                  <a:pt x="229468" y="-50895"/>
+                  <a:pt x="294370" y="35903"/>
+                  <a:pt x="544337" y="0"/>
+                </a:cubicBezTo>
+                <a:cubicBezTo>
+                  <a:pt x="794304" y="-35903"/>
+                  <a:pt x="820079" y="34170"/>
+                  <a:pt x="994006" y="0"/>
+                </a:cubicBezTo>
+                <a:cubicBezTo>
+                  <a:pt x="1167933" y="-34170"/>
+                  <a:pt x="1374133" y="58138"/>
+                  <a:pt x="1680344" y="0"/>
+                </a:cubicBezTo>
+                <a:cubicBezTo>
+                  <a:pt x="1986555" y="-58138"/>
+                  <a:pt x="2046752" y="42581"/>
+                  <a:pt x="2224681" y="0"/>
+                </a:cubicBezTo>
+                <a:cubicBezTo>
+                  <a:pt x="2402610" y="-42581"/>
+                  <a:pt x="2583036" y="36101"/>
+                  <a:pt x="2769018" y="0"/>
+                </a:cubicBezTo>
+                <a:cubicBezTo>
+                  <a:pt x="2955000" y="-36101"/>
+                  <a:pt x="3247585" y="49086"/>
+                  <a:pt x="3455356" y="0"/>
+                </a:cubicBezTo>
+                <a:cubicBezTo>
+                  <a:pt x="3663127" y="-49086"/>
+                  <a:pt x="3818168" y="55487"/>
+                  <a:pt x="3952359" y="0"/>
+                </a:cubicBezTo>
+                <a:cubicBezTo>
+                  <a:pt x="4086550" y="-55487"/>
+                  <a:pt x="4361088" y="71153"/>
+                  <a:pt x="4733364" y="0"/>
+                </a:cubicBezTo>
+                <a:cubicBezTo>
+                  <a:pt x="4774937" y="182907"/>
+                  <a:pt x="4683414" y="437336"/>
+                  <a:pt x="4733364" y="604150"/>
+                </a:cubicBezTo>
+                <a:cubicBezTo>
+                  <a:pt x="4783314" y="770964"/>
+                  <a:pt x="4731225" y="909997"/>
+                  <a:pt x="4733364" y="1161826"/>
+                </a:cubicBezTo>
+                <a:cubicBezTo>
+                  <a:pt x="4455532" y="1228628"/>
+                  <a:pt x="4325425" y="1122304"/>
+                  <a:pt x="4141694" y="1161826"/>
+                </a:cubicBezTo>
+                <a:cubicBezTo>
+                  <a:pt x="3957963" y="1201348"/>
+                  <a:pt x="3720866" y="1126498"/>
+                  <a:pt x="3597357" y="1161826"/>
+                </a:cubicBezTo>
+                <a:cubicBezTo>
+                  <a:pt x="3473848" y="1197154"/>
+                  <a:pt x="3108827" y="1156187"/>
+                  <a:pt x="2911019" y="1161826"/>
+                </a:cubicBezTo>
+                <a:cubicBezTo>
+                  <a:pt x="2713211" y="1167465"/>
+                  <a:pt x="2425949" y="1113687"/>
+                  <a:pt x="2224681" y="1161826"/>
+                </a:cubicBezTo>
+                <a:cubicBezTo>
+                  <a:pt x="2023413" y="1209965"/>
+                  <a:pt x="1839854" y="1107588"/>
+                  <a:pt x="1727678" y="1161826"/>
+                </a:cubicBezTo>
+                <a:cubicBezTo>
+                  <a:pt x="1615502" y="1216064"/>
+                  <a:pt x="1259688" y="1124550"/>
+                  <a:pt x="1136007" y="1161826"/>
+                </a:cubicBezTo>
+                <a:cubicBezTo>
+                  <a:pt x="1012326" y="1199102"/>
+                  <a:pt x="275734" y="1027589"/>
+                  <a:pt x="0" y="1161826"/>
+                </a:cubicBezTo>
+                <a:cubicBezTo>
+                  <a:pt x="-5849" y="889776"/>
+                  <a:pt x="16710" y="837427"/>
+                  <a:pt x="0" y="580913"/>
+                </a:cubicBezTo>
+                <a:cubicBezTo>
+                  <a:pt x="-16710" y="324399"/>
+                  <a:pt x="27932" y="254347"/>
+                  <a:pt x="0" y="0"/>
+                </a:cubicBezTo>
+                <a:close/>
+              </a:path>
+            </a:pathLst>
+          </a:custGeom>
+          <a:noFill/>
+          <a:ln>
+            <a:prstDash val="sysDash"/>
+            <a:extLst>
+              <a:ext uri="{C807C97D-BFC1-408E-A445-0C87EB9F89A2}">
+                <ask:lineSketchStyleProps xmlns:ask="http://schemas.microsoft.com/office/drawing/2018/sketchyshapes" sd="1219033472">
+                  <a:prstGeom prst="rect">
+                    <a:avLst/>
+                  </a:prstGeom>
+                  <ask:type>
+                    <ask:lineSketchScribble/>
+                  </ask:type>
+                </ask:lineSketchStyleProps>
+              </a:ext>
+            </a:extLst>
+          </a:ln>
+        </p:spPr>
+        <p:style>
+          <a:lnRef idx="2">
+            <a:schemeClr val="accent1">
+              <a:shade val="15000"/>
+            </a:schemeClr>
+          </a:lnRef>
+          <a:fillRef idx="1">
+            <a:schemeClr val="accent1"/>
+          </a:fillRef>
+          <a:effectRef idx="0">
+            <a:schemeClr val="accent1"/>
+          </a:effectRef>
+          <a:fontRef idx="minor">
+            <a:schemeClr val="lt1"/>
+          </a:fontRef>
+        </p:style>
+        <p:txBody>
+          <a:bodyPr rtlCol="0" anchor="ctr"/>
+          <a:lstStyle/>
+          <a:p>
+            <a:pPr algn="ctr"/>
+            <a:endParaRPr lang="en-US"/>
+          </a:p>
+        </p:txBody>
+      </p:sp>
+      <p:sp>
+        <p:nvSpPr>
+          <p:cNvPr id="9" name="Oval 8">
+            <a:extLst>
+              <a:ext uri="{FF2B5EF4-FFF2-40B4-BE49-F238E27FC236}">
+                <a16:creationId xmlns:a16="http://schemas.microsoft.com/office/drawing/2014/main" id="{1C599FD8-2975-8A4A-4073-614F1B8AB184}"/>
+              </a:ext>
+            </a:extLst>
+          </p:cNvPr>
+          <p:cNvSpPr/>
+          <p:nvPr/>
+        </p:nvSpPr>
+        <p:spPr>
+          <a:xfrm>
+            <a:off x="5589977" y="2806656"/>
+            <a:ext cx="1280160" cy="861061"/>
+          </a:xfrm>
+          <a:prstGeom prst="ellipse">
+            <a:avLst/>
+          </a:prstGeom>
+        </p:spPr>
+        <p:style>
+          <a:lnRef idx="2">
+            <a:schemeClr val="accent1">
+              <a:shade val="15000"/>
+            </a:schemeClr>
+          </a:lnRef>
+          <a:fillRef idx="1">
+            <a:schemeClr val="accent1"/>
+          </a:fillRef>
+          <a:effectRef idx="0">
+            <a:schemeClr val="accent1"/>
+          </a:effectRef>
+          <a:fontRef idx="minor">
+            <a:schemeClr val="lt1"/>
+          </a:fontRef>
+        </p:style>
+        <p:txBody>
+          <a:bodyPr rtlCol="0" anchor="ctr"/>
+          <a:lstStyle/>
+          <a:p>
+            <a:pPr algn="ctr"/>
+            <a:r>
+              <a:rPr lang="en-US" dirty="0"/>
+              <a:t>No Change!!!</a:t>
             </a:r>
           </a:p>
         </p:txBody>
@@ -8387,332 +8989,6 @@
       </p:sp>
       <p:sp>
         <p:nvSpPr>
-          <p:cNvPr id="6" name="TextBox 5">
-            <a:extLst>
-              <a:ext uri="{FF2B5EF4-FFF2-40B4-BE49-F238E27FC236}">
-                <a16:creationId xmlns:a16="http://schemas.microsoft.com/office/drawing/2014/main" id="{7488097A-53BB-23A6-8A12-22F976264474}"/>
-              </a:ext>
-            </a:extLst>
-          </p:cNvPr>
-          <p:cNvSpPr txBox="1"/>
-          <p:nvPr/>
-        </p:nvSpPr>
-        <p:spPr>
-          <a:xfrm>
-            <a:off x="654838" y="1690688"/>
-            <a:ext cx="4994122" cy="3323987"/>
-          </a:xfrm>
-          <a:prstGeom prst="rect">
-            <a:avLst/>
-          </a:prstGeom>
-          <a:noFill/>
-        </p:spPr>
-        <p:txBody>
-          <a:bodyPr wrap="square" rtlCol="0">
-            <a:spAutoFit/>
-          </a:bodyPr>
-          <a:lstStyle/>
-          <a:p>
-            <a:r>
-              <a:rPr lang="en-US" sz="1400" dirty="0">
-                <a:latin typeface="Courier New" panose="02070309020205020404" pitchFamily="49" charset="0"/>
-                <a:cs typeface="Courier New" panose="02070309020205020404" pitchFamily="49" charset="0"/>
-              </a:rPr>
-              <a:t>{</a:t>
-            </a:r>
-          </a:p>
-          <a:p>
-            <a:r>
-              <a:rPr lang="en-US" sz="1400" dirty="0">
-                <a:latin typeface="Courier New" panose="02070309020205020404" pitchFamily="49" charset="0"/>
-                <a:cs typeface="Courier New" panose="02070309020205020404" pitchFamily="49" charset="0"/>
-              </a:rPr>
-              <a:t>  "</a:t>
-            </a:r>
-            <a:r>
-              <a:rPr lang="en-US" sz="1400" dirty="0" err="1">
-                <a:latin typeface="Courier New" panose="02070309020205020404" pitchFamily="49" charset="0"/>
-                <a:cs typeface="Courier New" panose="02070309020205020404" pitchFamily="49" charset="0"/>
-              </a:rPr>
-              <a:t>FullName</a:t>
-            </a:r>
-            <a:r>
-              <a:rPr lang="en-US" sz="1400" dirty="0">
-                <a:latin typeface="Courier New" panose="02070309020205020404" pitchFamily="49" charset="0"/>
-                <a:cs typeface="Courier New" panose="02070309020205020404" pitchFamily="49" charset="0"/>
-              </a:rPr>
-              <a:t>": "</a:t>
-            </a:r>
-            <a:r>
-              <a:rPr lang="en-US" sz="1400" dirty="0" err="1">
-                <a:latin typeface="Courier New" panose="02070309020205020404" pitchFamily="49" charset="0"/>
-                <a:cs typeface="Courier New" panose="02070309020205020404" pitchFamily="49" charset="0"/>
-              </a:rPr>
-              <a:t>SaasOneCS</a:t>
-            </a:r>
-            <a:r>
-              <a:rPr lang="en-US" sz="1400" dirty="0">
-                <a:latin typeface="Courier New" panose="02070309020205020404" pitchFamily="49" charset="0"/>
-                <a:cs typeface="Courier New" panose="02070309020205020404" pitchFamily="49" charset="0"/>
-              </a:rPr>
-              <a:t>/$OneCS1/</a:t>
-            </a:r>
-            <a:r>
-              <a:rPr lang="en-US" sz="1400" b="1" dirty="0">
-                <a:latin typeface="Courier New" panose="02070309020205020404" pitchFamily="49" charset="0"/>
-                <a:cs typeface="Courier New" panose="02070309020205020404" pitchFamily="49" charset="0"/>
-              </a:rPr>
-              <a:t>#Prod</a:t>
-            </a:r>
-            <a:r>
-              <a:rPr lang="en-US" sz="1400" dirty="0">
-                <a:latin typeface="Courier New" panose="02070309020205020404" pitchFamily="49" charset="0"/>
-                <a:cs typeface="Courier New" panose="02070309020205020404" pitchFamily="49" charset="0"/>
-              </a:rPr>
-              <a:t>",</a:t>
-            </a:r>
-            <a:br>
-              <a:rPr lang="en-US" sz="1400" dirty="0">
-                <a:latin typeface="Courier New" panose="02070309020205020404" pitchFamily="49" charset="0"/>
-                <a:cs typeface="Courier New" panose="02070309020205020404" pitchFamily="49" charset="0"/>
-              </a:rPr>
-            </a:br>
-            <a:r>
-              <a:rPr lang="en-US" sz="1400" dirty="0">
-                <a:latin typeface="Courier New" panose="02070309020205020404" pitchFamily="49" charset="0"/>
-                <a:cs typeface="Courier New" panose="02070309020205020404" pitchFamily="49" charset="0"/>
-              </a:rPr>
-              <a:t>  "Parties": [</a:t>
-            </a:r>
-            <a:br>
-              <a:rPr lang="en-US" sz="1400" dirty="0">
-                <a:latin typeface="Courier New" panose="02070309020205020404" pitchFamily="49" charset="0"/>
-                <a:cs typeface="Courier New" panose="02070309020205020404" pitchFamily="49" charset="0"/>
-              </a:rPr>
-            </a:br>
-            <a:r>
-              <a:rPr lang="en-US" sz="1400" dirty="0">
-                <a:latin typeface="Courier New" panose="02070309020205020404" pitchFamily="49" charset="0"/>
-                <a:cs typeface="Courier New" panose="02070309020205020404" pitchFamily="49" charset="0"/>
-              </a:rPr>
-              <a:t>  {</a:t>
-            </a:r>
-          </a:p>
-          <a:p>
-            <a:r>
-              <a:rPr lang="en-US" sz="1400" dirty="0">
-                <a:latin typeface="Courier New" panose="02070309020205020404" pitchFamily="49" charset="0"/>
-                <a:cs typeface="Courier New" panose="02070309020205020404" pitchFamily="49" charset="0"/>
-              </a:rPr>
-              <a:t>    "</a:t>
-            </a:r>
-            <a:r>
-              <a:rPr lang="en-US" sz="1400" dirty="0" err="1">
-                <a:latin typeface="Courier New" panose="02070309020205020404" pitchFamily="49" charset="0"/>
-                <a:cs typeface="Courier New" panose="02070309020205020404" pitchFamily="49" charset="0"/>
-              </a:rPr>
-              <a:t>DomainName</a:t>
-            </a:r>
-            <a:r>
-              <a:rPr lang="en-US" sz="1400" dirty="0">
-                <a:latin typeface="Courier New" panose="02070309020205020404" pitchFamily="49" charset="0"/>
-                <a:cs typeface="Courier New" panose="02070309020205020404" pitchFamily="49" charset="0"/>
-              </a:rPr>
-              <a:t>": "</a:t>
-            </a:r>
-            <a:r>
-              <a:rPr lang="en-US" sz="1400" dirty="0" err="1">
-                <a:latin typeface="Courier New" panose="02070309020205020404" pitchFamily="49" charset="0"/>
-                <a:cs typeface="Courier New" panose="02070309020205020404" pitchFamily="49" charset="0"/>
-              </a:rPr>
-              <a:t>LaToulousaine</a:t>
-            </a:r>
-            <a:r>
-              <a:rPr lang="en-US" sz="1400" dirty="0">
-                <a:latin typeface="Courier New" panose="02070309020205020404" pitchFamily="49" charset="0"/>
-                <a:cs typeface="Courier New" panose="02070309020205020404" pitchFamily="49" charset="0"/>
-              </a:rPr>
-              <a:t>",</a:t>
-            </a:r>
-          </a:p>
-          <a:p>
-            <a:r>
-              <a:rPr lang="en-US" sz="1400" dirty="0">
-                <a:latin typeface="Courier New" panose="02070309020205020404" pitchFamily="49" charset="0"/>
-                <a:cs typeface="Courier New" panose="02070309020205020404" pitchFamily="49" charset="0"/>
-              </a:rPr>
-              <a:t>    “</a:t>
-            </a:r>
-            <a:r>
-              <a:rPr lang="en-US" sz="1400" dirty="0" err="1">
-                <a:latin typeface="Courier New" panose="02070309020205020404" pitchFamily="49" charset="0"/>
-                <a:cs typeface="Courier New" panose="02070309020205020404" pitchFamily="49" charset="0"/>
-              </a:rPr>
-              <a:t>EnvironmentName</a:t>
-            </a:r>
-            <a:r>
-              <a:rPr lang="en-US" sz="1400" dirty="0">
-                <a:latin typeface="Courier New" panose="02070309020205020404" pitchFamily="49" charset="0"/>
-                <a:cs typeface="Courier New" panose="02070309020205020404" pitchFamily="49" charset="0"/>
-              </a:rPr>
-              <a:t>": </a:t>
-            </a:r>
-            <a:r>
-              <a:rPr lang="en-US" sz="1400" b="1" dirty="0">
-                <a:latin typeface="Courier New" panose="02070309020205020404" pitchFamily="49" charset="0"/>
-                <a:cs typeface="Courier New" panose="02070309020205020404" pitchFamily="49" charset="0"/>
-              </a:rPr>
-              <a:t>"#Staging"</a:t>
-            </a:r>
-            <a:r>
-              <a:rPr lang="en-US" sz="1400" dirty="0">
-                <a:latin typeface="Courier New" panose="02070309020205020404" pitchFamily="49" charset="0"/>
-                <a:cs typeface="Courier New" panose="02070309020205020404" pitchFamily="49" charset="0"/>
-              </a:rPr>
-              <a:t>, </a:t>
-            </a:r>
-          </a:p>
-          <a:p>
-            <a:r>
-              <a:rPr lang="en-US" sz="1400" dirty="0">
-                <a:latin typeface="Courier New" panose="02070309020205020404" pitchFamily="49" charset="0"/>
-                <a:cs typeface="Courier New" panose="02070309020205020404" pitchFamily="49" charset="0"/>
-              </a:rPr>
-              <a:t>    "Parties": [</a:t>
-            </a:r>
-          </a:p>
-          <a:p>
-            <a:r>
-              <a:rPr lang="en-US" sz="1400" dirty="0">
-                <a:latin typeface="Courier New" panose="02070309020205020404" pitchFamily="49" charset="0"/>
-                <a:cs typeface="Courier New" panose="02070309020205020404" pitchFamily="49" charset="0"/>
-              </a:rPr>
-              <a:t>    {</a:t>
-            </a:r>
-          </a:p>
-          <a:p>
-            <a:r>
-              <a:rPr lang="en-US" sz="1400" dirty="0">
-                <a:latin typeface="Courier New" panose="02070309020205020404" pitchFamily="49" charset="0"/>
-                <a:cs typeface="Courier New" panose="02070309020205020404" pitchFamily="49" charset="0"/>
-              </a:rPr>
-              <a:t>      "</a:t>
-            </a:r>
-            <a:r>
-              <a:rPr lang="en-US" sz="1400" dirty="0" err="1">
-                <a:latin typeface="Courier New" panose="02070309020205020404" pitchFamily="49" charset="0"/>
-                <a:cs typeface="Courier New" panose="02070309020205020404" pitchFamily="49" charset="0"/>
-              </a:rPr>
-              <a:t>PartyName</a:t>
-            </a:r>
-            <a:r>
-              <a:rPr lang="en-US" sz="1400" dirty="0">
-                <a:latin typeface="Courier New" panose="02070309020205020404" pitchFamily="49" charset="0"/>
-                <a:cs typeface="Courier New" panose="02070309020205020404" pitchFamily="49" charset="0"/>
-              </a:rPr>
-              <a:t>": "$</a:t>
-            </a:r>
-            <a:r>
-              <a:rPr lang="en-US" sz="1400" dirty="0" err="1">
-                <a:latin typeface="Courier New" panose="02070309020205020404" pitchFamily="49" charset="0"/>
-                <a:cs typeface="Courier New" panose="02070309020205020404" pitchFamily="49" charset="0"/>
-              </a:rPr>
-              <a:t>LaToulousaine</a:t>
-            </a:r>
-            <a:r>
-              <a:rPr lang="en-US" sz="1400" dirty="0">
-                <a:latin typeface="Courier New" panose="02070309020205020404" pitchFamily="49" charset="0"/>
-                <a:cs typeface="Courier New" panose="02070309020205020404" pitchFamily="49" charset="0"/>
-              </a:rPr>
-              <a:t>"</a:t>
-            </a:r>
-          </a:p>
-          <a:p>
-            <a:r>
-              <a:rPr lang="en-US" sz="1400" dirty="0">
-                <a:latin typeface="Courier New" panose="02070309020205020404" pitchFamily="49" charset="0"/>
-                <a:cs typeface="Courier New" panose="02070309020205020404" pitchFamily="49" charset="0"/>
-              </a:rPr>
-              <a:t>    },</a:t>
-            </a:r>
-          </a:p>
-          <a:p>
-            <a:r>
-              <a:rPr lang="en-US" sz="1400" dirty="0">
-                <a:latin typeface="Courier New" panose="02070309020205020404" pitchFamily="49" charset="0"/>
-                <a:cs typeface="Courier New" panose="02070309020205020404" pitchFamily="49" charset="0"/>
-              </a:rPr>
-              <a:t>    {</a:t>
-            </a:r>
-          </a:p>
-          <a:p>
-            <a:r>
-              <a:rPr lang="en-US" sz="1400" dirty="0">
-                <a:latin typeface="Courier New" panose="02070309020205020404" pitchFamily="49" charset="0"/>
-                <a:cs typeface="Courier New" panose="02070309020205020404" pitchFamily="49" charset="0"/>
-              </a:rPr>
-              <a:t>      "</a:t>
-            </a:r>
-            <a:r>
-              <a:rPr lang="en-US" sz="1400" dirty="0" err="1">
-                <a:latin typeface="Courier New" panose="02070309020205020404" pitchFamily="49" charset="0"/>
-                <a:cs typeface="Courier New" panose="02070309020205020404" pitchFamily="49" charset="0"/>
-              </a:rPr>
-              <a:t>PartyName</a:t>
-            </a:r>
-            <a:r>
-              <a:rPr lang="en-US" sz="1400" dirty="0">
-                <a:latin typeface="Courier New" panose="02070309020205020404" pitchFamily="49" charset="0"/>
-                <a:cs typeface="Courier New" panose="02070309020205020404" pitchFamily="49" charset="0"/>
-              </a:rPr>
-              <a:t>": "$</a:t>
-            </a:r>
-            <a:r>
-              <a:rPr lang="en-US" sz="1400" dirty="0" err="1">
-                <a:latin typeface="Courier New" panose="02070309020205020404" pitchFamily="49" charset="0"/>
-                <a:cs typeface="Courier New" panose="02070309020205020404" pitchFamily="49" charset="0"/>
-              </a:rPr>
-              <a:t>SignatureBox</a:t>
-            </a:r>
-            <a:r>
-              <a:rPr lang="en-US" sz="1400" dirty="0">
-                <a:latin typeface="Courier New" panose="02070309020205020404" pitchFamily="49" charset="0"/>
-                <a:cs typeface="Courier New" panose="02070309020205020404" pitchFamily="49" charset="0"/>
-              </a:rPr>
-              <a:t>"</a:t>
-            </a:r>
-          </a:p>
-          <a:p>
-            <a:r>
-              <a:rPr lang="en-US" sz="1400" dirty="0">
-                <a:latin typeface="Courier New" panose="02070309020205020404" pitchFamily="49" charset="0"/>
-                <a:cs typeface="Courier New" panose="02070309020205020404" pitchFamily="49" charset="0"/>
-              </a:rPr>
-              <a:t>    }]</a:t>
-            </a:r>
-          </a:p>
-          <a:p>
-            <a:r>
-              <a:rPr lang="en-US" sz="1400" dirty="0">
-                <a:latin typeface="Courier New" panose="02070309020205020404" pitchFamily="49" charset="0"/>
-                <a:cs typeface="Courier New" panose="02070309020205020404" pitchFamily="49" charset="0"/>
-              </a:rPr>
-              <a:t>  }]</a:t>
-            </a:r>
-          </a:p>
-          <a:p>
-            <a:r>
-              <a:rPr lang="en-US" sz="1400" dirty="0">
-                <a:latin typeface="Courier New" panose="02070309020205020404" pitchFamily="49" charset="0"/>
-                <a:cs typeface="Courier New" panose="02070309020205020404" pitchFamily="49" charset="0"/>
-              </a:rPr>
-              <a:t>}</a:t>
-            </a:r>
-          </a:p>
-        </p:txBody>
-      </p:sp>
-      <p:sp>
-        <p:nvSpPr>
           <p:cNvPr id="8" name="TextBox 7">
             <a:extLst>
               <a:ext uri="{FF2B5EF4-FFF2-40B4-BE49-F238E27FC236}">
@@ -9012,6 +9288,291 @@
                 <a:cs typeface="Courier New" panose="02070309020205020404" pitchFamily="49" charset="0"/>
               </a:rPr>
               <a:t>"Address": "27.28.29.30:3712"</a:t>
+            </a:r>
+          </a:p>
+          <a:p>
+            <a:r>
+              <a:rPr lang="en-US" sz="1400" dirty="0">
+                <a:latin typeface="Courier New" panose="02070309020205020404" pitchFamily="49" charset="0"/>
+                <a:cs typeface="Courier New" panose="02070309020205020404" pitchFamily="49" charset="0"/>
+              </a:rPr>
+              <a:t>  }]</a:t>
+            </a:r>
+          </a:p>
+          <a:p>
+            <a:r>
+              <a:rPr lang="en-US" sz="1400" dirty="0">
+                <a:latin typeface="Courier New" panose="02070309020205020404" pitchFamily="49" charset="0"/>
+                <a:cs typeface="Courier New" panose="02070309020205020404" pitchFamily="49" charset="0"/>
+              </a:rPr>
+              <a:t>}</a:t>
+            </a:r>
+          </a:p>
+        </p:txBody>
+      </p:sp>
+      <p:sp>
+        <p:nvSpPr>
+          <p:cNvPr id="3" name="TextBox 2">
+            <a:extLst>
+              <a:ext uri="{FF2B5EF4-FFF2-40B4-BE49-F238E27FC236}">
+                <a16:creationId xmlns:a16="http://schemas.microsoft.com/office/drawing/2014/main" id="{7ED1A3BB-C45C-40DE-67C0-50F9948E66FE}"/>
+              </a:ext>
+            </a:extLst>
+          </p:cNvPr>
+          <p:cNvSpPr txBox="1"/>
+          <p:nvPr/>
+        </p:nvSpPr>
+        <p:spPr>
+          <a:xfrm>
+            <a:off x="605123" y="1692425"/>
+            <a:ext cx="5347929" cy="2677656"/>
+          </a:xfrm>
+          <a:prstGeom prst="rect">
+            <a:avLst/>
+          </a:prstGeom>
+          <a:noFill/>
+        </p:spPr>
+        <p:txBody>
+          <a:bodyPr wrap="square" rtlCol="0">
+            <a:spAutoFit/>
+          </a:bodyPr>
+          <a:lstStyle/>
+          <a:p>
+            <a:r>
+              <a:rPr lang="en-US" sz="1400" dirty="0">
+                <a:latin typeface="Courier New" panose="02070309020205020404" pitchFamily="49" charset="0"/>
+                <a:cs typeface="Courier New" panose="02070309020205020404" pitchFamily="49" charset="0"/>
+              </a:rPr>
+              <a:t>{</a:t>
+            </a:r>
+          </a:p>
+          <a:p>
+            <a:r>
+              <a:rPr lang="en-US" sz="1400" dirty="0">
+                <a:latin typeface="Courier New" panose="02070309020205020404" pitchFamily="49" charset="0"/>
+                <a:cs typeface="Courier New" panose="02070309020205020404" pitchFamily="49" charset="0"/>
+              </a:rPr>
+              <a:t>  "</a:t>
+            </a:r>
+            <a:r>
+              <a:rPr lang="en-US" sz="1400" dirty="0" err="1">
+                <a:latin typeface="Courier New" panose="02070309020205020404" pitchFamily="49" charset="0"/>
+                <a:cs typeface="Courier New" panose="02070309020205020404" pitchFamily="49" charset="0"/>
+              </a:rPr>
+              <a:t>FullName</a:t>
+            </a:r>
+            <a:r>
+              <a:rPr lang="en-US" sz="1400" dirty="0">
+                <a:latin typeface="Courier New" panose="02070309020205020404" pitchFamily="49" charset="0"/>
+                <a:cs typeface="Courier New" panose="02070309020205020404" pitchFamily="49" charset="0"/>
+              </a:rPr>
+              <a:t>": "</a:t>
+            </a:r>
+            <a:r>
+              <a:rPr lang="en-US" sz="1400" dirty="0" err="1">
+                <a:latin typeface="Courier New" panose="02070309020205020404" pitchFamily="49" charset="0"/>
+                <a:cs typeface="Courier New" panose="02070309020205020404" pitchFamily="49" charset="0"/>
+              </a:rPr>
+              <a:t>SaasOneCS</a:t>
+            </a:r>
+            <a:r>
+              <a:rPr lang="en-US" sz="1400" dirty="0">
+                <a:latin typeface="Courier New" panose="02070309020205020404" pitchFamily="49" charset="0"/>
+                <a:cs typeface="Courier New" panose="02070309020205020404" pitchFamily="49" charset="0"/>
+              </a:rPr>
+              <a:t>/$OneCS1/</a:t>
+            </a:r>
+            <a:r>
+              <a:rPr lang="en-US" sz="1400" b="1" dirty="0">
+                <a:latin typeface="Courier New" panose="02070309020205020404" pitchFamily="49" charset="0"/>
+                <a:cs typeface="Courier New" panose="02070309020205020404" pitchFamily="49" charset="0"/>
+              </a:rPr>
+              <a:t>#Production</a:t>
+            </a:r>
+            <a:r>
+              <a:rPr lang="en-US" sz="1400" dirty="0">
+                <a:latin typeface="Courier New" panose="02070309020205020404" pitchFamily="49" charset="0"/>
+                <a:cs typeface="Courier New" panose="02070309020205020404" pitchFamily="49" charset="0"/>
+              </a:rPr>
+              <a:t>",</a:t>
+            </a:r>
+            <a:br>
+              <a:rPr lang="en-US" sz="1400" dirty="0">
+                <a:latin typeface="Courier New" panose="02070309020205020404" pitchFamily="49" charset="0"/>
+                <a:cs typeface="Courier New" panose="02070309020205020404" pitchFamily="49" charset="0"/>
+              </a:rPr>
+            </a:br>
+            <a:r>
+              <a:rPr lang="en-US" sz="1400" dirty="0">
+                <a:latin typeface="Courier New" panose="02070309020205020404" pitchFamily="49" charset="0"/>
+                <a:cs typeface="Courier New" panose="02070309020205020404" pitchFamily="49" charset="0"/>
+              </a:rPr>
+              <a:t>  "Parties": [</a:t>
+            </a:r>
+            <a:br>
+              <a:rPr lang="en-US" sz="1400" dirty="0">
+                <a:latin typeface="Courier New" panose="02070309020205020404" pitchFamily="49" charset="0"/>
+                <a:cs typeface="Courier New" panose="02070309020205020404" pitchFamily="49" charset="0"/>
+              </a:rPr>
+            </a:br>
+            <a:r>
+              <a:rPr lang="en-US" sz="1400" dirty="0">
+                <a:latin typeface="Courier New" panose="02070309020205020404" pitchFamily="49" charset="0"/>
+                <a:cs typeface="Courier New" panose="02070309020205020404" pitchFamily="49" charset="0"/>
+              </a:rPr>
+              <a:t>  {</a:t>
+            </a:r>
+          </a:p>
+          <a:p>
+            <a:r>
+              <a:rPr lang="en-US" sz="1400" dirty="0">
+                <a:latin typeface="Courier New" panose="02070309020205020404" pitchFamily="49" charset="0"/>
+                <a:cs typeface="Courier New" panose="02070309020205020404" pitchFamily="49" charset="0"/>
+              </a:rPr>
+              <a:t>    "</a:t>
+            </a:r>
+            <a:r>
+              <a:rPr lang="en-US" sz="1400" dirty="0" err="1">
+                <a:latin typeface="Courier New" panose="02070309020205020404" pitchFamily="49" charset="0"/>
+                <a:cs typeface="Courier New" panose="02070309020205020404" pitchFamily="49" charset="0"/>
+              </a:rPr>
+              <a:t>FullName</a:t>
+            </a:r>
+            <a:r>
+              <a:rPr lang="en-US" sz="1400" dirty="0">
+                <a:latin typeface="Courier New" panose="02070309020205020404" pitchFamily="49" charset="0"/>
+                <a:cs typeface="Courier New" panose="02070309020205020404" pitchFamily="49" charset="0"/>
+              </a:rPr>
+              <a:t>": "</a:t>
+            </a:r>
+            <a:r>
+              <a:rPr lang="en-US" sz="1400" dirty="0" err="1">
+                <a:latin typeface="Courier New" panose="02070309020205020404" pitchFamily="49" charset="0"/>
+                <a:cs typeface="Courier New" panose="02070309020205020404" pitchFamily="49" charset="0"/>
+              </a:rPr>
+              <a:t>LaToulousaine</a:t>
+            </a:r>
+            <a:r>
+              <a:rPr lang="en-US" sz="1400" dirty="0">
+                <a:latin typeface="Courier New" panose="02070309020205020404" pitchFamily="49" charset="0"/>
+                <a:cs typeface="Courier New" panose="02070309020205020404" pitchFamily="49" charset="0"/>
+              </a:rPr>
+              <a:t>/$</a:t>
+            </a:r>
+            <a:r>
+              <a:rPr lang="en-US" sz="1400" dirty="0" err="1">
+                <a:latin typeface="Courier New" panose="02070309020205020404" pitchFamily="49" charset="0"/>
+                <a:cs typeface="Courier New" panose="02070309020205020404" pitchFamily="49" charset="0"/>
+              </a:rPr>
+              <a:t>LaToulousaine</a:t>
+            </a:r>
+            <a:r>
+              <a:rPr lang="en-US" sz="1400" dirty="0">
+                <a:latin typeface="Courier New" panose="02070309020205020404" pitchFamily="49" charset="0"/>
+                <a:cs typeface="Courier New" panose="02070309020205020404" pitchFamily="49" charset="0"/>
+              </a:rPr>
+              <a:t>",</a:t>
+            </a:r>
+          </a:p>
+          <a:p>
+            <a:r>
+              <a:rPr lang="en-US" sz="1400" dirty="0">
+                <a:latin typeface="Courier New" panose="02070309020205020404" pitchFamily="49" charset="0"/>
+                <a:cs typeface="Courier New" panose="02070309020205020404" pitchFamily="49" charset="0"/>
+              </a:rPr>
+              <a:t>    "</a:t>
+            </a:r>
+            <a:r>
+              <a:rPr lang="en-US" sz="1400" dirty="0" err="1">
+                <a:latin typeface="Courier New" panose="02070309020205020404" pitchFamily="49" charset="0"/>
+                <a:cs typeface="Courier New" panose="02070309020205020404" pitchFamily="49" charset="0"/>
+              </a:rPr>
+              <a:t>EnvironmentName</a:t>
+            </a:r>
+            <a:r>
+              <a:rPr lang="en-US" sz="1400" dirty="0">
+                <a:latin typeface="Courier New" panose="02070309020205020404" pitchFamily="49" charset="0"/>
+                <a:cs typeface="Courier New" panose="02070309020205020404" pitchFamily="49" charset="0"/>
+              </a:rPr>
+              <a:t>": "</a:t>
+            </a:r>
+            <a:r>
+              <a:rPr lang="en-US" sz="1400" b="1" dirty="0">
+                <a:latin typeface="Courier New" panose="02070309020205020404" pitchFamily="49" charset="0"/>
+                <a:cs typeface="Courier New" panose="02070309020205020404" pitchFamily="49" charset="0"/>
+              </a:rPr>
+              <a:t>#Staging</a:t>
+            </a:r>
+            <a:r>
+              <a:rPr lang="en-US" sz="1400" dirty="0">
+                <a:latin typeface="Courier New" panose="02070309020205020404" pitchFamily="49" charset="0"/>
+                <a:cs typeface="Courier New" panose="02070309020205020404" pitchFamily="49" charset="0"/>
+              </a:rPr>
+              <a:t>",</a:t>
+            </a:r>
+          </a:p>
+          <a:p>
+            <a:r>
+              <a:rPr lang="en-US" sz="1400" dirty="0">
+                <a:latin typeface="Courier New" panose="02070309020205020404" pitchFamily="49" charset="0"/>
+                <a:cs typeface="Courier New" panose="02070309020205020404" pitchFamily="49" charset="0"/>
+              </a:rPr>
+              <a:t>    "Parties": [</a:t>
+            </a:r>
+          </a:p>
+          <a:p>
+            <a:r>
+              <a:rPr lang="en-US" sz="1400" dirty="0">
+                <a:latin typeface="Courier New" panose="02070309020205020404" pitchFamily="49" charset="0"/>
+                <a:cs typeface="Courier New" panose="02070309020205020404" pitchFamily="49" charset="0"/>
+              </a:rPr>
+              <a:t>    {</a:t>
+            </a:r>
+          </a:p>
+          <a:p>
+            <a:r>
+              <a:rPr lang="en-US" sz="1400" dirty="0">
+                <a:latin typeface="Courier New" panose="02070309020205020404" pitchFamily="49" charset="0"/>
+                <a:cs typeface="Courier New" panose="02070309020205020404" pitchFamily="49" charset="0"/>
+              </a:rPr>
+              <a:t>      "</a:t>
+            </a:r>
+            <a:r>
+              <a:rPr lang="en-US" sz="1400" dirty="0" err="1">
+                <a:latin typeface="Courier New" panose="02070309020205020404" pitchFamily="49" charset="0"/>
+                <a:cs typeface="Courier New" panose="02070309020205020404" pitchFamily="49" charset="0"/>
+              </a:rPr>
+              <a:t>PartyName</a:t>
+            </a:r>
+            <a:r>
+              <a:rPr lang="en-US" sz="1400" dirty="0">
+                <a:latin typeface="Courier New" panose="02070309020205020404" pitchFamily="49" charset="0"/>
+                <a:cs typeface="Courier New" panose="02070309020205020404" pitchFamily="49" charset="0"/>
+              </a:rPr>
+              <a:t>": "$</a:t>
+            </a:r>
+            <a:r>
+              <a:rPr lang="en-US" sz="1400" dirty="0" err="1">
+                <a:latin typeface="Courier New" panose="02070309020205020404" pitchFamily="49" charset="0"/>
+                <a:cs typeface="Courier New" panose="02070309020205020404" pitchFamily="49" charset="0"/>
+              </a:rPr>
+              <a:t>SignatureBox</a:t>
+            </a:r>
+            <a:r>
+              <a:rPr lang="en-US" sz="1400" dirty="0">
+                <a:latin typeface="Courier New" panose="02070309020205020404" pitchFamily="49" charset="0"/>
+                <a:cs typeface="Courier New" panose="02070309020205020404" pitchFamily="49" charset="0"/>
+              </a:rPr>
+              <a:t>"</a:t>
+            </a:r>
+          </a:p>
+          <a:p>
+            <a:r>
+              <a:rPr lang="en-US" sz="1400" dirty="0">
+                <a:latin typeface="Courier New" panose="02070309020205020404" pitchFamily="49" charset="0"/>
+                <a:cs typeface="Courier New" panose="02070309020205020404" pitchFamily="49" charset="0"/>
+              </a:rPr>
+              <a:t>    }]</a:t>
             </a:r>
           </a:p>
           <a:p>
@@ -9253,10 +9814,10 @@
       </p:sp>
       <p:sp>
         <p:nvSpPr>
-          <p:cNvPr id="4" name="TextBox 3">
+          <p:cNvPr id="3" name="TextBox 2">
             <a:extLst>
               <a:ext uri="{FF2B5EF4-FFF2-40B4-BE49-F238E27FC236}">
-                <a16:creationId xmlns:a16="http://schemas.microsoft.com/office/drawing/2014/main" id="{1BEF56BE-36E9-9C16-0573-8234C8D9F689}"/>
+                <a16:creationId xmlns:a16="http://schemas.microsoft.com/office/drawing/2014/main" id="{27F5718A-75F5-2836-EB73-22530B20A975}"/>
               </a:ext>
             </a:extLst>
           </p:cNvPr>
@@ -9265,8 +9826,8 @@
         </p:nvSpPr>
         <p:spPr>
           <a:xfrm>
-            <a:off x="838201" y="1544768"/>
-            <a:ext cx="4759960" cy="4401205"/>
+            <a:off x="654837" y="1690688"/>
+            <a:ext cx="6789455" cy="3970318"/>
           </a:xfrm>
           <a:prstGeom prst="rect">
             <a:avLst/>
@@ -9300,7 +9861,7 @@
                 <a:latin typeface="Courier New" panose="02070309020205020404" pitchFamily="49" charset="0"/>
                 <a:cs typeface="Courier New" panose="02070309020205020404" pitchFamily="49" charset="0"/>
               </a:rPr>
-              <a:t>DomainName</a:t>
+              <a:t>FullName</a:t>
             </a:r>
             <a:r>
               <a:rPr lang="en-US" sz="1400" dirty="0">
@@ -9321,6 +9882,366 @@
                 <a:latin typeface="Courier New" panose="02070309020205020404" pitchFamily="49" charset="0"/>
                 <a:cs typeface="Courier New" panose="02070309020205020404" pitchFamily="49" charset="0"/>
               </a:rPr>
+              <a:t>/$OneCS1",</a:t>
+            </a:r>
+            <a:br>
+              <a:rPr lang="en-US" sz="1400" dirty="0">
+                <a:latin typeface="Courier New" panose="02070309020205020404" pitchFamily="49" charset="0"/>
+                <a:cs typeface="Courier New" panose="02070309020205020404" pitchFamily="49" charset="0"/>
+              </a:rPr>
+            </a:br>
+            <a:r>
+              <a:rPr lang="en-US" sz="1400" dirty="0">
+                <a:latin typeface="Courier New" panose="02070309020205020404" pitchFamily="49" charset="0"/>
+                <a:cs typeface="Courier New" panose="02070309020205020404" pitchFamily="49" charset="0"/>
+              </a:rPr>
+              <a:t>  "Parties": [</a:t>
+            </a:r>
+            <a:br>
+              <a:rPr lang="en-US" sz="1400" dirty="0">
+                <a:latin typeface="Courier New" panose="02070309020205020404" pitchFamily="49" charset="0"/>
+                <a:cs typeface="Courier New" panose="02070309020205020404" pitchFamily="49" charset="0"/>
+              </a:rPr>
+            </a:br>
+            <a:r>
+              <a:rPr lang="en-US" sz="1400" dirty="0">
+                <a:latin typeface="Courier New" panose="02070309020205020404" pitchFamily="49" charset="0"/>
+                <a:cs typeface="Courier New" panose="02070309020205020404" pitchFamily="49" charset="0"/>
+              </a:rPr>
+              <a:t>  {</a:t>
+            </a:r>
+          </a:p>
+          <a:p>
+            <a:r>
+              <a:rPr lang="en-US" sz="1400" dirty="0">
+                <a:latin typeface="Courier New" panose="02070309020205020404" pitchFamily="49" charset="0"/>
+                <a:cs typeface="Courier New" panose="02070309020205020404" pitchFamily="49" charset="0"/>
+              </a:rPr>
+              <a:t>    "</a:t>
+            </a:r>
+            <a:r>
+              <a:rPr lang="en-US" sz="1400" dirty="0" err="1">
+                <a:latin typeface="Courier New" panose="02070309020205020404" pitchFamily="49" charset="0"/>
+                <a:cs typeface="Courier New" panose="02070309020205020404" pitchFamily="49" charset="0"/>
+              </a:rPr>
+              <a:t>FullName</a:t>
+            </a:r>
+            <a:r>
+              <a:rPr lang="en-US" sz="1400" dirty="0">
+                <a:latin typeface="Courier New" panose="02070309020205020404" pitchFamily="49" charset="0"/>
+                <a:cs typeface="Courier New" panose="02070309020205020404" pitchFamily="49" charset="0"/>
+              </a:rPr>
+              <a:t>": "</a:t>
+            </a:r>
+            <a:r>
+              <a:rPr lang="en-US" sz="1400" dirty="0" err="1">
+                <a:latin typeface="Courier New" panose="02070309020205020404" pitchFamily="49" charset="0"/>
+                <a:cs typeface="Courier New" panose="02070309020205020404" pitchFamily="49" charset="0"/>
+              </a:rPr>
+              <a:t>LaToulousaine</a:t>
+            </a:r>
+            <a:r>
+              <a:rPr lang="en-US" sz="1400" dirty="0">
+                <a:latin typeface="Courier New" panose="02070309020205020404" pitchFamily="49" charset="0"/>
+                <a:cs typeface="Courier New" panose="02070309020205020404" pitchFamily="49" charset="0"/>
+              </a:rPr>
+              <a:t>/France/$France",</a:t>
+            </a:r>
+          </a:p>
+          <a:p>
+            <a:r>
+              <a:rPr lang="en-US" sz="1400" dirty="0">
+                <a:latin typeface="Courier New" panose="02070309020205020404" pitchFamily="49" charset="0"/>
+                <a:cs typeface="Courier New" panose="02070309020205020404" pitchFamily="49" charset="0"/>
+              </a:rPr>
+              <a:t>    "Parties": [</a:t>
+            </a:r>
+          </a:p>
+          <a:p>
+            <a:r>
+              <a:rPr lang="en-US" sz="1400" dirty="0">
+                <a:latin typeface="Courier New" panose="02070309020205020404" pitchFamily="49" charset="0"/>
+                <a:cs typeface="Courier New" panose="02070309020205020404" pitchFamily="49" charset="0"/>
+              </a:rPr>
+              <a:t>    {</a:t>
+            </a:r>
+          </a:p>
+          <a:p>
+            <a:r>
+              <a:rPr lang="en-US" sz="1400" dirty="0">
+                <a:latin typeface="Courier New" panose="02070309020205020404" pitchFamily="49" charset="0"/>
+                <a:cs typeface="Courier New" panose="02070309020205020404" pitchFamily="49" charset="0"/>
+              </a:rPr>
+              <a:t>      "</a:t>
+            </a:r>
+            <a:r>
+              <a:rPr lang="en-US" sz="1400" dirty="0" err="1">
+                <a:latin typeface="Courier New" panose="02070309020205020404" pitchFamily="49" charset="0"/>
+                <a:cs typeface="Courier New" panose="02070309020205020404" pitchFamily="49" charset="0"/>
+              </a:rPr>
+              <a:t>PartyName</a:t>
+            </a:r>
+            <a:r>
+              <a:rPr lang="en-US" sz="1400" dirty="0">
+                <a:latin typeface="Courier New" panose="02070309020205020404" pitchFamily="49" charset="0"/>
+                <a:cs typeface="Courier New" panose="02070309020205020404" pitchFamily="49" charset="0"/>
+              </a:rPr>
+              <a:t>": "$</a:t>
+            </a:r>
+            <a:r>
+              <a:rPr lang="en-US" sz="1400" dirty="0" err="1">
+                <a:latin typeface="Courier New" panose="02070309020205020404" pitchFamily="49" charset="0"/>
+                <a:cs typeface="Courier New" panose="02070309020205020404" pitchFamily="49" charset="0"/>
+              </a:rPr>
+              <a:t>SignatureBox</a:t>
+            </a:r>
+            <a:r>
+              <a:rPr lang="en-US" sz="1400" dirty="0">
+                <a:latin typeface="Courier New" panose="02070309020205020404" pitchFamily="49" charset="0"/>
+                <a:cs typeface="Courier New" panose="02070309020205020404" pitchFamily="49" charset="0"/>
+              </a:rPr>
+              <a:t>"</a:t>
+            </a:r>
+          </a:p>
+          <a:p>
+            <a:r>
+              <a:rPr lang="en-US" sz="1400" dirty="0">
+                <a:latin typeface="Courier New" panose="02070309020205020404" pitchFamily="49" charset="0"/>
+                <a:cs typeface="Courier New" panose="02070309020205020404" pitchFamily="49" charset="0"/>
+              </a:rPr>
+              <a:t>    }]</a:t>
+            </a:r>
+          </a:p>
+          <a:p>
+            <a:r>
+              <a:rPr lang="en-US" sz="1400" dirty="0">
+                <a:latin typeface="Courier New" panose="02070309020205020404" pitchFamily="49" charset="0"/>
+                <a:cs typeface="Courier New" panose="02070309020205020404" pitchFamily="49" charset="0"/>
+              </a:rPr>
+              <a:t>  },</a:t>
+            </a:r>
+          </a:p>
+          <a:p>
+            <a:r>
+              <a:rPr lang="en-US" sz="1400" dirty="0">
+                <a:latin typeface="Courier New" panose="02070309020205020404" pitchFamily="49" charset="0"/>
+                <a:cs typeface="Courier New" panose="02070309020205020404" pitchFamily="49" charset="0"/>
+              </a:rPr>
+              <a:t>  {</a:t>
+            </a:r>
+          </a:p>
+          <a:p>
+            <a:r>
+              <a:rPr lang="en-US" sz="1400" dirty="0">
+                <a:latin typeface="Courier New" panose="02070309020205020404" pitchFamily="49" charset="0"/>
+                <a:cs typeface="Courier New" panose="02070309020205020404" pitchFamily="49" charset="0"/>
+              </a:rPr>
+              <a:t>    "</a:t>
+            </a:r>
+            <a:r>
+              <a:rPr lang="en-US" sz="1400" dirty="0" err="1">
+                <a:latin typeface="Courier New" panose="02070309020205020404" pitchFamily="49" charset="0"/>
+                <a:cs typeface="Courier New" panose="02070309020205020404" pitchFamily="49" charset="0"/>
+              </a:rPr>
+              <a:t>FullName</a:t>
+            </a:r>
+            <a:r>
+              <a:rPr lang="en-US" sz="1400" dirty="0">
+                <a:latin typeface="Courier New" panose="02070309020205020404" pitchFamily="49" charset="0"/>
+                <a:cs typeface="Courier New" panose="02070309020205020404" pitchFamily="49" charset="0"/>
+              </a:rPr>
+              <a:t>": "</a:t>
+            </a:r>
+            <a:r>
+              <a:rPr lang="en-US" sz="1400" dirty="0" err="1">
+                <a:latin typeface="Courier New" panose="02070309020205020404" pitchFamily="49" charset="0"/>
+                <a:cs typeface="Courier New" panose="02070309020205020404" pitchFamily="49" charset="0"/>
+              </a:rPr>
+              <a:t>LaToulousaine</a:t>
+            </a:r>
+            <a:r>
+              <a:rPr lang="en-US" sz="1400" dirty="0">
+                <a:latin typeface="Courier New" panose="02070309020205020404" pitchFamily="49" charset="0"/>
+                <a:cs typeface="Courier New" panose="02070309020205020404" pitchFamily="49" charset="0"/>
+              </a:rPr>
+              <a:t>/London/$London",</a:t>
+            </a:r>
+          </a:p>
+          <a:p>
+            <a:r>
+              <a:rPr lang="en-US" sz="1400" dirty="0">
+                <a:latin typeface="Courier New" panose="02070309020205020404" pitchFamily="49" charset="0"/>
+                <a:cs typeface="Courier New" panose="02070309020205020404" pitchFamily="49" charset="0"/>
+              </a:rPr>
+              <a:t>    "Parties": [</a:t>
+            </a:r>
+          </a:p>
+          <a:p>
+            <a:r>
+              <a:rPr lang="en-US" sz="1400" dirty="0">
+                <a:latin typeface="Courier New" panose="02070309020205020404" pitchFamily="49" charset="0"/>
+                <a:cs typeface="Courier New" panose="02070309020205020404" pitchFamily="49" charset="0"/>
+              </a:rPr>
+              <a:t>    {</a:t>
+            </a:r>
+          </a:p>
+          <a:p>
+            <a:r>
+              <a:rPr lang="en-US" sz="1400" dirty="0">
+                <a:latin typeface="Courier New" panose="02070309020205020404" pitchFamily="49" charset="0"/>
+                <a:cs typeface="Courier New" panose="02070309020205020404" pitchFamily="49" charset="0"/>
+              </a:rPr>
+              <a:t>      "</a:t>
+            </a:r>
+            <a:r>
+              <a:rPr lang="en-US" sz="1400" dirty="0" err="1">
+                <a:latin typeface="Courier New" panose="02070309020205020404" pitchFamily="49" charset="0"/>
+                <a:cs typeface="Courier New" panose="02070309020205020404" pitchFamily="49" charset="0"/>
+              </a:rPr>
+              <a:t>PartyName</a:t>
+            </a:r>
+            <a:r>
+              <a:rPr lang="en-US" sz="1400" dirty="0">
+                <a:latin typeface="Courier New" panose="02070309020205020404" pitchFamily="49" charset="0"/>
+                <a:cs typeface="Courier New" panose="02070309020205020404" pitchFamily="49" charset="0"/>
+              </a:rPr>
+              <a:t>": "$</a:t>
+            </a:r>
+            <a:r>
+              <a:rPr lang="en-US" sz="1400" dirty="0" err="1">
+                <a:latin typeface="Courier New" panose="02070309020205020404" pitchFamily="49" charset="0"/>
+                <a:cs typeface="Courier New" panose="02070309020205020404" pitchFamily="49" charset="0"/>
+              </a:rPr>
+              <a:t>SignatureBox</a:t>
+            </a:r>
+            <a:r>
+              <a:rPr lang="en-US" sz="1400" dirty="0">
+                <a:latin typeface="Courier New" panose="02070309020205020404" pitchFamily="49" charset="0"/>
+                <a:cs typeface="Courier New" panose="02070309020205020404" pitchFamily="49" charset="0"/>
+              </a:rPr>
+              <a:t>"</a:t>
+            </a:r>
+          </a:p>
+          <a:p>
+            <a:r>
+              <a:rPr lang="en-US" sz="1400" dirty="0">
+                <a:latin typeface="Courier New" panose="02070309020205020404" pitchFamily="49" charset="0"/>
+                <a:cs typeface="Courier New" panose="02070309020205020404" pitchFamily="49" charset="0"/>
+              </a:rPr>
+              <a:t>    }]</a:t>
+            </a:r>
+          </a:p>
+          <a:p>
+            <a:r>
+              <a:rPr lang="en-US" sz="1400" dirty="0">
+                <a:latin typeface="Courier New" panose="02070309020205020404" pitchFamily="49" charset="0"/>
+                <a:cs typeface="Courier New" panose="02070309020205020404" pitchFamily="49" charset="0"/>
+              </a:rPr>
+              <a:t>  }]</a:t>
+            </a:r>
+          </a:p>
+          <a:p>
+            <a:r>
+              <a:rPr lang="en-US" sz="1400" dirty="0">
+                <a:latin typeface="Courier New" panose="02070309020205020404" pitchFamily="49" charset="0"/>
+                <a:cs typeface="Courier New" panose="02070309020205020404" pitchFamily="49" charset="0"/>
+              </a:rPr>
+              <a:t>}</a:t>
+            </a:r>
+          </a:p>
+        </p:txBody>
+      </p:sp>
+      <p:sp>
+        <p:nvSpPr>
+          <p:cNvPr id="5" name="TextBox 4">
+            <a:extLst>
+              <a:ext uri="{FF2B5EF4-FFF2-40B4-BE49-F238E27FC236}">
+                <a16:creationId xmlns:a16="http://schemas.microsoft.com/office/drawing/2014/main" id="{D8052A3A-EBF7-3C28-4E2D-D46F44ACBE03}"/>
+              </a:ext>
+            </a:extLst>
+          </p:cNvPr>
+          <p:cNvSpPr txBox="1"/>
+          <p:nvPr/>
+        </p:nvSpPr>
+        <p:spPr>
+          <a:xfrm>
+            <a:off x="6280824" y="1690688"/>
+            <a:ext cx="5613588" cy="1815882"/>
+          </a:xfrm>
+          <a:prstGeom prst="rect">
+            <a:avLst/>
+          </a:prstGeom>
+          <a:noFill/>
+        </p:spPr>
+        <p:txBody>
+          <a:bodyPr wrap="square" rtlCol="0">
+            <a:spAutoFit/>
+          </a:bodyPr>
+          <a:lstStyle/>
+          <a:p>
+            <a:r>
+              <a:rPr lang="en-US" sz="1400" dirty="0">
+                <a:latin typeface="Courier New" panose="02070309020205020404" pitchFamily="49" charset="0"/>
+                <a:cs typeface="Courier New" panose="02070309020205020404" pitchFamily="49" charset="0"/>
+              </a:rPr>
+              <a:t>{</a:t>
+            </a:r>
+          </a:p>
+          <a:p>
+            <a:r>
+              <a:rPr lang="en-US" sz="1400" dirty="0">
+                <a:latin typeface="Courier New" panose="02070309020205020404" pitchFamily="49" charset="0"/>
+                <a:cs typeface="Courier New" panose="02070309020205020404" pitchFamily="49" charset="0"/>
+              </a:rPr>
+              <a:t>  "</a:t>
+            </a:r>
+            <a:r>
+              <a:rPr lang="en-US" sz="1400" dirty="0" err="1">
+                <a:latin typeface="Courier New" panose="02070309020205020404" pitchFamily="49" charset="0"/>
+                <a:cs typeface="Courier New" panose="02070309020205020404" pitchFamily="49" charset="0"/>
+              </a:rPr>
+              <a:t>FullName</a:t>
+            </a:r>
+            <a:r>
+              <a:rPr lang="en-US" sz="1400" dirty="0">
+                <a:latin typeface="Courier New" panose="02070309020205020404" pitchFamily="49" charset="0"/>
+                <a:cs typeface="Courier New" panose="02070309020205020404" pitchFamily="49" charset="0"/>
+              </a:rPr>
+              <a:t>": "</a:t>
+            </a:r>
+            <a:r>
+              <a:rPr lang="en-US" sz="1400" dirty="0" err="1">
+                <a:latin typeface="Courier New" panose="02070309020205020404" pitchFamily="49" charset="0"/>
+                <a:cs typeface="Courier New" panose="02070309020205020404" pitchFamily="49" charset="0"/>
+              </a:rPr>
+              <a:t>LaToulousaine</a:t>
+            </a:r>
+            <a:r>
+              <a:rPr lang="en-US" sz="1400" dirty="0">
+                <a:latin typeface="Courier New" panose="02070309020205020404" pitchFamily="49" charset="0"/>
+                <a:cs typeface="Courier New" panose="02070309020205020404" pitchFamily="49" charset="0"/>
+              </a:rPr>
+              <a:t>/France/</a:t>
+            </a:r>
+            <a:r>
+              <a:rPr lang="en-US" sz="1400" b="1" dirty="0">
+                <a:latin typeface="Courier New" panose="02070309020205020404" pitchFamily="49" charset="0"/>
+                <a:cs typeface="Courier New" panose="02070309020205020404" pitchFamily="49" charset="0"/>
+              </a:rPr>
+              <a:t>$</a:t>
+            </a:r>
+            <a:r>
+              <a:rPr lang="en-US" sz="1400" b="1" dirty="0" err="1">
+                <a:latin typeface="Courier New" panose="02070309020205020404" pitchFamily="49" charset="0"/>
+                <a:cs typeface="Courier New" panose="02070309020205020404" pitchFamily="49" charset="0"/>
+              </a:rPr>
+              <a:t>SignatureBox</a:t>
+            </a:r>
+            <a:r>
+              <a:rPr lang="en-US" sz="1400" dirty="0">
+                <a:latin typeface="Courier New" panose="02070309020205020404" pitchFamily="49" charset="0"/>
+                <a:cs typeface="Courier New" panose="02070309020205020404" pitchFamily="49" charset="0"/>
+              </a:rPr>
               <a:t>",</a:t>
             </a:r>
           </a:p>
@@ -9330,68 +10251,182 @@
                 <a:latin typeface="Courier New" panose="02070309020205020404" pitchFamily="49" charset="0"/>
                 <a:cs typeface="Courier New" panose="02070309020205020404" pitchFamily="49" charset="0"/>
               </a:rPr>
-              <a:t>  </a:t>
+              <a:t>  "Parties": [</a:t>
+            </a:r>
+          </a:p>
+          <a:p>
+            <a:r>
+              <a:rPr lang="en-US" sz="1400" dirty="0">
+                <a:latin typeface="Courier New" panose="02070309020205020404" pitchFamily="49" charset="0"/>
+                <a:cs typeface="Courier New" panose="02070309020205020404" pitchFamily="49" charset="0"/>
+              </a:rPr>
+              <a:t>  {</a:t>
+            </a:r>
+          </a:p>
+          <a:p>
+            <a:r>
+              <a:rPr lang="en-US" sz="1400" dirty="0">
+                <a:latin typeface="Courier New" panose="02070309020205020404" pitchFamily="49" charset="0"/>
+                <a:cs typeface="Courier New" panose="02070309020205020404" pitchFamily="49" charset="0"/>
+              </a:rPr>
+              <a:t>    </a:t>
             </a:r>
             <a:r>
               <a:rPr lang="en-US" sz="1400" b="1" dirty="0">
                 <a:latin typeface="Courier New" panose="02070309020205020404" pitchFamily="49" charset="0"/>
                 <a:cs typeface="Courier New" panose="02070309020205020404" pitchFamily="49" charset="0"/>
               </a:rPr>
-              <a:t>"Environment": "#Production"</a:t>
-            </a:r>
-            <a:r>
-              <a:rPr lang="en-US" sz="1400" dirty="0">
-                <a:latin typeface="Courier New" panose="02070309020205020404" pitchFamily="49" charset="0"/>
-                <a:cs typeface="Courier New" panose="02070309020205020404" pitchFamily="49" charset="0"/>
-              </a:rPr>
-              <a:t>,</a:t>
-            </a:r>
-          </a:p>
-          <a:p>
-            <a:r>
-              <a:rPr lang="en-US" sz="1400" dirty="0">
-                <a:latin typeface="Courier New" panose="02070309020205020404" pitchFamily="49" charset="0"/>
-                <a:cs typeface="Courier New" panose="02070309020205020404" pitchFamily="49" charset="0"/>
-              </a:rPr>
-              <a:t>  "Local": {</a:t>
-            </a:r>
-          </a:p>
-          <a:p>
-            <a:r>
-              <a:rPr lang="en-US" sz="1400" dirty="0">
-                <a:latin typeface="Courier New" panose="02070309020205020404" pitchFamily="49" charset="0"/>
-                <a:cs typeface="Courier New" panose="02070309020205020404" pitchFamily="49" charset="0"/>
-              </a:rPr>
-              <a:t>    "Name": "OneCS1"</a:t>
-            </a:r>
-          </a:p>
-          <a:p>
-            <a:r>
-              <a:rPr lang="en-US" sz="1400" dirty="0">
-                <a:latin typeface="Courier New" panose="02070309020205020404" pitchFamily="49" charset="0"/>
-                <a:cs typeface="Courier New" panose="02070309020205020404" pitchFamily="49" charset="0"/>
-              </a:rPr>
-              <a:t>  },</a:t>
-            </a:r>
-            <a:br>
-              <a:rPr lang="en-US" sz="1400" dirty="0">
-                <a:latin typeface="Courier New" panose="02070309020205020404" pitchFamily="49" charset="0"/>
-                <a:cs typeface="Courier New" panose="02070309020205020404" pitchFamily="49" charset="0"/>
-              </a:rPr>
-            </a:br>
-            <a:r>
-              <a:rPr lang="en-US" sz="1400" dirty="0">
-                <a:latin typeface="Courier New" panose="02070309020205020404" pitchFamily="49" charset="0"/>
-                <a:cs typeface="Courier New" panose="02070309020205020404" pitchFamily="49" charset="0"/>
-              </a:rPr>
-              <a:t>  "Remotes": [</a:t>
-            </a:r>
-            <a:br>
-              <a:rPr lang="en-US" sz="1400" dirty="0">
-                <a:latin typeface="Courier New" panose="02070309020205020404" pitchFamily="49" charset="0"/>
-                <a:cs typeface="Courier New" panose="02070309020205020404" pitchFamily="49" charset="0"/>
-              </a:rPr>
-            </a:br>
+              <a:t>"</a:t>
+            </a:r>
+            <a:r>
+              <a:rPr lang="en-US" sz="1400" b="1" dirty="0" err="1">
+                <a:latin typeface="Courier New" panose="02070309020205020404" pitchFamily="49" charset="0"/>
+                <a:cs typeface="Courier New" panose="02070309020205020404" pitchFamily="49" charset="0"/>
+              </a:rPr>
+              <a:t>PartyName</a:t>
+            </a:r>
+            <a:r>
+              <a:rPr lang="en-US" sz="1400" b="1" dirty="0">
+                <a:latin typeface="Courier New" panose="02070309020205020404" pitchFamily="49" charset="0"/>
+                <a:cs typeface="Courier New" panose="02070309020205020404" pitchFamily="49" charset="0"/>
+              </a:rPr>
+              <a:t>": "$France",</a:t>
+            </a:r>
+          </a:p>
+          <a:p>
+            <a:pPr lvl="1"/>
+            <a:r>
+              <a:rPr lang="en-US" sz="1400" b="1" dirty="0">
+                <a:latin typeface="Courier New" panose="02070309020205020404" pitchFamily="49" charset="0"/>
+                <a:cs typeface="Courier New" panose="02070309020205020404" pitchFamily="49" charset="0"/>
+              </a:rPr>
+              <a:t>"Address": "27.28.29.30:3712"</a:t>
+            </a:r>
+          </a:p>
+          <a:p>
+            <a:r>
+              <a:rPr lang="en-US" sz="1400" dirty="0">
+                <a:latin typeface="Courier New" panose="02070309020205020404" pitchFamily="49" charset="0"/>
+                <a:cs typeface="Courier New" panose="02070309020205020404" pitchFamily="49" charset="0"/>
+              </a:rPr>
+              <a:t>  }]</a:t>
+            </a:r>
+          </a:p>
+          <a:p>
+            <a:r>
+              <a:rPr lang="en-US" sz="1400" dirty="0">
+                <a:latin typeface="Courier New" panose="02070309020205020404" pitchFamily="49" charset="0"/>
+                <a:cs typeface="Courier New" panose="02070309020205020404" pitchFamily="49" charset="0"/>
+              </a:rPr>
+              <a:t>}</a:t>
+            </a:r>
+          </a:p>
+        </p:txBody>
+      </p:sp>
+      <p:sp>
+        <p:nvSpPr>
+          <p:cNvPr id="6" name="TextBox 5">
+            <a:extLst>
+              <a:ext uri="{FF2B5EF4-FFF2-40B4-BE49-F238E27FC236}">
+                <a16:creationId xmlns:a16="http://schemas.microsoft.com/office/drawing/2014/main" id="{548426AA-A61E-323E-1908-225D6883F628}"/>
+              </a:ext>
+            </a:extLst>
+          </p:cNvPr>
+          <p:cNvSpPr txBox="1"/>
+          <p:nvPr/>
+        </p:nvSpPr>
+        <p:spPr>
+          <a:xfrm>
+            <a:off x="6280824" y="3759063"/>
+            <a:ext cx="5613588" cy="1815882"/>
+          </a:xfrm>
+          <a:prstGeom prst="rect">
+            <a:avLst/>
+          </a:prstGeom>
+          <a:noFill/>
+        </p:spPr>
+        <p:txBody>
+          <a:bodyPr wrap="square" rtlCol="0">
+            <a:spAutoFit/>
+          </a:bodyPr>
+          <a:lstStyle/>
+          <a:p>
+            <a:r>
+              <a:rPr lang="en-US" sz="1400" dirty="0">
+                <a:latin typeface="Courier New" panose="02070309020205020404" pitchFamily="49" charset="0"/>
+                <a:cs typeface="Courier New" panose="02070309020205020404" pitchFamily="49" charset="0"/>
+              </a:rPr>
+              <a:t>{</a:t>
+            </a:r>
+          </a:p>
+          <a:p>
+            <a:r>
+              <a:rPr lang="en-US" sz="1400" dirty="0">
+                <a:latin typeface="Courier New" panose="02070309020205020404" pitchFamily="49" charset="0"/>
+                <a:cs typeface="Courier New" panose="02070309020205020404" pitchFamily="49" charset="0"/>
+              </a:rPr>
+              <a:t>  "</a:t>
+            </a:r>
+            <a:r>
+              <a:rPr lang="en-US" sz="1400" dirty="0" err="1">
+                <a:latin typeface="Courier New" panose="02070309020205020404" pitchFamily="49" charset="0"/>
+                <a:cs typeface="Courier New" panose="02070309020205020404" pitchFamily="49" charset="0"/>
+              </a:rPr>
+              <a:t>FullName</a:t>
+            </a:r>
+            <a:r>
+              <a:rPr lang="en-US" sz="1400" dirty="0">
+                <a:latin typeface="Courier New" panose="02070309020205020404" pitchFamily="49" charset="0"/>
+                <a:cs typeface="Courier New" panose="02070309020205020404" pitchFamily="49" charset="0"/>
+              </a:rPr>
+              <a:t>": "</a:t>
+            </a:r>
+            <a:r>
+              <a:rPr lang="en-US" sz="1400" dirty="0" err="1">
+                <a:latin typeface="Courier New" panose="02070309020205020404" pitchFamily="49" charset="0"/>
+                <a:cs typeface="Courier New" panose="02070309020205020404" pitchFamily="49" charset="0"/>
+              </a:rPr>
+              <a:t>LaToulousaine</a:t>
+            </a:r>
+            <a:r>
+              <a:rPr lang="en-US" sz="1400" dirty="0">
+                <a:latin typeface="Courier New" panose="02070309020205020404" pitchFamily="49" charset="0"/>
+                <a:cs typeface="Courier New" panose="02070309020205020404" pitchFamily="49" charset="0"/>
+              </a:rPr>
+              <a:t>/London/</a:t>
+            </a:r>
+            <a:r>
+              <a:rPr lang="en-US" sz="1400" b="1" dirty="0">
+                <a:latin typeface="Courier New" panose="02070309020205020404" pitchFamily="49" charset="0"/>
+                <a:cs typeface="Courier New" panose="02070309020205020404" pitchFamily="49" charset="0"/>
+              </a:rPr>
+              <a:t>$</a:t>
+            </a:r>
+            <a:r>
+              <a:rPr lang="en-US" sz="1400" b="1" dirty="0" err="1">
+                <a:latin typeface="Courier New" panose="02070309020205020404" pitchFamily="49" charset="0"/>
+                <a:cs typeface="Courier New" panose="02070309020205020404" pitchFamily="49" charset="0"/>
+              </a:rPr>
+              <a:t>SignatureBox</a:t>
+            </a:r>
+            <a:r>
+              <a:rPr lang="en-US" sz="1400" dirty="0">
+                <a:latin typeface="Courier New" panose="02070309020205020404" pitchFamily="49" charset="0"/>
+                <a:cs typeface="Courier New" panose="02070309020205020404" pitchFamily="49" charset="0"/>
+              </a:rPr>
+              <a:t>",</a:t>
+            </a:r>
+          </a:p>
+          <a:p>
+            <a:r>
+              <a:rPr lang="en-US" sz="1400" dirty="0">
+                <a:latin typeface="Courier New" panose="02070309020205020404" pitchFamily="49" charset="0"/>
+                <a:cs typeface="Courier New" panose="02070309020205020404" pitchFamily="49" charset="0"/>
+              </a:rPr>
+              <a:t>  "Parties": [</a:t>
+            </a:r>
+          </a:p>
+          <a:p>
             <a:r>
               <a:rPr lang="en-US" sz="1400" dirty="0">
                 <a:latin typeface="Courier New" panose="02070309020205020404" pitchFamily="49" charset="0"/>
@@ -9406,144 +10441,38 @@
                 <a:latin typeface="Courier New" panose="02070309020205020404" pitchFamily="49" charset="0"/>
                 <a:cs typeface="Courier New" panose="02070309020205020404" pitchFamily="49" charset="0"/>
               </a:rPr>
-              <a:t>    "</a:t>
-            </a:r>
-            <a:r>
-              <a:rPr lang="en-US" sz="1400" dirty="0" err="1">
-                <a:latin typeface="Courier New" panose="02070309020205020404" pitchFamily="49" charset="0"/>
-                <a:cs typeface="Courier New" panose="02070309020205020404" pitchFamily="49" charset="0"/>
-              </a:rPr>
-              <a:t>DomainName</a:t>
-            </a:r>
-            <a:r>
-              <a:rPr lang="en-US" sz="1400" dirty="0">
-                <a:latin typeface="Courier New" panose="02070309020205020404" pitchFamily="49" charset="0"/>
-                <a:cs typeface="Courier New" panose="02070309020205020404" pitchFamily="49" charset="0"/>
-              </a:rPr>
-              <a:t>": "</a:t>
-            </a:r>
-            <a:r>
-              <a:rPr lang="en-US" sz="1400" dirty="0" err="1">
-                <a:latin typeface="Courier New" panose="02070309020205020404" pitchFamily="49" charset="0"/>
-                <a:cs typeface="Courier New" panose="02070309020205020404" pitchFamily="49" charset="0"/>
-              </a:rPr>
-              <a:t>LaToulousaine</a:t>
-            </a:r>
-            <a:r>
-              <a:rPr lang="en-US" sz="1400" dirty="0">
-                <a:latin typeface="Courier New" panose="02070309020205020404" pitchFamily="49" charset="0"/>
-                <a:cs typeface="Courier New" panose="02070309020205020404" pitchFamily="49" charset="0"/>
-              </a:rPr>
-              <a:t>/France",</a:t>
-            </a:r>
-          </a:p>
-          <a:p>
-            <a:r>
-              <a:rPr lang="en-US" sz="1400" dirty="0">
-                <a:latin typeface="Courier New" panose="02070309020205020404" pitchFamily="49" charset="0"/>
-                <a:cs typeface="Courier New" panose="02070309020205020404" pitchFamily="49" charset="0"/>
-              </a:rPr>
-              <a:t>    "Domain": {</a:t>
-            </a:r>
-          </a:p>
-          <a:p>
-            <a:r>
-              <a:rPr lang="en-US" sz="1400" dirty="0">
-                <a:latin typeface="Courier New" panose="02070309020205020404" pitchFamily="49" charset="0"/>
-                <a:cs typeface="Courier New" panose="02070309020205020404" pitchFamily="49" charset="0"/>
-              </a:rPr>
-              <a:t>      "Remotes": [ … ]</a:t>
-            </a:r>
-          </a:p>
-          <a:p>
-            <a:r>
-              <a:rPr lang="en-US" sz="1400" dirty="0">
-                <a:latin typeface="Courier New" panose="02070309020205020404" pitchFamily="49" charset="0"/>
-                <a:cs typeface="Courier New" panose="02070309020205020404" pitchFamily="49" charset="0"/>
-              </a:rPr>
-              <a:t>    }</a:t>
-            </a:r>
-          </a:p>
-          <a:p>
-            <a:r>
-              <a:rPr lang="en-US" sz="1400" dirty="0">
-                <a:latin typeface="Courier New" panose="02070309020205020404" pitchFamily="49" charset="0"/>
-                <a:cs typeface="Courier New" panose="02070309020205020404" pitchFamily="49" charset="0"/>
-              </a:rPr>
-              <a:t>  },</a:t>
-            </a:r>
-          </a:p>
-          <a:p>
-            <a:r>
-              <a:rPr lang="en-US" sz="1400" dirty="0">
-                <a:latin typeface="Courier New" panose="02070309020205020404" pitchFamily="49" charset="0"/>
-                <a:cs typeface="Courier New" panose="02070309020205020404" pitchFamily="49" charset="0"/>
-              </a:rPr>
-              <a:t>  {</a:t>
-            </a:r>
-          </a:p>
-          <a:p>
-            <a:r>
-              <a:rPr lang="en-US" sz="1400" dirty="0">
-                <a:latin typeface="Courier New" panose="02070309020205020404" pitchFamily="49" charset="0"/>
-                <a:cs typeface="Courier New" panose="02070309020205020404" pitchFamily="49" charset="0"/>
-              </a:rPr>
-              <a:t>    "</a:t>
-            </a:r>
-            <a:r>
-              <a:rPr lang="en-US" sz="1400" dirty="0" err="1">
-                <a:latin typeface="Courier New" panose="02070309020205020404" pitchFamily="49" charset="0"/>
-                <a:cs typeface="Courier New" panose="02070309020205020404" pitchFamily="49" charset="0"/>
-              </a:rPr>
-              <a:t>DomainName</a:t>
-            </a:r>
-            <a:r>
-              <a:rPr lang="en-US" sz="1400" dirty="0">
-                <a:latin typeface="Courier New" panose="02070309020205020404" pitchFamily="49" charset="0"/>
-                <a:cs typeface="Courier New" panose="02070309020205020404" pitchFamily="49" charset="0"/>
-              </a:rPr>
-              <a:t>": "</a:t>
-            </a:r>
-            <a:r>
-              <a:rPr lang="en-US" sz="1400" dirty="0" err="1">
-                <a:latin typeface="Courier New" panose="02070309020205020404" pitchFamily="49" charset="0"/>
-                <a:cs typeface="Courier New" panose="02070309020205020404" pitchFamily="49" charset="0"/>
-              </a:rPr>
-              <a:t>LaToulousaine</a:t>
-            </a:r>
-            <a:r>
-              <a:rPr lang="en-US" sz="1400" dirty="0">
-                <a:latin typeface="Courier New" panose="02070309020205020404" pitchFamily="49" charset="0"/>
-                <a:cs typeface="Courier New" panose="02070309020205020404" pitchFamily="49" charset="0"/>
-              </a:rPr>
-              <a:t>/London",</a:t>
-            </a:r>
-          </a:p>
-          <a:p>
-            <a:r>
-              <a:rPr lang="en-US" sz="1400" dirty="0">
-                <a:latin typeface="Courier New" panose="02070309020205020404" pitchFamily="49" charset="0"/>
-                <a:cs typeface="Courier New" panose="02070309020205020404" pitchFamily="49" charset="0"/>
-              </a:rPr>
-              <a:t>    "Domain": {</a:t>
-            </a:r>
-          </a:p>
-          <a:p>
-            <a:r>
-              <a:rPr lang="en-US" sz="1400" dirty="0">
-                <a:latin typeface="Courier New" panose="02070309020205020404" pitchFamily="49" charset="0"/>
-                <a:cs typeface="Courier New" panose="02070309020205020404" pitchFamily="49" charset="0"/>
-              </a:rPr>
-              <a:t>      "Remotes": [ … ]</a:t>
-            </a:r>
-          </a:p>
-          <a:p>
-            <a:r>
-              <a:rPr lang="en-US" sz="1400" dirty="0">
-                <a:latin typeface="Courier New" panose="02070309020205020404" pitchFamily="49" charset="0"/>
-                <a:cs typeface="Courier New" panose="02070309020205020404" pitchFamily="49" charset="0"/>
-              </a:rPr>
-              <a:t>    }</a:t>
+              <a:t>    </a:t>
+            </a:r>
+            <a:r>
+              <a:rPr lang="en-US" sz="1400" b="1" dirty="0">
+                <a:latin typeface="Courier New" panose="02070309020205020404" pitchFamily="49" charset="0"/>
+                <a:cs typeface="Courier New" panose="02070309020205020404" pitchFamily="49" charset="0"/>
+              </a:rPr>
+              <a:t>"</a:t>
+            </a:r>
+            <a:r>
+              <a:rPr lang="en-US" sz="1400" b="1" dirty="0" err="1">
+                <a:latin typeface="Courier New" panose="02070309020205020404" pitchFamily="49" charset="0"/>
+                <a:cs typeface="Courier New" panose="02070309020205020404" pitchFamily="49" charset="0"/>
+              </a:rPr>
+              <a:t>PartyName</a:t>
+            </a:r>
+            <a:r>
+              <a:rPr lang="en-US" sz="1400" b="1" dirty="0">
+                <a:latin typeface="Courier New" panose="02070309020205020404" pitchFamily="49" charset="0"/>
+                <a:cs typeface="Courier New" panose="02070309020205020404" pitchFamily="49" charset="0"/>
+              </a:rPr>
+              <a:t>": "$London",</a:t>
+            </a:r>
+          </a:p>
+          <a:p>
+            <a:pPr lvl="1"/>
+            <a:r>
+              <a:rPr lang="en-US" sz="1400" b="1" dirty="0">
+                <a:latin typeface="Courier New" panose="02070309020205020404" pitchFamily="49" charset="0"/>
+                <a:cs typeface="Courier New" panose="02070309020205020404" pitchFamily="49" charset="0"/>
+              </a:rPr>
+              <a:t>"Address": "27.28.29.30:3712"</a:t>
             </a:r>
           </a:p>
           <a:p>
@@ -9779,7 +10708,7 @@
         </p:nvSpPr>
         <p:spPr>
           <a:xfrm>
-            <a:off x="838200" y="1825625"/>
+            <a:off x="838200" y="1690688"/>
             <a:ext cx="10515600" cy="888392"/>
           </a:xfrm>
         </p:spPr>
@@ -10127,7 +11056,7 @@
                 <a:latin typeface="Courier New" panose="02070309020205020404" pitchFamily="49" charset="0"/>
                 <a:cs typeface="Courier New" panose="02070309020205020404" pitchFamily="49" charset="0"/>
               </a:rPr>
-              <a:t>": "Undefined"</a:t>
+              <a:t>": "External"</a:t>
             </a:r>
             <a:r>
               <a:rPr lang="en-US" sz="1400" dirty="0">
@@ -10344,7 +11273,21 @@
                 <a:latin typeface="Courier New" panose="02070309020205020404" pitchFamily="49" charset="0"/>
                 <a:cs typeface="Courier New" panose="02070309020205020404" pitchFamily="49" charset="0"/>
               </a:rPr>
-              <a:t>": "Undefined",</a:t>
+              <a:t>": "</a:t>
+            </a:r>
+            <a:r>
+              <a:rPr lang="en-US" sz="1400" b="1" dirty="0">
+                <a:latin typeface="Courier New" panose="02070309020205020404" pitchFamily="49" charset="0"/>
+                <a:cs typeface="Courier New" panose="02070309020205020404" pitchFamily="49" charset="0"/>
+              </a:rPr>
+              <a:t>External</a:t>
+            </a:r>
+            <a:r>
+              <a:rPr lang="en-US" sz="1400" dirty="0">
+                <a:latin typeface="Courier New" panose="02070309020205020404" pitchFamily="49" charset="0"/>
+                <a:cs typeface="Courier New" panose="02070309020205020404" pitchFamily="49" charset="0"/>
+              </a:rPr>
+              <a:t>",</a:t>
             </a:r>
           </a:p>
           <a:p>
@@ -10716,7 +11659,7 @@
           <a:p>
             <a:r>
               <a:rPr lang="en-US" dirty="0"/>
-              <a:t>“Undefined” is the reserved Domain name that means “external to the System”</a:t>
+              <a:t>“External” and “Undefined” are the reserved Domain names that means “external to the System”</a:t>
             </a:r>
           </a:p>
           <a:p>
@@ -10956,6 +11899,86 @@
           <p:cNvPr id="2" name="Title 1">
             <a:extLst>
               <a:ext uri="{FF2B5EF4-FFF2-40B4-BE49-F238E27FC236}">
+                <a16:creationId xmlns:a16="http://schemas.microsoft.com/office/drawing/2014/main" id="{2ADDEB0D-75FE-A9E7-AE5D-1A00BE2CB4EF}"/>
+              </a:ext>
+            </a:extLst>
+          </p:cNvPr>
+          <p:cNvSpPr>
+            <a:spLocks noGrp="1"/>
+          </p:cNvSpPr>
+          <p:nvPr>
+            <p:ph type="title"/>
+          </p:nvPr>
+        </p:nvSpPr>
+        <p:spPr/>
+        <p:txBody>
+          <a:bodyPr/>
+          <a:lstStyle/>
+          <a:p>
+            <a:endParaRPr lang="en-US"/>
+          </a:p>
+        </p:txBody>
+      </p:sp>
+      <p:sp>
+        <p:nvSpPr>
+          <p:cNvPr id="3" name="Content Placeholder 2">
+            <a:extLst>
+              <a:ext uri="{FF2B5EF4-FFF2-40B4-BE49-F238E27FC236}">
+                <a16:creationId xmlns:a16="http://schemas.microsoft.com/office/drawing/2014/main" id="{69BD3F96-4E3A-A64D-A143-5E0F643AB7C5}"/>
+              </a:ext>
+            </a:extLst>
+          </p:cNvPr>
+          <p:cNvSpPr>
+            <a:spLocks noGrp="1"/>
+          </p:cNvSpPr>
+          <p:nvPr>
+            <p:ph idx="1"/>
+          </p:nvPr>
+        </p:nvSpPr>
+        <p:spPr/>
+        <p:txBody>
+          <a:bodyPr/>
+          <a:lstStyle/>
+          <a:p>
+            <a:endParaRPr lang="en-US"/>
+          </a:p>
+        </p:txBody>
+      </p:sp>
+    </p:spTree>
+    <p:extLst>
+      <p:ext uri="{BB962C8B-B14F-4D97-AF65-F5344CB8AC3E}">
+        <p14:creationId xmlns:p14="http://schemas.microsoft.com/office/powerpoint/2010/main" val="4293717367"/>
+      </p:ext>
+    </p:extLst>
+  </p:cSld>
+  <p:clrMapOvr>
+    <a:masterClrMapping/>
+  </p:clrMapOvr>
+</p:sld>
+</file>
+
+<file path=ppt/slides/slide21.xml><?xml version="1.0" encoding="utf-8"?>
+<p:sld xmlns:a="http://schemas.openxmlformats.org/drawingml/2006/main" xmlns:r="http://schemas.openxmlformats.org/officeDocument/2006/relationships" xmlns:p="http://schemas.openxmlformats.org/presentationml/2006/main">
+  <p:cSld>
+    <p:spTree>
+      <p:nvGrpSpPr>
+        <p:cNvPr id="1" name=""/>
+        <p:cNvGrpSpPr/>
+        <p:nvPr/>
+      </p:nvGrpSpPr>
+      <p:grpSpPr>
+        <a:xfrm>
+          <a:off x="0" y="0"/>
+          <a:ext cx="0" cy="0"/>
+          <a:chOff x="0" y="0"/>
+          <a:chExt cx="0" cy="0"/>
+        </a:xfrm>
+      </p:grpSpPr>
+      <p:sp>
+        <p:nvSpPr>
+          <p:cNvPr id="2" name="Title 1">
+            <a:extLst>
+              <a:ext uri="{FF2B5EF4-FFF2-40B4-BE49-F238E27FC236}">
                 <a16:creationId xmlns:a16="http://schemas.microsoft.com/office/drawing/2014/main" id="{A798245F-DD26-ADCC-6CD2-D5ED5F5598A9}"/>
               </a:ext>
             </a:extLst>
@@ -11027,7 +12050,7 @@
 </p:sld>
 </file>
 
-<file path=ppt/slides/slide21.xml><?xml version="1.0" encoding="utf-8"?>
+<file path=ppt/slides/slide22.xml><?xml version="1.0" encoding="utf-8"?>
 <p:sld xmlns:a="http://schemas.openxmlformats.org/drawingml/2006/main" xmlns:r="http://schemas.openxmlformats.org/officeDocument/2006/relationships" xmlns:p="http://schemas.openxmlformats.org/presentationml/2006/main">
   <p:cSld>
     <p:spTree>
@@ -11178,8 +12201,8 @@
         </p:nvSpPr>
         <p:spPr>
           <a:xfrm>
-            <a:off x="1066803" y="4760763"/>
-            <a:ext cx="10609382" cy="1815882"/>
+            <a:off x="981811" y="4895700"/>
+            <a:ext cx="10609382" cy="1569660"/>
           </a:xfrm>
           <a:prstGeom prst="rect">
             <a:avLst/>
@@ -11193,7 +12216,7 @@
           <a:lstStyle/>
           <a:p>
             <a:r>
-              <a:rPr lang="en-US" sz="1600">
+              <a:rPr lang="en-US" sz="1600" dirty="0">
                 <a:solidFill>
                   <a:srgbClr val="0000FF"/>
                 </a:solidFill>
@@ -11202,29 +12225,47 @@
               <a:t>var</a:t>
             </a:r>
             <a:r>
-              <a:rPr lang="en-US" sz="1600">
+              <a:rPr lang="en-US" sz="1600" dirty="0">
                 <a:solidFill>
                   <a:srgbClr val="000000"/>
                 </a:solidFill>
                 <a:latin typeface="Consolas" panose="020B0609020204030204" pitchFamily="49" charset="0"/>
               </a:rPr>
-              <a:t> configuration = ApplicationIdentityConfiguration.Create( monitor, c =&gt;</a:t>
-            </a:r>
-          </a:p>
-          <a:p>
-            <a:r>
-              <a:rPr lang="en-US" sz="1600">
+              <a:t> configuration = </a:t>
+            </a:r>
+            <a:r>
+              <a:rPr lang="en-US" sz="1600" dirty="0" err="1">
                 <a:solidFill>
                   <a:srgbClr val="000000"/>
                 </a:solidFill>
                 <a:latin typeface="Consolas" panose="020B0609020204030204" pitchFamily="49" charset="0"/>
               </a:rPr>
+              <a:t>ApplicationIdentityConfiguration.Create</a:t>
+            </a:r>
+            <a:r>
+              <a:rPr lang="en-US" sz="1600" dirty="0">
+                <a:solidFill>
+                  <a:srgbClr val="000000"/>
+                </a:solidFill>
+                <a:latin typeface="Consolas" panose="020B0609020204030204" pitchFamily="49" charset="0"/>
+              </a:rPr>
+              <a:t>( monitor, c =&gt;</a:t>
+            </a:r>
+          </a:p>
+          <a:p>
+            <a:r>
+              <a:rPr lang="en-US" sz="1600" dirty="0">
+                <a:solidFill>
+                  <a:srgbClr val="000000"/>
+                </a:solidFill>
+                <a:latin typeface="Consolas" panose="020B0609020204030204" pitchFamily="49" charset="0"/>
+              </a:rPr>
               <a:t>{</a:t>
             </a:r>
           </a:p>
           <a:p>
             <a:r>
-              <a:rPr lang="en-US" sz="1600">
+              <a:rPr lang="en-US" sz="1600" dirty="0">
                 <a:solidFill>
                   <a:srgbClr val="000000"/>
                 </a:solidFill>
@@ -11233,16 +12274,34 @@
               <a:t>  c[</a:t>
             </a:r>
             <a:r>
-              <a:rPr lang="en-US" sz="1600">
+              <a:rPr lang="en-US" sz="1600" dirty="0">
                 <a:solidFill>
                   <a:srgbClr val="A31515"/>
                 </a:solidFill>
                 <a:latin typeface="Consolas" panose="020B0609020204030204" pitchFamily="49" charset="0"/>
               </a:rPr>
-              <a:t>"DomainName"</a:t>
-            </a:r>
-            <a:r>
-              <a:rPr lang="en-US" sz="1600">
+              <a:t>"</a:t>
+            </a:r>
+            <a:r>
+              <a:rPr lang="en-US" sz="1600" dirty="0" err="1">
+                <a:solidFill>
+                  <a:srgbClr val="A31515"/>
+                </a:solidFill>
+                <a:latin typeface="Consolas" panose="020B0609020204030204" pitchFamily="49" charset="0"/>
+              </a:rPr>
+              <a:t>FullName</a:t>
+            </a:r>
+            <a:r>
+              <a:rPr lang="en-US" sz="1600" dirty="0">
+                <a:solidFill>
+                  <a:srgbClr val="A31515"/>
+                </a:solidFill>
+                <a:latin typeface="Consolas" panose="020B0609020204030204" pitchFamily="49" charset="0"/>
+              </a:rPr>
+              <a:t>"</a:t>
+            </a:r>
+            <a:r>
+              <a:rPr lang="en-US" sz="1600" dirty="0">
                 <a:solidFill>
                   <a:srgbClr val="000000"/>
                 </a:solidFill>
@@ -11251,16 +12310,16 @@
               <a:t>] = </a:t>
             </a:r>
             <a:r>
-              <a:rPr lang="en-US" sz="1600">
+              <a:rPr lang="en-US" sz="1600" dirty="0">
                 <a:solidFill>
                   <a:srgbClr val="A31515"/>
                 </a:solidFill>
                 <a:latin typeface="Consolas" panose="020B0609020204030204" pitchFamily="49" charset="0"/>
               </a:rPr>
-              <a:t>"Test"</a:t>
-            </a:r>
-            <a:r>
-              <a:rPr lang="en-US" sz="1600">
+              <a:t>"Test/$Listener"</a:t>
+            </a:r>
+            <a:r>
+              <a:rPr lang="en-US" sz="1600" dirty="0">
                 <a:solidFill>
                   <a:srgbClr val="000000"/>
                 </a:solidFill>
@@ -11271,7 +12330,7 @@
           </a:p>
           <a:p>
             <a:r>
-              <a:rPr lang="en-US" sz="1600">
+              <a:rPr lang="en-US" sz="1600" dirty="0">
                 <a:solidFill>
                   <a:srgbClr val="000000"/>
                 </a:solidFill>
@@ -11280,16 +12339,16 @@
               <a:t>  c[</a:t>
             </a:r>
             <a:r>
-              <a:rPr lang="en-US" sz="1600">
+              <a:rPr lang="en-US" sz="1600" dirty="0">
                 <a:solidFill>
                   <a:srgbClr val="A31515"/>
                 </a:solidFill>
                 <a:latin typeface="Consolas" panose="020B0609020204030204" pitchFamily="49" charset="0"/>
               </a:rPr>
-              <a:t>"Local:Name"</a:t>
-            </a:r>
-            <a:r>
-              <a:rPr lang="en-US" sz="1600">
+              <a:t>"Remotes:0:PartyName"</a:t>
+            </a:r>
+            <a:r>
+              <a:rPr lang="en-US" sz="1600" dirty="0">
                 <a:solidFill>
                   <a:srgbClr val="000000"/>
                 </a:solidFill>
@@ -11298,16 +12357,16 @@
               <a:t>] = </a:t>
             </a:r>
             <a:r>
-              <a:rPr lang="en-US" sz="1600">
+              <a:rPr lang="en-US" sz="1600" dirty="0">
                 <a:solidFill>
                   <a:srgbClr val="A31515"/>
                 </a:solidFill>
                 <a:latin typeface="Consolas" panose="020B0609020204030204" pitchFamily="49" charset="0"/>
               </a:rPr>
-              <a:t>"Listener"</a:t>
-            </a:r>
-            <a:r>
-              <a:rPr lang="en-US" sz="1600">
+              <a:t>"Sender"</a:t>
+            </a:r>
+            <a:r>
+              <a:rPr lang="en-US" sz="1600" dirty="0">
                 <a:solidFill>
                   <a:srgbClr val="000000"/>
                 </a:solidFill>
@@ -11318,7 +12377,7 @@
           </a:p>
           <a:p>
             <a:r>
-              <a:rPr lang="en-US" sz="1600">
+              <a:rPr lang="en-US" sz="1600" dirty="0">
                 <a:solidFill>
                   <a:srgbClr val="000000"/>
                 </a:solidFill>
@@ -11327,16 +12386,34 @@
               <a:t>  c[</a:t>
             </a:r>
             <a:r>
-              <a:rPr lang="en-US" sz="1600">
+              <a:rPr lang="en-US" sz="1600" dirty="0">
                 <a:solidFill>
                   <a:srgbClr val="A31515"/>
                 </a:solidFill>
                 <a:latin typeface="Consolas" panose="020B0609020204030204" pitchFamily="49" charset="0"/>
               </a:rPr>
-              <a:t>"Remotes:0:Name"</a:t>
-            </a:r>
-            <a:r>
-              <a:rPr lang="en-US" sz="1600">
+              <a:t>"</a:t>
+            </a:r>
+            <a:r>
+              <a:rPr lang="en-US" sz="1600" dirty="0" err="1">
+                <a:solidFill>
+                  <a:srgbClr val="A31515"/>
+                </a:solidFill>
+                <a:latin typeface="Consolas" panose="020B0609020204030204" pitchFamily="49" charset="0"/>
+              </a:rPr>
+              <a:t>AllowFeatures</a:t>
+            </a:r>
+            <a:r>
+              <a:rPr lang="en-US" sz="1600" dirty="0">
+                <a:solidFill>
+                  <a:srgbClr val="A31515"/>
+                </a:solidFill>
+                <a:latin typeface="Consolas" panose="020B0609020204030204" pitchFamily="49" charset="0"/>
+              </a:rPr>
+              <a:t>"</a:t>
+            </a:r>
+            <a:r>
+              <a:rPr lang="en-US" sz="1600" dirty="0">
                 <a:solidFill>
                   <a:srgbClr val="000000"/>
                 </a:solidFill>
@@ -11345,16 +12422,34 @@
               <a:t>] = </a:t>
             </a:r>
             <a:r>
-              <a:rPr lang="en-US" sz="1600">
+              <a:rPr lang="en-US" sz="1600" dirty="0">
                 <a:solidFill>
                   <a:srgbClr val="A31515"/>
                 </a:solidFill>
                 <a:latin typeface="Consolas" panose="020B0609020204030204" pitchFamily="49" charset="0"/>
               </a:rPr>
-              <a:t>"Sender"</a:t>
-            </a:r>
-            <a:r>
-              <a:rPr lang="en-US" sz="1600">
+              <a:t>"</a:t>
+            </a:r>
+            <a:r>
+              <a:rPr lang="en-US" sz="1600" dirty="0" err="1">
+                <a:solidFill>
+                  <a:srgbClr val="A31515"/>
+                </a:solidFill>
+                <a:latin typeface="Consolas" panose="020B0609020204030204" pitchFamily="49" charset="0"/>
+              </a:rPr>
+              <a:t>BlobChannel</a:t>
+            </a:r>
+            <a:r>
+              <a:rPr lang="en-US" sz="1600" dirty="0">
+                <a:solidFill>
+                  <a:srgbClr val="A31515"/>
+                </a:solidFill>
+                <a:latin typeface="Consolas" panose="020B0609020204030204" pitchFamily="49" charset="0"/>
+              </a:rPr>
+              <a:t>"</a:t>
+            </a:r>
+            <a:r>
+              <a:rPr lang="en-US" sz="1600" dirty="0">
                 <a:solidFill>
                   <a:srgbClr val="000000"/>
                 </a:solidFill>
@@ -11365,54 +12460,7 @@
           </a:p>
           <a:p>
             <a:r>
-              <a:rPr lang="en-US" sz="1600">
-                <a:solidFill>
-                  <a:srgbClr val="000000"/>
-                </a:solidFill>
-                <a:latin typeface="Consolas" panose="020B0609020204030204" pitchFamily="49" charset="0"/>
-              </a:rPr>
-              <a:t>  c[</a:t>
-            </a:r>
-            <a:r>
-              <a:rPr lang="en-US" sz="1600">
-                <a:solidFill>
-                  <a:srgbClr val="A31515"/>
-                </a:solidFill>
-                <a:latin typeface="Consolas" panose="020B0609020204030204" pitchFamily="49" charset="0"/>
-              </a:rPr>
-              <a:t>"AllowFeatures"</a:t>
-            </a:r>
-            <a:r>
-              <a:rPr lang="en-US" sz="1600">
-                <a:solidFill>
-                  <a:srgbClr val="000000"/>
-                </a:solidFill>
-                <a:latin typeface="Consolas" panose="020B0609020204030204" pitchFamily="49" charset="0"/>
-              </a:rPr>
-              <a:t>] = </a:t>
-            </a:r>
-            <a:r>
-              <a:rPr lang="en-US" sz="1600">
-                <a:solidFill>
-                  <a:srgbClr val="A31515"/>
-                </a:solidFill>
-                <a:latin typeface="Consolas" panose="020B0609020204030204" pitchFamily="49" charset="0"/>
-              </a:rPr>
-              <a:t>"BlobChannel"</a:t>
-            </a:r>
-            <a:r>
-              <a:rPr lang="en-US" sz="1600">
-                <a:solidFill>
-                  <a:srgbClr val="000000"/>
-                </a:solidFill>
-                <a:latin typeface="Consolas" panose="020B0609020204030204" pitchFamily="49" charset="0"/>
-              </a:rPr>
-              <a:t>;</a:t>
-            </a:r>
-          </a:p>
-          <a:p>
-            <a:r>
-              <a:rPr lang="en-US" sz="1600">
+              <a:rPr lang="en-US" sz="1600" dirty="0">
                 <a:solidFill>
                   <a:srgbClr val="000000"/>
                 </a:solidFill>
@@ -11636,7 +12684,7 @@
                 </a:solidFill>
                 <a:latin typeface="Consolas" panose="020B0609020204030204" pitchFamily="49" charset="0"/>
               </a:rPr>
-              <a:t>“#Development"</a:t>
+              <a:t>"#Development"</a:t>
             </a:r>
             <a:r>
               <a:rPr lang="en-US" sz="1600" dirty="0">
@@ -11664,7 +12712,7 @@
 </p:sld>
 </file>
 
-<file path=ppt/slides/slide22.xml><?xml version="1.0" encoding="utf-8"?>
+<file path=ppt/slides/slide23.xml><?xml version="1.0" encoding="utf-8"?>
 <p:sld xmlns:a="http://schemas.openxmlformats.org/drawingml/2006/main" xmlns:r="http://schemas.openxmlformats.org/officeDocument/2006/relationships" xmlns:p="http://schemas.openxmlformats.org/presentationml/2006/main">
   <p:cSld>
     <p:spTree>
@@ -12058,7 +13106,7 @@
 </p:sld>
 </file>
 
-<file path=ppt/slides/slide23.xml><?xml version="1.0" encoding="utf-8"?>
+<file path=ppt/slides/slide24.xml><?xml version="1.0" encoding="utf-8"?>
 <p:sld xmlns:a="http://schemas.openxmlformats.org/drawingml/2006/main" xmlns:r="http://schemas.openxmlformats.org/officeDocument/2006/relationships" xmlns:p="http://schemas.openxmlformats.org/presentationml/2006/main">
   <p:cSld>
     <p:spTree>
@@ -12341,7 +13389,7 @@
 </p:sld>
 </file>
 
-<file path=ppt/slides/slide24.xml><?xml version="1.0" encoding="utf-8"?>
+<file path=ppt/slides/slide25.xml><?xml version="1.0" encoding="utf-8"?>
 <p:sld xmlns:a="http://schemas.openxmlformats.org/drawingml/2006/main" xmlns:r="http://schemas.openxmlformats.org/officeDocument/2006/relationships" xmlns:p="http://schemas.openxmlformats.org/presentationml/2006/main">
   <p:cSld>
     <p:spTree>
@@ -12675,7 +13723,7 @@
 </p:sld>
 </file>
 
-<file path=ppt/slides/slide25.xml><?xml version="1.0" encoding="utf-8"?>
+<file path=ppt/slides/slide26.xml><?xml version="1.0" encoding="utf-8"?>
 <p:sld xmlns:a="http://schemas.openxmlformats.org/drawingml/2006/main" xmlns:r="http://schemas.openxmlformats.org/officeDocument/2006/relationships" xmlns:p="http://schemas.openxmlformats.org/presentationml/2006/main">
   <p:cSld>
     <p:spTree>
@@ -13877,7 +14925,7 @@
 </p:sld>
 </file>
 
-<file path=ppt/slides/slide26.xml><?xml version="1.0" encoding="utf-8"?>
+<file path=ppt/slides/slide27.xml><?xml version="1.0" encoding="utf-8"?>
 <p:sld xmlns:a="http://schemas.openxmlformats.org/drawingml/2006/main" xmlns:r="http://schemas.openxmlformats.org/officeDocument/2006/relationships" xmlns:p="http://schemas.openxmlformats.org/presentationml/2006/main">
   <p:cSld>
     <p:spTree>
@@ -14171,7 +15219,7 @@
 </p:sld>
 </file>
 
-<file path=ppt/slides/slide27.xml><?xml version="1.0" encoding="utf-8"?>
+<file path=ppt/slides/slide28.xml><?xml version="1.0" encoding="utf-8"?>
 <p:sld xmlns:a="http://schemas.openxmlformats.org/drawingml/2006/main" xmlns:r="http://schemas.openxmlformats.org/officeDocument/2006/relationships" xmlns:p="http://schemas.openxmlformats.org/presentationml/2006/main">
   <p:cSld>
     <p:spTree>
@@ -14340,7 +15388,7 @@
 </p:sld>
 </file>
 
-<file path=ppt/slides/slide28.xml><?xml version="1.0" encoding="utf-8"?>
+<file path=ppt/slides/slide29.xml><?xml version="1.0" encoding="utf-8"?>
 <p:sld xmlns:a="http://schemas.openxmlformats.org/drawingml/2006/main" xmlns:r="http://schemas.openxmlformats.org/officeDocument/2006/relationships" xmlns:p="http://schemas.openxmlformats.org/presentationml/2006/main">
   <p:cSld>
     <p:spTree>
@@ -14772,151 +15820,6 @@
 </p:sld>
 </file>
 
-<file path=ppt/slides/slide29.xml><?xml version="1.0" encoding="utf-8"?>
-<p:sld xmlns:a="http://schemas.openxmlformats.org/drawingml/2006/main" xmlns:r="http://schemas.openxmlformats.org/officeDocument/2006/relationships" xmlns:p="http://schemas.openxmlformats.org/presentationml/2006/main">
-  <p:cSld>
-    <p:spTree>
-      <p:nvGrpSpPr>
-        <p:cNvPr id="1" name=""/>
-        <p:cNvGrpSpPr/>
-        <p:nvPr/>
-      </p:nvGrpSpPr>
-      <p:grpSpPr>
-        <a:xfrm>
-          <a:off x="0" y="0"/>
-          <a:ext cx="0" cy="0"/>
-          <a:chOff x="0" y="0"/>
-          <a:chExt cx="0" cy="0"/>
-        </a:xfrm>
-      </p:grpSpPr>
-      <p:sp>
-        <p:nvSpPr>
-          <p:cNvPr id="2" name="Title 1">
-            <a:extLst>
-              <a:ext uri="{FF2B5EF4-FFF2-40B4-BE49-F238E27FC236}">
-                <a16:creationId xmlns:a16="http://schemas.microsoft.com/office/drawing/2014/main" id="{BCFC278E-8E30-3459-41D7-7185BA86296A}"/>
-              </a:ext>
-            </a:extLst>
-          </p:cNvPr>
-          <p:cNvSpPr>
-            <a:spLocks noGrp="1"/>
-          </p:cNvSpPr>
-          <p:nvPr>
-            <p:ph type="title"/>
-          </p:nvPr>
-        </p:nvSpPr>
-        <p:spPr/>
-        <p:txBody>
-          <a:bodyPr/>
-          <a:lstStyle/>
-          <a:p>
-            <a:r>
-              <a:rPr lang="en-US" dirty="0"/>
-              <a:t>The 8 protocols maximal count</a:t>
-            </a:r>
-          </a:p>
-        </p:txBody>
-      </p:sp>
-      <p:sp>
-        <p:nvSpPr>
-          <p:cNvPr id="3" name="Content Placeholder 2">
-            <a:extLst>
-              <a:ext uri="{FF2B5EF4-FFF2-40B4-BE49-F238E27FC236}">
-                <a16:creationId xmlns:a16="http://schemas.microsoft.com/office/drawing/2014/main" id="{AC71B80D-91E5-6DC7-AB87-2CFAAF04179A}"/>
-              </a:ext>
-            </a:extLst>
-          </p:cNvPr>
-          <p:cNvSpPr>
-            <a:spLocks noGrp="1"/>
-          </p:cNvSpPr>
-          <p:nvPr>
-            <p:ph idx="1"/>
-          </p:nvPr>
-        </p:nvSpPr>
-        <p:spPr>
-          <a:xfrm>
-            <a:off x="838200" y="1825625"/>
-            <a:ext cx="10515600" cy="4516560"/>
-          </a:xfrm>
-        </p:spPr>
-        <p:txBody>
-          <a:bodyPr>
-            <a:normAutofit lnSpcReduction="10000"/>
-          </a:bodyPr>
-          <a:lstStyle/>
-          <a:p>
-            <a:r>
-              <a:rPr lang="en-US" dirty="0"/>
-              <a:t>Only 8 protocols can be expressed.</a:t>
-            </a:r>
-          </a:p>
-          <a:p>
-            <a:pPr lvl="1"/>
-            <a:r>
-              <a:rPr lang="en-US" dirty="0"/>
-              <a:t>The “0 Protocol” protocol is reserved: this is the protocol of </a:t>
-            </a:r>
-            <a:r>
-              <a:rPr lang="en-US" dirty="0" err="1"/>
-              <a:t>CK.AppIdentity.TransportLayer</a:t>
-            </a:r>
-            <a:r>
-              <a:rPr lang="en-US" dirty="0"/>
-              <a:t> itself that handles special messages used to negotiate, accept, reject incoming parties and outgoing connections.</a:t>
-            </a:r>
-          </a:p>
-          <a:p>
-            <a:pPr lvl="1"/>
-            <a:r>
-              <a:rPr lang="en-US" dirty="0"/>
-              <a:t>This lets 7 possible protocols. </a:t>
-            </a:r>
-          </a:p>
-          <a:p>
-            <a:pPr lvl="1"/>
-            <a:endParaRPr lang="en-US" dirty="0"/>
-          </a:p>
-          <a:p>
-            <a:r>
-              <a:rPr lang="en-US" dirty="0"/>
-              <a:t>This limit applies to a Remote party pair: </a:t>
-            </a:r>
-          </a:p>
-          <a:p>
-            <a:pPr lvl="1"/>
-            <a:r>
-              <a:rPr lang="en-US" dirty="0"/>
-              <a:t>There can be any number of possible protocols in an application</a:t>
-            </a:r>
-          </a:p>
-          <a:p>
-            <a:pPr lvl="1"/>
-            <a:r>
-              <a:rPr lang="en-US" dirty="0"/>
-              <a:t>2 parties that start to interact initially negotiate the ones they can and want to use. </a:t>
-            </a:r>
-          </a:p>
-          <a:p>
-            <a:r>
-              <a:rPr lang="en-US" dirty="0"/>
-              <a:t>Any Transport between 2 parties can simultaneously support up to 7 different protocols.</a:t>
-            </a:r>
-          </a:p>
-        </p:txBody>
-      </p:sp>
-    </p:spTree>
-    <p:extLst>
-      <p:ext uri="{BB962C8B-B14F-4D97-AF65-F5344CB8AC3E}">
-        <p14:creationId xmlns:p14="http://schemas.microsoft.com/office/powerpoint/2010/main" val="1820346205"/>
-      </p:ext>
-    </p:extLst>
-  </p:cSld>
-  <p:clrMapOvr>
-    <a:masterClrMapping/>
-  </p:clrMapOvr>
-</p:sld>
-</file>
-
 <file path=ppt/slides/slide3.xml><?xml version="1.0" encoding="utf-8"?>
 <p:sld xmlns:a="http://schemas.openxmlformats.org/drawingml/2006/main" xmlns:r="http://schemas.openxmlformats.org/officeDocument/2006/relationships" xmlns:p="http://schemas.openxmlformats.org/presentationml/2006/main">
   <p:cSld>
@@ -15073,6 +15976,151 @@
 </file>
 
 <file path=ppt/slides/slide30.xml><?xml version="1.0" encoding="utf-8"?>
+<p:sld xmlns:a="http://schemas.openxmlformats.org/drawingml/2006/main" xmlns:r="http://schemas.openxmlformats.org/officeDocument/2006/relationships" xmlns:p="http://schemas.openxmlformats.org/presentationml/2006/main">
+  <p:cSld>
+    <p:spTree>
+      <p:nvGrpSpPr>
+        <p:cNvPr id="1" name=""/>
+        <p:cNvGrpSpPr/>
+        <p:nvPr/>
+      </p:nvGrpSpPr>
+      <p:grpSpPr>
+        <a:xfrm>
+          <a:off x="0" y="0"/>
+          <a:ext cx="0" cy="0"/>
+          <a:chOff x="0" y="0"/>
+          <a:chExt cx="0" cy="0"/>
+        </a:xfrm>
+      </p:grpSpPr>
+      <p:sp>
+        <p:nvSpPr>
+          <p:cNvPr id="2" name="Title 1">
+            <a:extLst>
+              <a:ext uri="{FF2B5EF4-FFF2-40B4-BE49-F238E27FC236}">
+                <a16:creationId xmlns:a16="http://schemas.microsoft.com/office/drawing/2014/main" id="{BCFC278E-8E30-3459-41D7-7185BA86296A}"/>
+              </a:ext>
+            </a:extLst>
+          </p:cNvPr>
+          <p:cNvSpPr>
+            <a:spLocks noGrp="1"/>
+          </p:cNvSpPr>
+          <p:nvPr>
+            <p:ph type="title"/>
+          </p:nvPr>
+        </p:nvSpPr>
+        <p:spPr/>
+        <p:txBody>
+          <a:bodyPr/>
+          <a:lstStyle/>
+          <a:p>
+            <a:r>
+              <a:rPr lang="en-US" dirty="0"/>
+              <a:t>The 8 protocols maximal count</a:t>
+            </a:r>
+          </a:p>
+        </p:txBody>
+      </p:sp>
+      <p:sp>
+        <p:nvSpPr>
+          <p:cNvPr id="3" name="Content Placeholder 2">
+            <a:extLst>
+              <a:ext uri="{FF2B5EF4-FFF2-40B4-BE49-F238E27FC236}">
+                <a16:creationId xmlns:a16="http://schemas.microsoft.com/office/drawing/2014/main" id="{AC71B80D-91E5-6DC7-AB87-2CFAAF04179A}"/>
+              </a:ext>
+            </a:extLst>
+          </p:cNvPr>
+          <p:cNvSpPr>
+            <a:spLocks noGrp="1"/>
+          </p:cNvSpPr>
+          <p:nvPr>
+            <p:ph idx="1"/>
+          </p:nvPr>
+        </p:nvSpPr>
+        <p:spPr>
+          <a:xfrm>
+            <a:off x="838200" y="1825625"/>
+            <a:ext cx="10515600" cy="4516560"/>
+          </a:xfrm>
+        </p:spPr>
+        <p:txBody>
+          <a:bodyPr>
+            <a:normAutofit lnSpcReduction="10000"/>
+          </a:bodyPr>
+          <a:lstStyle/>
+          <a:p>
+            <a:r>
+              <a:rPr lang="en-US" dirty="0"/>
+              <a:t>Only 8 protocols can be expressed.</a:t>
+            </a:r>
+          </a:p>
+          <a:p>
+            <a:pPr lvl="1"/>
+            <a:r>
+              <a:rPr lang="en-US" dirty="0"/>
+              <a:t>The “0 Protocol” protocol is reserved: this is the protocol of </a:t>
+            </a:r>
+            <a:r>
+              <a:rPr lang="en-US" dirty="0" err="1"/>
+              <a:t>CK.AppIdentity.TransportLayer</a:t>
+            </a:r>
+            <a:r>
+              <a:rPr lang="en-US" dirty="0"/>
+              <a:t> itself that handles special messages used to negotiate, accept, reject incoming parties and outgoing connections.</a:t>
+            </a:r>
+          </a:p>
+          <a:p>
+            <a:pPr lvl="1"/>
+            <a:r>
+              <a:rPr lang="en-US" dirty="0"/>
+              <a:t>This lets 7 possible protocols. </a:t>
+            </a:r>
+          </a:p>
+          <a:p>
+            <a:pPr lvl="1"/>
+            <a:endParaRPr lang="en-US" dirty="0"/>
+          </a:p>
+          <a:p>
+            <a:r>
+              <a:rPr lang="en-US" dirty="0"/>
+              <a:t>This limit applies to a Remote party pair: </a:t>
+            </a:r>
+          </a:p>
+          <a:p>
+            <a:pPr lvl="1"/>
+            <a:r>
+              <a:rPr lang="en-US" dirty="0"/>
+              <a:t>There can be any number of possible protocols in an application</a:t>
+            </a:r>
+          </a:p>
+          <a:p>
+            <a:pPr lvl="1"/>
+            <a:r>
+              <a:rPr lang="en-US" dirty="0"/>
+              <a:t>2 parties that start to interact initially negotiate the ones they can and want to use. </a:t>
+            </a:r>
+          </a:p>
+          <a:p>
+            <a:r>
+              <a:rPr lang="en-US" dirty="0"/>
+              <a:t>Any Transport between 2 parties can simultaneously support up to 7 different protocols.</a:t>
+            </a:r>
+          </a:p>
+        </p:txBody>
+      </p:sp>
+    </p:spTree>
+    <p:extLst>
+      <p:ext uri="{BB962C8B-B14F-4D97-AF65-F5344CB8AC3E}">
+        <p14:creationId xmlns:p14="http://schemas.microsoft.com/office/powerpoint/2010/main" val="1820346205"/>
+      </p:ext>
+    </p:extLst>
+  </p:cSld>
+  <p:clrMapOvr>
+    <a:masterClrMapping/>
+  </p:clrMapOvr>
+</p:sld>
+</file>
+
+<file path=ppt/slides/slide31.xml><?xml version="1.0" encoding="utf-8"?>
 <p:sld xmlns:a="http://schemas.openxmlformats.org/drawingml/2006/main" xmlns:r="http://schemas.openxmlformats.org/officeDocument/2006/relationships" xmlns:p="http://schemas.openxmlformats.org/presentationml/2006/main">
   <p:cSld>
     <p:spTree>
@@ -15791,7 +16839,7 @@
 </p:sld>
 </file>
 
-<file path=ppt/slides/slide31.xml><?xml version="1.0" encoding="utf-8"?>
+<file path=ppt/slides/slide32.xml><?xml version="1.0" encoding="utf-8"?>
 <p:sld xmlns:a="http://schemas.openxmlformats.org/drawingml/2006/main" xmlns:r="http://schemas.openxmlformats.org/officeDocument/2006/relationships" xmlns:p="http://schemas.openxmlformats.org/presentationml/2006/main">
   <p:cSld>
     <p:spTree>
@@ -16512,7 +17560,7 @@
 </p:sld>
 </file>
 
-<file path=ppt/slides/slide32.xml><?xml version="1.0" encoding="utf-8"?>
+<file path=ppt/slides/slide33.xml><?xml version="1.0" encoding="utf-8"?>
 <p:sld xmlns:a="http://schemas.openxmlformats.org/drawingml/2006/main" xmlns:r="http://schemas.openxmlformats.org/officeDocument/2006/relationships" xmlns:p="http://schemas.openxmlformats.org/presentationml/2006/main">
   <p:cSld>
     <p:bg>
@@ -16769,7 +17817,7 @@
 </p:sld>
 </file>
 
-<file path=ppt/slides/slide33.xml><?xml version="1.0" encoding="utf-8"?>
+<file path=ppt/slides/slide34.xml><?xml version="1.0" encoding="utf-8"?>
 <p:sld xmlns:a="http://schemas.openxmlformats.org/drawingml/2006/main" xmlns:r="http://schemas.openxmlformats.org/officeDocument/2006/relationships" xmlns:p="http://schemas.openxmlformats.org/presentationml/2006/main">
   <p:cSld>
     <p:spTree>
@@ -17103,7 +18151,7 @@
 </p:sld>
 </file>
 
-<file path=ppt/slides/slide34.xml><?xml version="1.0" encoding="utf-8"?>
+<file path=ppt/slides/slide35.xml><?xml version="1.0" encoding="utf-8"?>
 <p:sld xmlns:a="http://schemas.openxmlformats.org/drawingml/2006/main" xmlns:r="http://schemas.openxmlformats.org/officeDocument/2006/relationships" xmlns:p="http://schemas.openxmlformats.org/presentationml/2006/main">
   <p:cSld>
     <p:spTree>
@@ -17334,7 +18382,7 @@
 </p:sld>
 </file>
 
-<file path=ppt/slides/slide35.xml><?xml version="1.0" encoding="utf-8"?>
+<file path=ppt/slides/slide36.xml><?xml version="1.0" encoding="utf-8"?>
 <p:sld xmlns:a="http://schemas.openxmlformats.org/drawingml/2006/main" xmlns:r="http://schemas.openxmlformats.org/officeDocument/2006/relationships" xmlns:p="http://schemas.openxmlformats.org/presentationml/2006/main">
   <p:cSld>
     <p:spTree>
@@ -17582,7 +18630,7 @@
 </p:sld>
 </file>
 
-<file path=ppt/slides/slide36.xml><?xml version="1.0" encoding="utf-8"?>
+<file path=ppt/slides/slide37.xml><?xml version="1.0" encoding="utf-8"?>
 <p:sld xmlns:a="http://schemas.openxmlformats.org/drawingml/2006/main" xmlns:r="http://schemas.openxmlformats.org/officeDocument/2006/relationships" xmlns:p="http://schemas.openxmlformats.org/presentationml/2006/main">
   <p:cSld>
     <p:spTree>
@@ -17719,7 +18767,7 @@
 </p:sld>
 </file>
 
-<file path=ppt/slides/slide37.xml><?xml version="1.0" encoding="utf-8"?>
+<file path=ppt/slides/slide38.xml><?xml version="1.0" encoding="utf-8"?>
 <p:sld xmlns:a="http://schemas.openxmlformats.org/drawingml/2006/main" xmlns:r="http://schemas.openxmlformats.org/officeDocument/2006/relationships" xmlns:p="http://schemas.openxmlformats.org/presentationml/2006/main">
   <p:cSld>
     <p:spTree>
@@ -17943,7 +18991,7 @@
 </p:sld>
 </file>
 
-<file path=ppt/slides/slide38.xml><?xml version="1.0" encoding="utf-8"?>
+<file path=ppt/slides/slide39.xml><?xml version="1.0" encoding="utf-8"?>
 <p:sld xmlns:a="http://schemas.openxmlformats.org/drawingml/2006/main" xmlns:r="http://schemas.openxmlformats.org/officeDocument/2006/relationships" xmlns:p="http://schemas.openxmlformats.org/presentationml/2006/main">
   <p:cSld>
     <p:spTree>
@@ -18218,7 +19266,203 @@
 </p:sld>
 </file>
 
-<file path=ppt/slides/slide39.xml><?xml version="1.0" encoding="utf-8"?>
+<file path=ppt/slides/slide4.xml><?xml version="1.0" encoding="utf-8"?>
+<p:sld xmlns:a="http://schemas.openxmlformats.org/drawingml/2006/main" xmlns:r="http://schemas.openxmlformats.org/officeDocument/2006/relationships" xmlns:p="http://schemas.openxmlformats.org/presentationml/2006/main">
+  <p:cSld>
+    <p:spTree>
+      <p:nvGrpSpPr>
+        <p:cNvPr id="1" name=""/>
+        <p:cNvGrpSpPr/>
+        <p:nvPr/>
+      </p:nvGrpSpPr>
+      <p:grpSpPr>
+        <a:xfrm>
+          <a:off x="0" y="0"/>
+          <a:ext cx="0" cy="0"/>
+          <a:chOff x="0" y="0"/>
+          <a:chExt cx="0" cy="0"/>
+        </a:xfrm>
+      </p:grpSpPr>
+      <p:sp>
+        <p:nvSpPr>
+          <p:cNvPr id="2" name="Title 1">
+            <a:extLst>
+              <a:ext uri="{FF2B5EF4-FFF2-40B4-BE49-F238E27FC236}">
+                <a16:creationId xmlns:a16="http://schemas.microsoft.com/office/drawing/2014/main" id="{2A6B8B24-8DD6-5A25-2C4D-FFCB005460FB}"/>
+              </a:ext>
+            </a:extLst>
+          </p:cNvPr>
+          <p:cNvSpPr>
+            <a:spLocks noGrp="1"/>
+          </p:cNvSpPr>
+          <p:nvPr>
+            <p:ph type="title"/>
+          </p:nvPr>
+        </p:nvSpPr>
+        <p:spPr/>
+        <p:txBody>
+          <a:bodyPr/>
+          <a:lstStyle/>
+          <a:p>
+            <a:r>
+              <a:rPr lang="en-US" dirty="0" err="1"/>
+              <a:t>DomainName</a:t>
+            </a:r>
+            <a:r>
+              <a:rPr lang="en-US" dirty="0"/>
+              <a:t>/</a:t>
+            </a:r>
+            <a:r>
+              <a:rPr lang="en-US" dirty="0" err="1"/>
+              <a:t>PartyName</a:t>
+            </a:r>
+            <a:r>
+              <a:rPr lang="en-US" dirty="0"/>
+              <a:t>/</a:t>
+            </a:r>
+            <a:r>
+              <a:rPr lang="en-US" dirty="0" err="1"/>
+              <a:t>EnvironmentName</a:t>
+            </a:r>
+            <a:endParaRPr lang="en-US" dirty="0"/>
+          </a:p>
+        </p:txBody>
+      </p:sp>
+      <p:sp>
+        <p:nvSpPr>
+          <p:cNvPr id="3" name="Content Placeholder 2">
+            <a:extLst>
+              <a:ext uri="{FF2B5EF4-FFF2-40B4-BE49-F238E27FC236}">
+                <a16:creationId xmlns:a16="http://schemas.microsoft.com/office/drawing/2014/main" id="{DD3871EE-3844-1222-56FF-A3C3C4D91B8A}"/>
+              </a:ext>
+            </a:extLst>
+          </p:cNvPr>
+          <p:cNvSpPr>
+            <a:spLocks noGrp="1"/>
+          </p:cNvSpPr>
+          <p:nvPr>
+            <p:ph idx="1"/>
+          </p:nvPr>
+        </p:nvSpPr>
+        <p:spPr>
+          <a:xfrm>
+            <a:off x="838200" y="1825624"/>
+            <a:ext cx="10515600" cy="4361815"/>
+          </a:xfrm>
+        </p:spPr>
+        <p:txBody>
+          <a:bodyPr>
+            <a:normAutofit/>
+          </a:bodyPr>
+          <a:lstStyle/>
+          <a:p>
+            <a:r>
+              <a:rPr lang="en-US" dirty="0"/>
+              <a:t>This triple identifies any Party in the Universe.</a:t>
+            </a:r>
+          </a:p>
+          <a:p>
+            <a:r>
+              <a:rPr lang="en-US" dirty="0"/>
+              <a:t>This drives the Observability layer</a:t>
+            </a:r>
+          </a:p>
+          <a:p>
+            <a:pPr lvl="1"/>
+            <a:r>
+              <a:rPr lang="en-US" dirty="0"/>
+              <a:t>Logs are collected with this 3-levels hierarchy.</a:t>
+            </a:r>
+          </a:p>
+          <a:p>
+            <a:pPr lvl="1"/>
+            <a:r>
+              <a:rPr lang="en-US" dirty="0"/>
+              <a:t>Any “Event Source” (whatever the </a:t>
+            </a:r>
+            <a:r>
+              <a:rPr lang="en-US" i="1" dirty="0"/>
+              <a:t>event</a:t>
+            </a:r>
+            <a:r>
+              <a:rPr lang="en-US" dirty="0"/>
+              <a:t> is) is identified by this triple.</a:t>
+            </a:r>
+          </a:p>
+          <a:p>
+            <a:r>
+              <a:rPr lang="en-US" dirty="0" err="1"/>
+              <a:t>DomainName</a:t>
+            </a:r>
+            <a:r>
+              <a:rPr lang="en-US" dirty="0"/>
+              <a:t> can be a path.</a:t>
+            </a:r>
+          </a:p>
+          <a:p>
+            <a:r>
+              <a:rPr lang="en-US" dirty="0" err="1"/>
+              <a:t>PartyName</a:t>
+            </a:r>
+            <a:r>
+              <a:rPr lang="en-US" dirty="0"/>
+              <a:t> is usually prefixed by ‘$’.</a:t>
+            </a:r>
+          </a:p>
+          <a:p>
+            <a:r>
+              <a:rPr lang="en-US" dirty="0" err="1"/>
+              <a:t>EnvironmentName</a:t>
+            </a:r>
+            <a:r>
+              <a:rPr lang="en-US" dirty="0"/>
+              <a:t> is always prefixed by ‘#’.</a:t>
+            </a:r>
+          </a:p>
+          <a:p>
+            <a:r>
+              <a:rPr lang="en-US" dirty="0"/>
+              <a:t>The triple can be expressed as a simple </a:t>
+            </a:r>
+            <a:r>
+              <a:rPr lang="en-US" dirty="0" err="1"/>
+              <a:t>FullName</a:t>
+            </a:r>
+            <a:r>
+              <a:rPr lang="en-US" dirty="0"/>
+              <a:t> string. </a:t>
+            </a:r>
+          </a:p>
+          <a:p>
+            <a:pPr lvl="1"/>
+            <a:endParaRPr lang="en-US" dirty="0"/>
+          </a:p>
+          <a:p>
+            <a:pPr lvl="1"/>
+            <a:endParaRPr lang="en-US" dirty="0"/>
+          </a:p>
+          <a:p>
+            <a:endParaRPr lang="en-US" dirty="0"/>
+          </a:p>
+          <a:p>
+            <a:endParaRPr lang="en-US" dirty="0"/>
+          </a:p>
+        </p:txBody>
+      </p:sp>
+    </p:spTree>
+    <p:extLst>
+      <p:ext uri="{BB962C8B-B14F-4D97-AF65-F5344CB8AC3E}">
+        <p14:creationId xmlns:p14="http://schemas.microsoft.com/office/powerpoint/2010/main" val="1775483990"/>
+      </p:ext>
+    </p:extLst>
+  </p:cSld>
+  <p:clrMapOvr>
+    <a:masterClrMapping/>
+  </p:clrMapOvr>
+</p:sld>
+</file>
+
+<file path=ppt/slides/slide40.xml><?xml version="1.0" encoding="utf-8"?>
 <p:sld xmlns:a="http://schemas.openxmlformats.org/drawingml/2006/main" xmlns:r="http://schemas.openxmlformats.org/officeDocument/2006/relationships" xmlns:p="http://schemas.openxmlformats.org/presentationml/2006/main">
   <p:cSld>
     <p:spTree>
@@ -18589,203 +19833,7 @@
 </p:sld>
 </file>
 
-<file path=ppt/slides/slide4.xml><?xml version="1.0" encoding="utf-8"?>
-<p:sld xmlns:a="http://schemas.openxmlformats.org/drawingml/2006/main" xmlns:r="http://schemas.openxmlformats.org/officeDocument/2006/relationships" xmlns:p="http://schemas.openxmlformats.org/presentationml/2006/main">
-  <p:cSld>
-    <p:spTree>
-      <p:nvGrpSpPr>
-        <p:cNvPr id="1" name=""/>
-        <p:cNvGrpSpPr/>
-        <p:nvPr/>
-      </p:nvGrpSpPr>
-      <p:grpSpPr>
-        <a:xfrm>
-          <a:off x="0" y="0"/>
-          <a:ext cx="0" cy="0"/>
-          <a:chOff x="0" y="0"/>
-          <a:chExt cx="0" cy="0"/>
-        </a:xfrm>
-      </p:grpSpPr>
-      <p:sp>
-        <p:nvSpPr>
-          <p:cNvPr id="2" name="Title 1">
-            <a:extLst>
-              <a:ext uri="{FF2B5EF4-FFF2-40B4-BE49-F238E27FC236}">
-                <a16:creationId xmlns:a16="http://schemas.microsoft.com/office/drawing/2014/main" id="{2A6B8B24-8DD6-5A25-2C4D-FFCB005460FB}"/>
-              </a:ext>
-            </a:extLst>
-          </p:cNvPr>
-          <p:cNvSpPr>
-            <a:spLocks noGrp="1"/>
-          </p:cNvSpPr>
-          <p:nvPr>
-            <p:ph type="title"/>
-          </p:nvPr>
-        </p:nvSpPr>
-        <p:spPr/>
-        <p:txBody>
-          <a:bodyPr/>
-          <a:lstStyle/>
-          <a:p>
-            <a:r>
-              <a:rPr lang="en-US" dirty="0" err="1"/>
-              <a:t>DomainName</a:t>
-            </a:r>
-            <a:r>
-              <a:rPr lang="en-US" dirty="0"/>
-              <a:t>/</a:t>
-            </a:r>
-            <a:r>
-              <a:rPr lang="en-US" dirty="0" err="1"/>
-              <a:t>PartyName</a:t>
-            </a:r>
-            <a:r>
-              <a:rPr lang="en-US" dirty="0"/>
-              <a:t>/</a:t>
-            </a:r>
-            <a:r>
-              <a:rPr lang="en-US" dirty="0" err="1"/>
-              <a:t>EnvironmentName</a:t>
-            </a:r>
-            <a:endParaRPr lang="en-US" dirty="0"/>
-          </a:p>
-        </p:txBody>
-      </p:sp>
-      <p:sp>
-        <p:nvSpPr>
-          <p:cNvPr id="3" name="Content Placeholder 2">
-            <a:extLst>
-              <a:ext uri="{FF2B5EF4-FFF2-40B4-BE49-F238E27FC236}">
-                <a16:creationId xmlns:a16="http://schemas.microsoft.com/office/drawing/2014/main" id="{DD3871EE-3844-1222-56FF-A3C3C4D91B8A}"/>
-              </a:ext>
-            </a:extLst>
-          </p:cNvPr>
-          <p:cNvSpPr>
-            <a:spLocks noGrp="1"/>
-          </p:cNvSpPr>
-          <p:nvPr>
-            <p:ph idx="1"/>
-          </p:nvPr>
-        </p:nvSpPr>
-        <p:spPr>
-          <a:xfrm>
-            <a:off x="838200" y="1825624"/>
-            <a:ext cx="10515600" cy="4361815"/>
-          </a:xfrm>
-        </p:spPr>
-        <p:txBody>
-          <a:bodyPr>
-            <a:normAutofit/>
-          </a:bodyPr>
-          <a:lstStyle/>
-          <a:p>
-            <a:r>
-              <a:rPr lang="en-US" dirty="0"/>
-              <a:t>This triple identifies any Party in the Universe.</a:t>
-            </a:r>
-          </a:p>
-          <a:p>
-            <a:r>
-              <a:rPr lang="en-US" dirty="0"/>
-              <a:t>This drives the Observability layer</a:t>
-            </a:r>
-          </a:p>
-          <a:p>
-            <a:pPr lvl="1"/>
-            <a:r>
-              <a:rPr lang="en-US" dirty="0"/>
-              <a:t>Logs are collected with this 3-levels hierarchy.</a:t>
-            </a:r>
-          </a:p>
-          <a:p>
-            <a:pPr lvl="1"/>
-            <a:r>
-              <a:rPr lang="en-US" dirty="0"/>
-              <a:t>Any “Event Source” (whatever the </a:t>
-            </a:r>
-            <a:r>
-              <a:rPr lang="en-US" i="1" dirty="0"/>
-              <a:t>event</a:t>
-            </a:r>
-            <a:r>
-              <a:rPr lang="en-US" dirty="0"/>
-              <a:t> is) is identified by this triple.</a:t>
-            </a:r>
-          </a:p>
-          <a:p>
-            <a:r>
-              <a:rPr lang="en-US" dirty="0" err="1"/>
-              <a:t>DomainName</a:t>
-            </a:r>
-            <a:r>
-              <a:rPr lang="en-US" dirty="0"/>
-              <a:t> can be a path.</a:t>
-            </a:r>
-          </a:p>
-          <a:p>
-            <a:r>
-              <a:rPr lang="en-US" dirty="0" err="1"/>
-              <a:t>PartyName</a:t>
-            </a:r>
-            <a:r>
-              <a:rPr lang="en-US" dirty="0"/>
-              <a:t> is usually prefixed by ‘$’.</a:t>
-            </a:r>
-          </a:p>
-          <a:p>
-            <a:r>
-              <a:rPr lang="en-US" dirty="0" err="1"/>
-              <a:t>EnvironmentName</a:t>
-            </a:r>
-            <a:r>
-              <a:rPr lang="en-US" dirty="0"/>
-              <a:t> is always prefixed by ‘#’.</a:t>
-            </a:r>
-          </a:p>
-          <a:p>
-            <a:r>
-              <a:rPr lang="en-US" dirty="0"/>
-              <a:t>The triple can be expressed as a simple </a:t>
-            </a:r>
-            <a:r>
-              <a:rPr lang="en-US" dirty="0" err="1"/>
-              <a:t>FullName</a:t>
-            </a:r>
-            <a:r>
-              <a:rPr lang="en-US" dirty="0"/>
-              <a:t> string. </a:t>
-            </a:r>
-          </a:p>
-          <a:p>
-            <a:pPr lvl="1"/>
-            <a:endParaRPr lang="en-US" dirty="0"/>
-          </a:p>
-          <a:p>
-            <a:pPr lvl="1"/>
-            <a:endParaRPr lang="en-US" dirty="0"/>
-          </a:p>
-          <a:p>
-            <a:endParaRPr lang="en-US" dirty="0"/>
-          </a:p>
-          <a:p>
-            <a:endParaRPr lang="en-US" dirty="0"/>
-          </a:p>
-        </p:txBody>
-      </p:sp>
-    </p:spTree>
-    <p:extLst>
-      <p:ext uri="{BB962C8B-B14F-4D97-AF65-F5344CB8AC3E}">
-        <p14:creationId xmlns:p14="http://schemas.microsoft.com/office/powerpoint/2010/main" val="1775483990"/>
-      </p:ext>
-    </p:extLst>
-  </p:cSld>
-  <p:clrMapOvr>
-    <a:masterClrMapping/>
-  </p:clrMapOvr>
-</p:sld>
-</file>
-
-<file path=ppt/slides/slide40.xml><?xml version="1.0" encoding="utf-8"?>
+<file path=ppt/slides/slide41.xml><?xml version="1.0" encoding="utf-8"?>
 <p:sld xmlns:a="http://schemas.openxmlformats.org/drawingml/2006/main" xmlns:r="http://schemas.openxmlformats.org/officeDocument/2006/relationships" xmlns:p="http://schemas.openxmlformats.org/presentationml/2006/main">
   <p:cSld>
     <p:spTree>
@@ -18888,7 +19936,7 @@
 </p:sld>
 </file>
 
-<file path=ppt/slides/slide41.xml><?xml version="1.0" encoding="utf-8"?>
+<file path=ppt/slides/slide42.xml><?xml version="1.0" encoding="utf-8"?>
 <p:sld xmlns:a="http://schemas.openxmlformats.org/drawingml/2006/main" xmlns:r="http://schemas.openxmlformats.org/officeDocument/2006/relationships" xmlns:p="http://schemas.openxmlformats.org/presentationml/2006/main">
   <p:cSld>
     <p:spTree>
@@ -19135,7 +20183,7 @@
 </p:sld>
 </file>
 
-<file path=ppt/slides/slide42.xml><?xml version="1.0" encoding="utf-8"?>
+<file path=ppt/slides/slide43.xml><?xml version="1.0" encoding="utf-8"?>
 <p:sld xmlns:a="http://schemas.openxmlformats.org/drawingml/2006/main" xmlns:r="http://schemas.openxmlformats.org/officeDocument/2006/relationships" xmlns:p="http://schemas.openxmlformats.org/presentationml/2006/main">
   <p:cSld>
     <p:spTree>
@@ -19678,7 +20726,7 @@
 </p:sld>
 </file>
 
-<file path=ppt/slides/slide43.xml><?xml version="1.0" encoding="utf-8"?>
+<file path=ppt/slides/slide44.xml><?xml version="1.0" encoding="utf-8"?>
 <p:sld xmlns:a="http://schemas.openxmlformats.org/drawingml/2006/main" xmlns:r="http://schemas.openxmlformats.org/officeDocument/2006/relationships" xmlns:p="http://schemas.openxmlformats.org/presentationml/2006/main">
   <p:cSld>
     <p:spTree>
@@ -19880,7 +20928,7 @@
 </p:sld>
 </file>
 
-<file path=ppt/slides/slide44.xml><?xml version="1.0" encoding="utf-8"?>
+<file path=ppt/slides/slide45.xml><?xml version="1.0" encoding="utf-8"?>
 <p:sld xmlns:a="http://schemas.openxmlformats.org/drawingml/2006/main" xmlns:r="http://schemas.openxmlformats.org/officeDocument/2006/relationships" xmlns:p="http://schemas.openxmlformats.org/presentationml/2006/main">
   <p:cSld>
     <p:spTree>
@@ -21348,13 +22396,27 @@
                 <a:latin typeface="Courier New" panose="02070309020205020404" pitchFamily="49" charset="0"/>
                 <a:cs typeface="Courier New" panose="02070309020205020404" pitchFamily="49" charset="0"/>
               </a:rPr>
-              <a:t>     "Name": "$</a:t>
+              <a:t>     "</a:t>
             </a:r>
             <a:r>
               <a:rPr lang="en-US" sz="1400" dirty="0" err="1">
                 <a:latin typeface="Courier New" panose="02070309020205020404" pitchFamily="49" charset="0"/>
                 <a:cs typeface="Courier New" panose="02070309020205020404" pitchFamily="49" charset="0"/>
               </a:rPr>
+              <a:t>PartyName</a:t>
+            </a:r>
+            <a:r>
+              <a:rPr lang="en-US" sz="1400" dirty="0">
+                <a:latin typeface="Courier New" panose="02070309020205020404" pitchFamily="49" charset="0"/>
+                <a:cs typeface="Courier New" panose="02070309020205020404" pitchFamily="49" charset="0"/>
+              </a:rPr>
+              <a:t>": "$</a:t>
+            </a:r>
+            <a:r>
+              <a:rPr lang="en-US" sz="1400" dirty="0" err="1">
+                <a:latin typeface="Courier New" panose="02070309020205020404" pitchFamily="49" charset="0"/>
+                <a:cs typeface="Courier New" panose="02070309020205020404" pitchFamily="49" charset="0"/>
+              </a:rPr>
               <a:t>LogTower</a:t>
             </a:r>
             <a:r>
@@ -21398,7 +22460,21 @@
                 <a:latin typeface="Courier New" panose="02070309020205020404" pitchFamily="49" charset="0"/>
                 <a:cs typeface="Courier New" panose="02070309020205020404" pitchFamily="49" charset="0"/>
               </a:rPr>
-              <a:t>     "Name": "$</a:t>
+              <a:t>     "</a:t>
+            </a:r>
+            <a:r>
+              <a:rPr lang="en-US" sz="1400" dirty="0" err="1">
+                <a:latin typeface="Courier New" panose="02070309020205020404" pitchFamily="49" charset="0"/>
+                <a:cs typeface="Courier New" panose="02070309020205020404" pitchFamily="49" charset="0"/>
+              </a:rPr>
+              <a:t>PartyName</a:t>
+            </a:r>
+            <a:r>
+              <a:rPr lang="en-US" sz="1400" dirty="0">
+                <a:latin typeface="Courier New" panose="02070309020205020404" pitchFamily="49" charset="0"/>
+                <a:cs typeface="Courier New" panose="02070309020205020404" pitchFamily="49" charset="0"/>
+              </a:rPr>
+              <a:t>": "$</a:t>
             </a:r>
             <a:r>
               <a:rPr lang="en-US" sz="1400" dirty="0" err="1">

</xml_diff>

<commit_message>
WIP. Refactor done (except Cris).
Now that store model is fine, we must use it
to support KeyManagement feature.
</commit_message>
<xml_diff>
--- a/Doc/CK-AppIdentity.pptx
+++ b/Doc/CK-AppIdentity.pptx
@@ -27,20 +27,20 @@
     <p:sldId id="303" r:id="rId18"/>
     <p:sldId id="274" r:id="rId19"/>
     <p:sldId id="275" r:id="rId20"/>
-    <p:sldId id="304" r:id="rId21"/>
-    <p:sldId id="276" r:id="rId22"/>
-    <p:sldId id="277" r:id="rId23"/>
-    <p:sldId id="278" r:id="rId24"/>
-    <p:sldId id="279" r:id="rId25"/>
-    <p:sldId id="280" r:id="rId26"/>
-    <p:sldId id="282" r:id="rId27"/>
-    <p:sldId id="281" r:id="rId28"/>
+    <p:sldId id="276" r:id="rId21"/>
+    <p:sldId id="277" r:id="rId22"/>
+    <p:sldId id="278" r:id="rId23"/>
+    <p:sldId id="279" r:id="rId24"/>
+    <p:sldId id="280" r:id="rId25"/>
+    <p:sldId id="282" r:id="rId26"/>
+    <p:sldId id="281" r:id="rId27"/>
+    <p:sldId id="288" r:id="rId28"/>
     <p:sldId id="283" r:id="rId29"/>
-    <p:sldId id="284" r:id="rId30"/>
-    <p:sldId id="285" r:id="rId31"/>
-    <p:sldId id="286" r:id="rId32"/>
-    <p:sldId id="287" r:id="rId33"/>
-    <p:sldId id="288" r:id="rId34"/>
+    <p:sldId id="304" r:id="rId30"/>
+    <p:sldId id="284" r:id="rId31"/>
+    <p:sldId id="285" r:id="rId32"/>
+    <p:sldId id="286" r:id="rId33"/>
+    <p:sldId id="287" r:id="rId34"/>
     <p:sldId id="289" r:id="rId35"/>
     <p:sldId id="290" r:id="rId36"/>
     <p:sldId id="297" r:id="rId37"/>
@@ -299,7 +299,7 @@
           <a:p>
             <a:fld id="{7EBA75D8-A9A5-4FAF-B563-7A079B630A7E}" type="datetimeFigureOut">
               <a:rPr lang="en-US" smtClean="0"/>
-              <a:t>6/26/2023</a:t>
+              <a:t>6/28/2023</a:t>
             </a:fld>
             <a:endParaRPr lang="en-US"/>
           </a:p>
@@ -771,7 +771,7 @@
           <a:p>
             <a:fld id="{E05EDB92-2FE2-4164-AA27-D03258A20DF4}" type="slidenum">
               <a:rPr lang="en-US" smtClean="0"/>
-              <a:t>22</a:t>
+              <a:t>21</a:t>
             </a:fld>
             <a:endParaRPr lang="en-US"/>
           </a:p>
@@ -855,7 +855,7 @@
           <a:p>
             <a:fld id="{E05EDB92-2FE2-4164-AA27-D03258A20DF4}" type="slidenum">
               <a:rPr lang="en-US" smtClean="0"/>
-              <a:t>23</a:t>
+              <a:t>22</a:t>
             </a:fld>
             <a:endParaRPr lang="en-US"/>
           </a:p>
@@ -953,7 +953,7 @@
           <a:p>
             <a:fld id="{E05EDB92-2FE2-4164-AA27-D03258A20DF4}" type="slidenum">
               <a:rPr lang="en-US" smtClean="0"/>
-              <a:t>26</a:t>
+              <a:t>25</a:t>
             </a:fld>
             <a:endParaRPr lang="en-US"/>
           </a:p>
@@ -1016,28 +1016,6 @@
           <a:bodyPr/>
           <a:lstStyle/>
           <a:p>
-            <a:r>
-              <a:rPr lang="en-US" dirty="0"/>
-              <a:t>Before detailing the Channels, we need to cover the </a:t>
-            </a:r>
-            <a:r>
-              <a:rPr lang="en-US" dirty="0" err="1"/>
-              <a:t>TransportMessage</a:t>
-            </a:r>
-            <a:r>
-              <a:rPr lang="en-US" dirty="0"/>
-              <a:t> and its Factories and the Transport and </a:t>
-            </a:r>
-            <a:r>
-              <a:rPr lang="en-US" dirty="0" err="1"/>
-              <a:t>TransportType</a:t>
-            </a:r>
-            <a:r>
-              <a:rPr lang="en-US" dirty="0"/>
-              <a:t> model.</a:t>
-            </a:r>
-          </a:p>
-          <a:p>
             <a:endParaRPr lang="en-US" dirty="0"/>
           </a:p>
         </p:txBody>
@@ -1059,7 +1037,7 @@
           <a:p>
             <a:fld id="{E05EDB92-2FE2-4164-AA27-D03258A20DF4}" type="slidenum">
               <a:rPr lang="en-US" smtClean="0"/>
-              <a:t>28</a:t>
+              <a:t>27</a:t>
             </a:fld>
             <a:endParaRPr lang="en-US"/>
           </a:p>
@@ -1068,7 +1046,7 @@
     </p:spTree>
     <p:extLst>
       <p:ext uri="{BB962C8B-B14F-4D97-AF65-F5344CB8AC3E}">
-        <p14:creationId xmlns:p14="http://schemas.microsoft.com/office/powerpoint/2010/main" val="1107907762"/>
+        <p14:creationId xmlns:p14="http://schemas.microsoft.com/office/powerpoint/2010/main" val="1570586495"/>
       </p:ext>
     </p:extLst>
   </p:cSld>
@@ -1123,387 +1101,28 @@
           <a:lstStyle/>
           <a:p>
             <a:r>
-              <a:rPr lang="en-US" sz="1800" dirty="0">
-                <a:solidFill>
-                  <a:srgbClr val="000000"/>
-                </a:solidFill>
-                <a:latin typeface="Consolas" panose="020B0609020204030204" pitchFamily="49" charset="0"/>
-              </a:rPr>
-              <a:t>All messages exchanged by the Transport layer are prefixed by the message's protocol and length.</a:t>
-            </a:r>
-          </a:p>
-          <a:p>
-            <a:r>
-              <a:rPr lang="en-US" sz="1800" dirty="0">
-                <a:solidFill>
-                  <a:srgbClr val="000000"/>
-                </a:solidFill>
-                <a:latin typeface="Consolas" panose="020B0609020204030204" pitchFamily="49" charset="0"/>
-              </a:rPr>
-              <a:t>- The prefix starts with a first byte: </a:t>
-            </a:r>
-            <a:r>
-              <a:rPr lang="en-US" sz="1800" dirty="0">
-                <a:solidFill>
-                  <a:srgbClr val="0000FF"/>
-                </a:solidFill>
-                <a:latin typeface="Consolas" panose="020B0609020204030204" pitchFamily="49" charset="0"/>
-              </a:rPr>
-              <a:t>`|L0|L1|CD|R0|R1|P0|P1|P2|`</a:t>
-            </a:r>
-            <a:r>
-              <a:rPr lang="en-US" sz="1800" dirty="0">
-                <a:solidFill>
-                  <a:srgbClr val="000000"/>
-                </a:solidFill>
-                <a:latin typeface="Consolas" panose="020B0609020204030204" pitchFamily="49" charset="0"/>
-              </a:rPr>
-              <a:t>.</a:t>
-            </a:r>
-          </a:p>
-          <a:p>
-            <a:r>
-              <a:rPr lang="en-US" sz="1800" dirty="0">
-                <a:solidFill>
-                  <a:srgbClr val="000000"/>
-                </a:solidFill>
-                <a:latin typeface="Consolas" panose="020B0609020204030204" pitchFamily="49" charset="0"/>
-              </a:rPr>
-              <a:t>  - The 2 MSB (L0-L1) gives us the number of bytes of the message length:</a:t>
-            </a:r>
-          </a:p>
-          <a:p>
-            <a:r>
-              <a:rPr lang="en-US" sz="1800" dirty="0">
-                <a:solidFill>
-                  <a:srgbClr val="000000"/>
-                </a:solidFill>
-                <a:latin typeface="Consolas" panose="020B0609020204030204" pitchFamily="49" charset="0"/>
-              </a:rPr>
-              <a:t>    - </a:t>
-            </a:r>
-            <a:r>
-              <a:rPr lang="en-US" sz="1800" dirty="0">
-                <a:solidFill>
-                  <a:srgbClr val="0000FF"/>
-                </a:solidFill>
-                <a:latin typeface="Consolas" panose="020B0609020204030204" pitchFamily="49" charset="0"/>
-              </a:rPr>
-              <a:t>`00`</a:t>
-            </a:r>
-            <a:r>
-              <a:rPr lang="en-US" sz="1800" dirty="0">
-                <a:solidFill>
-                  <a:srgbClr val="000000"/>
-                </a:solidFill>
-                <a:latin typeface="Consolas" panose="020B0609020204030204" pitchFamily="49" charset="0"/>
-              </a:rPr>
-              <a:t> 1 byte, the message length is between 0 and 255 bytes.</a:t>
-            </a:r>
-          </a:p>
-          <a:p>
-            <a:r>
-              <a:rPr lang="en-US" sz="1800" dirty="0">
-                <a:solidFill>
-                  <a:srgbClr val="000000"/>
-                </a:solidFill>
-                <a:latin typeface="Consolas" panose="020B0609020204030204" pitchFamily="49" charset="0"/>
-              </a:rPr>
-              <a:t>    - </a:t>
-            </a:r>
-            <a:r>
-              <a:rPr lang="en-US" sz="1800" dirty="0">
-                <a:solidFill>
-                  <a:srgbClr val="0000FF"/>
-                </a:solidFill>
-                <a:latin typeface="Consolas" panose="020B0609020204030204" pitchFamily="49" charset="0"/>
-              </a:rPr>
-              <a:t>`01`</a:t>
-            </a:r>
-            <a:r>
-              <a:rPr lang="en-US" sz="1800" dirty="0">
-                <a:solidFill>
-                  <a:srgbClr val="000000"/>
-                </a:solidFill>
-                <a:latin typeface="Consolas" panose="020B0609020204030204" pitchFamily="49" charset="0"/>
-              </a:rPr>
-              <a:t> 2 bytes, the message length is between 256 and 65535 bytes.</a:t>
-            </a:r>
-          </a:p>
-          <a:p>
-            <a:r>
-              <a:rPr lang="en-US" sz="1800" dirty="0">
-                <a:solidFill>
-                  <a:srgbClr val="000000"/>
-                </a:solidFill>
-                <a:latin typeface="Consolas" panose="020B0609020204030204" pitchFamily="49" charset="0"/>
-              </a:rPr>
-              <a:t>    - </a:t>
-            </a:r>
-            <a:r>
-              <a:rPr lang="en-US" sz="1800" dirty="0">
-                <a:solidFill>
-                  <a:srgbClr val="0000FF"/>
-                </a:solidFill>
-                <a:latin typeface="Consolas" panose="020B0609020204030204" pitchFamily="49" charset="0"/>
-              </a:rPr>
-              <a:t>`10`</a:t>
-            </a:r>
-            <a:r>
-              <a:rPr lang="en-US" sz="1800" dirty="0">
-                <a:solidFill>
-                  <a:srgbClr val="000000"/>
-                </a:solidFill>
-                <a:latin typeface="Consolas" panose="020B0609020204030204" pitchFamily="49" charset="0"/>
-              </a:rPr>
-              <a:t> 3 bytes, the message length is between 65536 and 16 777 215 bytes.</a:t>
-            </a:r>
-          </a:p>
-          <a:p>
-            <a:r>
-              <a:rPr lang="en-US" sz="1800" dirty="0">
-                <a:solidFill>
-                  <a:srgbClr val="000000"/>
-                </a:solidFill>
-                <a:latin typeface="Consolas" panose="020B0609020204030204" pitchFamily="49" charset="0"/>
-              </a:rPr>
-              <a:t>    - </a:t>
-            </a:r>
-            <a:r>
-              <a:rPr lang="en-US" sz="1800" dirty="0">
-                <a:solidFill>
-                  <a:srgbClr val="0000FF"/>
-                </a:solidFill>
-                <a:latin typeface="Consolas" panose="020B0609020204030204" pitchFamily="49" charset="0"/>
-              </a:rPr>
-              <a:t>`11`</a:t>
-            </a:r>
-            <a:r>
-              <a:rPr lang="en-US" sz="1800" dirty="0">
-                <a:solidFill>
-                  <a:srgbClr val="000000"/>
-                </a:solidFill>
-                <a:latin typeface="Consolas" panose="020B0609020204030204" pitchFamily="49" charset="0"/>
-              </a:rPr>
-              <a:t> 4 bytes, the message length is between 16 777 216 and 2 147 483 648 bytes (2 Gib).</a:t>
-            </a:r>
-          </a:p>
-          <a:p>
-            <a:r>
-              <a:rPr lang="en-US" sz="1800" dirty="0">
-                <a:solidFill>
-                  <a:srgbClr val="000000"/>
-                </a:solidFill>
-                <a:latin typeface="Consolas" panose="020B0609020204030204" pitchFamily="49" charset="0"/>
-              </a:rPr>
-              <a:t>  - The </a:t>
-            </a:r>
-            <a:r>
-              <a:rPr lang="en-US" sz="1800" dirty="0">
-                <a:solidFill>
-                  <a:srgbClr val="0000FF"/>
-                </a:solidFill>
-                <a:latin typeface="Consolas" panose="020B0609020204030204" pitchFamily="49" charset="0"/>
-              </a:rPr>
-              <a:t>`CD`</a:t>
-            </a:r>
-            <a:r>
-              <a:rPr lang="en-US" sz="1800" dirty="0">
-                <a:solidFill>
-                  <a:srgbClr val="000000"/>
-                </a:solidFill>
-                <a:latin typeface="Consolas" panose="020B0609020204030204" pitchFamily="49" charset="0"/>
-              </a:rPr>
-              <a:t> bit is the "Control vs. Data" bit. This is a convenient bit that can be used by protocols</a:t>
-            </a:r>
-          </a:p>
-          <a:p>
-            <a:r>
-              <a:rPr lang="en-US" sz="1800" dirty="0">
-                <a:solidFill>
-                  <a:srgbClr val="000000"/>
-                </a:solidFill>
-                <a:latin typeface="Consolas" panose="020B0609020204030204" pitchFamily="49" charset="0"/>
-              </a:rPr>
-              <a:t>    as a one-bit discriminator, typically between a regular data message and one (or more) control message.</a:t>
-            </a:r>
-          </a:p>
-          <a:p>
-            <a:r>
-              <a:rPr lang="en-US" sz="1800" dirty="0">
-                <a:solidFill>
-                  <a:srgbClr val="000000"/>
-                </a:solidFill>
-                <a:latin typeface="Consolas" panose="020B0609020204030204" pitchFamily="49" charset="0"/>
-              </a:rPr>
-              <a:t>  - </a:t>
-            </a:r>
-            <a:r>
-              <a:rPr lang="en-US" sz="1800" dirty="0">
-                <a:solidFill>
-                  <a:srgbClr val="0000FF"/>
-                </a:solidFill>
-                <a:latin typeface="Consolas" panose="020B0609020204030204" pitchFamily="49" charset="0"/>
-              </a:rPr>
-              <a:t>`R0`</a:t>
-            </a:r>
-            <a:r>
-              <a:rPr lang="en-US" sz="1800" dirty="0">
-                <a:solidFill>
-                  <a:srgbClr val="000000"/>
-                </a:solidFill>
-                <a:latin typeface="Consolas" panose="020B0609020204030204" pitchFamily="49" charset="0"/>
-              </a:rPr>
-              <a:t> and </a:t>
-            </a:r>
-            <a:r>
-              <a:rPr lang="en-US" sz="1800" dirty="0">
-                <a:solidFill>
-                  <a:srgbClr val="0000FF"/>
-                </a:solidFill>
-                <a:latin typeface="Consolas" panose="020B0609020204030204" pitchFamily="49" charset="0"/>
-              </a:rPr>
-              <a:t>`R1`</a:t>
-            </a:r>
-            <a:r>
-              <a:rPr lang="en-US" sz="1800" dirty="0">
-                <a:solidFill>
-                  <a:srgbClr val="000000"/>
-                </a:solidFill>
-                <a:latin typeface="Consolas" panose="020B0609020204030204" pitchFamily="49" charset="0"/>
-              </a:rPr>
-              <a:t> bit are reserved for future use.</a:t>
-            </a:r>
-          </a:p>
-          <a:p>
-            <a:r>
-              <a:rPr lang="en-US" sz="1800" dirty="0">
-                <a:solidFill>
-                  <a:srgbClr val="000000"/>
-                </a:solidFill>
-                <a:latin typeface="Consolas" panose="020B0609020204030204" pitchFamily="49" charset="0"/>
-              </a:rPr>
-              <a:t>  - P0-P2 bits is the Protocol, a number between 0 and 7. This number defines the "type" of the</a:t>
-            </a:r>
-          </a:p>
-          <a:p>
-            <a:r>
-              <a:rPr lang="en-US" sz="1800" dirty="0">
-                <a:solidFill>
-                  <a:srgbClr val="000000"/>
-                </a:solidFill>
-                <a:latin typeface="Consolas" panose="020B0609020204030204" pitchFamily="49" charset="0"/>
-              </a:rPr>
-              <a:t>  message: the writer or serializer that has been used to write the payload and the reader or "</a:t>
-            </a:r>
-            <a:r>
-              <a:rPr lang="en-US" sz="1800" dirty="0" err="1">
-                <a:solidFill>
-                  <a:srgbClr val="000000"/>
-                </a:solidFill>
-                <a:latin typeface="Consolas" panose="020B0609020204030204" pitchFamily="49" charset="0"/>
-              </a:rPr>
-              <a:t>deserializer</a:t>
-            </a:r>
-            <a:r>
-              <a:rPr lang="en-US" sz="1800" dirty="0">
-                <a:solidFill>
-                  <a:srgbClr val="000000"/>
-                </a:solidFill>
-                <a:latin typeface="Consolas" panose="020B0609020204030204" pitchFamily="49" charset="0"/>
-              </a:rPr>
-              <a:t>"</a:t>
-            </a:r>
-          </a:p>
-          <a:p>
-            <a:r>
-              <a:rPr lang="en-US" sz="1800" dirty="0">
-                <a:solidFill>
-                  <a:srgbClr val="000000"/>
-                </a:solidFill>
-                <a:latin typeface="Consolas" panose="020B0609020204030204" pitchFamily="49" charset="0"/>
-              </a:rPr>
-              <a:t>  that must be used to read it back.</a:t>
-            </a:r>
-          </a:p>
-          <a:p>
-            <a:r>
-              <a:rPr lang="en-US" sz="1800" dirty="0">
-                <a:solidFill>
-                  <a:srgbClr val="000000"/>
-                </a:solidFill>
-                <a:latin typeface="Consolas" panose="020B0609020204030204" pitchFamily="49" charset="0"/>
-              </a:rPr>
-              <a:t>- Then comes the message length itself (1 to 4 bytes)</a:t>
-            </a:r>
-          </a:p>
-          <a:p>
-            <a:r>
-              <a:rPr lang="en-US" sz="1800" dirty="0">
-                <a:solidFill>
-                  <a:srgbClr val="000000"/>
-                </a:solidFill>
-                <a:latin typeface="Consolas" panose="020B0609020204030204" pitchFamily="49" charset="0"/>
-              </a:rPr>
-              <a:t>- Then the message payload itself.</a:t>
-            </a:r>
-          </a:p>
-          <a:p>
-            <a:endParaRPr lang="en-US" sz="1800" dirty="0">
-              <a:solidFill>
-                <a:srgbClr val="000000"/>
-              </a:solidFill>
-              <a:latin typeface="Consolas" panose="020B0609020204030204" pitchFamily="49" charset="0"/>
-            </a:endParaRPr>
-          </a:p>
-          <a:p>
-            <a:r>
-              <a:rPr lang="en-US" sz="1800" dirty="0">
-                <a:solidFill>
-                  <a:srgbClr val="000000"/>
-                </a:solidFill>
-                <a:latin typeface="Consolas" panose="020B0609020204030204" pitchFamily="49" charset="0"/>
-              </a:rPr>
-              <a:t>At a higher level </a:t>
-            </a:r>
-            <a:r>
-              <a:rPr lang="en-US" sz="1800" dirty="0">
-                <a:solidFill>
-                  <a:srgbClr val="A31515"/>
-                </a:solidFill>
-                <a:latin typeface="Consolas" panose="020B0609020204030204" pitchFamily="49" charset="0"/>
-              </a:rPr>
-              <a:t>"</a:t>
-            </a:r>
-            <a:r>
-              <a:rPr lang="en-US" sz="1800" dirty="0" err="1">
-                <a:solidFill>
-                  <a:srgbClr val="000000"/>
-                </a:solidFill>
-                <a:latin typeface="Consolas" panose="020B0609020204030204" pitchFamily="49" charset="0"/>
-              </a:rPr>
-              <a:t>MessageProtocol</a:t>
-            </a:r>
-            <a:r>
-              <a:rPr lang="en-US" sz="1800" dirty="0">
-                <a:solidFill>
-                  <a:srgbClr val="000000"/>
-                </a:solidFill>
-                <a:latin typeface="Consolas" panose="020B0609020204030204" pitchFamily="49" charset="0"/>
-              </a:rPr>
-              <a:t>” are identified by a string (its unique name).</a:t>
-            </a:r>
-          </a:p>
-          <a:p>
-            <a:r>
-              <a:rPr lang="en-US" sz="1800" dirty="0">
-                <a:solidFill>
-                  <a:srgbClr val="000000"/>
-                </a:solidFill>
-                <a:latin typeface="Consolas" panose="020B0609020204030204" pitchFamily="49" charset="0"/>
-              </a:rPr>
-              <a:t>A protocol defines how the message is encoded and how they are exchanged: by merging these 2 concepts here, we greatly simplify the implementation and the understandability of the Transport layer. The protocol simply defines the encoding it uses.</a:t>
-            </a:r>
+              <a:rPr lang="en-US" dirty="0"/>
+              <a:t>Before detailing the Channels, we need to cover the </a:t>
+            </a:r>
+            <a:r>
+              <a:rPr lang="en-US" dirty="0" err="1"/>
+              <a:t>TransportMessage</a:t>
+            </a:r>
+            <a:r>
+              <a:rPr lang="en-US" dirty="0"/>
+              <a:t> and its Factories and the Transport and </a:t>
+            </a:r>
+            <a:r>
+              <a:rPr lang="en-US" dirty="0" err="1"/>
+              <a:t>TransportType</a:t>
+            </a:r>
+            <a:r>
+              <a:rPr lang="en-US" dirty="0"/>
+              <a:t> model.</a:t>
+            </a:r>
+          </a:p>
+          <a:p>
+            <a:endParaRPr lang="en-US" dirty="0"/>
           </a:p>
         </p:txBody>
       </p:sp>
@@ -1524,7 +1143,7 @@
           <a:p>
             <a:fld id="{E05EDB92-2FE2-4164-AA27-D03258A20DF4}" type="slidenum">
               <a:rPr lang="en-US" smtClean="0"/>
-              <a:t>29</a:t>
+              <a:t>28</a:t>
             </a:fld>
             <a:endParaRPr lang="en-US"/>
           </a:p>
@@ -1533,7 +1152,7 @@
     </p:spTree>
     <p:extLst>
       <p:ext uri="{BB962C8B-B14F-4D97-AF65-F5344CB8AC3E}">
-        <p14:creationId xmlns:p14="http://schemas.microsoft.com/office/powerpoint/2010/main" val="4115452317"/>
+        <p14:creationId xmlns:p14="http://schemas.microsoft.com/office/powerpoint/2010/main" val="1107907762"/>
       </p:ext>
     </p:extLst>
   </p:cSld>
@@ -1594,16 +1213,27 @@
                 </a:solidFill>
                 <a:latin typeface="Consolas" panose="020B0609020204030204" pitchFamily="49" charset="0"/>
               </a:rPr>
-              <a:t>The </a:t>
-            </a:r>
+              <a:t>All messages exchanged by the Transport layer are prefixed by the message's protocol and length.</a:t>
+            </a:r>
+          </a:p>
+          <a:p>
             <a:r>
               <a:rPr lang="en-US" sz="1800" dirty="0">
                 <a:solidFill>
+                  <a:srgbClr val="000000"/>
+                </a:solidFill>
+                <a:latin typeface="Consolas" panose="020B0609020204030204" pitchFamily="49" charset="0"/>
+              </a:rPr>
+              <a:t>- The prefix starts with a first byte: </a:t>
+            </a:r>
+            <a:r>
+              <a:rPr lang="en-US" sz="1800" dirty="0">
+                <a:solidFill>
                   <a:srgbClr val="0000FF"/>
                 </a:solidFill>
                 <a:latin typeface="Consolas" panose="020B0609020204030204" pitchFamily="49" charset="0"/>
               </a:rPr>
-              <a:t>`"0 Protocol"`</a:t>
+              <a:t>`|L0|L1|CD|R0|R1|P0|P1|P2|`</a:t>
             </a:r>
             <a:r>
               <a:rPr lang="en-US" sz="1800" dirty="0">
@@ -1612,7 +1242,243 @@
                 </a:solidFill>
                 <a:latin typeface="Consolas" panose="020B0609020204030204" pitchFamily="49" charset="0"/>
               </a:rPr>
-              <a:t> protocol name is reserved: this is the protocol of </a:t>
+              <a:t>.</a:t>
+            </a:r>
+          </a:p>
+          <a:p>
+            <a:r>
+              <a:rPr lang="en-US" sz="1800" dirty="0">
+                <a:solidFill>
+                  <a:srgbClr val="000000"/>
+                </a:solidFill>
+                <a:latin typeface="Consolas" panose="020B0609020204030204" pitchFamily="49" charset="0"/>
+              </a:rPr>
+              <a:t>  - The 2 MSB (L0-L1) gives us the number of bytes of the message length:</a:t>
+            </a:r>
+          </a:p>
+          <a:p>
+            <a:r>
+              <a:rPr lang="en-US" sz="1800" dirty="0">
+                <a:solidFill>
+                  <a:srgbClr val="000000"/>
+                </a:solidFill>
+                <a:latin typeface="Consolas" panose="020B0609020204030204" pitchFamily="49" charset="0"/>
+              </a:rPr>
+              <a:t>    - </a:t>
+            </a:r>
+            <a:r>
+              <a:rPr lang="en-US" sz="1800" dirty="0">
+                <a:solidFill>
+                  <a:srgbClr val="0000FF"/>
+                </a:solidFill>
+                <a:latin typeface="Consolas" panose="020B0609020204030204" pitchFamily="49" charset="0"/>
+              </a:rPr>
+              <a:t>`00`</a:t>
+            </a:r>
+            <a:r>
+              <a:rPr lang="en-US" sz="1800" dirty="0">
+                <a:solidFill>
+                  <a:srgbClr val="000000"/>
+                </a:solidFill>
+                <a:latin typeface="Consolas" panose="020B0609020204030204" pitchFamily="49" charset="0"/>
+              </a:rPr>
+              <a:t> 1 byte, the message length is between 0 and 255 bytes.</a:t>
+            </a:r>
+          </a:p>
+          <a:p>
+            <a:r>
+              <a:rPr lang="en-US" sz="1800" dirty="0">
+                <a:solidFill>
+                  <a:srgbClr val="000000"/>
+                </a:solidFill>
+                <a:latin typeface="Consolas" panose="020B0609020204030204" pitchFamily="49" charset="0"/>
+              </a:rPr>
+              <a:t>    - </a:t>
+            </a:r>
+            <a:r>
+              <a:rPr lang="en-US" sz="1800" dirty="0">
+                <a:solidFill>
+                  <a:srgbClr val="0000FF"/>
+                </a:solidFill>
+                <a:latin typeface="Consolas" panose="020B0609020204030204" pitchFamily="49" charset="0"/>
+              </a:rPr>
+              <a:t>`01`</a:t>
+            </a:r>
+            <a:r>
+              <a:rPr lang="en-US" sz="1800" dirty="0">
+                <a:solidFill>
+                  <a:srgbClr val="000000"/>
+                </a:solidFill>
+                <a:latin typeface="Consolas" panose="020B0609020204030204" pitchFamily="49" charset="0"/>
+              </a:rPr>
+              <a:t> 2 bytes, the message length is between 256 and 65535 bytes.</a:t>
+            </a:r>
+          </a:p>
+          <a:p>
+            <a:r>
+              <a:rPr lang="en-US" sz="1800" dirty="0">
+                <a:solidFill>
+                  <a:srgbClr val="000000"/>
+                </a:solidFill>
+                <a:latin typeface="Consolas" panose="020B0609020204030204" pitchFamily="49" charset="0"/>
+              </a:rPr>
+              <a:t>    - </a:t>
+            </a:r>
+            <a:r>
+              <a:rPr lang="en-US" sz="1800" dirty="0">
+                <a:solidFill>
+                  <a:srgbClr val="0000FF"/>
+                </a:solidFill>
+                <a:latin typeface="Consolas" panose="020B0609020204030204" pitchFamily="49" charset="0"/>
+              </a:rPr>
+              <a:t>`10`</a:t>
+            </a:r>
+            <a:r>
+              <a:rPr lang="en-US" sz="1800" dirty="0">
+                <a:solidFill>
+                  <a:srgbClr val="000000"/>
+                </a:solidFill>
+                <a:latin typeface="Consolas" panose="020B0609020204030204" pitchFamily="49" charset="0"/>
+              </a:rPr>
+              <a:t> 3 bytes, the message length is between 65536 and 16 777 215 bytes.</a:t>
+            </a:r>
+          </a:p>
+          <a:p>
+            <a:r>
+              <a:rPr lang="en-US" sz="1800" dirty="0">
+                <a:solidFill>
+                  <a:srgbClr val="000000"/>
+                </a:solidFill>
+                <a:latin typeface="Consolas" panose="020B0609020204030204" pitchFamily="49" charset="0"/>
+              </a:rPr>
+              <a:t>    - </a:t>
+            </a:r>
+            <a:r>
+              <a:rPr lang="en-US" sz="1800" dirty="0">
+                <a:solidFill>
+                  <a:srgbClr val="0000FF"/>
+                </a:solidFill>
+                <a:latin typeface="Consolas" panose="020B0609020204030204" pitchFamily="49" charset="0"/>
+              </a:rPr>
+              <a:t>`11`</a:t>
+            </a:r>
+            <a:r>
+              <a:rPr lang="en-US" sz="1800" dirty="0">
+                <a:solidFill>
+                  <a:srgbClr val="000000"/>
+                </a:solidFill>
+                <a:latin typeface="Consolas" panose="020B0609020204030204" pitchFamily="49" charset="0"/>
+              </a:rPr>
+              <a:t> 4 bytes, the message length is between 16 777 216 and 2 147 483 648 bytes (2 Gib).</a:t>
+            </a:r>
+          </a:p>
+          <a:p>
+            <a:r>
+              <a:rPr lang="en-US" sz="1800" dirty="0">
+                <a:solidFill>
+                  <a:srgbClr val="000000"/>
+                </a:solidFill>
+                <a:latin typeface="Consolas" panose="020B0609020204030204" pitchFamily="49" charset="0"/>
+              </a:rPr>
+              <a:t>  - The </a:t>
+            </a:r>
+            <a:r>
+              <a:rPr lang="en-US" sz="1800" dirty="0">
+                <a:solidFill>
+                  <a:srgbClr val="0000FF"/>
+                </a:solidFill>
+                <a:latin typeface="Consolas" panose="020B0609020204030204" pitchFamily="49" charset="0"/>
+              </a:rPr>
+              <a:t>`CD`</a:t>
+            </a:r>
+            <a:r>
+              <a:rPr lang="en-US" sz="1800" dirty="0">
+                <a:solidFill>
+                  <a:srgbClr val="000000"/>
+                </a:solidFill>
+                <a:latin typeface="Consolas" panose="020B0609020204030204" pitchFamily="49" charset="0"/>
+              </a:rPr>
+              <a:t> bit is the "Control vs. Data" bit. This is a convenient bit that can be used by protocols</a:t>
+            </a:r>
+          </a:p>
+          <a:p>
+            <a:r>
+              <a:rPr lang="en-US" sz="1800" dirty="0">
+                <a:solidFill>
+                  <a:srgbClr val="000000"/>
+                </a:solidFill>
+                <a:latin typeface="Consolas" panose="020B0609020204030204" pitchFamily="49" charset="0"/>
+              </a:rPr>
+              <a:t>    as a one-bit discriminator, typically between a regular data message and one (or more) control message.</a:t>
+            </a:r>
+          </a:p>
+          <a:p>
+            <a:r>
+              <a:rPr lang="en-US" sz="1800" dirty="0">
+                <a:solidFill>
+                  <a:srgbClr val="000000"/>
+                </a:solidFill>
+                <a:latin typeface="Consolas" panose="020B0609020204030204" pitchFamily="49" charset="0"/>
+              </a:rPr>
+              <a:t>  - </a:t>
+            </a:r>
+            <a:r>
+              <a:rPr lang="en-US" sz="1800" dirty="0">
+                <a:solidFill>
+                  <a:srgbClr val="0000FF"/>
+                </a:solidFill>
+                <a:latin typeface="Consolas" panose="020B0609020204030204" pitchFamily="49" charset="0"/>
+              </a:rPr>
+              <a:t>`R0`</a:t>
+            </a:r>
+            <a:r>
+              <a:rPr lang="en-US" sz="1800" dirty="0">
+                <a:solidFill>
+                  <a:srgbClr val="000000"/>
+                </a:solidFill>
+                <a:latin typeface="Consolas" panose="020B0609020204030204" pitchFamily="49" charset="0"/>
+              </a:rPr>
+              <a:t> and </a:t>
+            </a:r>
+            <a:r>
+              <a:rPr lang="en-US" sz="1800" dirty="0">
+                <a:solidFill>
+                  <a:srgbClr val="0000FF"/>
+                </a:solidFill>
+                <a:latin typeface="Consolas" panose="020B0609020204030204" pitchFamily="49" charset="0"/>
+              </a:rPr>
+              <a:t>`R1`</a:t>
+            </a:r>
+            <a:r>
+              <a:rPr lang="en-US" sz="1800" dirty="0">
+                <a:solidFill>
+                  <a:srgbClr val="000000"/>
+                </a:solidFill>
+                <a:latin typeface="Consolas" panose="020B0609020204030204" pitchFamily="49" charset="0"/>
+              </a:rPr>
+              <a:t> bit are reserved for future use.</a:t>
+            </a:r>
+          </a:p>
+          <a:p>
+            <a:r>
+              <a:rPr lang="en-US" sz="1800" dirty="0">
+                <a:solidFill>
+                  <a:srgbClr val="000000"/>
+                </a:solidFill>
+                <a:latin typeface="Consolas" panose="020B0609020204030204" pitchFamily="49" charset="0"/>
+              </a:rPr>
+              <a:t>  - P0-P2 bits is the Protocol, a number between 0 and 7. This number defines the "type" of the</a:t>
+            </a:r>
+          </a:p>
+          <a:p>
+            <a:r>
+              <a:rPr lang="en-US" sz="1800" dirty="0">
+                <a:solidFill>
+                  <a:srgbClr val="000000"/>
+                </a:solidFill>
+                <a:latin typeface="Consolas" panose="020B0609020204030204" pitchFamily="49" charset="0"/>
+              </a:rPr>
+              <a:t>  message: the writer or serializer that has been used to write the payload and the reader or "</a:t>
             </a:r>
             <a:r>
               <a:rPr lang="en-US" sz="1800" dirty="0" err="1">
@@ -1621,7 +1487,7 @@
                 </a:solidFill>
                 <a:latin typeface="Consolas" panose="020B0609020204030204" pitchFamily="49" charset="0"/>
               </a:rPr>
-              <a:t>CK.AppIdentity.TransportLayer</a:t>
+              <a:t>deserializer</a:t>
             </a:r>
             <a:r>
               <a:rPr lang="en-US" sz="1800" dirty="0">
@@ -1630,7 +1496,7 @@
                 </a:solidFill>
                 <a:latin typeface="Consolas" panose="020B0609020204030204" pitchFamily="49" charset="0"/>
               </a:rPr>
-              <a:t> itself that handles</a:t>
+              <a:t>"</a:t>
             </a:r>
           </a:p>
           <a:p>
@@ -1641,7 +1507,7 @@
                 </a:solidFill>
                 <a:latin typeface="Consolas" panose="020B0609020204030204" pitchFamily="49" charset="0"/>
               </a:rPr>
-              <a:t>special messages used to negotiate, accept, reject incoming parties and outgoing connections.</a:t>
+              <a:t>  that must be used to read it back.</a:t>
             </a:r>
           </a:p>
           <a:p>
@@ -1652,7 +1518,7 @@
                 </a:solidFill>
                 <a:latin typeface="Consolas" panose="020B0609020204030204" pitchFamily="49" charset="0"/>
               </a:rPr>
-              <a:t>This lets 7 possible protocols. This may seem a limitation however this limit applies to a Remote party pair: there</a:t>
+              <a:t>- Then comes the message length itself (1 to 4 bytes)</a:t>
             </a:r>
           </a:p>
           <a:p>
@@ -1663,18 +1529,7 @@
                 </a:solidFill>
                 <a:latin typeface="Consolas" panose="020B0609020204030204" pitchFamily="49" charset="0"/>
               </a:rPr>
-              <a:t>can be any number of possible protocols in an application, among them 2 parties that start to interact initially</a:t>
-            </a:r>
-          </a:p>
-          <a:p>
-            <a:r>
-              <a:rPr lang="en-US" sz="1800" dirty="0">
-                <a:solidFill>
-                  <a:srgbClr val="000000"/>
-                </a:solidFill>
-                <a:latin typeface="Consolas" panose="020B0609020204030204" pitchFamily="49" charset="0"/>
-              </a:rPr>
-              <a:t>negotiate the ones they can and want to use. Any Transport between 2 parties can support up to 7 different protocols.</a:t>
+              <a:t>- Then the message payload itself.</a:t>
             </a:r>
           </a:p>
           <a:p>
@@ -1693,22 +1548,46 @@
                 </a:solidFill>
                 <a:latin typeface="Consolas" panose="020B0609020204030204" pitchFamily="49" charset="0"/>
               </a:rPr>
-              <a:t>The final length of a message on the wire is between 2 bytes (the special Empty message, see below) and 2 Gib.</a:t>
-            </a:r>
-          </a:p>
-          <a:p>
+              <a:t>At a higher level </a:t>
+            </a:r>
             <a:r>
               <a:rPr lang="en-US" sz="1800" dirty="0">
                 <a:solidFill>
+                  <a:srgbClr val="A31515"/>
+                </a:solidFill>
+                <a:latin typeface="Consolas" panose="020B0609020204030204" pitchFamily="49" charset="0"/>
+              </a:rPr>
+              <a:t>"</a:t>
+            </a:r>
+            <a:r>
+              <a:rPr lang="en-US" sz="1800" dirty="0" err="1">
+                <a:solidFill>
                   <a:srgbClr val="000000"/>
                 </a:solidFill>
                 <a:latin typeface="Consolas" panose="020B0609020204030204" pitchFamily="49" charset="0"/>
               </a:rPr>
-              <a:t>A minimal 1 byte message requires 3 bytes (in any of the 7 available protocols). </a:t>
-            </a:r>
-          </a:p>
-          <a:p>
-            <a:endParaRPr lang="en-US" dirty="0"/>
+              <a:t>MessageProtocol</a:t>
+            </a:r>
+            <a:r>
+              <a:rPr lang="en-US" sz="1800" dirty="0">
+                <a:solidFill>
+                  <a:srgbClr val="000000"/>
+                </a:solidFill>
+                <a:latin typeface="Consolas" panose="020B0609020204030204" pitchFamily="49" charset="0"/>
+              </a:rPr>
+              <a:t>” are identified by a string (its unique name).</a:t>
+            </a:r>
+          </a:p>
+          <a:p>
+            <a:r>
+              <a:rPr lang="en-US" sz="1800" dirty="0">
+                <a:solidFill>
+                  <a:srgbClr val="000000"/>
+                </a:solidFill>
+                <a:latin typeface="Consolas" panose="020B0609020204030204" pitchFamily="49" charset="0"/>
+              </a:rPr>
+              <a:t>A protocol defines how the message is encoded and how they are exchanged: by merging these 2 concepts here, we greatly simplify the implementation and the understandability of the Transport layer. The protocol simply defines the encoding it uses.</a:t>
+            </a:r>
           </a:p>
         </p:txBody>
       </p:sp>
@@ -1738,7 +1617,7 @@
     </p:spTree>
     <p:extLst>
       <p:ext uri="{BB962C8B-B14F-4D97-AF65-F5344CB8AC3E}">
-        <p14:creationId xmlns:p14="http://schemas.microsoft.com/office/powerpoint/2010/main" val="1132549190"/>
+        <p14:creationId xmlns:p14="http://schemas.microsoft.com/office/powerpoint/2010/main" val="4115452317"/>
       </p:ext>
     </p:extLst>
   </p:cSld>
@@ -1792,6 +1671,127 @@
           <a:bodyPr/>
           <a:lstStyle/>
           <a:p>
+            <a:r>
+              <a:rPr lang="en-US" sz="1800" dirty="0">
+                <a:solidFill>
+                  <a:srgbClr val="000000"/>
+                </a:solidFill>
+                <a:latin typeface="Consolas" panose="020B0609020204030204" pitchFamily="49" charset="0"/>
+              </a:rPr>
+              <a:t>The </a:t>
+            </a:r>
+            <a:r>
+              <a:rPr lang="en-US" sz="1800" dirty="0">
+                <a:solidFill>
+                  <a:srgbClr val="0000FF"/>
+                </a:solidFill>
+                <a:latin typeface="Consolas" panose="020B0609020204030204" pitchFamily="49" charset="0"/>
+              </a:rPr>
+              <a:t>`"0 Protocol"`</a:t>
+            </a:r>
+            <a:r>
+              <a:rPr lang="en-US" sz="1800" dirty="0">
+                <a:solidFill>
+                  <a:srgbClr val="000000"/>
+                </a:solidFill>
+                <a:latin typeface="Consolas" panose="020B0609020204030204" pitchFamily="49" charset="0"/>
+              </a:rPr>
+              <a:t> protocol name is reserved: this is the protocol of </a:t>
+            </a:r>
+            <a:r>
+              <a:rPr lang="en-US" sz="1800" dirty="0" err="1">
+                <a:solidFill>
+                  <a:srgbClr val="000000"/>
+                </a:solidFill>
+                <a:latin typeface="Consolas" panose="020B0609020204030204" pitchFamily="49" charset="0"/>
+              </a:rPr>
+              <a:t>CK.AppIdentity.TransportLayer</a:t>
+            </a:r>
+            <a:r>
+              <a:rPr lang="en-US" sz="1800" dirty="0">
+                <a:solidFill>
+                  <a:srgbClr val="000000"/>
+                </a:solidFill>
+                <a:latin typeface="Consolas" panose="020B0609020204030204" pitchFamily="49" charset="0"/>
+              </a:rPr>
+              <a:t> itself that handles</a:t>
+            </a:r>
+          </a:p>
+          <a:p>
+            <a:r>
+              <a:rPr lang="en-US" sz="1800" dirty="0">
+                <a:solidFill>
+                  <a:srgbClr val="000000"/>
+                </a:solidFill>
+                <a:latin typeface="Consolas" panose="020B0609020204030204" pitchFamily="49" charset="0"/>
+              </a:rPr>
+              <a:t>special messages used to negotiate, accept, reject incoming parties and outgoing connections.</a:t>
+            </a:r>
+          </a:p>
+          <a:p>
+            <a:r>
+              <a:rPr lang="en-US" sz="1800" dirty="0">
+                <a:solidFill>
+                  <a:srgbClr val="000000"/>
+                </a:solidFill>
+                <a:latin typeface="Consolas" panose="020B0609020204030204" pitchFamily="49" charset="0"/>
+              </a:rPr>
+              <a:t>This lets 7 possible protocols. This may seem a limitation however this limit applies to a Remote party pair: there</a:t>
+            </a:r>
+          </a:p>
+          <a:p>
+            <a:r>
+              <a:rPr lang="en-US" sz="1800" dirty="0">
+                <a:solidFill>
+                  <a:srgbClr val="000000"/>
+                </a:solidFill>
+                <a:latin typeface="Consolas" panose="020B0609020204030204" pitchFamily="49" charset="0"/>
+              </a:rPr>
+              <a:t>can be any number of possible protocols in an application, among them 2 parties that start to interact initially</a:t>
+            </a:r>
+          </a:p>
+          <a:p>
+            <a:r>
+              <a:rPr lang="en-US" sz="1800" dirty="0">
+                <a:solidFill>
+                  <a:srgbClr val="000000"/>
+                </a:solidFill>
+                <a:latin typeface="Consolas" panose="020B0609020204030204" pitchFamily="49" charset="0"/>
+              </a:rPr>
+              <a:t>negotiate the ones they can and want to use. Any Transport between 2 parties can support up to 7 different protocols.</a:t>
+            </a:r>
+          </a:p>
+          <a:p>
+            <a:endParaRPr lang="en-US" sz="1800" dirty="0">
+              <a:solidFill>
+                <a:srgbClr val="000000"/>
+              </a:solidFill>
+              <a:latin typeface="Consolas" panose="020B0609020204030204" pitchFamily="49" charset="0"/>
+            </a:endParaRPr>
+          </a:p>
+          <a:p>
+            <a:r>
+              <a:rPr lang="en-US" sz="1800" dirty="0">
+                <a:solidFill>
+                  <a:srgbClr val="000000"/>
+                </a:solidFill>
+                <a:latin typeface="Consolas" panose="020B0609020204030204" pitchFamily="49" charset="0"/>
+              </a:rPr>
+              <a:t>The final length of a message on the wire is between 2 bytes (the special Empty message, see below) and 2 Gib.</a:t>
+            </a:r>
+          </a:p>
+          <a:p>
+            <a:r>
+              <a:rPr lang="en-US" sz="1800" dirty="0">
+                <a:solidFill>
+                  <a:srgbClr val="000000"/>
+                </a:solidFill>
+                <a:latin typeface="Consolas" panose="020B0609020204030204" pitchFamily="49" charset="0"/>
+              </a:rPr>
+              <a:t>A minimal 1 byte message requires 3 bytes (in any of the 7 available protocols). </a:t>
+            </a:r>
+          </a:p>
+          <a:p>
             <a:endParaRPr lang="en-US" dirty="0"/>
           </a:p>
         </p:txBody>
@@ -1813,7 +1813,7 @@
           <a:p>
             <a:fld id="{E05EDB92-2FE2-4164-AA27-D03258A20DF4}" type="slidenum">
               <a:rPr lang="en-US" smtClean="0"/>
-              <a:t>32</a:t>
+              <a:t>31</a:t>
             </a:fld>
             <a:endParaRPr lang="en-US"/>
           </a:p>
@@ -1822,7 +1822,7 @@
     </p:spTree>
     <p:extLst>
       <p:ext uri="{BB962C8B-B14F-4D97-AF65-F5344CB8AC3E}">
-        <p14:creationId xmlns:p14="http://schemas.microsoft.com/office/powerpoint/2010/main" val="213048778"/>
+        <p14:creationId xmlns:p14="http://schemas.microsoft.com/office/powerpoint/2010/main" val="1132549190"/>
       </p:ext>
     </p:extLst>
   </p:cSld>
@@ -1906,7 +1906,7 @@
     </p:spTree>
     <p:extLst>
       <p:ext uri="{BB962C8B-B14F-4D97-AF65-F5344CB8AC3E}">
-        <p14:creationId xmlns:p14="http://schemas.microsoft.com/office/powerpoint/2010/main" val="1570586495"/>
+        <p14:creationId xmlns:p14="http://schemas.microsoft.com/office/powerpoint/2010/main" val="213048778"/>
       </p:ext>
     </p:extLst>
   </p:cSld>
@@ -2063,7 +2063,7 @@
           <a:p>
             <a:fld id="{7D1F2140-8D48-49AC-AD8D-683E6FF4DC34}" type="datetimeFigureOut">
               <a:rPr lang="en-US" smtClean="0"/>
-              <a:t>6/26/2023</a:t>
+              <a:t>6/28/2023</a:t>
             </a:fld>
             <a:endParaRPr lang="en-US"/>
           </a:p>
@@ -2261,7 +2261,7 @@
           <a:p>
             <a:fld id="{7D1F2140-8D48-49AC-AD8D-683E6FF4DC34}" type="datetimeFigureOut">
               <a:rPr lang="en-US" smtClean="0"/>
-              <a:t>6/26/2023</a:t>
+              <a:t>6/28/2023</a:t>
             </a:fld>
             <a:endParaRPr lang="en-US"/>
           </a:p>
@@ -2469,7 +2469,7 @@
           <a:p>
             <a:fld id="{7D1F2140-8D48-49AC-AD8D-683E6FF4DC34}" type="datetimeFigureOut">
               <a:rPr lang="en-US" smtClean="0"/>
-              <a:t>6/26/2023</a:t>
+              <a:t>6/28/2023</a:t>
             </a:fld>
             <a:endParaRPr lang="en-US"/>
           </a:p>
@@ -2667,7 +2667,7 @@
           <a:p>
             <a:fld id="{7D1F2140-8D48-49AC-AD8D-683E6FF4DC34}" type="datetimeFigureOut">
               <a:rPr lang="en-US" smtClean="0"/>
-              <a:t>6/26/2023</a:t>
+              <a:t>6/28/2023</a:t>
             </a:fld>
             <a:endParaRPr lang="en-US"/>
           </a:p>
@@ -2942,7 +2942,7 @@
           <a:p>
             <a:fld id="{7D1F2140-8D48-49AC-AD8D-683E6FF4DC34}" type="datetimeFigureOut">
               <a:rPr lang="en-US" smtClean="0"/>
-              <a:t>6/26/2023</a:t>
+              <a:t>6/28/2023</a:t>
             </a:fld>
             <a:endParaRPr lang="en-US"/>
           </a:p>
@@ -3207,7 +3207,7 @@
           <a:p>
             <a:fld id="{7D1F2140-8D48-49AC-AD8D-683E6FF4DC34}" type="datetimeFigureOut">
               <a:rPr lang="en-US" smtClean="0"/>
-              <a:t>6/26/2023</a:t>
+              <a:t>6/28/2023</a:t>
             </a:fld>
             <a:endParaRPr lang="en-US"/>
           </a:p>
@@ -3619,7 +3619,7 @@
           <a:p>
             <a:fld id="{7D1F2140-8D48-49AC-AD8D-683E6FF4DC34}" type="datetimeFigureOut">
               <a:rPr lang="en-US" smtClean="0"/>
-              <a:t>6/26/2023</a:t>
+              <a:t>6/28/2023</a:t>
             </a:fld>
             <a:endParaRPr lang="en-US"/>
           </a:p>
@@ -3760,7 +3760,7 @@
           <a:p>
             <a:fld id="{7D1F2140-8D48-49AC-AD8D-683E6FF4DC34}" type="datetimeFigureOut">
               <a:rPr lang="en-US" smtClean="0"/>
-              <a:t>6/26/2023</a:t>
+              <a:t>6/28/2023</a:t>
             </a:fld>
             <a:endParaRPr lang="en-US"/>
           </a:p>
@@ -3873,7 +3873,7 @@
           <a:p>
             <a:fld id="{7D1F2140-8D48-49AC-AD8D-683E6FF4DC34}" type="datetimeFigureOut">
               <a:rPr lang="en-US" smtClean="0"/>
-              <a:t>6/26/2023</a:t>
+              <a:t>6/28/2023</a:t>
             </a:fld>
             <a:endParaRPr lang="en-US"/>
           </a:p>
@@ -4184,7 +4184,7 @@
           <a:p>
             <a:fld id="{7D1F2140-8D48-49AC-AD8D-683E6FF4DC34}" type="datetimeFigureOut">
               <a:rPr lang="en-US" smtClean="0"/>
-              <a:t>6/26/2023</a:t>
+              <a:t>6/28/2023</a:t>
             </a:fld>
             <a:endParaRPr lang="en-US"/>
           </a:p>
@@ -4472,7 +4472,7 @@
           <a:p>
             <a:fld id="{7D1F2140-8D48-49AC-AD8D-683E6FF4DC34}" type="datetimeFigureOut">
               <a:rPr lang="en-US" smtClean="0"/>
-              <a:t>6/26/2023</a:t>
+              <a:t>6/28/2023</a:t>
             </a:fld>
             <a:endParaRPr lang="en-US"/>
           </a:p>
@@ -4713,7 +4713,7 @@
           <a:p>
             <a:fld id="{7D1F2140-8D48-49AC-AD8D-683E6FF4DC34}" type="datetimeFigureOut">
               <a:rPr lang="en-US" smtClean="0"/>
-              <a:t>6/26/2023</a:t>
+              <a:t>6/28/2023</a:t>
             </a:fld>
             <a:endParaRPr lang="en-US"/>
           </a:p>
@@ -11255,89 +11255,42 @@
               <a:buNone/>
             </a:pPr>
             <a:r>
-              <a:rPr lang="en-US" sz="1400" dirty="0">
+              <a:rPr lang="en-US" sz="1400" b="1" dirty="0">
                 <a:latin typeface="Courier New" panose="02070309020205020404" pitchFamily="49" charset="0"/>
                 <a:cs typeface="Courier New" panose="02070309020205020404" pitchFamily="49" charset="0"/>
               </a:rPr>
               <a:t>    "</a:t>
             </a:r>
             <a:r>
-              <a:rPr lang="en-US" sz="1400" dirty="0" err="1">
-                <a:latin typeface="Courier New" panose="02070309020205020404" pitchFamily="49" charset="0"/>
-                <a:cs typeface="Courier New" panose="02070309020205020404" pitchFamily="49" charset="0"/>
-              </a:rPr>
-              <a:t>DomainName</a:t>
-            </a:r>
-            <a:r>
-              <a:rPr lang="en-US" sz="1400" dirty="0">
-                <a:latin typeface="Courier New" panose="02070309020205020404" pitchFamily="49" charset="0"/>
-                <a:cs typeface="Courier New" panose="02070309020205020404" pitchFamily="49" charset="0"/>
-              </a:rPr>
-              <a:t>": "</a:t>
+              <a:rPr lang="en-US" sz="1400" b="1" dirty="0" err="1">
+                <a:latin typeface="Courier New" panose="02070309020205020404" pitchFamily="49" charset="0"/>
+                <a:cs typeface="Courier New" panose="02070309020205020404" pitchFamily="49" charset="0"/>
+              </a:rPr>
+              <a:t>FullName</a:t>
             </a:r>
             <a:r>
               <a:rPr lang="en-US" sz="1400" b="1" dirty="0">
                 <a:latin typeface="Courier New" panose="02070309020205020404" pitchFamily="49" charset="0"/>
                 <a:cs typeface="Courier New" panose="02070309020205020404" pitchFamily="49" charset="0"/>
               </a:rPr>
-              <a:t>External</a:t>
-            </a:r>
-            <a:r>
-              <a:rPr lang="en-US" sz="1400" dirty="0">
+              <a:t>": "External/$</a:t>
+            </a:r>
+            <a:r>
+              <a:rPr lang="en-US" sz="1400" b="1" dirty="0" err="1">
+                <a:latin typeface="Courier New" panose="02070309020205020404" pitchFamily="49" charset="0"/>
+                <a:cs typeface="Courier New" panose="02070309020205020404" pitchFamily="49" charset="0"/>
+              </a:rPr>
+              <a:t>GitSource</a:t>
+            </a:r>
+            <a:r>
+              <a:rPr lang="en-US" sz="1400" b="1" dirty="0">
                 <a:latin typeface="Courier New" panose="02070309020205020404" pitchFamily="49" charset="0"/>
                 <a:cs typeface="Courier New" panose="02070309020205020404" pitchFamily="49" charset="0"/>
               </a:rPr>
               <a:t>",</a:t>
             </a:r>
-          </a:p>
-          <a:p>
-            <a:pPr marL="0" indent="0">
-              <a:lnSpc>
-                <a:spcPct val="100000"/>
-              </a:lnSpc>
-              <a:spcBef>
-                <a:spcPts val="0"/>
-              </a:spcBef>
-              <a:buFont typeface="Arial" panose="020B0604020202020204" pitchFamily="34" charset="0"/>
-              <a:buNone/>
-            </a:pPr>
-            <a:r>
-              <a:rPr lang="en-US" sz="1400" dirty="0">
-                <a:latin typeface="Courier New" panose="02070309020205020404" pitchFamily="49" charset="0"/>
-                <a:cs typeface="Courier New" panose="02070309020205020404" pitchFamily="49" charset="0"/>
-              </a:rPr>
-              <a:t>    "</a:t>
-            </a:r>
-            <a:r>
-              <a:rPr lang="en-US" sz="1400" dirty="0" err="1">
-                <a:latin typeface="Courier New" panose="02070309020205020404" pitchFamily="49" charset="0"/>
-                <a:cs typeface="Courier New" panose="02070309020205020404" pitchFamily="49" charset="0"/>
-              </a:rPr>
-              <a:t>PartyName</a:t>
-            </a:r>
-            <a:r>
-              <a:rPr lang="en-US" sz="1400" dirty="0">
-                <a:latin typeface="Courier New" panose="02070309020205020404" pitchFamily="49" charset="0"/>
-                <a:cs typeface="Courier New" panose="02070309020205020404" pitchFamily="49" charset="0"/>
-              </a:rPr>
-              <a:t>": "</a:t>
-            </a:r>
-            <a:r>
-              <a:rPr lang="en-US" sz="1400" dirty="0" err="1">
-                <a:latin typeface="Courier New" panose="02070309020205020404" pitchFamily="49" charset="0"/>
-                <a:cs typeface="Courier New" panose="02070309020205020404" pitchFamily="49" charset="0"/>
-              </a:rPr>
-              <a:t>GitSource</a:t>
-            </a:r>
-            <a:r>
-              <a:rPr lang="en-US" sz="1400" dirty="0">
-                <a:latin typeface="Courier New" panose="02070309020205020404" pitchFamily="49" charset="0"/>
-                <a:cs typeface="Courier New" panose="02070309020205020404" pitchFamily="49" charset="0"/>
-              </a:rPr>
-              <a:t>",</a:t>
-            </a:r>
             <a:br>
-              <a:rPr lang="en-US" sz="1400" dirty="0">
+              <a:rPr lang="en-US" sz="1400" b="1" dirty="0">
                 <a:latin typeface="Courier New" panose="02070309020205020404" pitchFamily="49" charset="0"/>
                 <a:cs typeface="Courier New" panose="02070309020205020404" pitchFamily="49" charset="0"/>
               </a:rPr>
@@ -11899,86 +11852,6 @@
           <p:cNvPr id="2" name="Title 1">
             <a:extLst>
               <a:ext uri="{FF2B5EF4-FFF2-40B4-BE49-F238E27FC236}">
-                <a16:creationId xmlns:a16="http://schemas.microsoft.com/office/drawing/2014/main" id="{2ADDEB0D-75FE-A9E7-AE5D-1A00BE2CB4EF}"/>
-              </a:ext>
-            </a:extLst>
-          </p:cNvPr>
-          <p:cNvSpPr>
-            <a:spLocks noGrp="1"/>
-          </p:cNvSpPr>
-          <p:nvPr>
-            <p:ph type="title"/>
-          </p:nvPr>
-        </p:nvSpPr>
-        <p:spPr/>
-        <p:txBody>
-          <a:bodyPr/>
-          <a:lstStyle/>
-          <a:p>
-            <a:endParaRPr lang="en-US"/>
-          </a:p>
-        </p:txBody>
-      </p:sp>
-      <p:sp>
-        <p:nvSpPr>
-          <p:cNvPr id="3" name="Content Placeholder 2">
-            <a:extLst>
-              <a:ext uri="{FF2B5EF4-FFF2-40B4-BE49-F238E27FC236}">
-                <a16:creationId xmlns:a16="http://schemas.microsoft.com/office/drawing/2014/main" id="{69BD3F96-4E3A-A64D-A143-5E0F643AB7C5}"/>
-              </a:ext>
-            </a:extLst>
-          </p:cNvPr>
-          <p:cNvSpPr>
-            <a:spLocks noGrp="1"/>
-          </p:cNvSpPr>
-          <p:nvPr>
-            <p:ph idx="1"/>
-          </p:nvPr>
-        </p:nvSpPr>
-        <p:spPr/>
-        <p:txBody>
-          <a:bodyPr/>
-          <a:lstStyle/>
-          <a:p>
-            <a:endParaRPr lang="en-US"/>
-          </a:p>
-        </p:txBody>
-      </p:sp>
-    </p:spTree>
-    <p:extLst>
-      <p:ext uri="{BB962C8B-B14F-4D97-AF65-F5344CB8AC3E}">
-        <p14:creationId xmlns:p14="http://schemas.microsoft.com/office/powerpoint/2010/main" val="4293717367"/>
-      </p:ext>
-    </p:extLst>
-  </p:cSld>
-  <p:clrMapOvr>
-    <a:masterClrMapping/>
-  </p:clrMapOvr>
-</p:sld>
-</file>
-
-<file path=ppt/slides/slide21.xml><?xml version="1.0" encoding="utf-8"?>
-<p:sld xmlns:a="http://schemas.openxmlformats.org/drawingml/2006/main" xmlns:r="http://schemas.openxmlformats.org/officeDocument/2006/relationships" xmlns:p="http://schemas.openxmlformats.org/presentationml/2006/main">
-  <p:cSld>
-    <p:spTree>
-      <p:nvGrpSpPr>
-        <p:cNvPr id="1" name=""/>
-        <p:cNvGrpSpPr/>
-        <p:nvPr/>
-      </p:nvGrpSpPr>
-      <p:grpSpPr>
-        <a:xfrm>
-          <a:off x="0" y="0"/>
-          <a:ext cx="0" cy="0"/>
-          <a:chOff x="0" y="0"/>
-          <a:chExt cx="0" cy="0"/>
-        </a:xfrm>
-      </p:grpSpPr>
-      <p:sp>
-        <p:nvSpPr>
-          <p:cNvPr id="2" name="Title 1">
-            <a:extLst>
-              <a:ext uri="{FF2B5EF4-FFF2-40B4-BE49-F238E27FC236}">
                 <a16:creationId xmlns:a16="http://schemas.microsoft.com/office/drawing/2014/main" id="{A798245F-DD26-ADCC-6CD2-D5ED5F5598A9}"/>
               </a:ext>
             </a:extLst>
@@ -11990,33 +11863,39 @@
             <p:ph type="title"/>
           </p:nvPr>
         </p:nvSpPr>
-        <p:spPr/>
+        <p:spPr>
+          <a:xfrm>
+            <a:off x="317385" y="117700"/>
+            <a:ext cx="3022899" cy="1689586"/>
+          </a:xfrm>
+        </p:spPr>
         <p:txBody>
-          <a:bodyPr/>
+          <a:bodyPr>
+            <a:normAutofit/>
+          </a:bodyPr>
           <a:lstStyle/>
           <a:p>
-            <a:r>
-              <a:rPr lang="en-US" dirty="0"/>
-              <a:t>A simple Configuration Model</a:t>
+            <a:pPr algn="r"/>
+            <a:r>
+              <a:rPr lang="en-US" sz="4000" dirty="0"/>
+              <a:t>Configuration Model</a:t>
             </a:r>
           </a:p>
         </p:txBody>
       </p:sp>
       <p:pic>
         <p:nvPicPr>
-          <p:cNvPr id="9" name="Content Placeholder 8" descr="Class diagram.">
+          <p:cNvPr id="6" name="Picture 5" descr="A screenshot of a computer&#10;&#10;Description automatically generated with medium confidence">
             <a:extLst>
               <a:ext uri="{FF2B5EF4-FFF2-40B4-BE49-F238E27FC236}">
-                <a16:creationId xmlns:a16="http://schemas.microsoft.com/office/drawing/2014/main" id="{EB82A400-7337-4C1F-868E-D34B84F5DF2F}"/>
+                <a16:creationId xmlns:a16="http://schemas.microsoft.com/office/drawing/2014/main" id="{64CAB341-0F45-EBF0-5542-74F695DF9CEF}"/>
               </a:ext>
             </a:extLst>
           </p:cNvPr>
           <p:cNvPicPr>
-            <a:picLocks noGrp="1" noChangeAspect="1"/>
+            <a:picLocks noChangeAspect="1"/>
           </p:cNvPicPr>
-          <p:nvPr>
-            <p:ph idx="1"/>
-          </p:nvPr>
+          <p:nvPr/>
         </p:nvPicPr>
         <p:blipFill>
           <a:blip r:embed="rId2">
@@ -12032,9 +11911,12 @@
         </p:blipFill>
         <p:spPr>
           <a:xfrm>
-            <a:off x="292025" y="1585180"/>
-            <a:ext cx="11794531" cy="4802187"/>
+            <a:off x="3340284" y="193508"/>
+            <a:ext cx="8655296" cy="6664492"/>
           </a:xfrm>
+          <a:prstGeom prst="rect">
+            <a:avLst/>
+          </a:prstGeom>
         </p:spPr>
       </p:pic>
     </p:spTree>
@@ -12050,7 +11932,7 @@
 </p:sld>
 </file>
 
-<file path=ppt/slides/slide22.xml><?xml version="1.0" encoding="utf-8"?>
+<file path=ppt/slides/slide21.xml><?xml version="1.0" encoding="utf-8"?>
 <p:sld xmlns:a="http://schemas.openxmlformats.org/drawingml/2006/main" xmlns:r="http://schemas.openxmlformats.org/officeDocument/2006/relationships" xmlns:p="http://schemas.openxmlformats.org/presentationml/2006/main">
   <p:cSld>
     <p:spTree>
@@ -12089,10 +11971,17 @@
           <a:lstStyle/>
           <a:p>
             <a:r>
-              <a:rPr lang="en-US"/>
-              <a:t>Exploit the .Net Configuration model</a:t>
-            </a:r>
-            <a:endParaRPr lang="en-US" dirty="0"/>
+              <a:rPr lang="en-US" dirty="0"/>
+              <a:t>Exploit the </a:t>
+            </a:r>
+            <a:r>
+              <a:rPr lang="en-US" dirty="0" err="1"/>
+              <a:t>.Net</a:t>
+            </a:r>
+            <a:r>
+              <a:rPr lang="en-US" dirty="0"/>
+              <a:t> Configuration API</a:t>
+            </a:r>
           </a:p>
         </p:txBody>
       </p:sp>
@@ -12712,7 +12601,7 @@
 </p:sld>
 </file>
 
-<file path=ppt/slides/slide23.xml><?xml version="1.0" encoding="utf-8"?>
+<file path=ppt/slides/slide22.xml><?xml version="1.0" encoding="utf-8"?>
 <p:sld xmlns:a="http://schemas.openxmlformats.org/drawingml/2006/main" xmlns:r="http://schemas.openxmlformats.org/officeDocument/2006/relationships" xmlns:p="http://schemas.openxmlformats.org/presentationml/2006/main">
   <p:cSld>
     <p:spTree>
@@ -12758,41 +12647,6 @@
           </a:p>
         </p:txBody>
       </p:sp>
-      <p:pic>
-        <p:nvPicPr>
-          <p:cNvPr id="10" name="Content Placeholder 9" descr="Diagram&#10;&#10;Description automatically generated">
-            <a:extLst>
-              <a:ext uri="{FF2B5EF4-FFF2-40B4-BE49-F238E27FC236}">
-                <a16:creationId xmlns:a16="http://schemas.microsoft.com/office/drawing/2014/main" id="{C7A97C5F-BEC2-106C-7C1F-260735E04677}"/>
-              </a:ext>
-            </a:extLst>
-          </p:cNvPr>
-          <p:cNvPicPr>
-            <a:picLocks noGrp="1" noChangeAspect="1"/>
-          </p:cNvPicPr>
-          <p:nvPr>
-            <p:ph idx="1"/>
-          </p:nvPr>
-        </p:nvPicPr>
-        <p:blipFill>
-          <a:blip r:embed="rId3">
-            <a:extLst>
-              <a:ext uri="{28A0092B-C50C-407E-A947-70E740481C1C}">
-                <a14:useLocalDpi xmlns:a14="http://schemas.microsoft.com/office/drawing/2010/main" val="0"/>
-              </a:ext>
-            </a:extLst>
-          </a:blip>
-          <a:stretch>
-            <a:fillRect/>
-          </a:stretch>
-        </p:blipFill>
-        <p:spPr>
-          <a:xfrm>
-            <a:off x="6845938" y="269631"/>
-            <a:ext cx="4963777" cy="6223244"/>
-          </a:xfrm>
-        </p:spPr>
-      </p:pic>
       <p:sp>
         <p:nvSpPr>
           <p:cNvPr id="11" name="Content Placeholder 2">
@@ -12818,7 +12672,7 @@
         </p:spPr>
         <p:txBody>
           <a:bodyPr vert="horz" lIns="91440" tIns="45720" rIns="91440" bIns="45720" rtlCol="0">
-            <a:normAutofit lnSpcReduction="10000"/>
+            <a:normAutofit/>
           </a:bodyPr>
           <a:lstStyle>
             <a:lvl1pPr marL="228600" indent="-228600" algn="l" defTabSz="914400" rtl="0" eaLnBrk="1" latinLnBrk="0" hangingPunct="1">
@@ -12994,7 +12848,7 @@
                 <a:latin typeface="Consolas" panose="020B0609020204030204" pitchFamily="49" charset="0"/>
                 <a:cs typeface="Courier New" panose="02070309020205020404" pitchFamily="49" charset="0"/>
               </a:rPr>
-              <a:t>ApplicationIdentityService</a:t>
+              <a:t>IApplicationIdentityService</a:t>
             </a:r>
             <a:r>
               <a:rPr lang="en-US" dirty="0"/>
@@ -13004,71 +12858,20 @@
           <a:p>
             <a:r>
               <a:rPr lang="en-US" dirty="0"/>
-              <a:t>A Remote can define a Domain.</a:t>
-            </a:r>
-          </a:p>
-          <a:p>
-            <a:r>
-              <a:rPr lang="en-US" dirty="0"/>
-              <a:t>New Remotes can be added dynamically (</a:t>
+              <a:t>Thread safety</a:t>
+            </a:r>
+          </a:p>
+          <a:p>
+            <a:pPr lvl="1"/>
+            <a:r>
+              <a:rPr lang="en-US" dirty="0"/>
+              <a:t>Once </a:t>
             </a:r>
             <a:r>
               <a:rPr lang="en-US" sz="2000" dirty="0" err="1">
                 <a:latin typeface="Consolas" panose="020B0609020204030204" pitchFamily="49" charset="0"/>
                 <a:cs typeface="Courier New" panose="02070309020205020404" pitchFamily="49" charset="0"/>
               </a:rPr>
-              <a:t>AddDynamicRemoteAsync</a:t>
-            </a:r>
-            <a:r>
-              <a:rPr lang="en-US" dirty="0"/>
-              <a:t>).</a:t>
-            </a:r>
-          </a:p>
-          <a:p>
-            <a:r>
-              <a:rPr lang="en-US" dirty="0"/>
-              <a:t>Only dynamic Remotes can be destroyed (</a:t>
-            </a:r>
-            <a:r>
-              <a:rPr lang="en-US" sz="2000" dirty="0" err="1">
-                <a:latin typeface="Consolas" panose="020B0609020204030204" pitchFamily="49" charset="0"/>
-                <a:cs typeface="Courier New" panose="02070309020205020404" pitchFamily="49" charset="0"/>
-              </a:rPr>
-              <a:t>SetDestroyed</a:t>
-            </a:r>
-            <a:r>
-              <a:rPr lang="en-US" dirty="0"/>
-              <a:t> or </a:t>
-            </a:r>
-            <a:r>
-              <a:rPr lang="en-US" sz="2000" dirty="0" err="1">
-                <a:latin typeface="Consolas" panose="020B0609020204030204" pitchFamily="49" charset="0"/>
-                <a:cs typeface="Courier New" panose="02070309020205020404" pitchFamily="49" charset="0"/>
-              </a:rPr>
-              <a:t>DestroyAsync</a:t>
-            </a:r>
-            <a:r>
-              <a:rPr lang="en-US" dirty="0"/>
-              <a:t>).</a:t>
-            </a:r>
-          </a:p>
-          <a:p>
-            <a:r>
-              <a:rPr lang="en-US" dirty="0"/>
-              <a:t>Thread safety</a:t>
-            </a:r>
-          </a:p>
-          <a:p>
-            <a:pPr lvl="1"/>
-            <a:r>
-              <a:rPr lang="en-US" dirty="0"/>
-              <a:t>Once </a:t>
-            </a:r>
-            <a:r>
-              <a:rPr lang="en-US" sz="2000" dirty="0" err="1">
-                <a:latin typeface="Consolas" panose="020B0609020204030204" pitchFamily="49" charset="0"/>
-                <a:cs typeface="Courier New" panose="02070309020205020404" pitchFamily="49" charset="0"/>
-              </a:rPr>
               <a:t>InitializationTask</a:t>
             </a:r>
             <a:r>
@@ -13093,6 +12896,42 @@
           </a:p>
         </p:txBody>
       </p:sp>
+      <p:pic>
+        <p:nvPicPr>
+          <p:cNvPr id="6" name="Picture 5" descr="A screenshot of a computer&#10;&#10;Description automatically generated with medium confidence">
+            <a:extLst>
+              <a:ext uri="{FF2B5EF4-FFF2-40B4-BE49-F238E27FC236}">
+                <a16:creationId xmlns:a16="http://schemas.microsoft.com/office/drawing/2014/main" id="{7C3DD65C-4947-6B81-85B3-712677F2FF91}"/>
+              </a:ext>
+            </a:extLst>
+          </p:cNvPr>
+          <p:cNvPicPr>
+            <a:picLocks noChangeAspect="1"/>
+          </p:cNvPicPr>
+          <p:nvPr/>
+        </p:nvPicPr>
+        <p:blipFill>
+          <a:blip r:embed="rId3">
+            <a:extLst>
+              <a:ext uri="{28A0092B-C50C-407E-A947-70E740481C1C}">
+                <a14:useLocalDpi xmlns:a14="http://schemas.microsoft.com/office/drawing/2010/main" val="0"/>
+              </a:ext>
+            </a:extLst>
+          </a:blip>
+          <a:stretch>
+            <a:fillRect/>
+          </a:stretch>
+        </p:blipFill>
+        <p:spPr>
+          <a:xfrm>
+            <a:off x="7287803" y="0"/>
+            <a:ext cx="4372195" cy="6858000"/>
+          </a:xfrm>
+          <a:prstGeom prst="rect">
+            <a:avLst/>
+          </a:prstGeom>
+        </p:spPr>
+      </p:pic>
     </p:spTree>
     <p:extLst>
       <p:ext uri="{BB962C8B-B14F-4D97-AF65-F5344CB8AC3E}">
@@ -13106,7 +12945,7 @@
 </p:sld>
 </file>
 
-<file path=ppt/slides/slide24.xml><?xml version="1.0" encoding="utf-8"?>
+<file path=ppt/slides/slide23.xml><?xml version="1.0" encoding="utf-8"?>
 <p:sld xmlns:a="http://schemas.openxmlformats.org/drawingml/2006/main" xmlns:r="http://schemas.openxmlformats.org/officeDocument/2006/relationships" xmlns:p="http://schemas.openxmlformats.org/presentationml/2006/main">
   <p:cSld>
     <p:spTree>
@@ -13170,7 +13009,7 @@
         <p:spPr/>
         <p:txBody>
           <a:bodyPr>
-            <a:normAutofit fontScale="92500" lnSpcReduction="10000"/>
+            <a:normAutofit/>
           </a:bodyPr>
           <a:lstStyle/>
           <a:p>
@@ -13222,58 +13061,13 @@
             </a:r>
             <a:r>
               <a:rPr lang="en-US" dirty="0"/>
-              <a:t> available on:</a:t>
-            </a:r>
-          </a:p>
-          <a:p>
-            <a:pPr lvl="1"/>
-            <a:r>
-              <a:rPr lang="en-US" dirty="0"/>
-              <a:t>The root </a:t>
-            </a:r>
-            <a:r>
-              <a:rPr lang="en-US" sz="2000" dirty="0" err="1">
-                <a:latin typeface="Consolas" panose="020B0609020204030204" pitchFamily="49" charset="0"/>
-                <a:cs typeface="Courier New" panose="02070309020205020404" pitchFamily="49" charset="0"/>
-              </a:rPr>
-              <a:t>ApplicationIdentityService</a:t>
-            </a:r>
-            <a:endParaRPr lang="en-US" sz="2000" dirty="0">
-              <a:latin typeface="Consolas" panose="020B0609020204030204" pitchFamily="49" charset="0"/>
-              <a:cs typeface="Courier New" panose="02070309020205020404" pitchFamily="49" charset="0"/>
-            </a:endParaRPr>
-          </a:p>
-          <a:p>
-            <a:pPr lvl="1"/>
-            <a:r>
-              <a:rPr lang="en-US" dirty="0"/>
-              <a:t>Local and Remote parties (but not on the </a:t>
-            </a:r>
-            <a:r>
-              <a:rPr lang="en-US" sz="2000" dirty="0" err="1">
-                <a:latin typeface="Consolas" panose="020B0609020204030204" pitchFamily="49" charset="0"/>
-                <a:cs typeface="Courier New" panose="02070309020205020404" pitchFamily="49" charset="0"/>
-              </a:rPr>
-              <a:t>DomainApplicationIdentity</a:t>
-            </a:r>
-            <a:r>
-              <a:rPr lang="en-US" dirty="0"/>
-              <a:t>).</a:t>
-            </a:r>
-            <a:br>
-              <a:rPr lang="en-US" sz="1600" dirty="0">
-                <a:solidFill>
-                  <a:srgbClr val="000000"/>
-                </a:solidFill>
-                <a:latin typeface="Consolas" panose="020B0609020204030204" pitchFamily="49" charset="0"/>
-              </a:rPr>
-            </a:br>
-            <a:endParaRPr lang="en-US" dirty="0"/>
-          </a:p>
-          <a:p>
-            <a:r>
-              <a:rPr lang="en-US" dirty="0"/>
-              <a:t>One can only add a Feature “from the outside”:</a:t>
+              <a:t> available on all parties.</a:t>
+            </a:r>
+          </a:p>
+          <a:p>
+            <a:r>
+              <a:rPr lang="en-US" dirty="0"/>
+              <a:t>Features can only be added:</a:t>
             </a:r>
           </a:p>
           <a:p>
@@ -13389,7 +13183,7 @@
 </p:sld>
 </file>
 
-<file path=ppt/slides/slide25.xml><?xml version="1.0" encoding="utf-8"?>
+<file path=ppt/slides/slide24.xml><?xml version="1.0" encoding="utf-8"?>
 <p:sld xmlns:a="http://schemas.openxmlformats.org/drawingml/2006/main" xmlns:r="http://schemas.openxmlformats.org/officeDocument/2006/relationships" xmlns:p="http://schemas.openxmlformats.org/presentationml/2006/main">
   <p:cSld>
     <p:spTree>
@@ -13434,41 +13228,6 @@
           </a:p>
         </p:txBody>
       </p:sp>
-      <p:pic>
-        <p:nvPicPr>
-          <p:cNvPr id="9" name="Content Placeholder 8" descr="Graphical user interface, text">
-            <a:extLst>
-              <a:ext uri="{FF2B5EF4-FFF2-40B4-BE49-F238E27FC236}">
-                <a16:creationId xmlns:a16="http://schemas.microsoft.com/office/drawing/2014/main" id="{3CFA42ED-F5B9-C118-B2B2-15CE4E6B30CF}"/>
-              </a:ext>
-            </a:extLst>
-          </p:cNvPr>
-          <p:cNvPicPr>
-            <a:picLocks noGrp="1" noChangeAspect="1"/>
-          </p:cNvPicPr>
-          <p:nvPr>
-            <p:ph idx="1"/>
-          </p:nvPr>
-        </p:nvPicPr>
-        <p:blipFill>
-          <a:blip r:embed="rId2">
-            <a:extLst>
-              <a:ext uri="{28A0092B-C50C-407E-A947-70E740481C1C}">
-                <a14:useLocalDpi xmlns:a14="http://schemas.microsoft.com/office/drawing/2010/main" val="0"/>
-              </a:ext>
-            </a:extLst>
-          </a:blip>
-          <a:stretch>
-            <a:fillRect/>
-          </a:stretch>
-        </p:blipFill>
-        <p:spPr>
-          <a:xfrm>
-            <a:off x="4620973" y="156674"/>
-            <a:ext cx="7399243" cy="6544652"/>
-          </a:xfrm>
-        </p:spPr>
-      </p:pic>
       <p:sp>
         <p:nvSpPr>
           <p:cNvPr id="10" name="Content Placeholder 2">
@@ -13710,6 +13469,42 @@
           </a:p>
         </p:txBody>
       </p:sp>
+      <p:pic>
+        <p:nvPicPr>
+          <p:cNvPr id="6" name="Picture 5" descr="A screenshot of a computer&#10;&#10;Description automatically generated">
+            <a:extLst>
+              <a:ext uri="{FF2B5EF4-FFF2-40B4-BE49-F238E27FC236}">
+                <a16:creationId xmlns:a16="http://schemas.microsoft.com/office/drawing/2014/main" id="{8B97A891-FB41-8020-AA4F-F29FF2B4EC67}"/>
+              </a:ext>
+            </a:extLst>
+          </p:cNvPr>
+          <p:cNvPicPr>
+            <a:picLocks noChangeAspect="1"/>
+          </p:cNvPicPr>
+          <p:nvPr/>
+        </p:nvPicPr>
+        <p:blipFill>
+          <a:blip r:embed="rId2">
+            <a:extLst>
+              <a:ext uri="{28A0092B-C50C-407E-A947-70E740481C1C}">
+                <a14:useLocalDpi xmlns:a14="http://schemas.microsoft.com/office/drawing/2010/main" val="0"/>
+              </a:ext>
+            </a:extLst>
+          </a:blip>
+          <a:stretch>
+            <a:fillRect/>
+          </a:stretch>
+        </p:blipFill>
+        <p:spPr>
+          <a:xfrm>
+            <a:off x="4608528" y="249293"/>
+            <a:ext cx="7337819" cy="6243582"/>
+          </a:xfrm>
+          <a:prstGeom prst="rect">
+            <a:avLst/>
+          </a:prstGeom>
+        </p:spPr>
+      </p:pic>
     </p:spTree>
     <p:extLst>
       <p:ext uri="{BB962C8B-B14F-4D97-AF65-F5344CB8AC3E}">
@@ -13723,7 +13518,7 @@
 </p:sld>
 </file>
 
-<file path=ppt/slides/slide26.xml><?xml version="1.0" encoding="utf-8"?>
+<file path=ppt/slides/slide25.xml><?xml version="1.0" encoding="utf-8"?>
 <p:sld xmlns:a="http://schemas.openxmlformats.org/drawingml/2006/main" xmlns:r="http://schemas.openxmlformats.org/officeDocument/2006/relationships" xmlns:p="http://schemas.openxmlformats.org/presentationml/2006/main">
   <p:cSld>
     <p:spTree>
@@ -14057,7 +13852,7 @@
         </p:spPr>
         <p:txBody>
           <a:bodyPr vert="horz" lIns="91440" tIns="45720" rIns="91440" bIns="45720" rtlCol="0">
-            <a:normAutofit lnSpcReduction="10000"/>
+            <a:normAutofit/>
           </a:bodyPr>
           <a:lstStyle>
             <a:lvl1pPr marL="228600" indent="-228600" algn="l" defTabSz="914400" rtl="0" eaLnBrk="1" latinLnBrk="0" hangingPunct="1">
@@ -14265,14 +14060,62 @@
                 <a:latin typeface="Courier New" panose="02070309020205020404" pitchFamily="49" charset="0"/>
                 <a:cs typeface="Courier New" panose="02070309020205020404" pitchFamily="49" charset="0"/>
               </a:rPr>
-              <a:t>DomainName</a:t>
-            </a:r>
-            <a:r>
-              <a:rPr lang="en-US" sz="1400" dirty="0">
-                <a:latin typeface="Courier New" panose="02070309020205020404" pitchFamily="49" charset="0"/>
-                <a:cs typeface="Courier New" panose="02070309020205020404" pitchFamily="49" charset="0"/>
-              </a:rPr>
-              <a:t>": "Test",</a:t>
+              <a:t>FullName</a:t>
+            </a:r>
+            <a:r>
+              <a:rPr lang="en-US" sz="1400" dirty="0">
+                <a:latin typeface="Courier New" panose="02070309020205020404" pitchFamily="49" charset="0"/>
+                <a:cs typeface="Courier New" panose="02070309020205020404" pitchFamily="49" charset="0"/>
+              </a:rPr>
+              <a:t>": "Test/$Sender",</a:t>
+            </a:r>
+            <a:br>
+              <a:rPr lang="en-US" sz="1400" dirty="0">
+                <a:latin typeface="Courier New" panose="02070309020205020404" pitchFamily="49" charset="0"/>
+                <a:cs typeface="Courier New" panose="02070309020205020404" pitchFamily="49" charset="0"/>
+              </a:rPr>
+            </a:br>
+            <a:r>
+              <a:rPr lang="en-US" sz="1400" dirty="0">
+                <a:latin typeface="Courier New" panose="02070309020205020404" pitchFamily="49" charset="0"/>
+                <a:cs typeface="Courier New" panose="02070309020205020404" pitchFamily="49" charset="0"/>
+              </a:rPr>
+              <a:t>  </a:t>
+            </a:r>
+            <a:r>
+              <a:rPr lang="en-US" sz="1400" b="1" dirty="0">
+                <a:latin typeface="Courier New" panose="02070309020205020404" pitchFamily="49" charset="0"/>
+                <a:cs typeface="Courier New" panose="02070309020205020404" pitchFamily="49" charset="0"/>
+              </a:rPr>
+              <a:t>"</a:t>
+            </a:r>
+            <a:r>
+              <a:rPr lang="en-US" sz="1400" b="1" dirty="0" err="1">
+                <a:latin typeface="Courier New" panose="02070309020205020404" pitchFamily="49" charset="0"/>
+                <a:cs typeface="Courier New" panose="02070309020205020404" pitchFamily="49" charset="0"/>
+              </a:rPr>
+              <a:t>AllowFeatures</a:t>
+            </a:r>
+            <a:r>
+              <a:rPr lang="en-US" sz="1400" b="1" dirty="0">
+                <a:latin typeface="Courier New" panose="02070309020205020404" pitchFamily="49" charset="0"/>
+                <a:cs typeface="Courier New" panose="02070309020205020404" pitchFamily="49" charset="0"/>
+              </a:rPr>
+              <a:t>": "</a:t>
+            </a:r>
+            <a:r>
+              <a:rPr lang="en-US" sz="1400" b="1" dirty="0" err="1">
+                <a:latin typeface="Courier New" panose="02070309020205020404" pitchFamily="49" charset="0"/>
+                <a:cs typeface="Courier New" panose="02070309020205020404" pitchFamily="49" charset="0"/>
+              </a:rPr>
+              <a:t>BlobChannel</a:t>
+            </a:r>
+            <a:r>
+              <a:rPr lang="en-US" sz="1400" b="1" dirty="0">
+                <a:latin typeface="Courier New" panose="02070309020205020404" pitchFamily="49" charset="0"/>
+                <a:cs typeface="Courier New" panose="02070309020205020404" pitchFamily="49" charset="0"/>
+              </a:rPr>
+              <a:t>"</a:t>
             </a:r>
           </a:p>
           <a:p>
@@ -14291,7 +14134,7 @@
                 <a:latin typeface="Courier New" panose="02070309020205020404" pitchFamily="49" charset="0"/>
                 <a:cs typeface="Courier New" panose="02070309020205020404" pitchFamily="49" charset="0"/>
               </a:rPr>
-              <a:t>  "Local": { "Name": "Sender" },</a:t>
+              <a:t>  "Parties": [</a:t>
             </a:r>
             <a:br>
               <a:rPr lang="en-US" sz="1400" dirty="0">
@@ -14304,42 +14147,7 @@
                 <a:latin typeface="Courier New" panose="02070309020205020404" pitchFamily="49" charset="0"/>
                 <a:cs typeface="Courier New" panose="02070309020205020404" pitchFamily="49" charset="0"/>
               </a:rPr>
-              <a:t>  </a:t>
-            </a:r>
-            <a:r>
-              <a:rPr lang="en-US" sz="1400" b="1" dirty="0">
-                <a:latin typeface="Courier New" panose="02070309020205020404" pitchFamily="49" charset="0"/>
-                <a:cs typeface="Courier New" panose="02070309020205020404" pitchFamily="49" charset="0"/>
-              </a:rPr>
-              <a:t>"</a:t>
-            </a:r>
-            <a:r>
-              <a:rPr lang="en-US" sz="1400" b="1" dirty="0" err="1">
-                <a:latin typeface="Courier New" panose="02070309020205020404" pitchFamily="49" charset="0"/>
-                <a:cs typeface="Courier New" panose="02070309020205020404" pitchFamily="49" charset="0"/>
-              </a:rPr>
-              <a:t>AllowFeatures</a:t>
-            </a:r>
-            <a:r>
-              <a:rPr lang="en-US" sz="1400" b="1" dirty="0">
-                <a:latin typeface="Courier New" panose="02070309020205020404" pitchFamily="49" charset="0"/>
-                <a:cs typeface="Courier New" panose="02070309020205020404" pitchFamily="49" charset="0"/>
-              </a:rPr>
-              <a:t>": "</a:t>
-            </a:r>
-            <a:r>
-              <a:rPr lang="en-US" sz="1400" b="1" dirty="0" err="1">
-                <a:latin typeface="Courier New" panose="02070309020205020404" pitchFamily="49" charset="0"/>
-                <a:cs typeface="Courier New" panose="02070309020205020404" pitchFamily="49" charset="0"/>
-              </a:rPr>
-              <a:t>BlobChannel</a:t>
-            </a:r>
-            <a:r>
-              <a:rPr lang="en-US" sz="1400" b="1" dirty="0">
-                <a:latin typeface="Courier New" panose="02070309020205020404" pitchFamily="49" charset="0"/>
-                <a:cs typeface="Courier New" panose="02070309020205020404" pitchFamily="49" charset="0"/>
-              </a:rPr>
-              <a:t>"</a:t>
+              <a:t>  {</a:t>
             </a:r>
           </a:p>
           <a:p>
@@ -14358,39 +14166,21 @@
                 <a:latin typeface="Courier New" panose="02070309020205020404" pitchFamily="49" charset="0"/>
                 <a:cs typeface="Courier New" panose="02070309020205020404" pitchFamily="49" charset="0"/>
               </a:rPr>
-              <a:t>  "Remotes": [</a:t>
-            </a:r>
-            <a:br>
-              <a:rPr lang="en-US" sz="1400" dirty="0">
-                <a:latin typeface="Courier New" panose="02070309020205020404" pitchFamily="49" charset="0"/>
-                <a:cs typeface="Courier New" panose="02070309020205020404" pitchFamily="49" charset="0"/>
-              </a:rPr>
-            </a:br>
-            <a:r>
-              <a:rPr lang="en-US" sz="1400" dirty="0">
-                <a:latin typeface="Courier New" panose="02070309020205020404" pitchFamily="49" charset="0"/>
-                <a:cs typeface="Courier New" panose="02070309020205020404" pitchFamily="49" charset="0"/>
-              </a:rPr>
-              <a:t>  {</a:t>
-            </a:r>
-          </a:p>
-          <a:p>
-            <a:pPr marL="0" indent="0">
-              <a:lnSpc>
-                <a:spcPct val="100000"/>
-              </a:lnSpc>
-              <a:spcBef>
-                <a:spcPts val="0"/>
-              </a:spcBef>
-              <a:buFont typeface="Arial" panose="020B0604020202020204" pitchFamily="34" charset="0"/>
-              <a:buNone/>
-            </a:pPr>
-            <a:r>
-              <a:rPr lang="en-US" sz="1400" dirty="0">
-                <a:latin typeface="Courier New" panose="02070309020205020404" pitchFamily="49" charset="0"/>
-                <a:cs typeface="Courier New" panose="02070309020205020404" pitchFamily="49" charset="0"/>
-              </a:rPr>
-              <a:t>    "Name": "Target",</a:t>
+              <a:t>    "</a:t>
+            </a:r>
+            <a:r>
+              <a:rPr lang="en-US" sz="1400" dirty="0" err="1">
+                <a:latin typeface="Courier New" panose="02070309020205020404" pitchFamily="49" charset="0"/>
+                <a:cs typeface="Courier New" panose="02070309020205020404" pitchFamily="49" charset="0"/>
+              </a:rPr>
+              <a:t>PartyName</a:t>
+            </a:r>
+            <a:r>
+              <a:rPr lang="en-US" sz="1400" dirty="0">
+                <a:latin typeface="Courier New" panose="02070309020205020404" pitchFamily="49" charset="0"/>
+                <a:cs typeface="Courier New" panose="02070309020205020404" pitchFamily="49" charset="0"/>
+              </a:rPr>
+              <a:t>": "Target",</a:t>
             </a:r>
             <a:br>
               <a:rPr lang="en-US" sz="1400" dirty="0">
@@ -14689,14 +14479,40 @@
                 <a:latin typeface="Courier New" panose="02070309020205020404" pitchFamily="49" charset="0"/>
                 <a:cs typeface="Courier New" panose="02070309020205020404" pitchFamily="49" charset="0"/>
               </a:rPr>
-              <a:t>DomainName</a:t>
-            </a:r>
-            <a:r>
-              <a:rPr lang="en-US" sz="1400" dirty="0">
-                <a:latin typeface="Courier New" panose="02070309020205020404" pitchFamily="49" charset="0"/>
-                <a:cs typeface="Courier New" panose="02070309020205020404" pitchFamily="49" charset="0"/>
-              </a:rPr>
-              <a:t>": "Test",</a:t>
+              <a:t>FullName</a:t>
+            </a:r>
+            <a:r>
+              <a:rPr lang="en-US" sz="1400" dirty="0">
+                <a:latin typeface="Courier New" panose="02070309020205020404" pitchFamily="49" charset="0"/>
+                <a:cs typeface="Courier New" panose="02070309020205020404" pitchFamily="49" charset="0"/>
+              </a:rPr>
+              <a:t>": "Test/$Target" },</a:t>
+            </a:r>
+            <a:br>
+              <a:rPr lang="en-US" sz="1400" dirty="0">
+                <a:latin typeface="Courier New" panose="02070309020205020404" pitchFamily="49" charset="0"/>
+                <a:cs typeface="Courier New" panose="02070309020205020404" pitchFamily="49" charset="0"/>
+              </a:rPr>
+            </a:br>
+            <a:r>
+              <a:rPr lang="en-US" sz="1400" dirty="0">
+                <a:latin typeface="Courier New" panose="02070309020205020404" pitchFamily="49" charset="0"/>
+                <a:cs typeface="Courier New" panose="02070309020205020404" pitchFamily="49" charset="0"/>
+              </a:rPr>
+              <a:t>  "Parties": [</a:t>
+            </a:r>
+            <a:br>
+              <a:rPr lang="en-US" sz="1400" dirty="0">
+                <a:latin typeface="Courier New" panose="02070309020205020404" pitchFamily="49" charset="0"/>
+                <a:cs typeface="Courier New" panose="02070309020205020404" pitchFamily="49" charset="0"/>
+              </a:rPr>
+            </a:br>
+            <a:r>
+              <a:rPr lang="en-US" sz="1400" dirty="0">
+                <a:latin typeface="Courier New" panose="02070309020205020404" pitchFamily="49" charset="0"/>
+                <a:cs typeface="Courier New" panose="02070309020205020404" pitchFamily="49" charset="0"/>
+              </a:rPr>
+              <a:t>  {</a:t>
             </a:r>
           </a:p>
           <a:p>
@@ -14715,52 +14531,21 @@
                 <a:latin typeface="Courier New" panose="02070309020205020404" pitchFamily="49" charset="0"/>
                 <a:cs typeface="Courier New" panose="02070309020205020404" pitchFamily="49" charset="0"/>
               </a:rPr>
-              <a:t>  "Local": { "Name": “Target" },</a:t>
-            </a:r>
-            <a:br>
-              <a:rPr lang="en-US" sz="1400" dirty="0">
-                <a:latin typeface="Courier New" panose="02070309020205020404" pitchFamily="49" charset="0"/>
-                <a:cs typeface="Courier New" panose="02070309020205020404" pitchFamily="49" charset="0"/>
-              </a:rPr>
-            </a:br>
-            <a:r>
-              <a:rPr lang="en-US" sz="1400" dirty="0">
-                <a:latin typeface="Courier New" panose="02070309020205020404" pitchFamily="49" charset="0"/>
-                <a:cs typeface="Courier New" panose="02070309020205020404" pitchFamily="49" charset="0"/>
-              </a:rPr>
-              <a:t>  "Remotes": [</a:t>
-            </a:r>
-            <a:br>
-              <a:rPr lang="en-US" sz="1400" dirty="0">
-                <a:latin typeface="Courier New" panose="02070309020205020404" pitchFamily="49" charset="0"/>
-                <a:cs typeface="Courier New" panose="02070309020205020404" pitchFamily="49" charset="0"/>
-              </a:rPr>
-            </a:br>
-            <a:r>
-              <a:rPr lang="en-US" sz="1400" dirty="0">
-                <a:latin typeface="Courier New" panose="02070309020205020404" pitchFamily="49" charset="0"/>
-                <a:cs typeface="Courier New" panose="02070309020205020404" pitchFamily="49" charset="0"/>
-              </a:rPr>
-              <a:t>  {</a:t>
-            </a:r>
-          </a:p>
-          <a:p>
-            <a:pPr marL="0" indent="0">
-              <a:lnSpc>
-                <a:spcPct val="100000"/>
-              </a:lnSpc>
-              <a:spcBef>
-                <a:spcPts val="0"/>
-              </a:spcBef>
-              <a:buFont typeface="Arial" panose="020B0604020202020204" pitchFamily="34" charset="0"/>
-              <a:buNone/>
-            </a:pPr>
-            <a:r>
-              <a:rPr lang="en-US" sz="1400" dirty="0">
-                <a:latin typeface="Courier New" panose="02070309020205020404" pitchFamily="49" charset="0"/>
-                <a:cs typeface="Courier New" panose="02070309020205020404" pitchFamily="49" charset="0"/>
-              </a:rPr>
-              <a:t>    "Name": "Sender",</a:t>
+              <a:t>    "</a:t>
+            </a:r>
+            <a:r>
+              <a:rPr lang="en-US" sz="1400" dirty="0" err="1">
+                <a:latin typeface="Courier New" panose="02070309020205020404" pitchFamily="49" charset="0"/>
+                <a:cs typeface="Courier New" panose="02070309020205020404" pitchFamily="49" charset="0"/>
+              </a:rPr>
+              <a:t>PartyName</a:t>
+            </a:r>
+            <a:r>
+              <a:rPr lang="en-US" sz="1400" dirty="0">
+                <a:latin typeface="Courier New" panose="02070309020205020404" pitchFamily="49" charset="0"/>
+                <a:cs typeface="Courier New" panose="02070309020205020404" pitchFamily="49" charset="0"/>
+              </a:rPr>
+              <a:t>": "Sender",</a:t>
             </a:r>
             <a:br>
               <a:rPr lang="en-US" sz="1400" dirty="0">
@@ -14925,7 +14710,7 @@
 </p:sld>
 </file>
 
-<file path=ppt/slides/slide27.xml><?xml version="1.0" encoding="utf-8"?>
+<file path=ppt/slides/slide26.xml><?xml version="1.0" encoding="utf-8"?>
 <p:sld xmlns:a="http://schemas.openxmlformats.org/drawingml/2006/main" xmlns:r="http://schemas.openxmlformats.org/officeDocument/2006/relationships" xmlns:p="http://schemas.openxmlformats.org/presentationml/2006/main">
   <p:cSld>
     <p:spTree>
@@ -15005,7 +14790,7 @@
           <a:p>
             <a:r>
               <a:rPr lang="en-US" dirty="0"/>
-              <a:t>Opt-out feature: available by default on all Remotes that are not in the domain “Undefined”</a:t>
+              <a:t>Opt-out feature: available by default on all Remotes (not External)</a:t>
             </a:r>
           </a:p>
           <a:p>
@@ -15219,6 +15004,338 @@
 </p:sld>
 </file>
 
+<file path=ppt/slides/slide27.xml><?xml version="1.0" encoding="utf-8"?>
+<p:sld xmlns:a="http://schemas.openxmlformats.org/drawingml/2006/main" xmlns:r="http://schemas.openxmlformats.org/officeDocument/2006/relationships" xmlns:p="http://schemas.openxmlformats.org/presentationml/2006/main">
+  <p:cSld>
+    <p:bg>
+      <p:bgPr>
+        <a:solidFill>
+          <a:schemeClr val="bg1"/>
+        </a:solidFill>
+        <a:effectLst/>
+      </p:bgPr>
+    </p:bg>
+    <p:spTree>
+      <p:nvGrpSpPr>
+        <p:cNvPr id="1" name=""/>
+        <p:cNvGrpSpPr/>
+        <p:nvPr/>
+      </p:nvGrpSpPr>
+      <p:grpSpPr>
+        <a:xfrm>
+          <a:off x="0" y="0"/>
+          <a:ext cx="0" cy="0"/>
+          <a:chOff x="0" y="0"/>
+          <a:chExt cx="0" cy="0"/>
+        </a:xfrm>
+      </p:grpSpPr>
+      <p:sp>
+        <p:nvSpPr>
+          <p:cNvPr id="5" name="Rectangle 4">
+            <a:extLst>
+              <a:ext uri="{FF2B5EF4-FFF2-40B4-BE49-F238E27FC236}">
+                <a16:creationId xmlns:a16="http://schemas.microsoft.com/office/drawing/2014/main" id="{0076ECA5-B2D7-A3E2-AE20-A7CA20368183}"/>
+              </a:ext>
+            </a:extLst>
+          </p:cNvPr>
+          <p:cNvSpPr/>
+          <p:nvPr/>
+        </p:nvSpPr>
+        <p:spPr>
+          <a:xfrm>
+            <a:off x="4765638" y="4346089"/>
+            <a:ext cx="7067774" cy="2491261"/>
+          </a:xfrm>
+          <a:prstGeom prst="rect">
+            <a:avLst/>
+          </a:prstGeom>
+        </p:spPr>
+        <p:style>
+          <a:lnRef idx="2">
+            <a:schemeClr val="accent1">
+              <a:shade val="15000"/>
+            </a:schemeClr>
+          </a:lnRef>
+          <a:fillRef idx="1">
+            <a:schemeClr val="accent1"/>
+          </a:fillRef>
+          <a:effectRef idx="0">
+            <a:schemeClr val="accent1"/>
+          </a:effectRef>
+          <a:fontRef idx="minor">
+            <a:schemeClr val="lt1"/>
+          </a:fontRef>
+        </p:style>
+        <p:txBody>
+          <a:bodyPr rtlCol="0" anchor="ctr"/>
+          <a:lstStyle/>
+          <a:p>
+            <a:pPr algn="ctr"/>
+            <a:endParaRPr lang="en-US"/>
+          </a:p>
+        </p:txBody>
+      </p:sp>
+      <p:pic>
+        <p:nvPicPr>
+          <p:cNvPr id="4" name="Picture 3" descr="A screenshot of a computer&#10;&#10;Description automatically generated with medium confidence">
+            <a:extLst>
+              <a:ext uri="{FF2B5EF4-FFF2-40B4-BE49-F238E27FC236}">
+                <a16:creationId xmlns:a16="http://schemas.microsoft.com/office/drawing/2014/main" id="{63B52CF8-3FE6-8853-772F-8B675D4EA729}"/>
+              </a:ext>
+            </a:extLst>
+          </p:cNvPr>
+          <p:cNvPicPr>
+            <a:picLocks noChangeAspect="1"/>
+          </p:cNvPicPr>
+          <p:nvPr/>
+        </p:nvPicPr>
+        <p:blipFill>
+          <a:blip r:embed="rId3">
+            <a:extLst>
+              <a:ext uri="{28A0092B-C50C-407E-A947-70E740481C1C}">
+                <a14:useLocalDpi xmlns:a14="http://schemas.microsoft.com/office/drawing/2010/main" val="0"/>
+              </a:ext>
+            </a:extLst>
+          </a:blip>
+          <a:stretch>
+            <a:fillRect/>
+          </a:stretch>
+        </p:blipFill>
+        <p:spPr>
+          <a:xfrm>
+            <a:off x="4842636" y="-31709"/>
+            <a:ext cx="6915472" cy="6869059"/>
+          </a:xfrm>
+          <a:prstGeom prst="rect">
+            <a:avLst/>
+          </a:prstGeom>
+        </p:spPr>
+      </p:pic>
+      <p:sp>
+        <p:nvSpPr>
+          <p:cNvPr id="2" name="Title 1">
+            <a:extLst>
+              <a:ext uri="{FF2B5EF4-FFF2-40B4-BE49-F238E27FC236}">
+                <a16:creationId xmlns:a16="http://schemas.microsoft.com/office/drawing/2014/main" id="{6D8CEF7E-C184-9ED5-678F-E522EE7861ED}"/>
+              </a:ext>
+            </a:extLst>
+          </p:cNvPr>
+          <p:cNvSpPr>
+            <a:spLocks noGrp="1"/>
+          </p:cNvSpPr>
+          <p:nvPr>
+            <p:ph type="title"/>
+          </p:nvPr>
+        </p:nvSpPr>
+        <p:spPr/>
+        <p:txBody>
+          <a:bodyPr/>
+          <a:lstStyle/>
+          <a:p>
+            <a:r>
+              <a:rPr lang="en-US" dirty="0"/>
+              <a:t>Implementing</a:t>
+            </a:r>
+            <a:br>
+              <a:rPr lang="en-US" dirty="0"/>
+            </a:br>
+            <a:r>
+              <a:rPr lang="en-US" dirty="0"/>
+              <a:t>Transports</a:t>
+            </a:r>
+          </a:p>
+        </p:txBody>
+      </p:sp>
+      <p:sp>
+        <p:nvSpPr>
+          <p:cNvPr id="9" name="Content Placeholder 8">
+            <a:extLst>
+              <a:ext uri="{FF2B5EF4-FFF2-40B4-BE49-F238E27FC236}">
+                <a16:creationId xmlns:a16="http://schemas.microsoft.com/office/drawing/2014/main" id="{9F56818D-148F-7DD5-0B72-C665916F8DDC}"/>
+              </a:ext>
+            </a:extLst>
+          </p:cNvPr>
+          <p:cNvSpPr>
+            <a:spLocks noGrp="1"/>
+          </p:cNvSpPr>
+          <p:nvPr>
+            <p:ph idx="1"/>
+          </p:nvPr>
+        </p:nvSpPr>
+        <p:spPr>
+          <a:xfrm>
+            <a:off x="358588" y="2299414"/>
+            <a:ext cx="4484048" cy="4558586"/>
+          </a:xfrm>
+        </p:spPr>
+        <p:txBody>
+          <a:bodyPr>
+            <a:normAutofit fontScale="92500" lnSpcReduction="20000"/>
+          </a:bodyPr>
+          <a:lstStyle/>
+          <a:p>
+            <a:r>
+              <a:rPr lang="en-US" sz="2400" dirty="0"/>
+              <a:t>3 classes to specialize.</a:t>
+            </a:r>
+          </a:p>
+          <a:p>
+            <a:r>
+              <a:rPr lang="en-US" sz="2400" dirty="0"/>
+              <a:t>Straight wrappers, no error management required.</a:t>
+            </a:r>
+          </a:p>
+          <a:p>
+            <a:r>
+              <a:rPr lang="en-US" sz="2400" dirty="0"/>
+              <a:t>Package First</a:t>
+            </a:r>
+          </a:p>
+          <a:p>
+            <a:endParaRPr lang="en-US" sz="2400" dirty="0"/>
+          </a:p>
+          <a:p>
+            <a:endParaRPr lang="en-US" sz="2400" dirty="0"/>
+          </a:p>
+          <a:p>
+            <a:r>
+              <a:rPr lang="en-US" sz="2400" dirty="0"/>
+              <a:t>Example of </a:t>
+            </a:r>
+            <a:r>
+              <a:rPr lang="en-US" sz="2400" dirty="0" err="1"/>
+              <a:t>TCPSocket</a:t>
+            </a:r>
+            <a:endParaRPr lang="en-US" sz="2400" dirty="0"/>
+          </a:p>
+          <a:p>
+            <a:pPr lvl="1"/>
+            <a:r>
+              <a:rPr lang="en-US" sz="2000" dirty="0" err="1"/>
+              <a:t>AddressProtocolName</a:t>
+            </a:r>
+            <a:r>
+              <a:rPr lang="en-US" sz="2000" dirty="0"/>
+              <a:t>: </a:t>
+            </a:r>
+          </a:p>
+          <a:p>
+            <a:pPr lvl="2"/>
+            <a:r>
+              <a:rPr lang="en-US" sz="1600" dirty="0"/>
+              <a:t>“</a:t>
+            </a:r>
+            <a:r>
+              <a:rPr lang="en-US" sz="1600" dirty="0" err="1"/>
+              <a:t>tcp</a:t>
+            </a:r>
+            <a:r>
+              <a:rPr lang="en-US" sz="1600" dirty="0"/>
+              <a:t>”</a:t>
+            </a:r>
+          </a:p>
+          <a:p>
+            <a:pPr lvl="1"/>
+            <a:r>
+              <a:rPr lang="en-US" sz="2000" dirty="0" err="1"/>
+              <a:t>DefaultListeningAddress</a:t>
+            </a:r>
+            <a:r>
+              <a:rPr lang="en-US" sz="2000" dirty="0"/>
+              <a:t>:</a:t>
+            </a:r>
+          </a:p>
+          <a:p>
+            <a:pPr lvl="2"/>
+            <a:r>
+              <a:rPr lang="en-US" sz="1600" dirty="0"/>
+              <a:t>new </a:t>
+            </a:r>
+            <a:r>
+              <a:rPr lang="en-US" sz="1600" dirty="0" err="1"/>
+              <a:t>IPEndpoint</a:t>
+            </a:r>
+            <a:r>
+              <a:rPr lang="en-US" sz="1600" dirty="0"/>
+              <a:t>(IPAddress.Any,37120)</a:t>
+            </a:r>
+          </a:p>
+          <a:p>
+            <a:endParaRPr lang="en-US" sz="2400" dirty="0"/>
+          </a:p>
+          <a:p>
+            <a:r>
+              <a:rPr lang="en-US" sz="2400" dirty="0"/>
+              <a:t>Developers don’t interact with Transports layer.</a:t>
+            </a:r>
+            <a:endParaRPr lang="en-US" sz="2000" dirty="0"/>
+          </a:p>
+        </p:txBody>
+      </p:sp>
+      <mc:AlternateContent xmlns:mc="http://schemas.openxmlformats.org/markup-compatibility/2006">
+        <mc:Choice xmlns:p14="http://schemas.microsoft.com/office/powerpoint/2010/main" Requires="p14">
+          <p:contentPart p14:bwMode="auto" r:id="rId4">
+            <p14:nvContentPartPr>
+              <p14:cNvPr id="16" name="Ink 15">
+                <a:extLst>
+                  <a:ext uri="{FF2B5EF4-FFF2-40B4-BE49-F238E27FC236}">
+                    <a16:creationId xmlns:a16="http://schemas.microsoft.com/office/drawing/2014/main" id="{50624A14-49A3-0F8D-AD90-36507C62CCDD}"/>
+                  </a:ext>
+                </a:extLst>
+              </p14:cNvPr>
+              <p14:cNvContentPartPr/>
+              <p14:nvPr/>
+            </p14:nvContentPartPr>
+            <p14:xfrm>
+              <a:off x="7894068" y="2881837"/>
+              <a:ext cx="1032840" cy="57600"/>
+            </p14:xfrm>
+          </p:contentPart>
+        </mc:Choice>
+        <mc:Fallback>
+          <p:pic>
+            <p:nvPicPr>
+              <p:cNvPr id="16" name="Ink 15">
+                <a:extLst>
+                  <a:ext uri="{FF2B5EF4-FFF2-40B4-BE49-F238E27FC236}">
+                    <a16:creationId xmlns:a16="http://schemas.microsoft.com/office/drawing/2014/main" id="{50624A14-49A3-0F8D-AD90-36507C62CCDD}"/>
+                  </a:ext>
+                </a:extLst>
+              </p:cNvPr>
+              <p:cNvPicPr/>
+              <p:nvPr/>
+            </p:nvPicPr>
+            <p:blipFill>
+              <a:blip r:embed="rId5"/>
+              <a:stretch>
+                <a:fillRect/>
+              </a:stretch>
+            </p:blipFill>
+            <p:spPr>
+              <a:xfrm>
+                <a:off x="7840068" y="2773837"/>
+                <a:ext cx="1140480" cy="273240"/>
+              </a:xfrm>
+              <a:prstGeom prst="rect">
+                <a:avLst/>
+              </a:prstGeom>
+            </p:spPr>
+          </p:pic>
+        </mc:Fallback>
+      </mc:AlternateContent>
+    </p:spTree>
+    <p:extLst>
+      <p:ext uri="{BB962C8B-B14F-4D97-AF65-F5344CB8AC3E}">
+        <p14:creationId xmlns:p14="http://schemas.microsoft.com/office/powerpoint/2010/main" val="2227821959"/>
+      </p:ext>
+    </p:extLst>
+  </p:cSld>
+  <p:clrMapOvr>
+    <a:masterClrMapping/>
+  </p:clrMapOvr>
+</p:sld>
+</file>
+
 <file path=ppt/slides/slide28.xml><?xml version="1.0" encoding="utf-8"?>
 <p:sld xmlns:a="http://schemas.openxmlformats.org/drawingml/2006/main" xmlns:r="http://schemas.openxmlformats.org/officeDocument/2006/relationships" xmlns:p="http://schemas.openxmlformats.org/presentationml/2006/main">
   <p:cSld>
@@ -15259,7 +15376,7 @@
           <a:p>
             <a:r>
               <a:rPr lang="en-US" dirty="0"/>
-              <a:t>The exchange Channels</a:t>
+              <a:t>The Channels</a:t>
             </a:r>
           </a:p>
         </p:txBody>
@@ -15389,6 +15506,244 @@
 </file>
 
 <file path=ppt/slides/slide29.xml><?xml version="1.0" encoding="utf-8"?>
+<p:sld xmlns:a="http://schemas.openxmlformats.org/drawingml/2006/main" xmlns:r="http://schemas.openxmlformats.org/officeDocument/2006/relationships" xmlns:p="http://schemas.openxmlformats.org/presentationml/2006/main">
+  <p:cSld>
+    <p:spTree>
+      <p:nvGrpSpPr>
+        <p:cNvPr id="1" name=""/>
+        <p:cNvGrpSpPr/>
+        <p:nvPr/>
+      </p:nvGrpSpPr>
+      <p:grpSpPr>
+        <a:xfrm>
+          <a:off x="0" y="0"/>
+          <a:ext cx="0" cy="0"/>
+          <a:chOff x="0" y="0"/>
+          <a:chExt cx="0" cy="0"/>
+        </a:xfrm>
+      </p:grpSpPr>
+      <p:sp>
+        <p:nvSpPr>
+          <p:cNvPr id="2" name="Title 1">
+            <a:extLst>
+              <a:ext uri="{FF2B5EF4-FFF2-40B4-BE49-F238E27FC236}">
+                <a16:creationId xmlns:a16="http://schemas.microsoft.com/office/drawing/2014/main" id="{2ADDEB0D-75FE-A9E7-AE5D-1A00BE2CB4EF}"/>
+              </a:ext>
+            </a:extLst>
+          </p:cNvPr>
+          <p:cNvSpPr>
+            <a:spLocks noGrp="1"/>
+          </p:cNvSpPr>
+          <p:nvPr>
+            <p:ph type="title"/>
+          </p:nvPr>
+        </p:nvSpPr>
+        <p:spPr/>
+        <p:txBody>
+          <a:bodyPr/>
+          <a:lstStyle/>
+          <a:p>
+            <a:r>
+              <a:rPr lang="en-US" dirty="0"/>
+              <a:t>UNSTABLE REMAINDER</a:t>
+            </a:r>
+          </a:p>
+        </p:txBody>
+      </p:sp>
+      <p:sp>
+        <p:nvSpPr>
+          <p:cNvPr id="3" name="Content Placeholder 2">
+            <a:extLst>
+              <a:ext uri="{FF2B5EF4-FFF2-40B4-BE49-F238E27FC236}">
+                <a16:creationId xmlns:a16="http://schemas.microsoft.com/office/drawing/2014/main" id="{69BD3F96-4E3A-A64D-A143-5E0F643AB7C5}"/>
+              </a:ext>
+            </a:extLst>
+          </p:cNvPr>
+          <p:cNvSpPr>
+            <a:spLocks noGrp="1"/>
+          </p:cNvSpPr>
+          <p:nvPr>
+            <p:ph idx="1"/>
+          </p:nvPr>
+        </p:nvSpPr>
+        <p:spPr/>
+        <p:txBody>
+          <a:bodyPr/>
+          <a:lstStyle/>
+          <a:p>
+            <a:endParaRPr lang="en-US"/>
+          </a:p>
+        </p:txBody>
+      </p:sp>
+    </p:spTree>
+    <p:extLst>
+      <p:ext uri="{BB962C8B-B14F-4D97-AF65-F5344CB8AC3E}">
+        <p14:creationId xmlns:p14="http://schemas.microsoft.com/office/powerpoint/2010/main" val="4293717367"/>
+      </p:ext>
+    </p:extLst>
+  </p:cSld>
+  <p:clrMapOvr>
+    <a:masterClrMapping/>
+  </p:clrMapOvr>
+</p:sld>
+</file>
+
+<file path=ppt/slides/slide3.xml><?xml version="1.0" encoding="utf-8"?>
+<p:sld xmlns:a="http://schemas.openxmlformats.org/drawingml/2006/main" xmlns:r="http://schemas.openxmlformats.org/officeDocument/2006/relationships" xmlns:p="http://schemas.openxmlformats.org/presentationml/2006/main">
+  <p:cSld>
+    <p:spTree>
+      <p:nvGrpSpPr>
+        <p:cNvPr id="1" name=""/>
+        <p:cNvGrpSpPr/>
+        <p:nvPr/>
+      </p:nvGrpSpPr>
+      <p:grpSpPr>
+        <a:xfrm>
+          <a:off x="0" y="0"/>
+          <a:ext cx="0" cy="0"/>
+          <a:chOff x="0" y="0"/>
+          <a:chExt cx="0" cy="0"/>
+        </a:xfrm>
+      </p:grpSpPr>
+      <p:sp>
+        <p:nvSpPr>
+          <p:cNvPr id="2" name="Title 1">
+            <a:extLst>
+              <a:ext uri="{FF2B5EF4-FFF2-40B4-BE49-F238E27FC236}">
+                <a16:creationId xmlns:a16="http://schemas.microsoft.com/office/drawing/2014/main" id="{8C94FF63-04EA-BCC5-D34D-9C25D186AFCA}"/>
+              </a:ext>
+            </a:extLst>
+          </p:cNvPr>
+          <p:cNvSpPr>
+            <a:spLocks noGrp="1"/>
+          </p:cNvSpPr>
+          <p:nvPr>
+            <p:ph type="title"/>
+          </p:nvPr>
+        </p:nvSpPr>
+        <p:spPr/>
+        <p:txBody>
+          <a:bodyPr/>
+          <a:lstStyle/>
+          <a:p>
+            <a:r>
+              <a:rPr lang="en-US" dirty="0"/>
+              <a:t>Secondary Objectives</a:t>
+            </a:r>
+          </a:p>
+        </p:txBody>
+      </p:sp>
+      <p:sp>
+        <p:nvSpPr>
+          <p:cNvPr id="3" name="Content Placeholder 2">
+            <a:extLst>
+              <a:ext uri="{FF2B5EF4-FFF2-40B4-BE49-F238E27FC236}">
+                <a16:creationId xmlns:a16="http://schemas.microsoft.com/office/drawing/2014/main" id="{936DC6D3-3B63-2CF7-C0E5-91BFC5BA1268}"/>
+              </a:ext>
+            </a:extLst>
+          </p:cNvPr>
+          <p:cNvSpPr>
+            <a:spLocks noGrp="1"/>
+          </p:cNvSpPr>
+          <p:nvPr>
+            <p:ph idx="1"/>
+          </p:nvPr>
+        </p:nvSpPr>
+        <p:spPr/>
+        <p:txBody>
+          <a:bodyPr/>
+          <a:lstStyle/>
+          <a:p>
+            <a:r>
+              <a:rPr lang="en-US" dirty="0"/>
+              <a:t>Follows the “Package First” approach.</a:t>
+            </a:r>
+          </a:p>
+          <a:p>
+            <a:r>
+              <a:rPr lang="en-US" dirty="0"/>
+              <a:t>Encapsulates complexities</a:t>
+            </a:r>
+          </a:p>
+          <a:p>
+            <a:pPr lvl="1"/>
+            <a:r>
+              <a:rPr lang="en-US" dirty="0"/>
+              <a:t>Capabilities discovery</a:t>
+            </a:r>
+          </a:p>
+          <a:p>
+            <a:pPr lvl="1"/>
+            <a:r>
+              <a:rPr lang="en-US" dirty="0"/>
+              <a:t>Secret keys management</a:t>
+            </a:r>
+          </a:p>
+          <a:p>
+            <a:r>
+              <a:rPr lang="en-US" dirty="0"/>
+              <a:t>Supports “Observability”</a:t>
+            </a:r>
+          </a:p>
+          <a:p>
+            <a:pPr lvl="1"/>
+            <a:r>
+              <a:rPr lang="en-US" dirty="0"/>
+              <a:t>Logs from a Party are identified and can be easily managed.</a:t>
+            </a:r>
+          </a:p>
+          <a:p>
+            <a:r>
+              <a:rPr lang="en-US" dirty="0"/>
+              <a:t>Be agnostic of deployment details</a:t>
+            </a:r>
+          </a:p>
+          <a:p>
+            <a:pPr lvl="1"/>
+            <a:r>
+              <a:rPr lang="en-US" dirty="0"/>
+              <a:t>Transport layers (TCP/IP, </a:t>
+            </a:r>
+            <a:r>
+              <a:rPr lang="en-US" dirty="0" err="1"/>
+              <a:t>quic</a:t>
+            </a:r>
+            <a:r>
+              <a:rPr lang="en-US" dirty="0"/>
+              <a:t>, </a:t>
+            </a:r>
+            <a:r>
+              <a:rPr lang="en-US" dirty="0" err="1"/>
+              <a:t>mqtt</a:t>
+            </a:r>
+            <a:r>
+              <a:rPr lang="en-US" dirty="0"/>
+              <a:t>, etc.)</a:t>
+            </a:r>
+          </a:p>
+          <a:p>
+            <a:pPr lvl="1"/>
+            <a:r>
+              <a:rPr lang="en-US" dirty="0"/>
+              <a:t>VLAN and/or WAN</a:t>
+            </a:r>
+          </a:p>
+        </p:txBody>
+      </p:sp>
+    </p:spTree>
+    <p:extLst>
+      <p:ext uri="{BB962C8B-B14F-4D97-AF65-F5344CB8AC3E}">
+        <p14:creationId xmlns:p14="http://schemas.microsoft.com/office/powerpoint/2010/main" val="1297341357"/>
+      </p:ext>
+    </p:extLst>
+  </p:cSld>
+  <p:clrMapOvr>
+    <a:masterClrMapping/>
+  </p:clrMapOvr>
+</p:sld>
+</file>
+
+<file path=ppt/slides/slide30.xml><?xml version="1.0" encoding="utf-8"?>
 <p:sld xmlns:a="http://schemas.openxmlformats.org/drawingml/2006/main" xmlns:r="http://schemas.openxmlformats.org/officeDocument/2006/relationships" xmlns:p="http://schemas.openxmlformats.org/presentationml/2006/main">
   <p:cSld>
     <p:spTree>
@@ -15820,162 +16175,7 @@
 </p:sld>
 </file>
 
-<file path=ppt/slides/slide3.xml><?xml version="1.0" encoding="utf-8"?>
-<p:sld xmlns:a="http://schemas.openxmlformats.org/drawingml/2006/main" xmlns:r="http://schemas.openxmlformats.org/officeDocument/2006/relationships" xmlns:p="http://schemas.openxmlformats.org/presentationml/2006/main">
-  <p:cSld>
-    <p:spTree>
-      <p:nvGrpSpPr>
-        <p:cNvPr id="1" name=""/>
-        <p:cNvGrpSpPr/>
-        <p:nvPr/>
-      </p:nvGrpSpPr>
-      <p:grpSpPr>
-        <a:xfrm>
-          <a:off x="0" y="0"/>
-          <a:ext cx="0" cy="0"/>
-          <a:chOff x="0" y="0"/>
-          <a:chExt cx="0" cy="0"/>
-        </a:xfrm>
-      </p:grpSpPr>
-      <p:sp>
-        <p:nvSpPr>
-          <p:cNvPr id="2" name="Title 1">
-            <a:extLst>
-              <a:ext uri="{FF2B5EF4-FFF2-40B4-BE49-F238E27FC236}">
-                <a16:creationId xmlns:a16="http://schemas.microsoft.com/office/drawing/2014/main" id="{8C94FF63-04EA-BCC5-D34D-9C25D186AFCA}"/>
-              </a:ext>
-            </a:extLst>
-          </p:cNvPr>
-          <p:cNvSpPr>
-            <a:spLocks noGrp="1"/>
-          </p:cNvSpPr>
-          <p:nvPr>
-            <p:ph type="title"/>
-          </p:nvPr>
-        </p:nvSpPr>
-        <p:spPr/>
-        <p:txBody>
-          <a:bodyPr/>
-          <a:lstStyle/>
-          <a:p>
-            <a:r>
-              <a:rPr lang="en-US" dirty="0"/>
-              <a:t>Secondary Objectives</a:t>
-            </a:r>
-          </a:p>
-        </p:txBody>
-      </p:sp>
-      <p:sp>
-        <p:nvSpPr>
-          <p:cNvPr id="3" name="Content Placeholder 2">
-            <a:extLst>
-              <a:ext uri="{FF2B5EF4-FFF2-40B4-BE49-F238E27FC236}">
-                <a16:creationId xmlns:a16="http://schemas.microsoft.com/office/drawing/2014/main" id="{936DC6D3-3B63-2CF7-C0E5-91BFC5BA1268}"/>
-              </a:ext>
-            </a:extLst>
-          </p:cNvPr>
-          <p:cNvSpPr>
-            <a:spLocks noGrp="1"/>
-          </p:cNvSpPr>
-          <p:nvPr>
-            <p:ph idx="1"/>
-          </p:nvPr>
-        </p:nvSpPr>
-        <p:spPr/>
-        <p:txBody>
-          <a:bodyPr/>
-          <a:lstStyle/>
-          <a:p>
-            <a:r>
-              <a:rPr lang="en-US" dirty="0"/>
-              <a:t>Follows the “Package First” approach.</a:t>
-            </a:r>
-          </a:p>
-          <a:p>
-            <a:r>
-              <a:rPr lang="en-US" dirty="0"/>
-              <a:t>Encapsulates complexities</a:t>
-            </a:r>
-          </a:p>
-          <a:p>
-            <a:pPr lvl="1"/>
-            <a:r>
-              <a:rPr lang="en-US" dirty="0"/>
-              <a:t>Capabilities discovery</a:t>
-            </a:r>
-          </a:p>
-          <a:p>
-            <a:pPr lvl="1"/>
-            <a:r>
-              <a:rPr lang="en-US" dirty="0"/>
-              <a:t>Secret keys management</a:t>
-            </a:r>
-          </a:p>
-          <a:p>
-            <a:r>
-              <a:rPr lang="en-US" dirty="0"/>
-              <a:t>Supports “Observability”</a:t>
-            </a:r>
-          </a:p>
-          <a:p>
-            <a:pPr lvl="1"/>
-            <a:r>
-              <a:rPr lang="en-US" dirty="0"/>
-              <a:t>Logs from a Party are identified and can be easily managed.</a:t>
-            </a:r>
-          </a:p>
-          <a:p>
-            <a:r>
-              <a:rPr lang="en-US" dirty="0"/>
-              <a:t>Be agnostic of deployment details</a:t>
-            </a:r>
-          </a:p>
-          <a:p>
-            <a:pPr lvl="1"/>
-            <a:r>
-              <a:rPr lang="en-US" dirty="0"/>
-              <a:t>Transport layers (TCP/IP, </a:t>
-            </a:r>
-            <a:r>
-              <a:rPr lang="en-US" dirty="0" err="1"/>
-              <a:t>quic</a:t>
-            </a:r>
-            <a:r>
-              <a:rPr lang="en-US" dirty="0"/>
-              <a:t>, </a:t>
-            </a:r>
-            <a:r>
-              <a:rPr lang="en-US" dirty="0" err="1"/>
-              <a:t>mqtt</a:t>
-            </a:r>
-            <a:r>
-              <a:rPr lang="en-US" dirty="0"/>
-              <a:t>, etc.)</a:t>
-            </a:r>
-          </a:p>
-          <a:p>
-            <a:pPr lvl="1"/>
-            <a:r>
-              <a:rPr lang="en-US" dirty="0"/>
-              <a:t>VLAN and/or WAN</a:t>
-            </a:r>
-          </a:p>
-        </p:txBody>
-      </p:sp>
-    </p:spTree>
-    <p:extLst>
-      <p:ext uri="{BB962C8B-B14F-4D97-AF65-F5344CB8AC3E}">
-        <p14:creationId xmlns:p14="http://schemas.microsoft.com/office/powerpoint/2010/main" val="1297341357"/>
-      </p:ext>
-    </p:extLst>
-  </p:cSld>
-  <p:clrMapOvr>
-    <a:masterClrMapping/>
-  </p:clrMapOvr>
-</p:sld>
-</file>
-
-<file path=ppt/slides/slide30.xml><?xml version="1.0" encoding="utf-8"?>
+<file path=ppt/slides/slide31.xml><?xml version="1.0" encoding="utf-8"?>
 <p:sld xmlns:a="http://schemas.openxmlformats.org/drawingml/2006/main" xmlns:r="http://schemas.openxmlformats.org/officeDocument/2006/relationships" xmlns:p="http://schemas.openxmlformats.org/presentationml/2006/main">
   <p:cSld>
     <p:spTree>
@@ -16120,7 +16320,7 @@
 </p:sld>
 </file>
 
-<file path=ppt/slides/slide31.xml><?xml version="1.0" encoding="utf-8"?>
+<file path=ppt/slides/slide32.xml><?xml version="1.0" encoding="utf-8"?>
 <p:sld xmlns:a="http://schemas.openxmlformats.org/drawingml/2006/main" xmlns:r="http://schemas.openxmlformats.org/officeDocument/2006/relationships" xmlns:p="http://schemas.openxmlformats.org/presentationml/2006/main">
   <p:cSld>
     <p:spTree>
@@ -16839,7 +17039,7 @@
 </p:sld>
 </file>
 
-<file path=ppt/slides/slide32.xml><?xml version="1.0" encoding="utf-8"?>
+<file path=ppt/slides/slide33.xml><?xml version="1.0" encoding="utf-8"?>
 <p:sld xmlns:a="http://schemas.openxmlformats.org/drawingml/2006/main" xmlns:r="http://schemas.openxmlformats.org/officeDocument/2006/relationships" xmlns:p="http://schemas.openxmlformats.org/presentationml/2006/main">
   <p:cSld>
     <p:spTree>
@@ -17551,263 +17751,6 @@
     <p:extLst>
       <p:ext uri="{BB962C8B-B14F-4D97-AF65-F5344CB8AC3E}">
         <p14:creationId xmlns:p14="http://schemas.microsoft.com/office/powerpoint/2010/main" val="1074243622"/>
-      </p:ext>
-    </p:extLst>
-  </p:cSld>
-  <p:clrMapOvr>
-    <a:masterClrMapping/>
-  </p:clrMapOvr>
-</p:sld>
-</file>
-
-<file path=ppt/slides/slide33.xml><?xml version="1.0" encoding="utf-8"?>
-<p:sld xmlns:a="http://schemas.openxmlformats.org/drawingml/2006/main" xmlns:r="http://schemas.openxmlformats.org/officeDocument/2006/relationships" xmlns:p="http://schemas.openxmlformats.org/presentationml/2006/main">
-  <p:cSld>
-    <p:bg>
-      <p:bgPr>
-        <a:solidFill>
-          <a:schemeClr val="bg1"/>
-        </a:solidFill>
-        <a:effectLst/>
-      </p:bgPr>
-    </p:bg>
-    <p:spTree>
-      <p:nvGrpSpPr>
-        <p:cNvPr id="1" name=""/>
-        <p:cNvGrpSpPr/>
-        <p:nvPr/>
-      </p:nvGrpSpPr>
-      <p:grpSpPr>
-        <a:xfrm>
-          <a:off x="0" y="0"/>
-          <a:ext cx="0" cy="0"/>
-          <a:chOff x="0" y="0"/>
-          <a:chExt cx="0" cy="0"/>
-        </a:xfrm>
-      </p:grpSpPr>
-      <p:sp>
-        <p:nvSpPr>
-          <p:cNvPr id="2" name="Title 1">
-            <a:extLst>
-              <a:ext uri="{FF2B5EF4-FFF2-40B4-BE49-F238E27FC236}">
-                <a16:creationId xmlns:a16="http://schemas.microsoft.com/office/drawing/2014/main" id="{6D8CEF7E-C184-9ED5-678F-E522EE7861ED}"/>
-              </a:ext>
-            </a:extLst>
-          </p:cNvPr>
-          <p:cNvSpPr>
-            <a:spLocks noGrp="1"/>
-          </p:cNvSpPr>
-          <p:nvPr>
-            <p:ph type="title"/>
-          </p:nvPr>
-        </p:nvSpPr>
-        <p:spPr/>
-        <p:txBody>
-          <a:bodyPr/>
-          <a:lstStyle/>
-          <a:p>
-            <a:r>
-              <a:rPr lang="en-US" dirty="0"/>
-              <a:t>Implementing</a:t>
-            </a:r>
-            <a:br>
-              <a:rPr lang="en-US" dirty="0"/>
-            </a:br>
-            <a:r>
-              <a:rPr lang="en-US" dirty="0"/>
-              <a:t>Transports</a:t>
-            </a:r>
-          </a:p>
-        </p:txBody>
-      </p:sp>
-      <p:sp>
-        <p:nvSpPr>
-          <p:cNvPr id="9" name="Content Placeholder 8">
-            <a:extLst>
-              <a:ext uri="{FF2B5EF4-FFF2-40B4-BE49-F238E27FC236}">
-                <a16:creationId xmlns:a16="http://schemas.microsoft.com/office/drawing/2014/main" id="{9F56818D-148F-7DD5-0B72-C665916F8DDC}"/>
-              </a:ext>
-            </a:extLst>
-          </p:cNvPr>
-          <p:cNvSpPr>
-            <a:spLocks noGrp="1"/>
-          </p:cNvSpPr>
-          <p:nvPr>
-            <p:ph idx="1"/>
-          </p:nvPr>
-        </p:nvSpPr>
-        <p:spPr>
-          <a:xfrm>
-            <a:off x="685800" y="2395330"/>
-            <a:ext cx="4446248" cy="4273825"/>
-          </a:xfrm>
-        </p:spPr>
-        <p:txBody>
-          <a:bodyPr>
-            <a:normAutofit/>
-          </a:bodyPr>
-          <a:lstStyle/>
-          <a:p>
-            <a:r>
-              <a:rPr lang="en-US" sz="2400" dirty="0"/>
-              <a:t>3 classes to specialize.</a:t>
-            </a:r>
-          </a:p>
-          <a:p>
-            <a:r>
-              <a:rPr lang="en-US" sz="2400" dirty="0"/>
-              <a:t>Straight wrappers, no error management required.</a:t>
-            </a:r>
-          </a:p>
-          <a:p>
-            <a:r>
-              <a:rPr lang="en-US" sz="2400" dirty="0"/>
-              <a:t>Package First</a:t>
-            </a:r>
-          </a:p>
-          <a:p>
-            <a:endParaRPr lang="en-US" sz="2400" dirty="0"/>
-          </a:p>
-          <a:p>
-            <a:r>
-              <a:rPr lang="en-US" sz="2400" dirty="0"/>
-              <a:t>Example of </a:t>
-            </a:r>
-            <a:r>
-              <a:rPr lang="en-US" sz="2400" dirty="0" err="1"/>
-              <a:t>TCPSocket</a:t>
-            </a:r>
-            <a:endParaRPr lang="en-US" sz="2400" dirty="0"/>
-          </a:p>
-          <a:p>
-            <a:pPr lvl="1"/>
-            <a:r>
-              <a:rPr lang="en-US" sz="2000" dirty="0" err="1"/>
-              <a:t>AddressProtocolName</a:t>
-            </a:r>
-            <a:r>
-              <a:rPr lang="en-US" sz="2000" dirty="0"/>
-              <a:t>: “</a:t>
-            </a:r>
-            <a:r>
-              <a:rPr lang="en-US" sz="2000" dirty="0" err="1"/>
-              <a:t>tcp</a:t>
-            </a:r>
-            <a:r>
-              <a:rPr lang="en-US" sz="2000" dirty="0"/>
-              <a:t>”</a:t>
-            </a:r>
-          </a:p>
-          <a:p>
-            <a:endParaRPr lang="en-US" sz="2400" dirty="0"/>
-          </a:p>
-          <a:p>
-            <a:r>
-              <a:rPr lang="en-US" sz="2400" dirty="0"/>
-              <a:t>Developers don’t interact with Transports layer.</a:t>
-            </a:r>
-          </a:p>
-          <a:p>
-            <a:pPr lvl="1"/>
-            <a:endParaRPr lang="en-US" sz="2000" dirty="0"/>
-          </a:p>
-          <a:p>
-            <a:pPr lvl="1"/>
-            <a:endParaRPr lang="en-US" sz="2000" dirty="0"/>
-          </a:p>
-        </p:txBody>
-      </p:sp>
-      <p:pic>
-        <p:nvPicPr>
-          <p:cNvPr id="13" name="Picture 12" descr="Diagram&#10;&#10;Description automatically generated">
-            <a:extLst>
-              <a:ext uri="{FF2B5EF4-FFF2-40B4-BE49-F238E27FC236}">
-                <a16:creationId xmlns:a16="http://schemas.microsoft.com/office/drawing/2014/main" id="{5B7E97A0-34C4-CC0C-12FC-6AFA8966FE23}"/>
-              </a:ext>
-            </a:extLst>
-          </p:cNvPr>
-          <p:cNvPicPr>
-            <a:picLocks noChangeAspect="1"/>
-          </p:cNvPicPr>
-          <p:nvPr/>
-        </p:nvPicPr>
-        <p:blipFill>
-          <a:blip r:embed="rId3">
-            <a:extLst>
-              <a:ext uri="{28A0092B-C50C-407E-A947-70E740481C1C}">
-                <a14:useLocalDpi xmlns:a14="http://schemas.microsoft.com/office/drawing/2010/main" val="0"/>
-              </a:ext>
-            </a:extLst>
-          </a:blip>
-          <a:stretch>
-            <a:fillRect/>
-          </a:stretch>
-        </p:blipFill>
-        <p:spPr>
-          <a:xfrm>
-            <a:off x="5204165" y="90854"/>
-            <a:ext cx="6812870" cy="6767146"/>
-          </a:xfrm>
-          <a:prstGeom prst="rect">
-            <a:avLst/>
-          </a:prstGeom>
-        </p:spPr>
-      </p:pic>
-      <mc:AlternateContent xmlns:mc="http://schemas.openxmlformats.org/markup-compatibility/2006" xmlns:p14="http://schemas.microsoft.com/office/powerpoint/2010/main">
-        <mc:Choice Requires="p14">
-          <p:contentPart p14:bwMode="auto" r:id="rId4">
-            <p14:nvContentPartPr>
-              <p14:cNvPr id="16" name="Ink 15">
-                <a:extLst>
-                  <a:ext uri="{FF2B5EF4-FFF2-40B4-BE49-F238E27FC236}">
-                    <a16:creationId xmlns:a16="http://schemas.microsoft.com/office/drawing/2014/main" id="{50624A14-49A3-0F8D-AD90-36507C62CCDD}"/>
-                  </a:ext>
-                </a:extLst>
-              </p14:cNvPr>
-              <p14:cNvContentPartPr/>
-              <p14:nvPr/>
-            </p14:nvContentPartPr>
-            <p14:xfrm>
-              <a:off x="8249071" y="2795776"/>
-              <a:ext cx="1032840" cy="57600"/>
-            </p14:xfrm>
-          </p:contentPart>
-        </mc:Choice>
-        <mc:Fallback xmlns="">
-          <p:pic>
-            <p:nvPicPr>
-              <p:cNvPr id="16" name="Ink 15">
-                <a:extLst>
-                  <a:ext uri="{FF2B5EF4-FFF2-40B4-BE49-F238E27FC236}">
-                    <a16:creationId xmlns:a16="http://schemas.microsoft.com/office/drawing/2014/main" id="{50624A14-49A3-0F8D-AD90-36507C62CCDD}"/>
-                  </a:ext>
-                </a:extLst>
-              </p:cNvPr>
-              <p:cNvPicPr/>
-              <p:nvPr/>
-            </p:nvPicPr>
-            <p:blipFill>
-              <a:blip r:embed="rId5"/>
-              <a:stretch>
-                <a:fillRect/>
-              </a:stretch>
-            </p:blipFill>
-            <p:spPr>
-              <a:xfrm>
-                <a:off x="8195071" y="2687776"/>
-                <a:ext cx="1140480" cy="273240"/>
-              </a:xfrm>
-              <a:prstGeom prst="rect">
-                <a:avLst/>
-              </a:prstGeom>
-            </p:spPr>
-          </p:pic>
-        </mc:Fallback>
-      </mc:AlternateContent>
-    </p:spTree>
-    <p:extLst>
-      <p:ext uri="{BB962C8B-B14F-4D97-AF65-F5344CB8AC3E}">
-        <p14:creationId xmlns:p14="http://schemas.microsoft.com/office/powerpoint/2010/main" val="2227821959"/>
       </p:ext>
     </p:extLst>
   </p:cSld>

</xml_diff>

<commit_message>
WIP: Ouch! It's definitely not simple :(.
</commit_message>
<xml_diff>
--- a/Doc/CK-AppIdentity.pptx
+++ b/Doc/CK-AppIdentity.pptx
@@ -299,7 +299,7 @@
           <a:p>
             <a:fld id="{7EBA75D8-A9A5-4FAF-B563-7A079B630A7E}" type="datetimeFigureOut">
               <a:rPr lang="en-US" smtClean="0"/>
-              <a:t>6/28/2023</a:t>
+              <a:t>7/1/2023</a:t>
             </a:fld>
             <a:endParaRPr lang="en-US"/>
           </a:p>
@@ -2063,7 +2063,7 @@
           <a:p>
             <a:fld id="{7D1F2140-8D48-49AC-AD8D-683E6FF4DC34}" type="datetimeFigureOut">
               <a:rPr lang="en-US" smtClean="0"/>
-              <a:t>6/28/2023</a:t>
+              <a:t>7/1/2023</a:t>
             </a:fld>
             <a:endParaRPr lang="en-US"/>
           </a:p>
@@ -2261,7 +2261,7 @@
           <a:p>
             <a:fld id="{7D1F2140-8D48-49AC-AD8D-683E6FF4DC34}" type="datetimeFigureOut">
               <a:rPr lang="en-US" smtClean="0"/>
-              <a:t>6/28/2023</a:t>
+              <a:t>7/1/2023</a:t>
             </a:fld>
             <a:endParaRPr lang="en-US"/>
           </a:p>
@@ -2469,7 +2469,7 @@
           <a:p>
             <a:fld id="{7D1F2140-8D48-49AC-AD8D-683E6FF4DC34}" type="datetimeFigureOut">
               <a:rPr lang="en-US" smtClean="0"/>
-              <a:t>6/28/2023</a:t>
+              <a:t>7/1/2023</a:t>
             </a:fld>
             <a:endParaRPr lang="en-US"/>
           </a:p>
@@ -2667,7 +2667,7 @@
           <a:p>
             <a:fld id="{7D1F2140-8D48-49AC-AD8D-683E6FF4DC34}" type="datetimeFigureOut">
               <a:rPr lang="en-US" smtClean="0"/>
-              <a:t>6/28/2023</a:t>
+              <a:t>7/1/2023</a:t>
             </a:fld>
             <a:endParaRPr lang="en-US"/>
           </a:p>
@@ -2942,7 +2942,7 @@
           <a:p>
             <a:fld id="{7D1F2140-8D48-49AC-AD8D-683E6FF4DC34}" type="datetimeFigureOut">
               <a:rPr lang="en-US" smtClean="0"/>
-              <a:t>6/28/2023</a:t>
+              <a:t>7/1/2023</a:t>
             </a:fld>
             <a:endParaRPr lang="en-US"/>
           </a:p>
@@ -3207,7 +3207,7 @@
           <a:p>
             <a:fld id="{7D1F2140-8D48-49AC-AD8D-683E6FF4DC34}" type="datetimeFigureOut">
               <a:rPr lang="en-US" smtClean="0"/>
-              <a:t>6/28/2023</a:t>
+              <a:t>7/1/2023</a:t>
             </a:fld>
             <a:endParaRPr lang="en-US"/>
           </a:p>
@@ -3619,7 +3619,7 @@
           <a:p>
             <a:fld id="{7D1F2140-8D48-49AC-AD8D-683E6FF4DC34}" type="datetimeFigureOut">
               <a:rPr lang="en-US" smtClean="0"/>
-              <a:t>6/28/2023</a:t>
+              <a:t>7/1/2023</a:t>
             </a:fld>
             <a:endParaRPr lang="en-US"/>
           </a:p>
@@ -3760,7 +3760,7 @@
           <a:p>
             <a:fld id="{7D1F2140-8D48-49AC-AD8D-683E6FF4DC34}" type="datetimeFigureOut">
               <a:rPr lang="en-US" smtClean="0"/>
-              <a:t>6/28/2023</a:t>
+              <a:t>7/1/2023</a:t>
             </a:fld>
             <a:endParaRPr lang="en-US"/>
           </a:p>
@@ -3873,7 +3873,7 @@
           <a:p>
             <a:fld id="{7D1F2140-8D48-49AC-AD8D-683E6FF4DC34}" type="datetimeFigureOut">
               <a:rPr lang="en-US" smtClean="0"/>
-              <a:t>6/28/2023</a:t>
+              <a:t>7/1/2023</a:t>
             </a:fld>
             <a:endParaRPr lang="en-US"/>
           </a:p>
@@ -4184,7 +4184,7 @@
           <a:p>
             <a:fld id="{7D1F2140-8D48-49AC-AD8D-683E6FF4DC34}" type="datetimeFigureOut">
               <a:rPr lang="en-US" smtClean="0"/>
-              <a:t>6/28/2023</a:t>
+              <a:t>7/1/2023</a:t>
             </a:fld>
             <a:endParaRPr lang="en-US"/>
           </a:p>
@@ -4472,7 +4472,7 @@
           <a:p>
             <a:fld id="{7D1F2140-8D48-49AC-AD8D-683E6FF4DC34}" type="datetimeFigureOut">
               <a:rPr lang="en-US" smtClean="0"/>
-              <a:t>6/28/2023</a:t>
+              <a:t>7/1/2023</a:t>
             </a:fld>
             <a:endParaRPr lang="en-US"/>
           </a:p>
@@ -4713,7 +4713,7 @@
           <a:p>
             <a:fld id="{7D1F2140-8D48-49AC-AD8D-683E6FF4DC34}" type="datetimeFigureOut">
               <a:rPr lang="en-US" smtClean="0"/>
-              <a:t>6/28/2023</a:t>
+              <a:t>7/1/2023</a:t>
             </a:fld>
             <a:endParaRPr lang="en-US"/>
           </a:p>
@@ -12942,6 +12942,14 @@
   <p:clrMapOvr>
     <a:masterClrMapping/>
   </p:clrMapOvr>
+  <mc:AlternateContent xmlns:mc="http://schemas.openxmlformats.org/markup-compatibility/2006">
+    <mc:Choice xmlns:p14="http://schemas.microsoft.com/office/powerpoint/2010/main" Requires="p14">
+      <p:transition spd="slow" p14:dur="2000" advTm="320"/>
+    </mc:Choice>
+    <mc:Fallback>
+      <p:transition spd="slow" advTm="320"/>
+    </mc:Fallback>
+  </mc:AlternateContent>
 </p:sld>
 </file>
 
@@ -13515,6 +13523,14 @@
   <p:clrMapOvr>
     <a:masterClrMapping/>
   </p:clrMapOvr>
+  <mc:AlternateContent xmlns:mc="http://schemas.openxmlformats.org/markup-compatibility/2006">
+    <mc:Choice xmlns:p14="http://schemas.microsoft.com/office/powerpoint/2010/main" Requires="p14">
+      <p:transition spd="slow" p14:dur="2000" advTm="15232"/>
+    </mc:Choice>
+    <mc:Fallback>
+      <p:transition spd="slow" advTm="15232"/>
+    </mc:Fallback>
+  </mc:AlternateContent>
 </p:sld>
 </file>
 
@@ -15272,8 +15288,8 @@
           </a:p>
         </p:txBody>
       </p:sp>
-      <mc:AlternateContent xmlns:mc="http://schemas.openxmlformats.org/markup-compatibility/2006">
-        <mc:Choice xmlns:p14="http://schemas.microsoft.com/office/powerpoint/2010/main" Requires="p14">
+      <mc:AlternateContent xmlns:mc="http://schemas.openxmlformats.org/markup-compatibility/2006" xmlns:p14="http://schemas.microsoft.com/office/powerpoint/2010/main">
+        <mc:Choice Requires="p14">
           <p:contentPart p14:bwMode="auto" r:id="rId4">
             <p14:nvContentPartPr>
               <p14:cNvPr id="16" name="Ink 15">
@@ -15292,7 +15308,7 @@
             </p14:xfrm>
           </p:contentPart>
         </mc:Choice>
-        <mc:Fallback>
+        <mc:Fallback xmlns="">
           <p:pic>
             <p:nvPicPr>
               <p:cNvPr id="16" name="Ink 15">

</xml_diff>

<commit_message>
Change! ClockOffset MUST be checked.
Nonce cache can be time bounded. This change has a lot of impacts :(.
</commit_message>
<xml_diff>
--- a/Doc/CK-AppIdentity.pptx
+++ b/Doc/CK-AppIdentity.pptx
@@ -299,7 +299,7 @@
           <a:p>
             <a:fld id="{7EBA75D8-A9A5-4FAF-B563-7A079B630A7E}" type="datetimeFigureOut">
               <a:rPr lang="en-US" smtClean="0"/>
-              <a:t>7/1/2023</a:t>
+              <a:t>7/17/2023</a:t>
             </a:fld>
             <a:endParaRPr lang="en-US"/>
           </a:p>
@@ -2063,7 +2063,7 @@
           <a:p>
             <a:fld id="{7D1F2140-8D48-49AC-AD8D-683E6FF4DC34}" type="datetimeFigureOut">
               <a:rPr lang="en-US" smtClean="0"/>
-              <a:t>7/1/2023</a:t>
+              <a:t>7/17/2023</a:t>
             </a:fld>
             <a:endParaRPr lang="en-US"/>
           </a:p>
@@ -2261,7 +2261,7 @@
           <a:p>
             <a:fld id="{7D1F2140-8D48-49AC-AD8D-683E6FF4DC34}" type="datetimeFigureOut">
               <a:rPr lang="en-US" smtClean="0"/>
-              <a:t>7/1/2023</a:t>
+              <a:t>7/17/2023</a:t>
             </a:fld>
             <a:endParaRPr lang="en-US"/>
           </a:p>
@@ -2469,7 +2469,7 @@
           <a:p>
             <a:fld id="{7D1F2140-8D48-49AC-AD8D-683E6FF4DC34}" type="datetimeFigureOut">
               <a:rPr lang="en-US" smtClean="0"/>
-              <a:t>7/1/2023</a:t>
+              <a:t>7/17/2023</a:t>
             </a:fld>
             <a:endParaRPr lang="en-US"/>
           </a:p>
@@ -2667,7 +2667,7 @@
           <a:p>
             <a:fld id="{7D1F2140-8D48-49AC-AD8D-683E6FF4DC34}" type="datetimeFigureOut">
               <a:rPr lang="en-US" smtClean="0"/>
-              <a:t>7/1/2023</a:t>
+              <a:t>7/17/2023</a:t>
             </a:fld>
             <a:endParaRPr lang="en-US"/>
           </a:p>
@@ -2942,7 +2942,7 @@
           <a:p>
             <a:fld id="{7D1F2140-8D48-49AC-AD8D-683E6FF4DC34}" type="datetimeFigureOut">
               <a:rPr lang="en-US" smtClean="0"/>
-              <a:t>7/1/2023</a:t>
+              <a:t>7/17/2023</a:t>
             </a:fld>
             <a:endParaRPr lang="en-US"/>
           </a:p>
@@ -3207,7 +3207,7 @@
           <a:p>
             <a:fld id="{7D1F2140-8D48-49AC-AD8D-683E6FF4DC34}" type="datetimeFigureOut">
               <a:rPr lang="en-US" smtClean="0"/>
-              <a:t>7/1/2023</a:t>
+              <a:t>7/17/2023</a:t>
             </a:fld>
             <a:endParaRPr lang="en-US"/>
           </a:p>
@@ -3619,7 +3619,7 @@
           <a:p>
             <a:fld id="{7D1F2140-8D48-49AC-AD8D-683E6FF4DC34}" type="datetimeFigureOut">
               <a:rPr lang="en-US" smtClean="0"/>
-              <a:t>7/1/2023</a:t>
+              <a:t>7/17/2023</a:t>
             </a:fld>
             <a:endParaRPr lang="en-US"/>
           </a:p>
@@ -3760,7 +3760,7 @@
           <a:p>
             <a:fld id="{7D1F2140-8D48-49AC-AD8D-683E6FF4DC34}" type="datetimeFigureOut">
               <a:rPr lang="en-US" smtClean="0"/>
-              <a:t>7/1/2023</a:t>
+              <a:t>7/17/2023</a:t>
             </a:fld>
             <a:endParaRPr lang="en-US"/>
           </a:p>
@@ -3873,7 +3873,7 @@
           <a:p>
             <a:fld id="{7D1F2140-8D48-49AC-AD8D-683E6FF4DC34}" type="datetimeFigureOut">
               <a:rPr lang="en-US" smtClean="0"/>
-              <a:t>7/1/2023</a:t>
+              <a:t>7/17/2023</a:t>
             </a:fld>
             <a:endParaRPr lang="en-US"/>
           </a:p>
@@ -4184,7 +4184,7 @@
           <a:p>
             <a:fld id="{7D1F2140-8D48-49AC-AD8D-683E6FF4DC34}" type="datetimeFigureOut">
               <a:rPr lang="en-US" smtClean="0"/>
-              <a:t>7/1/2023</a:t>
+              <a:t>7/17/2023</a:t>
             </a:fld>
             <a:endParaRPr lang="en-US"/>
           </a:p>
@@ -4472,7 +4472,7 @@
           <a:p>
             <a:fld id="{7D1F2140-8D48-49AC-AD8D-683E6FF4DC34}" type="datetimeFigureOut">
               <a:rPr lang="en-US" smtClean="0"/>
-              <a:t>7/1/2023</a:t>
+              <a:t>7/17/2023</a:t>
             </a:fld>
             <a:endParaRPr lang="en-US"/>
           </a:p>
@@ -4713,7 +4713,7 @@
           <a:p>
             <a:fld id="{7D1F2140-8D48-49AC-AD8D-683E6FF4DC34}" type="datetimeFigureOut">
               <a:rPr lang="en-US" smtClean="0"/>
-              <a:t>7/1/2023</a:t>
+              <a:t>7/17/2023</a:t>
             </a:fld>
             <a:endParaRPr lang="en-US"/>
           </a:p>
@@ -11346,7 +11346,7 @@
                 <a:latin typeface="Courier New" panose="02070309020205020404" pitchFamily="49" charset="0"/>
                 <a:cs typeface="Courier New" panose="02070309020205020404" pitchFamily="49" charset="0"/>
               </a:rPr>
-              <a:t>": “Lkjdchbej236ecec6876edc3evqwx57d2455zefdaa"</a:t>
+              <a:t>": "Lkjdchbej236ecec6876edc3evqwx57d2455zefdaa"</a:t>
             </a:r>
           </a:p>
           <a:p>
@@ -12942,11 +12942,11 @@
   <p:clrMapOvr>
     <a:masterClrMapping/>
   </p:clrMapOvr>
-  <mc:AlternateContent xmlns:mc="http://schemas.openxmlformats.org/markup-compatibility/2006">
-    <mc:Choice xmlns:p14="http://schemas.microsoft.com/office/powerpoint/2010/main" Requires="p14">
+  <mc:AlternateContent xmlns:mc="http://schemas.openxmlformats.org/markup-compatibility/2006" xmlns:p14="http://schemas.microsoft.com/office/powerpoint/2010/main">
+    <mc:Choice Requires="p14">
       <p:transition spd="slow" p14:dur="2000" advTm="320"/>
     </mc:Choice>
-    <mc:Fallback>
+    <mc:Fallback xmlns="">
       <p:transition spd="slow" advTm="320"/>
     </mc:Fallback>
   </mc:AlternateContent>
@@ -13523,11 +13523,11 @@
   <p:clrMapOvr>
     <a:masterClrMapping/>
   </p:clrMapOvr>
-  <mc:AlternateContent xmlns:mc="http://schemas.openxmlformats.org/markup-compatibility/2006">
-    <mc:Choice xmlns:p14="http://schemas.microsoft.com/office/powerpoint/2010/main" Requires="p14">
+  <mc:AlternateContent xmlns:mc="http://schemas.openxmlformats.org/markup-compatibility/2006" xmlns:p14="http://schemas.microsoft.com/office/powerpoint/2010/main">
+    <mc:Choice Requires="p14">
       <p:transition spd="slow" p14:dur="2000" advTm="15232"/>
     </mc:Choice>
-    <mc:Fallback>
+    <mc:Fallback xmlns="">
       <p:transition spd="slow" advTm="15232"/>
     </mc:Fallback>
   </mc:AlternateContent>

</xml_diff>

<commit_message>
WIP. MaxClockOffset and PeeringIssues.
The "Magic Nonce" idea is not dismissed: it will be possible
to support this later since this does not change the protocol:
the only change is in the fact that the Initiator will use a
Magic Nonce instead of a Nonce and that the Listener will
trust it blindly if configured. AutoTrustKey can be used for this:
if not "Never"/"Once"/"Always" then it can be a OTP string from
which a 64 bits nonce is derived.
</commit_message>
<xml_diff>
--- a/Doc/CK-AppIdentity.pptx
+++ b/Doc/CK-AppIdentity.pptx
@@ -5,7 +5,7 @@
     <p:sldMasterId id="2147483648" r:id="rId1"/>
   </p:sldMasterIdLst>
   <p:notesMasterIdLst>
-    <p:notesMasterId r:id="rId47"/>
+    <p:notesMasterId r:id="rId49"/>
   </p:notesMasterIdLst>
   <p:sldIdLst>
     <p:sldId id="256" r:id="rId2"/>
@@ -33,26 +33,28 @@
     <p:sldId id="279" r:id="rId24"/>
     <p:sldId id="280" r:id="rId25"/>
     <p:sldId id="282" r:id="rId26"/>
-    <p:sldId id="281" r:id="rId27"/>
-    <p:sldId id="288" r:id="rId28"/>
-    <p:sldId id="283" r:id="rId29"/>
-    <p:sldId id="304" r:id="rId30"/>
-    <p:sldId id="284" r:id="rId31"/>
-    <p:sldId id="285" r:id="rId32"/>
-    <p:sldId id="286" r:id="rId33"/>
-    <p:sldId id="287" r:id="rId34"/>
-    <p:sldId id="289" r:id="rId35"/>
-    <p:sldId id="290" r:id="rId36"/>
-    <p:sldId id="297" r:id="rId37"/>
-    <p:sldId id="298" r:id="rId38"/>
-    <p:sldId id="299" r:id="rId39"/>
-    <p:sldId id="300" r:id="rId40"/>
-    <p:sldId id="301" r:id="rId41"/>
-    <p:sldId id="302" r:id="rId42"/>
-    <p:sldId id="291" r:id="rId43"/>
-    <p:sldId id="292" r:id="rId44"/>
-    <p:sldId id="294" r:id="rId45"/>
-    <p:sldId id="293" r:id="rId46"/>
+    <p:sldId id="305" r:id="rId27"/>
+    <p:sldId id="281" r:id="rId28"/>
+    <p:sldId id="288" r:id="rId29"/>
+    <p:sldId id="306" r:id="rId30"/>
+    <p:sldId id="283" r:id="rId31"/>
+    <p:sldId id="304" r:id="rId32"/>
+    <p:sldId id="284" r:id="rId33"/>
+    <p:sldId id="285" r:id="rId34"/>
+    <p:sldId id="286" r:id="rId35"/>
+    <p:sldId id="287" r:id="rId36"/>
+    <p:sldId id="289" r:id="rId37"/>
+    <p:sldId id="290" r:id="rId38"/>
+    <p:sldId id="297" r:id="rId39"/>
+    <p:sldId id="298" r:id="rId40"/>
+    <p:sldId id="299" r:id="rId41"/>
+    <p:sldId id="300" r:id="rId42"/>
+    <p:sldId id="301" r:id="rId43"/>
+    <p:sldId id="302" r:id="rId44"/>
+    <p:sldId id="291" r:id="rId45"/>
+    <p:sldId id="292" r:id="rId46"/>
+    <p:sldId id="294" r:id="rId47"/>
+    <p:sldId id="293" r:id="rId48"/>
   </p:sldIdLst>
   <p:sldSz cx="12192000" cy="6858000"/>
   <p:notesSz cx="6858000" cy="9144000"/>
@@ -1037,7 +1039,7 @@
           <a:p>
             <a:fld id="{E05EDB92-2FE2-4164-AA27-D03258A20DF4}" type="slidenum">
               <a:rPr lang="en-US" smtClean="0"/>
-              <a:t>27</a:t>
+              <a:t>28</a:t>
             </a:fld>
             <a:endParaRPr lang="en-US"/>
           </a:p>
@@ -1143,7 +1145,7 @@
           <a:p>
             <a:fld id="{E05EDB92-2FE2-4164-AA27-D03258A20DF4}" type="slidenum">
               <a:rPr lang="en-US" smtClean="0"/>
-              <a:t>28</a:t>
+              <a:t>30</a:t>
             </a:fld>
             <a:endParaRPr lang="en-US"/>
           </a:p>
@@ -1608,7 +1610,7 @@
           <a:p>
             <a:fld id="{E05EDB92-2FE2-4164-AA27-D03258A20DF4}" type="slidenum">
               <a:rPr lang="en-US" smtClean="0"/>
-              <a:t>30</a:t>
+              <a:t>32</a:t>
             </a:fld>
             <a:endParaRPr lang="en-US"/>
           </a:p>
@@ -1813,7 +1815,7 @@
           <a:p>
             <a:fld id="{E05EDB92-2FE2-4164-AA27-D03258A20DF4}" type="slidenum">
               <a:rPr lang="en-US" smtClean="0"/>
-              <a:t>31</a:t>
+              <a:t>33</a:t>
             </a:fld>
             <a:endParaRPr lang="en-US"/>
           </a:p>
@@ -1897,7 +1899,7 @@
           <a:p>
             <a:fld id="{E05EDB92-2FE2-4164-AA27-D03258A20DF4}" type="slidenum">
               <a:rPr lang="en-US" smtClean="0"/>
-              <a:t>33</a:t>
+              <a:t>35</a:t>
             </a:fld>
             <a:endParaRPr lang="en-US"/>
           </a:p>
@@ -14748,6 +14750,115 @@
           <p:cNvPr id="2" name="Title 1">
             <a:extLst>
               <a:ext uri="{FF2B5EF4-FFF2-40B4-BE49-F238E27FC236}">
+                <a16:creationId xmlns:a16="http://schemas.microsoft.com/office/drawing/2014/main" id="{5EBCFA60-C87B-4FE3-EF05-A4AD08BA5E70}"/>
+              </a:ext>
+            </a:extLst>
+          </p:cNvPr>
+          <p:cNvSpPr>
+            <a:spLocks noGrp="1"/>
+          </p:cNvSpPr>
+          <p:nvPr>
+            <p:ph type="title"/>
+          </p:nvPr>
+        </p:nvSpPr>
+        <p:spPr/>
+        <p:txBody>
+          <a:bodyPr/>
+          <a:lstStyle/>
+          <a:p>
+            <a:r>
+              <a:rPr lang="en-US" dirty="0" err="1"/>
+              <a:t>TransportManagerFeature</a:t>
+            </a:r>
+            <a:endParaRPr lang="en-US" dirty="0"/>
+          </a:p>
+        </p:txBody>
+      </p:sp>
+      <p:sp>
+        <p:nvSpPr>
+          <p:cNvPr id="3" name="Content Placeholder 2">
+            <a:extLst>
+              <a:ext uri="{FF2B5EF4-FFF2-40B4-BE49-F238E27FC236}">
+                <a16:creationId xmlns:a16="http://schemas.microsoft.com/office/drawing/2014/main" id="{A66F53C4-7018-24F4-0D95-F239C1AB727A}"/>
+              </a:ext>
+            </a:extLst>
+          </p:cNvPr>
+          <p:cNvSpPr>
+            <a:spLocks noGrp="1"/>
+          </p:cNvSpPr>
+          <p:nvPr>
+            <p:ph idx="1"/>
+          </p:nvPr>
+        </p:nvSpPr>
+        <p:spPr/>
+        <p:txBody>
+          <a:bodyPr/>
+          <a:lstStyle/>
+          <a:p>
+            <a:r>
+              <a:rPr lang="en-US" dirty="0"/>
+              <a:t>Available on the root </a:t>
+            </a:r>
+            <a:r>
+              <a:rPr lang="en-US" dirty="0" err="1"/>
+              <a:t>ApplicationIdentityService</a:t>
+            </a:r>
+            <a:r>
+              <a:rPr lang="en-US" dirty="0"/>
+              <a:t>.</a:t>
+            </a:r>
+          </a:p>
+          <a:p>
+            <a:r>
+              <a:rPr lang="en-US" dirty="0"/>
+              <a:t>Centralizes transport events for all remote’s </a:t>
+            </a:r>
+            <a:r>
+              <a:rPr lang="en-US" dirty="0" err="1"/>
+              <a:t>TransportFeatures</a:t>
+            </a:r>
+            <a:r>
+              <a:rPr lang="en-US" dirty="0"/>
+              <a:t>.</a:t>
+            </a:r>
+          </a:p>
+        </p:txBody>
+      </p:sp>
+    </p:spTree>
+    <p:extLst>
+      <p:ext uri="{BB962C8B-B14F-4D97-AF65-F5344CB8AC3E}">
+        <p14:creationId xmlns:p14="http://schemas.microsoft.com/office/powerpoint/2010/main" val="1878279292"/>
+      </p:ext>
+    </p:extLst>
+  </p:cSld>
+  <p:clrMapOvr>
+    <a:masterClrMapping/>
+  </p:clrMapOvr>
+</p:sld>
+</file>
+
+<file path=ppt/slides/slide27.xml><?xml version="1.0" encoding="utf-8"?>
+<p:sld xmlns:a="http://schemas.openxmlformats.org/drawingml/2006/main" xmlns:r="http://schemas.openxmlformats.org/officeDocument/2006/relationships" xmlns:p="http://schemas.openxmlformats.org/presentationml/2006/main">
+  <p:cSld>
+    <p:spTree>
+      <p:nvGrpSpPr>
+        <p:cNvPr id="1" name=""/>
+        <p:cNvGrpSpPr/>
+        <p:nvPr/>
+      </p:nvGrpSpPr>
+      <p:grpSpPr>
+        <a:xfrm>
+          <a:off x="0" y="0"/>
+          <a:ext cx="0" cy="0"/>
+          <a:chOff x="0" y="0"/>
+          <a:chExt cx="0" cy="0"/>
+        </a:xfrm>
+      </p:grpSpPr>
+      <p:sp>
+        <p:nvSpPr>
+          <p:cNvPr id="2" name="Title 1">
+            <a:extLst>
+              <a:ext uri="{FF2B5EF4-FFF2-40B4-BE49-F238E27FC236}">
                 <a16:creationId xmlns:a16="http://schemas.microsoft.com/office/drawing/2014/main" id="{AB1D9BD9-E7B8-0308-F846-C5AE6E739C5F}"/>
               </a:ext>
             </a:extLst>
@@ -15020,7 +15131,7 @@
 </p:sld>
 </file>
 
-<file path=ppt/slides/slide27.xml><?xml version="1.0" encoding="utf-8"?>
+<file path=ppt/slides/slide28.xml><?xml version="1.0" encoding="utf-8"?>
 <p:sld xmlns:a="http://schemas.openxmlformats.org/drawingml/2006/main" xmlns:r="http://schemas.openxmlformats.org/officeDocument/2006/relationships" xmlns:p="http://schemas.openxmlformats.org/presentationml/2006/main">
   <p:cSld>
     <p:bg>
@@ -15352,175 +15463,6 @@
 </p:sld>
 </file>
 
-<file path=ppt/slides/slide28.xml><?xml version="1.0" encoding="utf-8"?>
-<p:sld xmlns:a="http://schemas.openxmlformats.org/drawingml/2006/main" xmlns:r="http://schemas.openxmlformats.org/officeDocument/2006/relationships" xmlns:p="http://schemas.openxmlformats.org/presentationml/2006/main">
-  <p:cSld>
-    <p:spTree>
-      <p:nvGrpSpPr>
-        <p:cNvPr id="1" name=""/>
-        <p:cNvGrpSpPr/>
-        <p:nvPr/>
-      </p:nvGrpSpPr>
-      <p:grpSpPr>
-        <a:xfrm>
-          <a:off x="0" y="0"/>
-          <a:ext cx="0" cy="0"/>
-          <a:chOff x="0" y="0"/>
-          <a:chExt cx="0" cy="0"/>
-        </a:xfrm>
-      </p:grpSpPr>
-      <p:sp>
-        <p:nvSpPr>
-          <p:cNvPr id="2" name="Title 1">
-            <a:extLst>
-              <a:ext uri="{FF2B5EF4-FFF2-40B4-BE49-F238E27FC236}">
-                <a16:creationId xmlns:a16="http://schemas.microsoft.com/office/drawing/2014/main" id="{E28F16C2-5FE3-B18B-1F5B-429CD7308A94}"/>
-              </a:ext>
-            </a:extLst>
-          </p:cNvPr>
-          <p:cNvSpPr>
-            <a:spLocks noGrp="1"/>
-          </p:cNvSpPr>
-          <p:nvPr>
-            <p:ph type="title"/>
-          </p:nvPr>
-        </p:nvSpPr>
-        <p:spPr/>
-        <p:txBody>
-          <a:bodyPr/>
-          <a:lstStyle/>
-          <a:p>
-            <a:r>
-              <a:rPr lang="en-US" dirty="0"/>
-              <a:t>The Channels</a:t>
-            </a:r>
-          </a:p>
-        </p:txBody>
-      </p:sp>
-      <p:sp>
-        <p:nvSpPr>
-          <p:cNvPr id="3" name="Content Placeholder 2">
-            <a:extLst>
-              <a:ext uri="{FF2B5EF4-FFF2-40B4-BE49-F238E27FC236}">
-                <a16:creationId xmlns:a16="http://schemas.microsoft.com/office/drawing/2014/main" id="{1819622E-A74C-BCB9-B3FA-CB06EC5A3192}"/>
-              </a:ext>
-            </a:extLst>
-          </p:cNvPr>
-          <p:cNvSpPr>
-            <a:spLocks noGrp="1"/>
-          </p:cNvSpPr>
-          <p:nvPr>
-            <p:ph idx="1"/>
-          </p:nvPr>
-        </p:nvSpPr>
-        <p:spPr>
-          <a:xfrm>
-            <a:off x="838199" y="1825625"/>
-            <a:ext cx="10732477" cy="4351338"/>
-          </a:xfrm>
-        </p:spPr>
-        <p:txBody>
-          <a:bodyPr/>
-          <a:lstStyle/>
-          <a:p>
-            <a:r>
-              <a:rPr lang="en-US" dirty="0"/>
-              <a:t>A Remote’s </a:t>
-            </a:r>
-            <a:r>
-              <a:rPr lang="en-US" dirty="0" err="1"/>
-              <a:t>TransportFeature</a:t>
-            </a:r>
-            <a:r>
-              <a:rPr lang="en-US" dirty="0"/>
-              <a:t> handles the transport to the other side.</a:t>
-            </a:r>
-          </a:p>
-          <a:p>
-            <a:pPr lvl="1"/>
-            <a:r>
-              <a:rPr lang="en-US" dirty="0"/>
-              <a:t>Listener vs. Sender is automatically handled based on the configuration.</a:t>
-            </a:r>
-          </a:p>
-          <a:p>
-            <a:pPr lvl="1"/>
-            <a:r>
-              <a:rPr lang="en-US" dirty="0"/>
-              <a:t>The transport technology can be specified. The default is “</a:t>
-            </a:r>
-            <a:r>
-              <a:rPr lang="en-US" dirty="0" err="1"/>
-              <a:t>tcp</a:t>
-            </a:r>
-            <a:r>
-              <a:rPr lang="en-US" dirty="0"/>
-              <a:t>”.</a:t>
-            </a:r>
-          </a:p>
-          <a:p>
-            <a:r>
-              <a:rPr lang="en-US" dirty="0"/>
-              <a:t>The </a:t>
-            </a:r>
-            <a:r>
-              <a:rPr lang="en-US" dirty="0" err="1"/>
-              <a:t>TransportFeatures</a:t>
-            </a:r>
-            <a:r>
-              <a:rPr lang="en-US" dirty="0"/>
-              <a:t> exposes the properties relevant to the communication but is not itself in charge of exchanging data.</a:t>
-            </a:r>
-          </a:p>
-          <a:p>
-            <a:r>
-              <a:rPr lang="en-US" dirty="0"/>
-              <a:t>Channels are Features that implements a protocol and exposes it to the developer.</a:t>
-            </a:r>
-          </a:p>
-          <a:p>
-            <a:r>
-              <a:rPr lang="en-US" dirty="0"/>
-              <a:t>Channels implementation provides:</a:t>
-            </a:r>
-          </a:p>
-          <a:p>
-            <a:pPr lvl="1"/>
-            <a:r>
-              <a:rPr lang="en-US" dirty="0"/>
-              <a:t>A Protocol that can be in multiple versions.</a:t>
-            </a:r>
-          </a:p>
-          <a:p>
-            <a:pPr lvl="1"/>
-            <a:r>
-              <a:rPr lang="en-US" dirty="0"/>
-              <a:t>A way to build and send, receive and parse </a:t>
-            </a:r>
-            <a:r>
-              <a:rPr lang="en-US" dirty="0" err="1"/>
-              <a:t>TransportMessage</a:t>
-            </a:r>
-            <a:r>
-              <a:rPr lang="en-US" dirty="0"/>
-              <a:t> objects.</a:t>
-            </a:r>
-          </a:p>
-        </p:txBody>
-      </p:sp>
-    </p:spTree>
-    <p:extLst>
-      <p:ext uri="{BB962C8B-B14F-4D97-AF65-F5344CB8AC3E}">
-        <p14:creationId xmlns:p14="http://schemas.microsoft.com/office/powerpoint/2010/main" val="857479250"/>
-      </p:ext>
-    </p:extLst>
-  </p:cSld>
-  <p:clrMapOvr>
-    <a:masterClrMapping/>
-  </p:clrMapOvr>
-</p:sld>
-</file>
-
 <file path=ppt/slides/slide29.xml><?xml version="1.0" encoding="utf-8"?>
 <p:sld xmlns:a="http://schemas.openxmlformats.org/drawingml/2006/main" xmlns:r="http://schemas.openxmlformats.org/officeDocument/2006/relationships" xmlns:p="http://schemas.openxmlformats.org/presentationml/2006/main">
   <p:cSld>
@@ -15540,61 +15482,162 @@
       </p:grpSpPr>
       <p:sp>
         <p:nvSpPr>
-          <p:cNvPr id="2" name="Title 1">
+          <p:cNvPr id="4" name="TextBox 3">
             <a:extLst>
               <a:ext uri="{FF2B5EF4-FFF2-40B4-BE49-F238E27FC236}">
-                <a16:creationId xmlns:a16="http://schemas.microsoft.com/office/drawing/2014/main" id="{2ADDEB0D-75FE-A9E7-AE5D-1A00BE2CB4EF}"/>
+                <a16:creationId xmlns:a16="http://schemas.microsoft.com/office/drawing/2014/main" id="{25EFDEFC-B78E-174F-345D-9ADFB3BE02CE}"/>
               </a:ext>
             </a:extLst>
           </p:cNvPr>
-          <p:cNvSpPr>
-            <a:spLocks noGrp="1"/>
-          </p:cNvSpPr>
-          <p:nvPr>
-            <p:ph type="title"/>
-          </p:nvPr>
+          <p:cNvSpPr txBox="1"/>
+          <p:nvPr/>
         </p:nvSpPr>
-        <p:spPr/>
+        <p:spPr>
+          <a:xfrm>
+            <a:off x="409904" y="441435"/>
+            <a:ext cx="932115" cy="369332"/>
+          </a:xfrm>
+          <a:prstGeom prst="rect">
+            <a:avLst/>
+          </a:prstGeom>
+          <a:noFill/>
+        </p:spPr>
         <p:txBody>
-          <a:bodyPr/>
+          <a:bodyPr wrap="none" rtlCol="0">
+            <a:spAutoFit/>
+          </a:bodyPr>
           <a:lstStyle/>
           <a:p>
             <a:r>
               <a:rPr lang="en-US" dirty="0"/>
-              <a:t>UNSTABLE REMAINDER</a:t>
+              <a:t>Initiator</a:t>
             </a:r>
           </a:p>
         </p:txBody>
       </p:sp>
       <p:sp>
         <p:nvSpPr>
-          <p:cNvPr id="3" name="Content Placeholder 2">
+          <p:cNvPr id="5" name="TextBox 4">
             <a:extLst>
               <a:ext uri="{FF2B5EF4-FFF2-40B4-BE49-F238E27FC236}">
-                <a16:creationId xmlns:a16="http://schemas.microsoft.com/office/drawing/2014/main" id="{69BD3F96-4E3A-A64D-A143-5E0F643AB7C5}"/>
+                <a16:creationId xmlns:a16="http://schemas.microsoft.com/office/drawing/2014/main" id="{055BE63A-E765-9A3B-B420-E1D43349F6BD}"/>
               </a:ext>
             </a:extLst>
           </p:cNvPr>
-          <p:cNvSpPr>
-            <a:spLocks noGrp="1"/>
-          </p:cNvSpPr>
-          <p:nvPr>
-            <p:ph idx="1"/>
-          </p:nvPr>
+          <p:cNvSpPr txBox="1"/>
+          <p:nvPr/>
         </p:nvSpPr>
-        <p:spPr/>
+        <p:spPr>
+          <a:xfrm>
+            <a:off x="4939862" y="302935"/>
+            <a:ext cx="3419206" cy="646331"/>
+          </a:xfrm>
+          <a:prstGeom prst="rect">
+            <a:avLst/>
+          </a:prstGeom>
+          <a:noFill/>
+        </p:spPr>
         <p:txBody>
-          <a:bodyPr/>
+          <a:bodyPr wrap="none" rtlCol="0">
+            <a:spAutoFit/>
+          </a:bodyPr>
           <a:lstStyle/>
           <a:p>
-            <a:endParaRPr lang="en-US"/>
+            <a:r>
+              <a:rPr lang="en-US" dirty="0" err="1"/>
+              <a:t>InitialMessage</a:t>
+            </a:r>
+            <a:br>
+              <a:rPr lang="en-US" dirty="0"/>
+            </a:br>
+            <a:r>
+              <a:rPr lang="en-US" dirty="0"/>
+              <a:t>nonce, now, identities/signatures</a:t>
+            </a:r>
+          </a:p>
+        </p:txBody>
+      </p:sp>
+      <p:sp>
+        <p:nvSpPr>
+          <p:cNvPr id="6" name="TextBox 5">
+            <a:extLst>
+              <a:ext uri="{FF2B5EF4-FFF2-40B4-BE49-F238E27FC236}">
+                <a16:creationId xmlns:a16="http://schemas.microsoft.com/office/drawing/2014/main" id="{6355DB36-5851-93F8-DEB3-4574616C41FA}"/>
+              </a:ext>
+            </a:extLst>
+          </p:cNvPr>
+          <p:cNvSpPr txBox="1"/>
+          <p:nvPr/>
+        </p:nvSpPr>
+        <p:spPr>
+          <a:xfrm>
+            <a:off x="409904" y="1555532"/>
+            <a:ext cx="929806" cy="369332"/>
+          </a:xfrm>
+          <a:prstGeom prst="rect">
+            <a:avLst/>
+          </a:prstGeom>
+          <a:noFill/>
+        </p:spPr>
+        <p:txBody>
+          <a:bodyPr wrap="none" rtlCol="0">
+            <a:spAutoFit/>
+          </a:bodyPr>
+          <a:lstStyle/>
+          <a:p>
+            <a:r>
+              <a:rPr lang="en-US" dirty="0"/>
+              <a:t>Listener</a:t>
+            </a:r>
+          </a:p>
+        </p:txBody>
+      </p:sp>
+      <p:sp>
+        <p:nvSpPr>
+          <p:cNvPr id="7" name="TextBox 6">
+            <a:extLst>
+              <a:ext uri="{FF2B5EF4-FFF2-40B4-BE49-F238E27FC236}">
+                <a16:creationId xmlns:a16="http://schemas.microsoft.com/office/drawing/2014/main" id="{DD72CD61-B5C4-4FAA-59FA-A385567C5281}"/>
+              </a:ext>
+            </a:extLst>
+          </p:cNvPr>
+          <p:cNvSpPr txBox="1"/>
+          <p:nvPr/>
+        </p:nvSpPr>
+        <p:spPr>
+          <a:xfrm>
+            <a:off x="4939862" y="1134043"/>
+            <a:ext cx="3419206" cy="646331"/>
+          </a:xfrm>
+          <a:prstGeom prst="rect">
+            <a:avLst/>
+          </a:prstGeom>
+          <a:noFill/>
+        </p:spPr>
+        <p:txBody>
+          <a:bodyPr wrap="none" rtlCol="0">
+            <a:spAutoFit/>
+          </a:bodyPr>
+          <a:lstStyle/>
+          <a:p>
+            <a:r>
+              <a:rPr lang="en-US" dirty="0" err="1"/>
+              <a:t>InitialMessage</a:t>
+            </a:r>
+            <a:br>
+              <a:rPr lang="en-US" dirty="0"/>
+            </a:br>
+            <a:r>
+              <a:rPr lang="en-US" dirty="0"/>
+              <a:t>nonce, now, identities/signatures</a:t>
+            </a:r>
           </a:p>
         </p:txBody>
       </p:sp>
     </p:spTree>
     <p:extLst>
       <p:ext uri="{BB962C8B-B14F-4D97-AF65-F5344CB8AC3E}">
-        <p14:creationId xmlns:p14="http://schemas.microsoft.com/office/powerpoint/2010/main" val="4293717367"/>
+        <p14:creationId xmlns:p14="http://schemas.microsoft.com/office/powerpoint/2010/main" val="390213551"/>
       </p:ext>
     </p:extLst>
   </p:cSld>
@@ -15781,6 +15824,258 @@
           <p:cNvPr id="2" name="Title 1">
             <a:extLst>
               <a:ext uri="{FF2B5EF4-FFF2-40B4-BE49-F238E27FC236}">
+                <a16:creationId xmlns:a16="http://schemas.microsoft.com/office/drawing/2014/main" id="{E28F16C2-5FE3-B18B-1F5B-429CD7308A94}"/>
+              </a:ext>
+            </a:extLst>
+          </p:cNvPr>
+          <p:cNvSpPr>
+            <a:spLocks noGrp="1"/>
+          </p:cNvSpPr>
+          <p:nvPr>
+            <p:ph type="title"/>
+          </p:nvPr>
+        </p:nvSpPr>
+        <p:spPr/>
+        <p:txBody>
+          <a:bodyPr/>
+          <a:lstStyle/>
+          <a:p>
+            <a:r>
+              <a:rPr lang="en-US" dirty="0"/>
+              <a:t>The Channels</a:t>
+            </a:r>
+          </a:p>
+        </p:txBody>
+      </p:sp>
+      <p:sp>
+        <p:nvSpPr>
+          <p:cNvPr id="3" name="Content Placeholder 2">
+            <a:extLst>
+              <a:ext uri="{FF2B5EF4-FFF2-40B4-BE49-F238E27FC236}">
+                <a16:creationId xmlns:a16="http://schemas.microsoft.com/office/drawing/2014/main" id="{1819622E-A74C-BCB9-B3FA-CB06EC5A3192}"/>
+              </a:ext>
+            </a:extLst>
+          </p:cNvPr>
+          <p:cNvSpPr>
+            <a:spLocks noGrp="1"/>
+          </p:cNvSpPr>
+          <p:nvPr>
+            <p:ph idx="1"/>
+          </p:nvPr>
+        </p:nvSpPr>
+        <p:spPr>
+          <a:xfrm>
+            <a:off x="838199" y="1825625"/>
+            <a:ext cx="10732477" cy="4351338"/>
+          </a:xfrm>
+        </p:spPr>
+        <p:txBody>
+          <a:bodyPr/>
+          <a:lstStyle/>
+          <a:p>
+            <a:r>
+              <a:rPr lang="en-US" dirty="0"/>
+              <a:t>A Remote’s </a:t>
+            </a:r>
+            <a:r>
+              <a:rPr lang="en-US" dirty="0" err="1"/>
+              <a:t>TransportFeature</a:t>
+            </a:r>
+            <a:r>
+              <a:rPr lang="en-US" dirty="0"/>
+              <a:t> handles the transport to the other side.</a:t>
+            </a:r>
+          </a:p>
+          <a:p>
+            <a:pPr lvl="1"/>
+            <a:r>
+              <a:rPr lang="en-US" dirty="0"/>
+              <a:t>Listener vs. Sender is automatically handled based on the configuration.</a:t>
+            </a:r>
+          </a:p>
+          <a:p>
+            <a:pPr lvl="1"/>
+            <a:r>
+              <a:rPr lang="en-US" dirty="0"/>
+              <a:t>The transport technology can be specified. The default is “</a:t>
+            </a:r>
+            <a:r>
+              <a:rPr lang="en-US" dirty="0" err="1"/>
+              <a:t>tcp</a:t>
+            </a:r>
+            <a:r>
+              <a:rPr lang="en-US" dirty="0"/>
+              <a:t>”.</a:t>
+            </a:r>
+          </a:p>
+          <a:p>
+            <a:r>
+              <a:rPr lang="en-US" dirty="0"/>
+              <a:t>The </a:t>
+            </a:r>
+            <a:r>
+              <a:rPr lang="en-US" dirty="0" err="1"/>
+              <a:t>TransportFeatures</a:t>
+            </a:r>
+            <a:r>
+              <a:rPr lang="en-US" dirty="0"/>
+              <a:t> exposes the properties relevant to the communication but is not itself in charge of exchanging data.</a:t>
+            </a:r>
+          </a:p>
+          <a:p>
+            <a:r>
+              <a:rPr lang="en-US" dirty="0"/>
+              <a:t>Channels are Features that implements a protocol and exposes it to the developer.</a:t>
+            </a:r>
+          </a:p>
+          <a:p>
+            <a:r>
+              <a:rPr lang="en-US" dirty="0"/>
+              <a:t>Channels implementation provides:</a:t>
+            </a:r>
+          </a:p>
+          <a:p>
+            <a:pPr lvl="1"/>
+            <a:r>
+              <a:rPr lang="en-US" dirty="0"/>
+              <a:t>A Protocol that can be in multiple versions.</a:t>
+            </a:r>
+          </a:p>
+          <a:p>
+            <a:pPr lvl="1"/>
+            <a:r>
+              <a:rPr lang="en-US" dirty="0"/>
+              <a:t>A way to build and send, receive and parse </a:t>
+            </a:r>
+            <a:r>
+              <a:rPr lang="en-US" dirty="0" err="1"/>
+              <a:t>TransportMessage</a:t>
+            </a:r>
+            <a:r>
+              <a:rPr lang="en-US" dirty="0"/>
+              <a:t> objects.</a:t>
+            </a:r>
+          </a:p>
+        </p:txBody>
+      </p:sp>
+    </p:spTree>
+    <p:extLst>
+      <p:ext uri="{BB962C8B-B14F-4D97-AF65-F5344CB8AC3E}">
+        <p14:creationId xmlns:p14="http://schemas.microsoft.com/office/powerpoint/2010/main" val="857479250"/>
+      </p:ext>
+    </p:extLst>
+  </p:cSld>
+  <p:clrMapOvr>
+    <a:masterClrMapping/>
+  </p:clrMapOvr>
+</p:sld>
+</file>
+
+<file path=ppt/slides/slide31.xml><?xml version="1.0" encoding="utf-8"?>
+<p:sld xmlns:a="http://schemas.openxmlformats.org/drawingml/2006/main" xmlns:r="http://schemas.openxmlformats.org/officeDocument/2006/relationships" xmlns:p="http://schemas.openxmlformats.org/presentationml/2006/main">
+  <p:cSld>
+    <p:spTree>
+      <p:nvGrpSpPr>
+        <p:cNvPr id="1" name=""/>
+        <p:cNvGrpSpPr/>
+        <p:nvPr/>
+      </p:nvGrpSpPr>
+      <p:grpSpPr>
+        <a:xfrm>
+          <a:off x="0" y="0"/>
+          <a:ext cx="0" cy="0"/>
+          <a:chOff x="0" y="0"/>
+          <a:chExt cx="0" cy="0"/>
+        </a:xfrm>
+      </p:grpSpPr>
+      <p:sp>
+        <p:nvSpPr>
+          <p:cNvPr id="2" name="Title 1">
+            <a:extLst>
+              <a:ext uri="{FF2B5EF4-FFF2-40B4-BE49-F238E27FC236}">
+                <a16:creationId xmlns:a16="http://schemas.microsoft.com/office/drawing/2014/main" id="{2ADDEB0D-75FE-A9E7-AE5D-1A00BE2CB4EF}"/>
+              </a:ext>
+            </a:extLst>
+          </p:cNvPr>
+          <p:cNvSpPr>
+            <a:spLocks noGrp="1"/>
+          </p:cNvSpPr>
+          <p:nvPr>
+            <p:ph type="title"/>
+          </p:nvPr>
+        </p:nvSpPr>
+        <p:spPr/>
+        <p:txBody>
+          <a:bodyPr/>
+          <a:lstStyle/>
+          <a:p>
+            <a:r>
+              <a:rPr lang="en-US" dirty="0"/>
+              <a:t>UNSTABLE REMAINDER</a:t>
+            </a:r>
+          </a:p>
+        </p:txBody>
+      </p:sp>
+      <p:sp>
+        <p:nvSpPr>
+          <p:cNvPr id="3" name="Content Placeholder 2">
+            <a:extLst>
+              <a:ext uri="{FF2B5EF4-FFF2-40B4-BE49-F238E27FC236}">
+                <a16:creationId xmlns:a16="http://schemas.microsoft.com/office/drawing/2014/main" id="{69BD3F96-4E3A-A64D-A143-5E0F643AB7C5}"/>
+              </a:ext>
+            </a:extLst>
+          </p:cNvPr>
+          <p:cNvSpPr>
+            <a:spLocks noGrp="1"/>
+          </p:cNvSpPr>
+          <p:nvPr>
+            <p:ph idx="1"/>
+          </p:nvPr>
+        </p:nvSpPr>
+        <p:spPr/>
+        <p:txBody>
+          <a:bodyPr/>
+          <a:lstStyle/>
+          <a:p>
+            <a:endParaRPr lang="en-US"/>
+          </a:p>
+        </p:txBody>
+      </p:sp>
+    </p:spTree>
+    <p:extLst>
+      <p:ext uri="{BB962C8B-B14F-4D97-AF65-F5344CB8AC3E}">
+        <p14:creationId xmlns:p14="http://schemas.microsoft.com/office/powerpoint/2010/main" val="4293717367"/>
+      </p:ext>
+    </p:extLst>
+  </p:cSld>
+  <p:clrMapOvr>
+    <a:masterClrMapping/>
+  </p:clrMapOvr>
+</p:sld>
+</file>
+
+<file path=ppt/slides/slide32.xml><?xml version="1.0" encoding="utf-8"?>
+<p:sld xmlns:a="http://schemas.openxmlformats.org/drawingml/2006/main" xmlns:r="http://schemas.openxmlformats.org/officeDocument/2006/relationships" xmlns:p="http://schemas.openxmlformats.org/presentationml/2006/main">
+  <p:cSld>
+    <p:spTree>
+      <p:nvGrpSpPr>
+        <p:cNvPr id="1" name=""/>
+        <p:cNvGrpSpPr/>
+        <p:nvPr/>
+      </p:nvGrpSpPr>
+      <p:grpSpPr>
+        <a:xfrm>
+          <a:off x="0" y="0"/>
+          <a:ext cx="0" cy="0"/>
+          <a:chOff x="0" y="0"/>
+          <a:chExt cx="0" cy="0"/>
+        </a:xfrm>
+      </p:grpSpPr>
+      <p:sp>
+        <p:nvSpPr>
+          <p:cNvPr id="2" name="Title 1">
+            <a:extLst>
+              <a:ext uri="{FF2B5EF4-FFF2-40B4-BE49-F238E27FC236}">
                 <a16:creationId xmlns:a16="http://schemas.microsoft.com/office/drawing/2014/main" id="{D234F961-5C07-CC54-4D89-C39917A7A683}"/>
               </a:ext>
             </a:extLst>
@@ -16191,7 +16486,7 @@
 </p:sld>
 </file>
 
-<file path=ppt/slides/slide31.xml><?xml version="1.0" encoding="utf-8"?>
+<file path=ppt/slides/slide33.xml><?xml version="1.0" encoding="utf-8"?>
 <p:sld xmlns:a="http://schemas.openxmlformats.org/drawingml/2006/main" xmlns:r="http://schemas.openxmlformats.org/officeDocument/2006/relationships" xmlns:p="http://schemas.openxmlformats.org/presentationml/2006/main">
   <p:cSld>
     <p:spTree>
@@ -16336,7 +16631,7 @@
 </p:sld>
 </file>
 
-<file path=ppt/slides/slide32.xml><?xml version="1.0" encoding="utf-8"?>
+<file path=ppt/slides/slide34.xml><?xml version="1.0" encoding="utf-8"?>
 <p:sld xmlns:a="http://schemas.openxmlformats.org/drawingml/2006/main" xmlns:r="http://schemas.openxmlformats.org/officeDocument/2006/relationships" xmlns:p="http://schemas.openxmlformats.org/presentationml/2006/main">
   <p:cSld>
     <p:spTree>
@@ -17055,7 +17350,7 @@
 </p:sld>
 </file>
 
-<file path=ppt/slides/slide33.xml><?xml version="1.0" encoding="utf-8"?>
+<file path=ppt/slides/slide35.xml><?xml version="1.0" encoding="utf-8"?>
 <p:sld xmlns:a="http://schemas.openxmlformats.org/drawingml/2006/main" xmlns:r="http://schemas.openxmlformats.org/officeDocument/2006/relationships" xmlns:p="http://schemas.openxmlformats.org/presentationml/2006/main">
   <p:cSld>
     <p:spTree>
@@ -17776,7 +18071,7 @@
 </p:sld>
 </file>
 
-<file path=ppt/slides/slide34.xml><?xml version="1.0" encoding="utf-8"?>
+<file path=ppt/slides/slide36.xml><?xml version="1.0" encoding="utf-8"?>
 <p:sld xmlns:a="http://schemas.openxmlformats.org/drawingml/2006/main" xmlns:r="http://schemas.openxmlformats.org/officeDocument/2006/relationships" xmlns:p="http://schemas.openxmlformats.org/presentationml/2006/main">
   <p:cSld>
     <p:spTree>
@@ -18110,7 +18405,7 @@
 </p:sld>
 </file>
 
-<file path=ppt/slides/slide35.xml><?xml version="1.0" encoding="utf-8"?>
+<file path=ppt/slides/slide37.xml><?xml version="1.0" encoding="utf-8"?>
 <p:sld xmlns:a="http://schemas.openxmlformats.org/drawingml/2006/main" xmlns:r="http://schemas.openxmlformats.org/officeDocument/2006/relationships" xmlns:p="http://schemas.openxmlformats.org/presentationml/2006/main">
   <p:cSld>
     <p:spTree>
@@ -18341,7 +18636,7 @@
 </p:sld>
 </file>
 
-<file path=ppt/slides/slide36.xml><?xml version="1.0" encoding="utf-8"?>
+<file path=ppt/slides/slide38.xml><?xml version="1.0" encoding="utf-8"?>
 <p:sld xmlns:a="http://schemas.openxmlformats.org/drawingml/2006/main" xmlns:r="http://schemas.openxmlformats.org/officeDocument/2006/relationships" xmlns:p="http://schemas.openxmlformats.org/presentationml/2006/main">
   <p:cSld>
     <p:spTree>
@@ -18580,367 +18875,6 @@
     <p:extLst>
       <p:ext uri="{BB962C8B-B14F-4D97-AF65-F5344CB8AC3E}">
         <p14:creationId xmlns:p14="http://schemas.microsoft.com/office/powerpoint/2010/main" val="3523950704"/>
-      </p:ext>
-    </p:extLst>
-  </p:cSld>
-  <p:clrMapOvr>
-    <a:masterClrMapping/>
-  </p:clrMapOvr>
-</p:sld>
-</file>
-
-<file path=ppt/slides/slide37.xml><?xml version="1.0" encoding="utf-8"?>
-<p:sld xmlns:a="http://schemas.openxmlformats.org/drawingml/2006/main" xmlns:r="http://schemas.openxmlformats.org/officeDocument/2006/relationships" xmlns:p="http://schemas.openxmlformats.org/presentationml/2006/main">
-  <p:cSld>
-    <p:spTree>
-      <p:nvGrpSpPr>
-        <p:cNvPr id="1" name=""/>
-        <p:cNvGrpSpPr/>
-        <p:nvPr/>
-      </p:nvGrpSpPr>
-      <p:grpSpPr>
-        <a:xfrm>
-          <a:off x="0" y="0"/>
-          <a:ext cx="0" cy="0"/>
-          <a:chOff x="0" y="0"/>
-          <a:chExt cx="0" cy="0"/>
-        </a:xfrm>
-      </p:grpSpPr>
-      <p:sp>
-        <p:nvSpPr>
-          <p:cNvPr id="2" name="Title 1">
-            <a:extLst>
-              <a:ext uri="{FF2B5EF4-FFF2-40B4-BE49-F238E27FC236}">
-                <a16:creationId xmlns:a16="http://schemas.microsoft.com/office/drawing/2014/main" id="{3C7698CC-396A-8454-36E2-A15EC4E6F4C6}"/>
-              </a:ext>
-            </a:extLst>
-          </p:cNvPr>
-          <p:cNvSpPr>
-            <a:spLocks noGrp="1"/>
-          </p:cNvSpPr>
-          <p:nvPr>
-            <p:ph type="title"/>
-          </p:nvPr>
-        </p:nvSpPr>
-        <p:spPr/>
-        <p:txBody>
-          <a:bodyPr/>
-          <a:lstStyle/>
-          <a:p>
-            <a:r>
-              <a:rPr lang="en-US" dirty="0"/>
-              <a:t>User and Commands through Parties (1/2)</a:t>
-            </a:r>
-          </a:p>
-        </p:txBody>
-      </p:sp>
-      <p:sp>
-        <p:nvSpPr>
-          <p:cNvPr id="3" name="Content Placeholder 2">
-            <a:extLst>
-              <a:ext uri="{FF2B5EF4-FFF2-40B4-BE49-F238E27FC236}">
-                <a16:creationId xmlns:a16="http://schemas.microsoft.com/office/drawing/2014/main" id="{4C31C601-D62B-370A-E39E-2DF1FE415FBB}"/>
-              </a:ext>
-            </a:extLst>
-          </p:cNvPr>
-          <p:cNvSpPr>
-            <a:spLocks noGrp="1"/>
-          </p:cNvSpPr>
-          <p:nvPr>
-            <p:ph idx="1"/>
-          </p:nvPr>
-        </p:nvSpPr>
-        <p:spPr/>
-        <p:txBody>
-          <a:bodyPr>
-            <a:normAutofit/>
-          </a:bodyPr>
-          <a:lstStyle/>
-          <a:p>
-            <a:r>
-              <a:rPr lang="en-US" dirty="0"/>
-              <a:t>“$Trolley1” can send an Authenticated Command to “$Box” in the name of (Alice,3712).</a:t>
-            </a:r>
-          </a:p>
-          <a:p>
-            <a:r>
-              <a:rPr lang="en-US" dirty="0"/>
-              <a:t>“$Trolley1” must provide a proof to “$Box” that Alice is the “real” Alice (otherwise the Authenticated Command will be rejected).</a:t>
-            </a:r>
-          </a:p>
-          <a:p>
-            <a:r>
-              <a:rPr lang="en-US" dirty="0"/>
-              <a:t>“$Trolley1” must first obtain this proof by:</a:t>
-            </a:r>
-          </a:p>
-          <a:p>
-            <a:pPr lvl="1"/>
-            <a:r>
-              <a:rPr lang="en-US" dirty="0"/>
-              <a:t>Let Alice logins herself into a “Central User Directory” shared with “$Box”</a:t>
-            </a:r>
-          </a:p>
-          <a:p>
-            <a:pPr lvl="1"/>
-            <a:r>
-              <a:rPr lang="en-US" dirty="0"/>
-              <a:t>The proof must be Alice’s </a:t>
-            </a:r>
-            <a:r>
-              <a:rPr lang="en-US" dirty="0" err="1"/>
-              <a:t>IAuthenticationInfo</a:t>
-            </a:r>
-            <a:r>
-              <a:rPr lang="en-US" dirty="0"/>
-              <a:t> and a digital signature.</a:t>
-            </a:r>
-          </a:p>
-          <a:p>
-            <a:pPr lvl="1"/>
-            <a:r>
-              <a:rPr lang="en-US" dirty="0"/>
-              <a:t>“$Box” can verify that the signature has been generated by the “Central User Directory” for “$Trolley1” and that the </a:t>
-            </a:r>
-            <a:r>
-              <a:rPr lang="en-US" dirty="0" err="1"/>
-              <a:t>IAuthenticationInfo</a:t>
-            </a:r>
-            <a:r>
-              <a:rPr lang="en-US" dirty="0"/>
-              <a:t> has not been tampered.</a:t>
-            </a:r>
-          </a:p>
-        </p:txBody>
-      </p:sp>
-    </p:spTree>
-    <p:extLst>
-      <p:ext uri="{BB962C8B-B14F-4D97-AF65-F5344CB8AC3E}">
-        <p14:creationId xmlns:p14="http://schemas.microsoft.com/office/powerpoint/2010/main" val="973874681"/>
-      </p:ext>
-    </p:extLst>
-  </p:cSld>
-  <p:clrMapOvr>
-    <a:masterClrMapping/>
-  </p:clrMapOvr>
-</p:sld>
-</file>
-
-<file path=ppt/slides/slide38.xml><?xml version="1.0" encoding="utf-8"?>
-<p:sld xmlns:a="http://schemas.openxmlformats.org/drawingml/2006/main" xmlns:r="http://schemas.openxmlformats.org/officeDocument/2006/relationships" xmlns:p="http://schemas.openxmlformats.org/presentationml/2006/main">
-  <p:cSld>
-    <p:spTree>
-      <p:nvGrpSpPr>
-        <p:cNvPr id="1" name=""/>
-        <p:cNvGrpSpPr/>
-        <p:nvPr/>
-      </p:nvGrpSpPr>
-      <p:grpSpPr>
-        <a:xfrm>
-          <a:off x="0" y="0"/>
-          <a:ext cx="0" cy="0"/>
-          <a:chOff x="0" y="0"/>
-          <a:chExt cx="0" cy="0"/>
-        </a:xfrm>
-      </p:grpSpPr>
-      <p:sp>
-        <p:nvSpPr>
-          <p:cNvPr id="2" name="Title 1">
-            <a:extLst>
-              <a:ext uri="{FF2B5EF4-FFF2-40B4-BE49-F238E27FC236}">
-                <a16:creationId xmlns:a16="http://schemas.microsoft.com/office/drawing/2014/main" id="{C22CBFFE-4E3A-2E51-3538-8811F1401233}"/>
-              </a:ext>
-            </a:extLst>
-          </p:cNvPr>
-          <p:cNvSpPr>
-            <a:spLocks noGrp="1"/>
-          </p:cNvSpPr>
-          <p:nvPr>
-            <p:ph type="title"/>
-          </p:nvPr>
-        </p:nvSpPr>
-        <p:spPr/>
-        <p:txBody>
-          <a:bodyPr/>
-          <a:lstStyle/>
-          <a:p>
-            <a:r>
-              <a:rPr lang="en-US" dirty="0"/>
-              <a:t>User and Commands through Parties (2/2)	</a:t>
-            </a:r>
-          </a:p>
-        </p:txBody>
-      </p:sp>
-      <p:sp>
-        <p:nvSpPr>
-          <p:cNvPr id="3" name="Content Placeholder 2">
-            <a:extLst>
-              <a:ext uri="{FF2B5EF4-FFF2-40B4-BE49-F238E27FC236}">
-                <a16:creationId xmlns:a16="http://schemas.microsoft.com/office/drawing/2014/main" id="{D2F4F95B-3516-EFB7-2D85-F2244EED81A5}"/>
-              </a:ext>
-            </a:extLst>
-          </p:cNvPr>
-          <p:cNvSpPr>
-            <a:spLocks noGrp="1"/>
-          </p:cNvSpPr>
-          <p:nvPr>
-            <p:ph idx="1"/>
-          </p:nvPr>
-        </p:nvSpPr>
-        <p:spPr>
-          <a:xfrm>
-            <a:off x="838200" y="1825624"/>
-            <a:ext cx="10515600" cy="4667251"/>
-          </a:xfrm>
-        </p:spPr>
-        <p:txBody>
-          <a:bodyPr>
-            <a:normAutofit fontScale="92500" lnSpcReduction="20000"/>
-          </a:bodyPr>
-          <a:lstStyle/>
-          <a:p>
-            <a:r>
-              <a:rPr lang="en-US" dirty="0"/>
-              <a:t>When “$Trolley1” sends a Command in the name of Alice to “$Box”…</a:t>
-            </a:r>
-          </a:p>
-          <a:p>
-            <a:pPr lvl="1"/>
-            <a:r>
-              <a:rPr lang="en-US" dirty="0"/>
-              <a:t>it also sends the proof.</a:t>
-            </a:r>
-          </a:p>
-          <a:p>
-            <a:r>
-              <a:rPr lang="en-US" dirty="0"/>
-              <a:t>“$Box” </a:t>
-            </a:r>
-            <a:r>
-              <a:rPr lang="en-US" dirty="0" err="1"/>
-              <a:t>AppIdentity’s</a:t>
-            </a:r>
-            <a:r>
-              <a:rPr lang="en-US" dirty="0"/>
-              <a:t> endpoint receives the command and the proof.</a:t>
-            </a:r>
-          </a:p>
-          <a:p>
-            <a:pPr lvl="1"/>
-            <a:r>
-              <a:rPr lang="en-US" dirty="0"/>
-              <a:t>It builds a “</a:t>
-            </a:r>
-            <a:r>
-              <a:rPr lang="en-US" dirty="0" err="1"/>
-              <a:t>ScopedData</a:t>
-            </a:r>
-            <a:r>
-              <a:rPr lang="en-US" dirty="0"/>
-              <a:t>” with the proof and the fact that it is “$Trolley1” that sent the command.</a:t>
-            </a:r>
-          </a:p>
-          <a:p>
-            <a:pPr lvl="1"/>
-            <a:r>
-              <a:rPr lang="en-US" dirty="0"/>
-              <a:t>Its Endpoint is configured to resolve the </a:t>
-            </a:r>
-            <a:r>
-              <a:rPr lang="en-US" dirty="0" err="1"/>
-              <a:t>IAuthenticationInfo</a:t>
-            </a:r>
-            <a:r>
-              <a:rPr lang="en-US" dirty="0"/>
-              <a:t> service by:</a:t>
-            </a:r>
-          </a:p>
-          <a:p>
-            <a:pPr lvl="2"/>
-            <a:r>
-              <a:rPr lang="en-US" dirty="0"/>
-              <a:t>Accessing the </a:t>
-            </a:r>
-            <a:r>
-              <a:rPr lang="en-US" dirty="0" err="1"/>
-              <a:t>ScopedData’s</a:t>
-            </a:r>
-            <a:r>
-              <a:rPr lang="en-US" dirty="0"/>
-              <a:t> proof and sender.</a:t>
-            </a:r>
-          </a:p>
-          <a:p>
-            <a:pPr lvl="2"/>
-            <a:r>
-              <a:rPr lang="en-US" dirty="0"/>
-              <a:t>Verifying the signature and on success, returns the </a:t>
-            </a:r>
-            <a:r>
-              <a:rPr lang="en-US" dirty="0" err="1"/>
-              <a:t>IAuthenticationInfo</a:t>
-            </a:r>
-            <a:r>
-              <a:rPr lang="en-US" dirty="0"/>
-              <a:t>.</a:t>
-            </a:r>
-          </a:p>
-          <a:p>
-            <a:r>
-              <a:rPr lang="en-US" dirty="0"/>
-              <a:t>“$Box” validates and executes the command</a:t>
-            </a:r>
-          </a:p>
-          <a:p>
-            <a:pPr lvl="1"/>
-            <a:r>
-              <a:rPr lang="en-US" dirty="0"/>
-              <a:t>Commands are executed in the background by runners in a scoped service container parametrized with the </a:t>
-            </a:r>
-            <a:r>
-              <a:rPr lang="en-US" dirty="0" err="1"/>
-              <a:t>ScopedData</a:t>
-            </a:r>
-            <a:r>
-              <a:rPr lang="en-US" dirty="0"/>
-              <a:t>.</a:t>
-            </a:r>
-          </a:p>
-          <a:p>
-            <a:pPr lvl="1"/>
-            <a:r>
-              <a:rPr lang="en-US" dirty="0"/>
-              <a:t>If any service involved in the validation or execution of the command requires the </a:t>
-            </a:r>
-            <a:r>
-              <a:rPr lang="en-US" dirty="0" err="1"/>
-              <a:t>IAuthenticationInfo</a:t>
-            </a:r>
-            <a:r>
-              <a:rPr lang="en-US" dirty="0"/>
-              <a:t>, it is resolved.</a:t>
-            </a:r>
-          </a:p>
-          <a:p>
-            <a:pPr lvl="1"/>
-            <a:r>
-              <a:rPr lang="en-US" dirty="0"/>
-              <a:t>Command execution outcomes (Validation result, events and result) are sent back to “$Trolley1”</a:t>
-            </a:r>
-          </a:p>
-          <a:p>
-            <a:pPr lvl="1"/>
-            <a:endParaRPr lang="en-US" dirty="0"/>
-          </a:p>
-          <a:p>
-            <a:endParaRPr lang="en-US" dirty="0"/>
-          </a:p>
-        </p:txBody>
-      </p:sp>
-    </p:spTree>
-    <p:extLst>
-      <p:ext uri="{BB962C8B-B14F-4D97-AF65-F5344CB8AC3E}">
-        <p14:creationId xmlns:p14="http://schemas.microsoft.com/office/powerpoint/2010/main" val="2929531232"/>
       </p:ext>
     </p:extLst>
   </p:cSld>
@@ -18972,7 +18906,7 @@
           <p:cNvPr id="2" name="Title 1">
             <a:extLst>
               <a:ext uri="{FF2B5EF4-FFF2-40B4-BE49-F238E27FC236}">
-                <a16:creationId xmlns:a16="http://schemas.microsoft.com/office/drawing/2014/main" id="{F028D4AF-53E9-FC4C-72A8-AAC9BDAA1F0D}"/>
+                <a16:creationId xmlns:a16="http://schemas.microsoft.com/office/drawing/2014/main" id="{3C7698CC-396A-8454-36E2-A15EC4E6F4C6}"/>
               </a:ext>
             </a:extLst>
           </p:cNvPr>
@@ -18990,15 +18924,7 @@
           <a:p>
             <a:r>
               <a:rPr lang="en-US" dirty="0"/>
-              <a:t>The “</a:t>
-            </a:r>
-            <a:r>
-              <a:rPr lang="en-US" dirty="0" err="1"/>
-              <a:t>PartyAuthenticationToken</a:t>
-            </a:r>
-            <a:r>
-              <a:rPr lang="en-US" dirty="0"/>
-              <a:t>”</a:t>
+              <a:t>User and Commands through Parties (1/2)</a:t>
             </a:r>
           </a:p>
         </p:txBody>
@@ -19008,7 +18934,7 @@
           <p:cNvPr id="3" name="Content Placeholder 2">
             <a:extLst>
               <a:ext uri="{FF2B5EF4-FFF2-40B4-BE49-F238E27FC236}">
-                <a16:creationId xmlns:a16="http://schemas.microsoft.com/office/drawing/2014/main" id="{5898F5DD-D01F-FADF-46B5-1C37122F4589}"/>
+                <a16:creationId xmlns:a16="http://schemas.microsoft.com/office/drawing/2014/main" id="{4C31C601-D62B-370A-E39E-2DF1FE415FBB}"/>
               </a:ext>
             </a:extLst>
           </p:cNvPr>
@@ -19022,36 +18948,39 @@
         <p:spPr/>
         <p:txBody>
           <a:bodyPr>
-            <a:normAutofit fontScale="92500" lnSpcReduction="20000"/>
+            <a:normAutofit/>
           </a:bodyPr>
           <a:lstStyle/>
           <a:p>
             <a:r>
               <a:rPr lang="en-US" dirty="0"/>
-              <a:t>Contains at least (</a:t>
-            </a:r>
-            <a:r>
-              <a:rPr lang="en-US" dirty="0" err="1"/>
-              <a:t>OpenId</a:t>
-            </a:r>
-            <a:r>
-              <a:rPr lang="en-US" dirty="0"/>
-              <a:t> compliant)</a:t>
+              <a:t>“$Trolley1” can send an Authenticated Command to “$Box” in the name of (Alice,3712).</a:t>
+            </a:r>
+          </a:p>
+          <a:p>
+            <a:r>
+              <a:rPr lang="en-US" dirty="0"/>
+              <a:t>“$Trolley1” must provide a proof to “$Box” that Alice is the “real” Alice (otherwise the Authenticated Command will be rejected).</a:t>
+            </a:r>
+          </a:p>
+          <a:p>
+            <a:r>
+              <a:rPr lang="en-US" dirty="0"/>
+              <a:t>“$Trolley1” must first obtain this proof by:</a:t>
             </a:r>
           </a:p>
           <a:p>
             <a:pPr lvl="1"/>
             <a:r>
               <a:rPr lang="en-US" dirty="0"/>
-              <a:t>The </a:t>
-            </a:r>
-            <a:r>
-              <a:rPr lang="en-US" b="1" dirty="0"/>
-              <a:t>sub</a:t>
-            </a:r>
-            <a:r>
-              <a:rPr lang="en-US" dirty="0"/>
-              <a:t>ject: the </a:t>
+              <a:t>Let Alice logins herself into a “Central User Directory” shared with “$Box”</a:t>
+            </a:r>
+          </a:p>
+          <a:p>
+            <a:pPr lvl="1"/>
+            <a:r>
+              <a:rPr lang="en-US" dirty="0"/>
+              <a:t>The proof must be Alice’s </a:t>
             </a:r>
             <a:r>
               <a:rPr lang="en-US" dirty="0" err="1"/>
@@ -19059,163 +18988,30 @@
             </a:r>
             <a:r>
               <a:rPr lang="en-US" dirty="0"/>
-              <a:t> </a:t>
-            </a:r>
-          </a:p>
-          <a:p>
-            <a:pPr lvl="2"/>
-            <a:r>
-              <a:rPr lang="en-US" dirty="0"/>
-              <a:t>with its </a:t>
+              <a:t> and a digital signature.</a:t>
+            </a:r>
+          </a:p>
+          <a:p>
+            <a:pPr lvl="1"/>
+            <a:r>
+              <a:rPr lang="en-US" dirty="0"/>
+              <a:t>“$Box” can verify that the signature has been generated by the “Central User Directory” for “$Trolley1” and that the </a:t>
             </a:r>
             <a:r>
               <a:rPr lang="en-US" dirty="0" err="1"/>
-              <a:t>CriticalExpires</a:t>
-            </a:r>
-            <a:r>
-              <a:rPr lang="en-US" dirty="0"/>
-              <a:t> and </a:t>
-            </a:r>
-            <a:r>
-              <a:rPr lang="en-US" b="1" dirty="0"/>
-              <a:t>Exp</a:t>
-            </a:r>
-            <a:r>
-              <a:rPr lang="en-US" dirty="0"/>
-              <a:t>ires dates).</a:t>
-            </a:r>
-          </a:p>
-          <a:p>
-            <a:pPr lvl="1"/>
-            <a:r>
-              <a:rPr lang="en-US" dirty="0"/>
-              <a:t>The </a:t>
-            </a:r>
-            <a:r>
-              <a:rPr lang="en-US" b="1" dirty="0"/>
-              <a:t>iss</a:t>
-            </a:r>
-            <a:r>
-              <a:rPr lang="en-US" dirty="0"/>
-              <a:t>uer: the “Central User Directory” identity full name.</a:t>
-            </a:r>
-          </a:p>
-          <a:p>
-            <a:pPr lvl="1"/>
-            <a:r>
-              <a:rPr lang="en-US" b="1" dirty="0"/>
-              <a:t>alg</a:t>
-            </a:r>
-            <a:r>
-              <a:rPr lang="en-US" dirty="0"/>
-              <a:t>orithm and key size should be decided and fixed (best practice – may be overridden later).</a:t>
-            </a:r>
-          </a:p>
-          <a:p>
-            <a:r>
-              <a:rPr lang="en-US" dirty="0"/>
-              <a:t>Options (more </a:t>
-            </a:r>
-            <a:r>
-              <a:rPr lang="en-US" dirty="0" err="1"/>
-              <a:t>Oauth</a:t>
-            </a:r>
-            <a:r>
-              <a:rPr lang="en-US" dirty="0"/>
-              <a:t> than </a:t>
-            </a:r>
-            <a:r>
-              <a:rPr lang="en-US" dirty="0" err="1"/>
-              <a:t>OpenId</a:t>
-            </a:r>
-            <a:r>
-              <a:rPr lang="en-US" dirty="0"/>
-              <a:t>)</a:t>
-            </a:r>
-          </a:p>
-          <a:p>
-            <a:pPr lvl="1"/>
-            <a:r>
-              <a:rPr lang="en-US" dirty="0"/>
-              <a:t>The </a:t>
-            </a:r>
-            <a:r>
-              <a:rPr lang="en-US" b="1" dirty="0"/>
-              <a:t>aud</a:t>
-            </a:r>
-            <a:r>
-              <a:rPr lang="en-US" dirty="0"/>
-              <a:t>ience: the “$Box” identity full name.</a:t>
-            </a:r>
-          </a:p>
-          <a:p>
-            <a:pPr lvl="1"/>
-            <a:r>
-              <a:rPr lang="en-US" dirty="0"/>
-              <a:t>“client” or “origin”: the “$Trolley1” identity full name to which the token has been delivered.</a:t>
-            </a:r>
-          </a:p>
-          <a:p>
-            <a:r>
-              <a:rPr lang="en-US" dirty="0"/>
-              <a:t>Open questions</a:t>
-            </a:r>
-          </a:p>
-          <a:p>
-            <a:pPr lvl="1"/>
-            <a:r>
-              <a:rPr lang="en-US" dirty="0"/>
-              <a:t>“issued at” (</a:t>
-            </a:r>
-            <a:r>
-              <a:rPr lang="en-US" b="1" dirty="0" err="1"/>
-              <a:t>iat</a:t>
-            </a:r>
-            <a:r>
-              <a:rPr lang="en-US" dirty="0"/>
-              <a:t>).</a:t>
-            </a:r>
-          </a:p>
-          <a:p>
-            <a:pPr lvl="1"/>
-            <a:r>
-              <a:rPr lang="en-US" dirty="0"/>
-              <a:t>“not before” (</a:t>
-            </a:r>
-            <a:r>
-              <a:rPr lang="en-US" b="1" dirty="0" err="1"/>
-              <a:t>nbf</a:t>
-            </a:r>
-            <a:r>
-              <a:rPr lang="en-US" dirty="0"/>
-              <a:t>).</a:t>
-            </a:r>
-          </a:p>
-          <a:p>
-            <a:pPr lvl="1"/>
-            <a:r>
-              <a:rPr lang="en-US" dirty="0"/>
-              <a:t>Key identifier (</a:t>
-            </a:r>
-            <a:r>
-              <a:rPr lang="en-US" b="1" dirty="0"/>
-              <a:t>kid</a:t>
-            </a:r>
-            <a:r>
-              <a:rPr lang="en-US" dirty="0"/>
-              <a:t>) or not.</a:t>
-            </a:r>
-          </a:p>
-          <a:p>
-            <a:pPr lvl="1"/>
-            <a:endParaRPr lang="en-US" dirty="0"/>
+              <a:t>IAuthenticationInfo</a:t>
+            </a:r>
+            <a:r>
+              <a:rPr lang="en-US" dirty="0"/>
+              <a:t> has not been tampered.</a:t>
+            </a:r>
           </a:p>
         </p:txBody>
       </p:sp>
     </p:spTree>
     <p:extLst>
       <p:ext uri="{BB962C8B-B14F-4D97-AF65-F5344CB8AC3E}">
-        <p14:creationId xmlns:p14="http://schemas.microsoft.com/office/powerpoint/2010/main" val="2057756364"/>
+        <p14:creationId xmlns:p14="http://schemas.microsoft.com/office/powerpoint/2010/main" val="973874681"/>
       </p:ext>
     </p:extLst>
   </p:cSld>
@@ -19443,6 +19239,505 @@
           <p:cNvPr id="2" name="Title 1">
             <a:extLst>
               <a:ext uri="{FF2B5EF4-FFF2-40B4-BE49-F238E27FC236}">
+                <a16:creationId xmlns:a16="http://schemas.microsoft.com/office/drawing/2014/main" id="{C22CBFFE-4E3A-2E51-3538-8811F1401233}"/>
+              </a:ext>
+            </a:extLst>
+          </p:cNvPr>
+          <p:cNvSpPr>
+            <a:spLocks noGrp="1"/>
+          </p:cNvSpPr>
+          <p:nvPr>
+            <p:ph type="title"/>
+          </p:nvPr>
+        </p:nvSpPr>
+        <p:spPr/>
+        <p:txBody>
+          <a:bodyPr/>
+          <a:lstStyle/>
+          <a:p>
+            <a:r>
+              <a:rPr lang="en-US" dirty="0"/>
+              <a:t>User and Commands through Parties (2/2)	</a:t>
+            </a:r>
+          </a:p>
+        </p:txBody>
+      </p:sp>
+      <p:sp>
+        <p:nvSpPr>
+          <p:cNvPr id="3" name="Content Placeholder 2">
+            <a:extLst>
+              <a:ext uri="{FF2B5EF4-FFF2-40B4-BE49-F238E27FC236}">
+                <a16:creationId xmlns:a16="http://schemas.microsoft.com/office/drawing/2014/main" id="{D2F4F95B-3516-EFB7-2D85-F2244EED81A5}"/>
+              </a:ext>
+            </a:extLst>
+          </p:cNvPr>
+          <p:cNvSpPr>
+            <a:spLocks noGrp="1"/>
+          </p:cNvSpPr>
+          <p:nvPr>
+            <p:ph idx="1"/>
+          </p:nvPr>
+        </p:nvSpPr>
+        <p:spPr>
+          <a:xfrm>
+            <a:off x="838200" y="1825624"/>
+            <a:ext cx="10515600" cy="4667251"/>
+          </a:xfrm>
+        </p:spPr>
+        <p:txBody>
+          <a:bodyPr>
+            <a:normAutofit fontScale="92500" lnSpcReduction="20000"/>
+          </a:bodyPr>
+          <a:lstStyle/>
+          <a:p>
+            <a:r>
+              <a:rPr lang="en-US" dirty="0"/>
+              <a:t>When “$Trolley1” sends a Command in the name of Alice to “$Box”…</a:t>
+            </a:r>
+          </a:p>
+          <a:p>
+            <a:pPr lvl="1"/>
+            <a:r>
+              <a:rPr lang="en-US" dirty="0"/>
+              <a:t>it also sends the proof.</a:t>
+            </a:r>
+          </a:p>
+          <a:p>
+            <a:r>
+              <a:rPr lang="en-US" dirty="0"/>
+              <a:t>“$Box” </a:t>
+            </a:r>
+            <a:r>
+              <a:rPr lang="en-US" dirty="0" err="1"/>
+              <a:t>AppIdentity’s</a:t>
+            </a:r>
+            <a:r>
+              <a:rPr lang="en-US" dirty="0"/>
+              <a:t> endpoint receives the command and the proof.</a:t>
+            </a:r>
+          </a:p>
+          <a:p>
+            <a:pPr lvl="1"/>
+            <a:r>
+              <a:rPr lang="en-US" dirty="0"/>
+              <a:t>It builds a “</a:t>
+            </a:r>
+            <a:r>
+              <a:rPr lang="en-US" dirty="0" err="1"/>
+              <a:t>ScopedData</a:t>
+            </a:r>
+            <a:r>
+              <a:rPr lang="en-US" dirty="0"/>
+              <a:t>” with the proof and the fact that it is “$Trolley1” that sent the command.</a:t>
+            </a:r>
+          </a:p>
+          <a:p>
+            <a:pPr lvl="1"/>
+            <a:r>
+              <a:rPr lang="en-US" dirty="0"/>
+              <a:t>Its Endpoint is configured to resolve the </a:t>
+            </a:r>
+            <a:r>
+              <a:rPr lang="en-US" dirty="0" err="1"/>
+              <a:t>IAuthenticationInfo</a:t>
+            </a:r>
+            <a:r>
+              <a:rPr lang="en-US" dirty="0"/>
+              <a:t> service by:</a:t>
+            </a:r>
+          </a:p>
+          <a:p>
+            <a:pPr lvl="2"/>
+            <a:r>
+              <a:rPr lang="en-US" dirty="0"/>
+              <a:t>Accessing the </a:t>
+            </a:r>
+            <a:r>
+              <a:rPr lang="en-US" dirty="0" err="1"/>
+              <a:t>ScopedData’s</a:t>
+            </a:r>
+            <a:r>
+              <a:rPr lang="en-US" dirty="0"/>
+              <a:t> proof and sender.</a:t>
+            </a:r>
+          </a:p>
+          <a:p>
+            <a:pPr lvl="2"/>
+            <a:r>
+              <a:rPr lang="en-US" dirty="0"/>
+              <a:t>Verifying the signature and on success, returns the </a:t>
+            </a:r>
+            <a:r>
+              <a:rPr lang="en-US" dirty="0" err="1"/>
+              <a:t>IAuthenticationInfo</a:t>
+            </a:r>
+            <a:r>
+              <a:rPr lang="en-US" dirty="0"/>
+              <a:t>.</a:t>
+            </a:r>
+          </a:p>
+          <a:p>
+            <a:r>
+              <a:rPr lang="en-US" dirty="0"/>
+              <a:t>“$Box” validates and executes the command</a:t>
+            </a:r>
+          </a:p>
+          <a:p>
+            <a:pPr lvl="1"/>
+            <a:r>
+              <a:rPr lang="en-US" dirty="0"/>
+              <a:t>Commands are executed in the background by runners in a scoped service container parametrized with the </a:t>
+            </a:r>
+            <a:r>
+              <a:rPr lang="en-US" dirty="0" err="1"/>
+              <a:t>ScopedData</a:t>
+            </a:r>
+            <a:r>
+              <a:rPr lang="en-US" dirty="0"/>
+              <a:t>.</a:t>
+            </a:r>
+          </a:p>
+          <a:p>
+            <a:pPr lvl="1"/>
+            <a:r>
+              <a:rPr lang="en-US" dirty="0"/>
+              <a:t>If any service involved in the validation or execution of the command requires the </a:t>
+            </a:r>
+            <a:r>
+              <a:rPr lang="en-US" dirty="0" err="1"/>
+              <a:t>IAuthenticationInfo</a:t>
+            </a:r>
+            <a:r>
+              <a:rPr lang="en-US" dirty="0"/>
+              <a:t>, it is resolved.</a:t>
+            </a:r>
+          </a:p>
+          <a:p>
+            <a:pPr lvl="1"/>
+            <a:r>
+              <a:rPr lang="en-US" dirty="0"/>
+              <a:t>Command execution outcomes (Validation result, events and result) are sent back to “$Trolley1”</a:t>
+            </a:r>
+          </a:p>
+          <a:p>
+            <a:pPr lvl="1"/>
+            <a:endParaRPr lang="en-US" dirty="0"/>
+          </a:p>
+          <a:p>
+            <a:endParaRPr lang="en-US" dirty="0"/>
+          </a:p>
+        </p:txBody>
+      </p:sp>
+    </p:spTree>
+    <p:extLst>
+      <p:ext uri="{BB962C8B-B14F-4D97-AF65-F5344CB8AC3E}">
+        <p14:creationId xmlns:p14="http://schemas.microsoft.com/office/powerpoint/2010/main" val="2929531232"/>
+      </p:ext>
+    </p:extLst>
+  </p:cSld>
+  <p:clrMapOvr>
+    <a:masterClrMapping/>
+  </p:clrMapOvr>
+</p:sld>
+</file>
+
+<file path=ppt/slides/slide41.xml><?xml version="1.0" encoding="utf-8"?>
+<p:sld xmlns:a="http://schemas.openxmlformats.org/drawingml/2006/main" xmlns:r="http://schemas.openxmlformats.org/officeDocument/2006/relationships" xmlns:p="http://schemas.openxmlformats.org/presentationml/2006/main">
+  <p:cSld>
+    <p:spTree>
+      <p:nvGrpSpPr>
+        <p:cNvPr id="1" name=""/>
+        <p:cNvGrpSpPr/>
+        <p:nvPr/>
+      </p:nvGrpSpPr>
+      <p:grpSpPr>
+        <a:xfrm>
+          <a:off x="0" y="0"/>
+          <a:ext cx="0" cy="0"/>
+          <a:chOff x="0" y="0"/>
+          <a:chExt cx="0" cy="0"/>
+        </a:xfrm>
+      </p:grpSpPr>
+      <p:sp>
+        <p:nvSpPr>
+          <p:cNvPr id="2" name="Title 1">
+            <a:extLst>
+              <a:ext uri="{FF2B5EF4-FFF2-40B4-BE49-F238E27FC236}">
+                <a16:creationId xmlns:a16="http://schemas.microsoft.com/office/drawing/2014/main" id="{F028D4AF-53E9-FC4C-72A8-AAC9BDAA1F0D}"/>
+              </a:ext>
+            </a:extLst>
+          </p:cNvPr>
+          <p:cNvSpPr>
+            <a:spLocks noGrp="1"/>
+          </p:cNvSpPr>
+          <p:nvPr>
+            <p:ph type="title"/>
+          </p:nvPr>
+        </p:nvSpPr>
+        <p:spPr/>
+        <p:txBody>
+          <a:bodyPr/>
+          <a:lstStyle/>
+          <a:p>
+            <a:r>
+              <a:rPr lang="en-US" dirty="0"/>
+              <a:t>The “</a:t>
+            </a:r>
+            <a:r>
+              <a:rPr lang="en-US" dirty="0" err="1"/>
+              <a:t>PartyAuthenticationToken</a:t>
+            </a:r>
+            <a:r>
+              <a:rPr lang="en-US" dirty="0"/>
+              <a:t>”</a:t>
+            </a:r>
+          </a:p>
+        </p:txBody>
+      </p:sp>
+      <p:sp>
+        <p:nvSpPr>
+          <p:cNvPr id="3" name="Content Placeholder 2">
+            <a:extLst>
+              <a:ext uri="{FF2B5EF4-FFF2-40B4-BE49-F238E27FC236}">
+                <a16:creationId xmlns:a16="http://schemas.microsoft.com/office/drawing/2014/main" id="{5898F5DD-D01F-FADF-46B5-1C37122F4589}"/>
+              </a:ext>
+            </a:extLst>
+          </p:cNvPr>
+          <p:cNvSpPr>
+            <a:spLocks noGrp="1"/>
+          </p:cNvSpPr>
+          <p:nvPr>
+            <p:ph idx="1"/>
+          </p:nvPr>
+        </p:nvSpPr>
+        <p:spPr/>
+        <p:txBody>
+          <a:bodyPr>
+            <a:normAutofit fontScale="92500" lnSpcReduction="20000"/>
+          </a:bodyPr>
+          <a:lstStyle/>
+          <a:p>
+            <a:r>
+              <a:rPr lang="en-US" dirty="0"/>
+              <a:t>Contains at least (</a:t>
+            </a:r>
+            <a:r>
+              <a:rPr lang="en-US" dirty="0" err="1"/>
+              <a:t>OpenId</a:t>
+            </a:r>
+            <a:r>
+              <a:rPr lang="en-US" dirty="0"/>
+              <a:t> compliant)</a:t>
+            </a:r>
+          </a:p>
+          <a:p>
+            <a:pPr lvl="1"/>
+            <a:r>
+              <a:rPr lang="en-US" dirty="0"/>
+              <a:t>The </a:t>
+            </a:r>
+            <a:r>
+              <a:rPr lang="en-US" b="1" dirty="0"/>
+              <a:t>sub</a:t>
+            </a:r>
+            <a:r>
+              <a:rPr lang="en-US" dirty="0"/>
+              <a:t>ject: the </a:t>
+            </a:r>
+            <a:r>
+              <a:rPr lang="en-US" dirty="0" err="1"/>
+              <a:t>IAuthenticationInfo</a:t>
+            </a:r>
+            <a:r>
+              <a:rPr lang="en-US" dirty="0"/>
+              <a:t> </a:t>
+            </a:r>
+          </a:p>
+          <a:p>
+            <a:pPr lvl="2"/>
+            <a:r>
+              <a:rPr lang="en-US" dirty="0"/>
+              <a:t>with its </a:t>
+            </a:r>
+            <a:r>
+              <a:rPr lang="en-US" dirty="0" err="1"/>
+              <a:t>CriticalExpires</a:t>
+            </a:r>
+            <a:r>
+              <a:rPr lang="en-US" dirty="0"/>
+              <a:t> and </a:t>
+            </a:r>
+            <a:r>
+              <a:rPr lang="en-US" b="1" dirty="0"/>
+              <a:t>Exp</a:t>
+            </a:r>
+            <a:r>
+              <a:rPr lang="en-US" dirty="0"/>
+              <a:t>ires dates).</a:t>
+            </a:r>
+          </a:p>
+          <a:p>
+            <a:pPr lvl="1"/>
+            <a:r>
+              <a:rPr lang="en-US" dirty="0"/>
+              <a:t>The </a:t>
+            </a:r>
+            <a:r>
+              <a:rPr lang="en-US" b="1" dirty="0"/>
+              <a:t>iss</a:t>
+            </a:r>
+            <a:r>
+              <a:rPr lang="en-US" dirty="0"/>
+              <a:t>uer: the “Central User Directory” identity full name.</a:t>
+            </a:r>
+          </a:p>
+          <a:p>
+            <a:pPr lvl="1"/>
+            <a:r>
+              <a:rPr lang="en-US" b="1" dirty="0"/>
+              <a:t>alg</a:t>
+            </a:r>
+            <a:r>
+              <a:rPr lang="en-US" dirty="0"/>
+              <a:t>orithm and key size should be decided and fixed (best practice – may be overridden later).</a:t>
+            </a:r>
+          </a:p>
+          <a:p>
+            <a:r>
+              <a:rPr lang="en-US" dirty="0"/>
+              <a:t>Options (more </a:t>
+            </a:r>
+            <a:r>
+              <a:rPr lang="en-US" dirty="0" err="1"/>
+              <a:t>Oauth</a:t>
+            </a:r>
+            <a:r>
+              <a:rPr lang="en-US" dirty="0"/>
+              <a:t> than </a:t>
+            </a:r>
+            <a:r>
+              <a:rPr lang="en-US" dirty="0" err="1"/>
+              <a:t>OpenId</a:t>
+            </a:r>
+            <a:r>
+              <a:rPr lang="en-US" dirty="0"/>
+              <a:t>)</a:t>
+            </a:r>
+          </a:p>
+          <a:p>
+            <a:pPr lvl="1"/>
+            <a:r>
+              <a:rPr lang="en-US" dirty="0"/>
+              <a:t>The </a:t>
+            </a:r>
+            <a:r>
+              <a:rPr lang="en-US" b="1" dirty="0"/>
+              <a:t>aud</a:t>
+            </a:r>
+            <a:r>
+              <a:rPr lang="en-US" dirty="0"/>
+              <a:t>ience: the “$Box” identity full name.</a:t>
+            </a:r>
+          </a:p>
+          <a:p>
+            <a:pPr lvl="1"/>
+            <a:r>
+              <a:rPr lang="en-US" dirty="0"/>
+              <a:t>“client” or “origin”: the “$Trolley1” identity full name to which the token has been delivered.</a:t>
+            </a:r>
+          </a:p>
+          <a:p>
+            <a:r>
+              <a:rPr lang="en-US" dirty="0"/>
+              <a:t>Open questions</a:t>
+            </a:r>
+          </a:p>
+          <a:p>
+            <a:pPr lvl="1"/>
+            <a:r>
+              <a:rPr lang="en-US" dirty="0"/>
+              <a:t>“issued at” (</a:t>
+            </a:r>
+            <a:r>
+              <a:rPr lang="en-US" b="1" dirty="0" err="1"/>
+              <a:t>iat</a:t>
+            </a:r>
+            <a:r>
+              <a:rPr lang="en-US" dirty="0"/>
+              <a:t>).</a:t>
+            </a:r>
+          </a:p>
+          <a:p>
+            <a:pPr lvl="1"/>
+            <a:r>
+              <a:rPr lang="en-US" dirty="0"/>
+              <a:t>“not before” (</a:t>
+            </a:r>
+            <a:r>
+              <a:rPr lang="en-US" b="1" dirty="0" err="1"/>
+              <a:t>nbf</a:t>
+            </a:r>
+            <a:r>
+              <a:rPr lang="en-US" dirty="0"/>
+              <a:t>).</a:t>
+            </a:r>
+          </a:p>
+          <a:p>
+            <a:pPr lvl="1"/>
+            <a:r>
+              <a:rPr lang="en-US" dirty="0"/>
+              <a:t>Key identifier (</a:t>
+            </a:r>
+            <a:r>
+              <a:rPr lang="en-US" b="1" dirty="0"/>
+              <a:t>kid</a:t>
+            </a:r>
+            <a:r>
+              <a:rPr lang="en-US" dirty="0"/>
+              <a:t>) or not.</a:t>
+            </a:r>
+          </a:p>
+          <a:p>
+            <a:pPr lvl="1"/>
+            <a:endParaRPr lang="en-US" dirty="0"/>
+          </a:p>
+        </p:txBody>
+      </p:sp>
+    </p:spTree>
+    <p:extLst>
+      <p:ext uri="{BB962C8B-B14F-4D97-AF65-F5344CB8AC3E}">
+        <p14:creationId xmlns:p14="http://schemas.microsoft.com/office/powerpoint/2010/main" val="2057756364"/>
+      </p:ext>
+    </p:extLst>
+  </p:cSld>
+  <p:clrMapOvr>
+    <a:masterClrMapping/>
+  </p:clrMapOvr>
+</p:sld>
+</file>
+
+<file path=ppt/slides/slide42.xml><?xml version="1.0" encoding="utf-8"?>
+<p:sld xmlns:a="http://schemas.openxmlformats.org/drawingml/2006/main" xmlns:r="http://schemas.openxmlformats.org/officeDocument/2006/relationships" xmlns:p="http://schemas.openxmlformats.org/presentationml/2006/main">
+  <p:cSld>
+    <p:spTree>
+      <p:nvGrpSpPr>
+        <p:cNvPr id="1" name=""/>
+        <p:cNvGrpSpPr/>
+        <p:nvPr/>
+      </p:nvGrpSpPr>
+      <p:grpSpPr>
+        <a:xfrm>
+          <a:off x="0" y="0"/>
+          <a:ext cx="0" cy="0"/>
+          <a:chOff x="0" y="0"/>
+          <a:chExt cx="0" cy="0"/>
+        </a:xfrm>
+      </p:grpSpPr>
+      <p:sp>
+        <p:nvSpPr>
+          <p:cNvPr id="2" name="Title 1">
+            <a:extLst>
+              <a:ext uri="{FF2B5EF4-FFF2-40B4-BE49-F238E27FC236}">
                 <a16:creationId xmlns:a16="http://schemas.microsoft.com/office/drawing/2014/main" id="{7DBA6962-B8F6-250D-79FF-D57BEC59F1C8}"/>
               </a:ext>
             </a:extLst>
@@ -19792,7 +20087,7 @@
 </p:sld>
 </file>
 
-<file path=ppt/slides/slide41.xml><?xml version="1.0" encoding="utf-8"?>
+<file path=ppt/slides/slide43.xml><?xml version="1.0" encoding="utf-8"?>
 <p:sld xmlns:a="http://schemas.openxmlformats.org/drawingml/2006/main" xmlns:r="http://schemas.openxmlformats.org/officeDocument/2006/relationships" xmlns:p="http://schemas.openxmlformats.org/presentationml/2006/main">
   <p:cSld>
     <p:spTree>
@@ -19895,7 +20190,7 @@
 </p:sld>
 </file>
 
-<file path=ppt/slides/slide42.xml><?xml version="1.0" encoding="utf-8"?>
+<file path=ppt/slides/slide44.xml><?xml version="1.0" encoding="utf-8"?>
 <p:sld xmlns:a="http://schemas.openxmlformats.org/drawingml/2006/main" xmlns:r="http://schemas.openxmlformats.org/officeDocument/2006/relationships" xmlns:p="http://schemas.openxmlformats.org/presentationml/2006/main">
   <p:cSld>
     <p:spTree>
@@ -20142,7 +20437,7 @@
 </p:sld>
 </file>
 
-<file path=ppt/slides/slide43.xml><?xml version="1.0" encoding="utf-8"?>
+<file path=ppt/slides/slide45.xml><?xml version="1.0" encoding="utf-8"?>
 <p:sld xmlns:a="http://schemas.openxmlformats.org/drawingml/2006/main" xmlns:r="http://schemas.openxmlformats.org/officeDocument/2006/relationships" xmlns:p="http://schemas.openxmlformats.org/presentationml/2006/main">
   <p:cSld>
     <p:spTree>
@@ -20685,7 +20980,7 @@
 </p:sld>
 </file>
 
-<file path=ppt/slides/slide44.xml><?xml version="1.0" encoding="utf-8"?>
+<file path=ppt/slides/slide46.xml><?xml version="1.0" encoding="utf-8"?>
 <p:sld xmlns:a="http://schemas.openxmlformats.org/drawingml/2006/main" xmlns:r="http://schemas.openxmlformats.org/officeDocument/2006/relationships" xmlns:p="http://schemas.openxmlformats.org/presentationml/2006/main">
   <p:cSld>
     <p:spTree>
@@ -20887,7 +21182,7 @@
 </p:sld>
 </file>
 
-<file path=ppt/slides/slide45.xml><?xml version="1.0" encoding="utf-8"?>
+<file path=ppt/slides/slide47.xml><?xml version="1.0" encoding="utf-8"?>
 <p:sld xmlns:a="http://schemas.openxmlformats.org/drawingml/2006/main" xmlns:r="http://schemas.openxmlformats.org/officeDocument/2006/relationships" xmlns:p="http://schemas.openxmlformats.org/presentationml/2006/main">
   <p:cSld>
     <p:spTree>

</xml_diff>